<commit_message>
docs: update report and slides to protocol 8
</commit_message>
<xml_diff>
--- a/report/presentation.pptx
+++ b/report/presentation.pptx
@@ -199,7 +199,7 @@
             </a:lvl1pPr>
           </a:lstStyle>
           <a:p>
-            <a:fld id="{F9C8945C-766C-475A-A5DD-D3A1B8424383}" type="datetimeFigureOut">
+            <a:fld id="{0F5D95D3-69C0-4FD3-AA6F-9D5AE9A289C2}" type="datetimeFigureOut">
               <a:rPr lang="ru-RU" smtClean="0"/>
               <a:t>27.09.2026</a:t>
             </a:fld>
@@ -357,7 +357,7 @@
             </a:lvl1pPr>
           </a:lstStyle>
           <a:p>
-            <a:fld id="{BA039F6B-EE3C-444F-95F7-297CFB6A7046}" type="slidenum">
+            <a:fld id="{2C2BA99B-F630-47CE-9753-CC6CB6C9239A}" type="slidenum">
               <a:rPr lang="ru-RU" smtClean="0"/>
               <a:t>‹#›</a:t>
             </a:fld>
@@ -368,7 +368,7 @@
     </p:spTree>
     <p:extLst>
       <p:ext uri="{BB962C8B-B14F-4D97-AF65-F5344CB8AC3E}">
-        <p14:creationId xmlns:p14="http://schemas.microsoft.com/office/powerpoint/2010/main" val="3527201056"/>
+        <p14:creationId xmlns:p14="http://schemas.microsoft.com/office/powerpoint/2010/main" val="2986896543"/>
       </p:ext>
     </p:extLst>
   </p:cSld>
@@ -534,7 +534,7 @@
           <a:bodyPr/>
           <a:lstStyle/>
           <a:p>
-            <a:fld id="{BA039F6B-EE3C-444F-95F7-297CFB6A7046}" type="slidenum">
+            <a:fld id="{2C2BA99B-F630-47CE-9753-CC6CB6C9239A}" type="slidenum">
               <a:rPr lang="ru-RU" smtClean="0"/>
               <a:t>1</a:t>
             </a:fld>
@@ -545,7 +545,7 @@
     </p:spTree>
     <p:extLst>
       <p:ext uri="{BB962C8B-B14F-4D97-AF65-F5344CB8AC3E}">
-        <p14:creationId xmlns:p14="http://schemas.microsoft.com/office/powerpoint/2010/main" val="703641916"/>
+        <p14:creationId xmlns:p14="http://schemas.microsoft.com/office/powerpoint/2010/main" val="2171493591"/>
       </p:ext>
     </p:extLst>
   </p:cSld>
@@ -601,7 +601,7 @@
           <a:p>
             <a:r>
               <a:rPr lang="ru-RU"/>
-              <a:t>Итог. Модель на минуте покоя даёт AUC 0.84 вне выборки и надёжно отделяет нормальное старение. Ограничения мы показываем открыто: с молодыми нормами модель держится на височных отведениях, соматоформных различает хуже, а когорты отличаются не только диагнозом. Для настоящего биомаркера нужны контроль с боевой травмой без ПТСР и одинаковые условия регистрации.</a:t>
+              <a:t>Итог. Модель на минуте покоя даёт AUC 0.86 вне выборки и надёжно отделяет нормальное старение. Ограничения мы показываем открыто: с молодыми нормами модель держится на височных отведениях, соматоформных различает хуже, а когорты отличаются не только диагнозом. Для настоящего биомаркера нужны контроль с боевой травмой без ПТСР и одинаковые условия регистрации.</a:t>
             </a:r>
           </a:p>
         </p:txBody>
@@ -621,7 +621,7 @@
           <a:bodyPr/>
           <a:lstStyle/>
           <a:p>
-            <a:fld id="{BA039F6B-EE3C-444F-95F7-297CFB6A7046}" type="slidenum">
+            <a:fld id="{2C2BA99B-F630-47CE-9753-CC6CB6C9239A}" type="slidenum">
               <a:rPr lang="ru-RU" smtClean="0"/>
               <a:t>10</a:t>
             </a:fld>
@@ -632,7 +632,7 @@
     </p:spTree>
     <p:extLst>
       <p:ext uri="{BB962C8B-B14F-4D97-AF65-F5344CB8AC3E}">
-        <p14:creationId xmlns:p14="http://schemas.microsoft.com/office/powerpoint/2010/main" val="2803200353"/>
+        <p14:creationId xmlns:p14="http://schemas.microsoft.com/office/powerpoint/2010/main" val="1501416866"/>
       </p:ext>
     </p:extLst>
   </p:cSld>
@@ -708,7 +708,7 @@
           <a:bodyPr/>
           <a:lstStyle/>
           <a:p>
-            <a:fld id="{BA039F6B-EE3C-444F-95F7-297CFB6A7046}" type="slidenum">
+            <a:fld id="{2C2BA99B-F630-47CE-9753-CC6CB6C9239A}" type="slidenum">
               <a:rPr lang="ru-RU" smtClean="0"/>
               <a:t>2</a:t>
             </a:fld>
@@ -719,7 +719,7 @@
     </p:spTree>
     <p:extLst>
       <p:ext uri="{BB962C8B-B14F-4D97-AF65-F5344CB8AC3E}">
-        <p14:creationId xmlns:p14="http://schemas.microsoft.com/office/powerpoint/2010/main" val="32598948"/>
+        <p14:creationId xmlns:p14="http://schemas.microsoft.com/office/powerpoint/2010/main" val="3237258632"/>
       </p:ext>
     </p:extLst>
   </p:cSld>
@@ -795,7 +795,7 @@
           <a:bodyPr/>
           <a:lstStyle/>
           <a:p>
-            <a:fld id="{BA039F6B-EE3C-444F-95F7-297CFB6A7046}" type="slidenum">
+            <a:fld id="{2C2BA99B-F630-47CE-9753-CC6CB6C9239A}" type="slidenum">
               <a:rPr lang="ru-RU" smtClean="0"/>
               <a:t>3</a:t>
             </a:fld>
@@ -806,7 +806,7 @@
     </p:spTree>
     <p:extLst>
       <p:ext uri="{BB962C8B-B14F-4D97-AF65-F5344CB8AC3E}">
-        <p14:creationId xmlns:p14="http://schemas.microsoft.com/office/powerpoint/2010/main" val="753259436"/>
+        <p14:creationId xmlns:p14="http://schemas.microsoft.com/office/powerpoint/2010/main" val="215966279"/>
       </p:ext>
     </p:extLst>
   </p:cSld>
@@ -882,7 +882,7 @@
           <a:bodyPr/>
           <a:lstStyle/>
           <a:p>
-            <a:fld id="{BA039F6B-EE3C-444F-95F7-297CFB6A7046}" type="slidenum">
+            <a:fld id="{2C2BA99B-F630-47CE-9753-CC6CB6C9239A}" type="slidenum">
               <a:rPr lang="ru-RU" smtClean="0"/>
               <a:t>4</a:t>
             </a:fld>
@@ -893,7 +893,7 @@
     </p:spTree>
     <p:extLst>
       <p:ext uri="{BB962C8B-B14F-4D97-AF65-F5344CB8AC3E}">
-        <p14:creationId xmlns:p14="http://schemas.microsoft.com/office/powerpoint/2010/main" val="2273387058"/>
+        <p14:creationId xmlns:p14="http://schemas.microsoft.com/office/powerpoint/2010/main" val="3126248795"/>
       </p:ext>
     </p:extLst>
   </p:cSld>
@@ -949,7 +949,7 @@
           <a:p>
             <a:r>
               <a:rPr lang="ru-RU"/>
-              <a:t>Все метрики вне выборки: каждого испытуемого предсказывает модель, которая его не видела. AUC против норм моложе 65 — 0.84 с интервалом от 0.77 до 0.90. Если убрать нетипичный формат C — 0.72. Чувствительность при пороге 0.5 — 0.80: мы специально выбрали сбалансированную калибровку, чтобы модель выявляла ПТСР, а не пряталась за низкими вероятностями.</a:t>
+              <a:t>Все метрики вне выборки: каждого испытуемого предсказывает модель, которая его не видела. AUC против норм моложе 65 — 0.86 с интервалом от 0.80 до 0.92. Если убрать нетипичный формат C — 0.77. Чувствительность при пороге 0.5 — 0.84: порог стоит в точке, где чувствительность равна специфичности на группах проверки, а нормам 65+ и соматоформным при обучении можно давать повышенный вес — это подняло и специфичность, и AUC.</a:t>
             </a:r>
           </a:p>
         </p:txBody>
@@ -969,7 +969,7 @@
           <a:bodyPr/>
           <a:lstStyle/>
           <a:p>
-            <a:fld id="{BA039F6B-EE3C-444F-95F7-297CFB6A7046}" type="slidenum">
+            <a:fld id="{2C2BA99B-F630-47CE-9753-CC6CB6C9239A}" type="slidenum">
               <a:rPr lang="ru-RU" smtClean="0"/>
               <a:t>5</a:t>
             </a:fld>
@@ -980,7 +980,7 @@
     </p:spTree>
     <p:extLst>
       <p:ext uri="{BB962C8B-B14F-4D97-AF65-F5344CB8AC3E}">
-        <p14:creationId xmlns:p14="http://schemas.microsoft.com/office/powerpoint/2010/main" val="715009253"/>
+        <p14:creationId xmlns:p14="http://schemas.microsoft.com/office/powerpoint/2010/main" val="1083067936"/>
       </p:ext>
     </p:extLst>
   </p:cSld>
@@ -1036,7 +1036,7 @@
           <a:p>
             <a:r>
               <a:rPr lang="ru-RU"/>
-              <a:t>Каждая точка — испытуемый. Пожилых модель отделяет хорошо: специфичность 0.78, потому что у них ослаблена и замедлена альфа. Соматоформные — самая трудная группа, 0.58: это клинически близкие пациенты с тревогой и соматическим возбуждением. Ошибаемся мы там, где у человека сохранна затылочная альфа.</a:t>
+              <a:t>Каждая точка — испытуемый. Пожилых модель отделяет хорошо: специфичность 0.87, потому что у них ослаблена и замедлена альфа. Соматоформные — самая трудная группа, 0.61. Мы проверили каждый признак: всё, что надёжно отличает ПТСР от нормы, так же сдвинуто и у соматоформных. Это общий клинический профиль гипервозбуждения, а не маркер травмы, и мы так и пишем.</a:t>
             </a:r>
           </a:p>
         </p:txBody>
@@ -1056,7 +1056,7 @@
           <a:bodyPr/>
           <a:lstStyle/>
           <a:p>
-            <a:fld id="{BA039F6B-EE3C-444F-95F7-297CFB6A7046}" type="slidenum">
+            <a:fld id="{2C2BA99B-F630-47CE-9753-CC6CB6C9239A}" type="slidenum">
               <a:rPr lang="ru-RU" smtClean="0"/>
               <a:t>6</a:t>
             </a:fld>
@@ -1067,7 +1067,7 @@
     </p:spTree>
     <p:extLst>
       <p:ext uri="{BB962C8B-B14F-4D97-AF65-F5344CB8AC3E}">
-        <p14:creationId xmlns:p14="http://schemas.microsoft.com/office/powerpoint/2010/main" val="4017893833"/>
+        <p14:creationId xmlns:p14="http://schemas.microsoft.com/office/powerpoint/2010/main" val="2487568492"/>
       </p:ext>
     </p:extLst>
   </p:cSld>
@@ -1123,7 +1123,7 @@
           <a:p>
             <a:r>
               <a:rPr lang="ru-RU"/>
-              <a:t>ТЗ требует три проверки, мы сделали больше. Формат: внутри одного формата B модель различает ПТСР и 65 норм с AUC 0.81, а модель на метаданных — ноль. Качество записи само по себе ничего не даёт. Возраст внутри партии признаки не предсказывают. От времени решения таблиц вероятность не зависит. Честное ограничение: различение с молодыми нормами держится на височных отведениях; без них AUC против норм A/B — 0.56.</a:t>
+              <a:t>ТЗ требует три проверки, мы сделали больше. Формат: внутри одного формата B модель различает ПТСР и 65 норм с AUC 0.84, а модель на метаданных — ноль. Качество записи само по себе ничего не даёт. Возраст внутри партии признаки не предсказывают. От времени решения таблиц вероятность не зависит. Честное ограничение: различение с молодыми нормами держится на височных отведениях; без них AUC против норм A/B — 0.57.</a:t>
             </a:r>
           </a:p>
         </p:txBody>
@@ -1143,7 +1143,7 @@
           <a:bodyPr/>
           <a:lstStyle/>
           <a:p>
-            <a:fld id="{BA039F6B-EE3C-444F-95F7-297CFB6A7046}" type="slidenum">
+            <a:fld id="{2C2BA99B-F630-47CE-9753-CC6CB6C9239A}" type="slidenum">
               <a:rPr lang="ru-RU" smtClean="0"/>
               <a:t>7</a:t>
             </a:fld>
@@ -1154,7 +1154,7 @@
     </p:spTree>
     <p:extLst>
       <p:ext uri="{BB962C8B-B14F-4D97-AF65-F5344CB8AC3E}">
-        <p14:creationId xmlns:p14="http://schemas.microsoft.com/office/powerpoint/2010/main" val="3264477850"/>
+        <p14:creationId xmlns:p14="http://schemas.microsoft.com/office/powerpoint/2010/main" val="1700393438"/>
       </p:ext>
     </p:extLst>
   </p:cSld>
@@ -1230,7 +1230,7 @@
           <a:bodyPr/>
           <a:lstStyle/>
           <a:p>
-            <a:fld id="{BA039F6B-EE3C-444F-95F7-297CFB6A7046}" type="slidenum">
+            <a:fld id="{2C2BA99B-F630-47CE-9753-CC6CB6C9239A}" type="slidenum">
               <a:rPr lang="ru-RU" smtClean="0"/>
               <a:t>8</a:t>
             </a:fld>
@@ -1241,7 +1241,7 @@
     </p:spTree>
     <p:extLst>
       <p:ext uri="{BB962C8B-B14F-4D97-AF65-F5344CB8AC3E}">
-        <p14:creationId xmlns:p14="http://schemas.microsoft.com/office/powerpoint/2010/main" val="291203459"/>
+        <p14:creationId xmlns:p14="http://schemas.microsoft.com/office/powerpoint/2010/main" val="3466478345"/>
       </p:ext>
     </p:extLst>
   </p:cSld>
@@ -1317,7 +1317,7 @@
           <a:bodyPr/>
           <a:lstStyle/>
           <a:p>
-            <a:fld id="{BA039F6B-EE3C-444F-95F7-297CFB6A7046}" type="slidenum">
+            <a:fld id="{2C2BA99B-F630-47CE-9753-CC6CB6C9239A}" type="slidenum">
               <a:rPr lang="ru-RU" smtClean="0"/>
               <a:t>9</a:t>
             </a:fld>
@@ -1328,7 +1328,7 @@
     </p:spTree>
     <p:extLst>
       <p:ext uri="{BB962C8B-B14F-4D97-AF65-F5344CB8AC3E}">
-        <p14:creationId xmlns:p14="http://schemas.microsoft.com/office/powerpoint/2010/main" val="3157573220"/>
+        <p14:creationId xmlns:p14="http://schemas.microsoft.com/office/powerpoint/2010/main" val="3426773826"/>
       </p:ext>
     </p:extLst>
   </p:cSld>
@@ -1360,7 +1360,7 @@
           <p:cNvPr id="2" name="Заголовок 1">
             <a:extLst>
               <a:ext uri="{FF2B5EF4-FFF2-40B4-BE49-F238E27FC236}">
-                <a16:creationId xmlns:a16="http://schemas.microsoft.com/office/drawing/2014/main" id="{629488C2-FA19-8700-9AE3-F31C50A48797}"/>
+                <a16:creationId xmlns:a16="http://schemas.microsoft.com/office/drawing/2014/main" id="{B20D7290-9B2B-ED61-88B2-E34098F37345}"/>
               </a:ext>
             </a:extLst>
           </p:cNvPr>
@@ -1397,7 +1397,7 @@
           <p:cNvPr id="3" name="Подзаголовок 2">
             <a:extLst>
               <a:ext uri="{FF2B5EF4-FFF2-40B4-BE49-F238E27FC236}">
-                <a16:creationId xmlns:a16="http://schemas.microsoft.com/office/drawing/2014/main" id="{CB7F10F3-9C5F-AF98-41C6-FF198E202874}"/>
+                <a16:creationId xmlns:a16="http://schemas.microsoft.com/office/drawing/2014/main" id="{B9F14E3E-442B-0D1B-F3FB-F38561B21134}"/>
               </a:ext>
             </a:extLst>
           </p:cNvPr>
@@ -1467,7 +1467,7 @@
           <p:cNvPr id="4" name="Дата 3">
             <a:extLst>
               <a:ext uri="{FF2B5EF4-FFF2-40B4-BE49-F238E27FC236}">
-                <a16:creationId xmlns:a16="http://schemas.microsoft.com/office/drawing/2014/main" id="{3C85B08D-EE6E-B486-EC1A-F1216A2751B1}"/>
+                <a16:creationId xmlns:a16="http://schemas.microsoft.com/office/drawing/2014/main" id="{7A1D5630-F3B2-D34D-7A9E-C95CA639F3AC}"/>
               </a:ext>
             </a:extLst>
           </p:cNvPr>
@@ -1483,7 +1483,7 @@
           <a:bodyPr/>
           <a:lstStyle/>
           <a:p>
-            <a:fld id="{F8E9631C-2ACB-43F0-9F5F-E603512EFCD2}" type="datetimeFigureOut">
+            <a:fld id="{68FB7DD9-D72B-4689-B288-600E97991DA7}" type="datetimeFigureOut">
               <a:rPr lang="ru-RU" smtClean="0"/>
               <a:t>27.09.2026</a:t>
             </a:fld>
@@ -1496,7 +1496,7 @@
           <p:cNvPr id="5" name="Нижний колонтитул 4">
             <a:extLst>
               <a:ext uri="{FF2B5EF4-FFF2-40B4-BE49-F238E27FC236}">
-                <a16:creationId xmlns:a16="http://schemas.microsoft.com/office/drawing/2014/main" id="{F3A84921-72ED-054B-4C6A-F5B0E0A15A38}"/>
+                <a16:creationId xmlns:a16="http://schemas.microsoft.com/office/drawing/2014/main" id="{F517FDB2-916F-A045-7799-55DB154A16DA}"/>
               </a:ext>
             </a:extLst>
           </p:cNvPr>
@@ -1521,7 +1521,7 @@
           <p:cNvPr id="6" name="Номер слайда 5">
             <a:extLst>
               <a:ext uri="{FF2B5EF4-FFF2-40B4-BE49-F238E27FC236}">
-                <a16:creationId xmlns:a16="http://schemas.microsoft.com/office/drawing/2014/main" id="{CAEA042C-4E00-3178-6133-7F3227EAFF02}"/>
+                <a16:creationId xmlns:a16="http://schemas.microsoft.com/office/drawing/2014/main" id="{3C2F37A0-D1FA-84F7-641C-B97F1FEA1B9E}"/>
               </a:ext>
             </a:extLst>
           </p:cNvPr>
@@ -1537,7 +1537,7 @@
           <a:bodyPr/>
           <a:lstStyle/>
           <a:p>
-            <a:fld id="{729F168C-9C9F-4A36-BFB6-942532E77215}" type="slidenum">
+            <a:fld id="{39330517-A617-4B46-A59A-9B1D4AB81A72}" type="slidenum">
               <a:rPr lang="ru-RU" smtClean="0"/>
               <a:t>‹#›</a:t>
             </a:fld>
@@ -1548,7 +1548,7 @@
     </p:spTree>
     <p:extLst>
       <p:ext uri="{BB962C8B-B14F-4D97-AF65-F5344CB8AC3E}">
-        <p14:creationId xmlns:p14="http://schemas.microsoft.com/office/powerpoint/2010/main" val="1280106696"/>
+        <p14:creationId xmlns:p14="http://schemas.microsoft.com/office/powerpoint/2010/main" val="2437811537"/>
       </p:ext>
     </p:extLst>
   </p:cSld>
@@ -1580,7 +1580,7 @@
           <p:cNvPr id="2" name="Заголовок 1">
             <a:extLst>
               <a:ext uri="{FF2B5EF4-FFF2-40B4-BE49-F238E27FC236}">
-                <a16:creationId xmlns:a16="http://schemas.microsoft.com/office/drawing/2014/main" id="{5C5C01E4-E8ED-97DE-853D-2E5F363915C0}"/>
+                <a16:creationId xmlns:a16="http://schemas.microsoft.com/office/drawing/2014/main" id="{C961A414-663C-EE40-D2C4-777EF4D90E49}"/>
               </a:ext>
             </a:extLst>
           </p:cNvPr>
@@ -1608,7 +1608,7 @@
           <p:cNvPr id="3" name="Вертикальный текст 2">
             <a:extLst>
               <a:ext uri="{FF2B5EF4-FFF2-40B4-BE49-F238E27FC236}">
-                <a16:creationId xmlns:a16="http://schemas.microsoft.com/office/drawing/2014/main" id="{5514EB4D-4916-3C44-39F0-4FC7C18ACB39}"/>
+                <a16:creationId xmlns:a16="http://schemas.microsoft.com/office/drawing/2014/main" id="{565E59A4-621C-710E-BA18-C1ECCB7659C0}"/>
               </a:ext>
             </a:extLst>
           </p:cNvPr>
@@ -1665,7 +1665,7 @@
           <p:cNvPr id="4" name="Дата 3">
             <a:extLst>
               <a:ext uri="{FF2B5EF4-FFF2-40B4-BE49-F238E27FC236}">
-                <a16:creationId xmlns:a16="http://schemas.microsoft.com/office/drawing/2014/main" id="{490DAAAD-612A-0B92-9DA1-B9ACDDAAB39F}"/>
+                <a16:creationId xmlns:a16="http://schemas.microsoft.com/office/drawing/2014/main" id="{11E96A27-D276-912D-BFD9-263EFAC57DF4}"/>
               </a:ext>
             </a:extLst>
           </p:cNvPr>
@@ -1681,7 +1681,7 @@
           <a:bodyPr/>
           <a:lstStyle/>
           <a:p>
-            <a:fld id="{F8E9631C-2ACB-43F0-9F5F-E603512EFCD2}" type="datetimeFigureOut">
+            <a:fld id="{68FB7DD9-D72B-4689-B288-600E97991DA7}" type="datetimeFigureOut">
               <a:rPr lang="ru-RU" smtClean="0"/>
               <a:t>27.09.2026</a:t>
             </a:fld>
@@ -1694,7 +1694,7 @@
           <p:cNvPr id="5" name="Нижний колонтитул 4">
             <a:extLst>
               <a:ext uri="{FF2B5EF4-FFF2-40B4-BE49-F238E27FC236}">
-                <a16:creationId xmlns:a16="http://schemas.microsoft.com/office/drawing/2014/main" id="{06029E4F-AB24-5D0E-A5F5-E6F31F8D860C}"/>
+                <a16:creationId xmlns:a16="http://schemas.microsoft.com/office/drawing/2014/main" id="{0E966320-DBA6-AA39-BA89-BD1E1ED657BD}"/>
               </a:ext>
             </a:extLst>
           </p:cNvPr>
@@ -1719,7 +1719,7 @@
           <p:cNvPr id="6" name="Номер слайда 5">
             <a:extLst>
               <a:ext uri="{FF2B5EF4-FFF2-40B4-BE49-F238E27FC236}">
-                <a16:creationId xmlns:a16="http://schemas.microsoft.com/office/drawing/2014/main" id="{6AD0A42B-DF06-59C1-FCA1-FFF996DDBE05}"/>
+                <a16:creationId xmlns:a16="http://schemas.microsoft.com/office/drawing/2014/main" id="{FD02CE73-B909-99E6-F547-5FAD3206FE62}"/>
               </a:ext>
             </a:extLst>
           </p:cNvPr>
@@ -1735,7 +1735,7 @@
           <a:bodyPr/>
           <a:lstStyle/>
           <a:p>
-            <a:fld id="{729F168C-9C9F-4A36-BFB6-942532E77215}" type="slidenum">
+            <a:fld id="{39330517-A617-4B46-A59A-9B1D4AB81A72}" type="slidenum">
               <a:rPr lang="ru-RU" smtClean="0"/>
               <a:t>‹#›</a:t>
             </a:fld>
@@ -1746,7 +1746,7 @@
     </p:spTree>
     <p:extLst>
       <p:ext uri="{BB962C8B-B14F-4D97-AF65-F5344CB8AC3E}">
-        <p14:creationId xmlns:p14="http://schemas.microsoft.com/office/powerpoint/2010/main" val="2853424497"/>
+        <p14:creationId xmlns:p14="http://schemas.microsoft.com/office/powerpoint/2010/main" val="838483556"/>
       </p:ext>
     </p:extLst>
   </p:cSld>
@@ -1778,7 +1778,7 @@
           <p:cNvPr id="2" name="Вертикальный заголовок 1">
             <a:extLst>
               <a:ext uri="{FF2B5EF4-FFF2-40B4-BE49-F238E27FC236}">
-                <a16:creationId xmlns:a16="http://schemas.microsoft.com/office/drawing/2014/main" id="{F9EA3F7D-4770-637F-2DA0-698A9F192712}"/>
+                <a16:creationId xmlns:a16="http://schemas.microsoft.com/office/drawing/2014/main" id="{4FFF8CB7-662F-039D-215F-7676A1212697}"/>
               </a:ext>
             </a:extLst>
           </p:cNvPr>
@@ -1811,7 +1811,7 @@
           <p:cNvPr id="3" name="Вертикальный текст 2">
             <a:extLst>
               <a:ext uri="{FF2B5EF4-FFF2-40B4-BE49-F238E27FC236}">
-                <a16:creationId xmlns:a16="http://schemas.microsoft.com/office/drawing/2014/main" id="{817B5A7D-116F-927C-096E-8E66805B541C}"/>
+                <a16:creationId xmlns:a16="http://schemas.microsoft.com/office/drawing/2014/main" id="{29759A71-5507-EC39-2158-2E7A4829651A}"/>
               </a:ext>
             </a:extLst>
           </p:cNvPr>
@@ -1873,7 +1873,7 @@
           <p:cNvPr id="4" name="Дата 3">
             <a:extLst>
               <a:ext uri="{FF2B5EF4-FFF2-40B4-BE49-F238E27FC236}">
-                <a16:creationId xmlns:a16="http://schemas.microsoft.com/office/drawing/2014/main" id="{7646681D-6630-B313-7390-6F2318B1F5ED}"/>
+                <a16:creationId xmlns:a16="http://schemas.microsoft.com/office/drawing/2014/main" id="{9F4E1DFA-F9C4-0520-F0C4-6B824D42C491}"/>
               </a:ext>
             </a:extLst>
           </p:cNvPr>
@@ -1889,7 +1889,7 @@
           <a:bodyPr/>
           <a:lstStyle/>
           <a:p>
-            <a:fld id="{F8E9631C-2ACB-43F0-9F5F-E603512EFCD2}" type="datetimeFigureOut">
+            <a:fld id="{68FB7DD9-D72B-4689-B288-600E97991DA7}" type="datetimeFigureOut">
               <a:rPr lang="ru-RU" smtClean="0"/>
               <a:t>27.09.2026</a:t>
             </a:fld>
@@ -1902,7 +1902,7 @@
           <p:cNvPr id="5" name="Нижний колонтитул 4">
             <a:extLst>
               <a:ext uri="{FF2B5EF4-FFF2-40B4-BE49-F238E27FC236}">
-                <a16:creationId xmlns:a16="http://schemas.microsoft.com/office/drawing/2014/main" id="{D2EFD5F2-D11E-A750-3CA6-D72783551994}"/>
+                <a16:creationId xmlns:a16="http://schemas.microsoft.com/office/drawing/2014/main" id="{FAE78DCB-2D36-1F74-73E1-5B95787C2E3D}"/>
               </a:ext>
             </a:extLst>
           </p:cNvPr>
@@ -1927,7 +1927,7 @@
           <p:cNvPr id="6" name="Номер слайда 5">
             <a:extLst>
               <a:ext uri="{FF2B5EF4-FFF2-40B4-BE49-F238E27FC236}">
-                <a16:creationId xmlns:a16="http://schemas.microsoft.com/office/drawing/2014/main" id="{C02CDCD0-4B59-2A5B-3415-E08CDF5B7177}"/>
+                <a16:creationId xmlns:a16="http://schemas.microsoft.com/office/drawing/2014/main" id="{CE69DCE6-0356-3AC1-A9AD-34F4A2B8D68B}"/>
               </a:ext>
             </a:extLst>
           </p:cNvPr>
@@ -1943,7 +1943,7 @@
           <a:bodyPr/>
           <a:lstStyle/>
           <a:p>
-            <a:fld id="{729F168C-9C9F-4A36-BFB6-942532E77215}" type="slidenum">
+            <a:fld id="{39330517-A617-4B46-A59A-9B1D4AB81A72}" type="slidenum">
               <a:rPr lang="ru-RU" smtClean="0"/>
               <a:t>‹#›</a:t>
             </a:fld>
@@ -1954,7 +1954,7 @@
     </p:spTree>
     <p:extLst>
       <p:ext uri="{BB962C8B-B14F-4D97-AF65-F5344CB8AC3E}">
-        <p14:creationId xmlns:p14="http://schemas.microsoft.com/office/powerpoint/2010/main" val="2014304346"/>
+        <p14:creationId xmlns:p14="http://schemas.microsoft.com/office/powerpoint/2010/main" val="4073401200"/>
       </p:ext>
     </p:extLst>
   </p:cSld>
@@ -1986,7 +1986,7 @@
           <p:cNvPr id="2" name="Заголовок 1">
             <a:extLst>
               <a:ext uri="{FF2B5EF4-FFF2-40B4-BE49-F238E27FC236}">
-                <a16:creationId xmlns:a16="http://schemas.microsoft.com/office/drawing/2014/main" id="{52E970B9-38E1-3B21-61C4-FD4289EEE4C8}"/>
+                <a16:creationId xmlns:a16="http://schemas.microsoft.com/office/drawing/2014/main" id="{9E5A5A54-E372-A886-4887-7E22F9534DD2}"/>
               </a:ext>
             </a:extLst>
           </p:cNvPr>
@@ -2014,7 +2014,7 @@
           <p:cNvPr id="3" name="Объект 2">
             <a:extLst>
               <a:ext uri="{FF2B5EF4-FFF2-40B4-BE49-F238E27FC236}">
-                <a16:creationId xmlns:a16="http://schemas.microsoft.com/office/drawing/2014/main" id="{55246716-AF0A-C0E6-A2F2-1474131B3EC3}"/>
+                <a16:creationId xmlns:a16="http://schemas.microsoft.com/office/drawing/2014/main" id="{59A73EE0-D5CD-2337-F51C-D5A0475CC318}"/>
               </a:ext>
             </a:extLst>
           </p:cNvPr>
@@ -2071,7 +2071,7 @@
           <p:cNvPr id="4" name="Дата 3">
             <a:extLst>
               <a:ext uri="{FF2B5EF4-FFF2-40B4-BE49-F238E27FC236}">
-                <a16:creationId xmlns:a16="http://schemas.microsoft.com/office/drawing/2014/main" id="{FF5FB6F7-8461-64E8-934A-0F42BA7E527D}"/>
+                <a16:creationId xmlns:a16="http://schemas.microsoft.com/office/drawing/2014/main" id="{CC74AB28-1F12-6959-8D1D-20E030877F9D}"/>
               </a:ext>
             </a:extLst>
           </p:cNvPr>
@@ -2087,7 +2087,7 @@
           <a:bodyPr/>
           <a:lstStyle/>
           <a:p>
-            <a:fld id="{F8E9631C-2ACB-43F0-9F5F-E603512EFCD2}" type="datetimeFigureOut">
+            <a:fld id="{68FB7DD9-D72B-4689-B288-600E97991DA7}" type="datetimeFigureOut">
               <a:rPr lang="ru-RU" smtClean="0"/>
               <a:t>27.09.2026</a:t>
             </a:fld>
@@ -2100,7 +2100,7 @@
           <p:cNvPr id="5" name="Нижний колонтитул 4">
             <a:extLst>
               <a:ext uri="{FF2B5EF4-FFF2-40B4-BE49-F238E27FC236}">
-                <a16:creationId xmlns:a16="http://schemas.microsoft.com/office/drawing/2014/main" id="{45EF60FE-A961-C962-E8CA-7361B486381F}"/>
+                <a16:creationId xmlns:a16="http://schemas.microsoft.com/office/drawing/2014/main" id="{7B14188F-303A-5F0E-2B59-C4B4C77649B4}"/>
               </a:ext>
             </a:extLst>
           </p:cNvPr>
@@ -2125,7 +2125,7 @@
           <p:cNvPr id="6" name="Номер слайда 5">
             <a:extLst>
               <a:ext uri="{FF2B5EF4-FFF2-40B4-BE49-F238E27FC236}">
-                <a16:creationId xmlns:a16="http://schemas.microsoft.com/office/drawing/2014/main" id="{04A7F008-252E-F261-B602-639A53DC931E}"/>
+                <a16:creationId xmlns:a16="http://schemas.microsoft.com/office/drawing/2014/main" id="{076A00D4-D29B-BE39-4DC5-654E32AA1086}"/>
               </a:ext>
             </a:extLst>
           </p:cNvPr>
@@ -2141,7 +2141,7 @@
           <a:bodyPr/>
           <a:lstStyle/>
           <a:p>
-            <a:fld id="{729F168C-9C9F-4A36-BFB6-942532E77215}" type="slidenum">
+            <a:fld id="{39330517-A617-4B46-A59A-9B1D4AB81A72}" type="slidenum">
               <a:rPr lang="ru-RU" smtClean="0"/>
               <a:t>‹#›</a:t>
             </a:fld>
@@ -2152,7 +2152,7 @@
     </p:spTree>
     <p:extLst>
       <p:ext uri="{BB962C8B-B14F-4D97-AF65-F5344CB8AC3E}">
-        <p14:creationId xmlns:p14="http://schemas.microsoft.com/office/powerpoint/2010/main" val="2664986885"/>
+        <p14:creationId xmlns:p14="http://schemas.microsoft.com/office/powerpoint/2010/main" val="246759538"/>
       </p:ext>
     </p:extLst>
   </p:cSld>
@@ -2184,7 +2184,7 @@
           <p:cNvPr id="2" name="Заголовок 1">
             <a:extLst>
               <a:ext uri="{FF2B5EF4-FFF2-40B4-BE49-F238E27FC236}">
-                <a16:creationId xmlns:a16="http://schemas.microsoft.com/office/drawing/2014/main" id="{053370E3-9FD0-BFE4-D63E-D1F4906B7A79}"/>
+                <a16:creationId xmlns:a16="http://schemas.microsoft.com/office/drawing/2014/main" id="{4149D75D-6BFB-998C-8949-B510339A6F4C}"/>
               </a:ext>
             </a:extLst>
           </p:cNvPr>
@@ -2221,7 +2221,7 @@
           <p:cNvPr id="3" name="Текст 2">
             <a:extLst>
               <a:ext uri="{FF2B5EF4-FFF2-40B4-BE49-F238E27FC236}">
-                <a16:creationId xmlns:a16="http://schemas.microsoft.com/office/drawing/2014/main" id="{9554FEC4-B019-C983-D078-3E7E8FC738AA}"/>
+                <a16:creationId xmlns:a16="http://schemas.microsoft.com/office/drawing/2014/main" id="{6288D62F-054C-3DA9-0092-965A8999167D}"/>
               </a:ext>
             </a:extLst>
           </p:cNvPr>
@@ -2346,7 +2346,7 @@
           <p:cNvPr id="4" name="Дата 3">
             <a:extLst>
               <a:ext uri="{FF2B5EF4-FFF2-40B4-BE49-F238E27FC236}">
-                <a16:creationId xmlns:a16="http://schemas.microsoft.com/office/drawing/2014/main" id="{CB169B1B-4125-6FC8-2E47-6F31ACC12A1F}"/>
+                <a16:creationId xmlns:a16="http://schemas.microsoft.com/office/drawing/2014/main" id="{80BC58B2-1E6F-2280-B22F-78F5856E99E7}"/>
               </a:ext>
             </a:extLst>
           </p:cNvPr>
@@ -2362,7 +2362,7 @@
           <a:bodyPr/>
           <a:lstStyle/>
           <a:p>
-            <a:fld id="{F8E9631C-2ACB-43F0-9F5F-E603512EFCD2}" type="datetimeFigureOut">
+            <a:fld id="{68FB7DD9-D72B-4689-B288-600E97991DA7}" type="datetimeFigureOut">
               <a:rPr lang="ru-RU" smtClean="0"/>
               <a:t>27.09.2026</a:t>
             </a:fld>
@@ -2375,7 +2375,7 @@
           <p:cNvPr id="5" name="Нижний колонтитул 4">
             <a:extLst>
               <a:ext uri="{FF2B5EF4-FFF2-40B4-BE49-F238E27FC236}">
-                <a16:creationId xmlns:a16="http://schemas.microsoft.com/office/drawing/2014/main" id="{450C1AF6-C999-BA62-0701-FC76D129EFAD}"/>
+                <a16:creationId xmlns:a16="http://schemas.microsoft.com/office/drawing/2014/main" id="{76895E72-0FEA-7825-44A0-E85A27D1F2EB}"/>
               </a:ext>
             </a:extLst>
           </p:cNvPr>
@@ -2400,7 +2400,7 @@
           <p:cNvPr id="6" name="Номер слайда 5">
             <a:extLst>
               <a:ext uri="{FF2B5EF4-FFF2-40B4-BE49-F238E27FC236}">
-                <a16:creationId xmlns:a16="http://schemas.microsoft.com/office/drawing/2014/main" id="{98D642FB-9B8A-9FE3-F1B6-E1DFF062E1D5}"/>
+                <a16:creationId xmlns:a16="http://schemas.microsoft.com/office/drawing/2014/main" id="{6EF12E0D-49BD-D220-8862-31B3BF8326AD}"/>
               </a:ext>
             </a:extLst>
           </p:cNvPr>
@@ -2416,7 +2416,7 @@
           <a:bodyPr/>
           <a:lstStyle/>
           <a:p>
-            <a:fld id="{729F168C-9C9F-4A36-BFB6-942532E77215}" type="slidenum">
+            <a:fld id="{39330517-A617-4B46-A59A-9B1D4AB81A72}" type="slidenum">
               <a:rPr lang="ru-RU" smtClean="0"/>
               <a:t>‹#›</a:t>
             </a:fld>
@@ -2427,7 +2427,7 @@
     </p:spTree>
     <p:extLst>
       <p:ext uri="{BB962C8B-B14F-4D97-AF65-F5344CB8AC3E}">
-        <p14:creationId xmlns:p14="http://schemas.microsoft.com/office/powerpoint/2010/main" val="644979464"/>
+        <p14:creationId xmlns:p14="http://schemas.microsoft.com/office/powerpoint/2010/main" val="3170452091"/>
       </p:ext>
     </p:extLst>
   </p:cSld>
@@ -2459,7 +2459,7 @@
           <p:cNvPr id="2" name="Заголовок 1">
             <a:extLst>
               <a:ext uri="{FF2B5EF4-FFF2-40B4-BE49-F238E27FC236}">
-                <a16:creationId xmlns:a16="http://schemas.microsoft.com/office/drawing/2014/main" id="{AC19AA62-0F0D-2E57-5FF3-978336C49276}"/>
+                <a16:creationId xmlns:a16="http://schemas.microsoft.com/office/drawing/2014/main" id="{3B21A20D-90AB-C109-9221-3FC6CFFEA917}"/>
               </a:ext>
             </a:extLst>
           </p:cNvPr>
@@ -2487,7 +2487,7 @@
           <p:cNvPr id="3" name="Объект 2">
             <a:extLst>
               <a:ext uri="{FF2B5EF4-FFF2-40B4-BE49-F238E27FC236}">
-                <a16:creationId xmlns:a16="http://schemas.microsoft.com/office/drawing/2014/main" id="{75011595-B777-6BE8-F83F-331D8D983504}"/>
+                <a16:creationId xmlns:a16="http://schemas.microsoft.com/office/drawing/2014/main" id="{18727A26-8001-8928-8E25-234BF5A37C56}"/>
               </a:ext>
             </a:extLst>
           </p:cNvPr>
@@ -2549,7 +2549,7 @@
           <p:cNvPr id="4" name="Объект 3">
             <a:extLst>
               <a:ext uri="{FF2B5EF4-FFF2-40B4-BE49-F238E27FC236}">
-                <a16:creationId xmlns:a16="http://schemas.microsoft.com/office/drawing/2014/main" id="{1EB7572C-2164-5C85-1C4C-9D22A4F07604}"/>
+                <a16:creationId xmlns:a16="http://schemas.microsoft.com/office/drawing/2014/main" id="{A651224F-C8E8-711A-F36E-F105018DFAEF}"/>
               </a:ext>
             </a:extLst>
           </p:cNvPr>
@@ -2611,7 +2611,7 @@
           <p:cNvPr id="5" name="Дата 4">
             <a:extLst>
               <a:ext uri="{FF2B5EF4-FFF2-40B4-BE49-F238E27FC236}">
-                <a16:creationId xmlns:a16="http://schemas.microsoft.com/office/drawing/2014/main" id="{30F7911F-4548-BDE7-2C9D-904E2C45453D}"/>
+                <a16:creationId xmlns:a16="http://schemas.microsoft.com/office/drawing/2014/main" id="{D875BE67-7923-651B-61B5-FD80C56DFE5A}"/>
               </a:ext>
             </a:extLst>
           </p:cNvPr>
@@ -2627,7 +2627,7 @@
           <a:bodyPr/>
           <a:lstStyle/>
           <a:p>
-            <a:fld id="{F8E9631C-2ACB-43F0-9F5F-E603512EFCD2}" type="datetimeFigureOut">
+            <a:fld id="{68FB7DD9-D72B-4689-B288-600E97991DA7}" type="datetimeFigureOut">
               <a:rPr lang="ru-RU" smtClean="0"/>
               <a:t>27.09.2026</a:t>
             </a:fld>
@@ -2640,7 +2640,7 @@
           <p:cNvPr id="6" name="Нижний колонтитул 5">
             <a:extLst>
               <a:ext uri="{FF2B5EF4-FFF2-40B4-BE49-F238E27FC236}">
-                <a16:creationId xmlns:a16="http://schemas.microsoft.com/office/drawing/2014/main" id="{A881A5EF-9A5D-0239-8049-97A430091537}"/>
+                <a16:creationId xmlns:a16="http://schemas.microsoft.com/office/drawing/2014/main" id="{6BB7BCAB-5942-FA33-B90F-BA5538DFE029}"/>
               </a:ext>
             </a:extLst>
           </p:cNvPr>
@@ -2665,7 +2665,7 @@
           <p:cNvPr id="7" name="Номер слайда 6">
             <a:extLst>
               <a:ext uri="{FF2B5EF4-FFF2-40B4-BE49-F238E27FC236}">
-                <a16:creationId xmlns:a16="http://schemas.microsoft.com/office/drawing/2014/main" id="{7F3A5824-7301-B61A-C109-46146A6C9E6E}"/>
+                <a16:creationId xmlns:a16="http://schemas.microsoft.com/office/drawing/2014/main" id="{A56475E6-4303-746D-DB12-2B049D4A3F7A}"/>
               </a:ext>
             </a:extLst>
           </p:cNvPr>
@@ -2681,7 +2681,7 @@
           <a:bodyPr/>
           <a:lstStyle/>
           <a:p>
-            <a:fld id="{729F168C-9C9F-4A36-BFB6-942532E77215}" type="slidenum">
+            <a:fld id="{39330517-A617-4B46-A59A-9B1D4AB81A72}" type="slidenum">
               <a:rPr lang="ru-RU" smtClean="0"/>
               <a:t>‹#›</a:t>
             </a:fld>
@@ -2692,7 +2692,7 @@
     </p:spTree>
     <p:extLst>
       <p:ext uri="{BB962C8B-B14F-4D97-AF65-F5344CB8AC3E}">
-        <p14:creationId xmlns:p14="http://schemas.microsoft.com/office/powerpoint/2010/main" val="2251017267"/>
+        <p14:creationId xmlns:p14="http://schemas.microsoft.com/office/powerpoint/2010/main" val="3768202161"/>
       </p:ext>
     </p:extLst>
   </p:cSld>
@@ -2724,7 +2724,7 @@
           <p:cNvPr id="2" name="Заголовок 1">
             <a:extLst>
               <a:ext uri="{FF2B5EF4-FFF2-40B4-BE49-F238E27FC236}">
-                <a16:creationId xmlns:a16="http://schemas.microsoft.com/office/drawing/2014/main" id="{C8AB0DA1-16B8-5D07-0079-A1212BE9A927}"/>
+                <a16:creationId xmlns:a16="http://schemas.microsoft.com/office/drawing/2014/main" id="{126F8894-2622-C2A6-C970-35A34243DBC5}"/>
               </a:ext>
             </a:extLst>
           </p:cNvPr>
@@ -2757,7 +2757,7 @@
           <p:cNvPr id="3" name="Текст 2">
             <a:extLst>
               <a:ext uri="{FF2B5EF4-FFF2-40B4-BE49-F238E27FC236}">
-                <a16:creationId xmlns:a16="http://schemas.microsoft.com/office/drawing/2014/main" id="{82A8236D-B80C-1EF3-2117-6D11B64C8846}"/>
+                <a16:creationId xmlns:a16="http://schemas.microsoft.com/office/drawing/2014/main" id="{956CDF27-C46D-0DF5-F691-D6752FDDA08F}"/>
               </a:ext>
             </a:extLst>
           </p:cNvPr>
@@ -2828,7 +2828,7 @@
           <p:cNvPr id="4" name="Объект 3">
             <a:extLst>
               <a:ext uri="{FF2B5EF4-FFF2-40B4-BE49-F238E27FC236}">
-                <a16:creationId xmlns:a16="http://schemas.microsoft.com/office/drawing/2014/main" id="{36E2F934-C0A4-8099-9D3E-B83AF7BA5A7A}"/>
+                <a16:creationId xmlns:a16="http://schemas.microsoft.com/office/drawing/2014/main" id="{5D7FD7A1-0710-E3E0-467E-9B316DFFD323}"/>
               </a:ext>
             </a:extLst>
           </p:cNvPr>
@@ -2890,7 +2890,7 @@
           <p:cNvPr id="5" name="Текст 4">
             <a:extLst>
               <a:ext uri="{FF2B5EF4-FFF2-40B4-BE49-F238E27FC236}">
-                <a16:creationId xmlns:a16="http://schemas.microsoft.com/office/drawing/2014/main" id="{7B11DB60-8930-B8EA-7167-99434D500732}"/>
+                <a16:creationId xmlns:a16="http://schemas.microsoft.com/office/drawing/2014/main" id="{C68ECE2A-1CDE-2B13-D724-89F534403A8B}"/>
               </a:ext>
             </a:extLst>
           </p:cNvPr>
@@ -2961,7 +2961,7 @@
           <p:cNvPr id="6" name="Объект 5">
             <a:extLst>
               <a:ext uri="{FF2B5EF4-FFF2-40B4-BE49-F238E27FC236}">
-                <a16:creationId xmlns:a16="http://schemas.microsoft.com/office/drawing/2014/main" id="{2F3BB1E9-3EAB-B180-2A5D-4CA79D054B5D}"/>
+                <a16:creationId xmlns:a16="http://schemas.microsoft.com/office/drawing/2014/main" id="{3B4155CA-809E-EE51-56CD-065F356BE9CE}"/>
               </a:ext>
             </a:extLst>
           </p:cNvPr>
@@ -3023,7 +3023,7 @@
           <p:cNvPr id="7" name="Дата 6">
             <a:extLst>
               <a:ext uri="{FF2B5EF4-FFF2-40B4-BE49-F238E27FC236}">
-                <a16:creationId xmlns:a16="http://schemas.microsoft.com/office/drawing/2014/main" id="{2F044A16-1CA3-0549-3F32-FDF6B3AF4697}"/>
+                <a16:creationId xmlns:a16="http://schemas.microsoft.com/office/drawing/2014/main" id="{DA139707-E6B7-E5E4-D225-5E5771BAC15B}"/>
               </a:ext>
             </a:extLst>
           </p:cNvPr>
@@ -3039,7 +3039,7 @@
           <a:bodyPr/>
           <a:lstStyle/>
           <a:p>
-            <a:fld id="{F8E9631C-2ACB-43F0-9F5F-E603512EFCD2}" type="datetimeFigureOut">
+            <a:fld id="{68FB7DD9-D72B-4689-B288-600E97991DA7}" type="datetimeFigureOut">
               <a:rPr lang="ru-RU" smtClean="0"/>
               <a:t>27.09.2026</a:t>
             </a:fld>
@@ -3052,7 +3052,7 @@
           <p:cNvPr id="8" name="Нижний колонтитул 7">
             <a:extLst>
               <a:ext uri="{FF2B5EF4-FFF2-40B4-BE49-F238E27FC236}">
-                <a16:creationId xmlns:a16="http://schemas.microsoft.com/office/drawing/2014/main" id="{ADDBDEEC-6D2B-975B-1363-48B453D5E01E}"/>
+                <a16:creationId xmlns:a16="http://schemas.microsoft.com/office/drawing/2014/main" id="{B994C9FD-9D63-8030-FD6F-67FDBECE7C9D}"/>
               </a:ext>
             </a:extLst>
           </p:cNvPr>
@@ -3077,7 +3077,7 @@
           <p:cNvPr id="9" name="Номер слайда 8">
             <a:extLst>
               <a:ext uri="{FF2B5EF4-FFF2-40B4-BE49-F238E27FC236}">
-                <a16:creationId xmlns:a16="http://schemas.microsoft.com/office/drawing/2014/main" id="{B409EAFD-8CAB-B2E9-AF71-405D06176866}"/>
+                <a16:creationId xmlns:a16="http://schemas.microsoft.com/office/drawing/2014/main" id="{FD60E835-89A6-E1D3-DCAA-4F30F57208FD}"/>
               </a:ext>
             </a:extLst>
           </p:cNvPr>
@@ -3093,7 +3093,7 @@
           <a:bodyPr/>
           <a:lstStyle/>
           <a:p>
-            <a:fld id="{729F168C-9C9F-4A36-BFB6-942532E77215}" type="slidenum">
+            <a:fld id="{39330517-A617-4B46-A59A-9B1D4AB81A72}" type="slidenum">
               <a:rPr lang="ru-RU" smtClean="0"/>
               <a:t>‹#›</a:t>
             </a:fld>
@@ -3104,7 +3104,7 @@
     </p:spTree>
     <p:extLst>
       <p:ext uri="{BB962C8B-B14F-4D97-AF65-F5344CB8AC3E}">
-        <p14:creationId xmlns:p14="http://schemas.microsoft.com/office/powerpoint/2010/main" val="597194140"/>
+        <p14:creationId xmlns:p14="http://schemas.microsoft.com/office/powerpoint/2010/main" val="2073053450"/>
       </p:ext>
     </p:extLst>
   </p:cSld>
@@ -3136,7 +3136,7 @@
           <p:cNvPr id="2" name="Заголовок 1">
             <a:extLst>
               <a:ext uri="{FF2B5EF4-FFF2-40B4-BE49-F238E27FC236}">
-                <a16:creationId xmlns:a16="http://schemas.microsoft.com/office/drawing/2014/main" id="{3965DB80-82BA-65E0-0CA8-2D5559AA04B2}"/>
+                <a16:creationId xmlns:a16="http://schemas.microsoft.com/office/drawing/2014/main" id="{BB0CC021-2D70-8D8A-147A-4B54798D60F3}"/>
               </a:ext>
             </a:extLst>
           </p:cNvPr>
@@ -3164,7 +3164,7 @@
           <p:cNvPr id="3" name="Дата 2">
             <a:extLst>
               <a:ext uri="{FF2B5EF4-FFF2-40B4-BE49-F238E27FC236}">
-                <a16:creationId xmlns:a16="http://schemas.microsoft.com/office/drawing/2014/main" id="{29F6251C-DA11-F4D8-A855-08F7B36A49E4}"/>
+                <a16:creationId xmlns:a16="http://schemas.microsoft.com/office/drawing/2014/main" id="{89308C51-C802-72AC-38CA-23EA6F78A4EF}"/>
               </a:ext>
             </a:extLst>
           </p:cNvPr>
@@ -3180,7 +3180,7 @@
           <a:bodyPr/>
           <a:lstStyle/>
           <a:p>
-            <a:fld id="{F8E9631C-2ACB-43F0-9F5F-E603512EFCD2}" type="datetimeFigureOut">
+            <a:fld id="{68FB7DD9-D72B-4689-B288-600E97991DA7}" type="datetimeFigureOut">
               <a:rPr lang="ru-RU" smtClean="0"/>
               <a:t>27.09.2026</a:t>
             </a:fld>
@@ -3193,7 +3193,7 @@
           <p:cNvPr id="4" name="Нижний колонтитул 3">
             <a:extLst>
               <a:ext uri="{FF2B5EF4-FFF2-40B4-BE49-F238E27FC236}">
-                <a16:creationId xmlns:a16="http://schemas.microsoft.com/office/drawing/2014/main" id="{99A7F1BB-F1D6-195F-1E5A-4FC8540EEFFB}"/>
+                <a16:creationId xmlns:a16="http://schemas.microsoft.com/office/drawing/2014/main" id="{F9CB580C-5047-F3AB-F323-9ABB6FFD6B06}"/>
               </a:ext>
             </a:extLst>
           </p:cNvPr>
@@ -3218,7 +3218,7 @@
           <p:cNvPr id="5" name="Номер слайда 4">
             <a:extLst>
               <a:ext uri="{FF2B5EF4-FFF2-40B4-BE49-F238E27FC236}">
-                <a16:creationId xmlns:a16="http://schemas.microsoft.com/office/drawing/2014/main" id="{C332D122-B08C-7448-23B2-B81A8E711917}"/>
+                <a16:creationId xmlns:a16="http://schemas.microsoft.com/office/drawing/2014/main" id="{5BAE1C0E-7A77-0CA9-6A6E-B1E64CDC82EA}"/>
               </a:ext>
             </a:extLst>
           </p:cNvPr>
@@ -3234,7 +3234,7 @@
           <a:bodyPr/>
           <a:lstStyle/>
           <a:p>
-            <a:fld id="{729F168C-9C9F-4A36-BFB6-942532E77215}" type="slidenum">
+            <a:fld id="{39330517-A617-4B46-A59A-9B1D4AB81A72}" type="slidenum">
               <a:rPr lang="ru-RU" smtClean="0"/>
               <a:t>‹#›</a:t>
             </a:fld>
@@ -3245,7 +3245,7 @@
     </p:spTree>
     <p:extLst>
       <p:ext uri="{BB962C8B-B14F-4D97-AF65-F5344CB8AC3E}">
-        <p14:creationId xmlns:p14="http://schemas.microsoft.com/office/powerpoint/2010/main" val="1533109019"/>
+        <p14:creationId xmlns:p14="http://schemas.microsoft.com/office/powerpoint/2010/main" val="2033178998"/>
       </p:ext>
     </p:extLst>
   </p:cSld>
@@ -3277,7 +3277,7 @@
           <p:cNvPr id="2" name="Дата 1">
             <a:extLst>
               <a:ext uri="{FF2B5EF4-FFF2-40B4-BE49-F238E27FC236}">
-                <a16:creationId xmlns:a16="http://schemas.microsoft.com/office/drawing/2014/main" id="{3C4AEED4-9DEA-62DC-725B-F22CBDCDAB56}"/>
+                <a16:creationId xmlns:a16="http://schemas.microsoft.com/office/drawing/2014/main" id="{FFBB8C8E-48F5-C44E-0BB7-182E1D7F0336}"/>
               </a:ext>
             </a:extLst>
           </p:cNvPr>
@@ -3293,7 +3293,7 @@
           <a:bodyPr/>
           <a:lstStyle/>
           <a:p>
-            <a:fld id="{F8E9631C-2ACB-43F0-9F5F-E603512EFCD2}" type="datetimeFigureOut">
+            <a:fld id="{68FB7DD9-D72B-4689-B288-600E97991DA7}" type="datetimeFigureOut">
               <a:rPr lang="ru-RU" smtClean="0"/>
               <a:t>27.09.2026</a:t>
             </a:fld>
@@ -3306,7 +3306,7 @@
           <p:cNvPr id="3" name="Нижний колонтитул 2">
             <a:extLst>
               <a:ext uri="{FF2B5EF4-FFF2-40B4-BE49-F238E27FC236}">
-                <a16:creationId xmlns:a16="http://schemas.microsoft.com/office/drawing/2014/main" id="{C2A13DEF-7F45-69A4-4C16-910CF75F8635}"/>
+                <a16:creationId xmlns:a16="http://schemas.microsoft.com/office/drawing/2014/main" id="{A26B0730-F7AF-C3C2-7578-F3B9041EB043}"/>
               </a:ext>
             </a:extLst>
           </p:cNvPr>
@@ -3331,7 +3331,7 @@
           <p:cNvPr id="4" name="Номер слайда 3">
             <a:extLst>
               <a:ext uri="{FF2B5EF4-FFF2-40B4-BE49-F238E27FC236}">
-                <a16:creationId xmlns:a16="http://schemas.microsoft.com/office/drawing/2014/main" id="{3FB12D71-E599-B034-CFA8-A1B197BA0D29}"/>
+                <a16:creationId xmlns:a16="http://schemas.microsoft.com/office/drawing/2014/main" id="{BC87E48B-EF06-2643-CDCC-B283F4C9AE95}"/>
               </a:ext>
             </a:extLst>
           </p:cNvPr>
@@ -3347,7 +3347,7 @@
           <a:bodyPr/>
           <a:lstStyle/>
           <a:p>
-            <a:fld id="{729F168C-9C9F-4A36-BFB6-942532E77215}" type="slidenum">
+            <a:fld id="{39330517-A617-4B46-A59A-9B1D4AB81A72}" type="slidenum">
               <a:rPr lang="ru-RU" smtClean="0"/>
               <a:t>‹#›</a:t>
             </a:fld>
@@ -3358,7 +3358,7 @@
     </p:spTree>
     <p:extLst>
       <p:ext uri="{BB962C8B-B14F-4D97-AF65-F5344CB8AC3E}">
-        <p14:creationId xmlns:p14="http://schemas.microsoft.com/office/powerpoint/2010/main" val="83794509"/>
+        <p14:creationId xmlns:p14="http://schemas.microsoft.com/office/powerpoint/2010/main" val="3424432479"/>
       </p:ext>
     </p:extLst>
   </p:cSld>
@@ -3390,7 +3390,7 @@
           <p:cNvPr id="2" name="Заголовок 1">
             <a:extLst>
               <a:ext uri="{FF2B5EF4-FFF2-40B4-BE49-F238E27FC236}">
-                <a16:creationId xmlns:a16="http://schemas.microsoft.com/office/drawing/2014/main" id="{69BD5F94-F467-6F02-CABD-A14B3BCFB551}"/>
+                <a16:creationId xmlns:a16="http://schemas.microsoft.com/office/drawing/2014/main" id="{17E92675-962B-85C4-06EF-D47CD5A9AA97}"/>
               </a:ext>
             </a:extLst>
           </p:cNvPr>
@@ -3427,7 +3427,7 @@
           <p:cNvPr id="3" name="Объект 2">
             <a:extLst>
               <a:ext uri="{FF2B5EF4-FFF2-40B4-BE49-F238E27FC236}">
-                <a16:creationId xmlns:a16="http://schemas.microsoft.com/office/drawing/2014/main" id="{2B023232-6593-E691-9127-050B8D0B89E8}"/>
+                <a16:creationId xmlns:a16="http://schemas.microsoft.com/office/drawing/2014/main" id="{77C047B1-D5F0-8FF5-4534-1EABB2AD0F64}"/>
               </a:ext>
             </a:extLst>
           </p:cNvPr>
@@ -3517,7 +3517,7 @@
           <p:cNvPr id="4" name="Текст 3">
             <a:extLst>
               <a:ext uri="{FF2B5EF4-FFF2-40B4-BE49-F238E27FC236}">
-                <a16:creationId xmlns:a16="http://schemas.microsoft.com/office/drawing/2014/main" id="{E8CC5EC5-5DFD-3843-410B-73F6B39C5AF2}"/>
+                <a16:creationId xmlns:a16="http://schemas.microsoft.com/office/drawing/2014/main" id="{D2476F91-6619-3FF5-83C5-57909359CBB3}"/>
               </a:ext>
             </a:extLst>
           </p:cNvPr>
@@ -3588,7 +3588,7 @@
           <p:cNvPr id="5" name="Дата 4">
             <a:extLst>
               <a:ext uri="{FF2B5EF4-FFF2-40B4-BE49-F238E27FC236}">
-                <a16:creationId xmlns:a16="http://schemas.microsoft.com/office/drawing/2014/main" id="{FC813C79-2A6B-2568-3E6C-78EF7C50A999}"/>
+                <a16:creationId xmlns:a16="http://schemas.microsoft.com/office/drawing/2014/main" id="{925D8D94-2D95-68EB-E7A3-EDE58EBE0E17}"/>
               </a:ext>
             </a:extLst>
           </p:cNvPr>
@@ -3604,7 +3604,7 @@
           <a:bodyPr/>
           <a:lstStyle/>
           <a:p>
-            <a:fld id="{F8E9631C-2ACB-43F0-9F5F-E603512EFCD2}" type="datetimeFigureOut">
+            <a:fld id="{68FB7DD9-D72B-4689-B288-600E97991DA7}" type="datetimeFigureOut">
               <a:rPr lang="ru-RU" smtClean="0"/>
               <a:t>27.09.2026</a:t>
             </a:fld>
@@ -3617,7 +3617,7 @@
           <p:cNvPr id="6" name="Нижний колонтитул 5">
             <a:extLst>
               <a:ext uri="{FF2B5EF4-FFF2-40B4-BE49-F238E27FC236}">
-                <a16:creationId xmlns:a16="http://schemas.microsoft.com/office/drawing/2014/main" id="{A9907BCC-E8FF-06CA-CB0D-928C6404ADAF}"/>
+                <a16:creationId xmlns:a16="http://schemas.microsoft.com/office/drawing/2014/main" id="{06EA314F-8370-DA54-023F-774A46802200}"/>
               </a:ext>
             </a:extLst>
           </p:cNvPr>
@@ -3642,7 +3642,7 @@
           <p:cNvPr id="7" name="Номер слайда 6">
             <a:extLst>
               <a:ext uri="{FF2B5EF4-FFF2-40B4-BE49-F238E27FC236}">
-                <a16:creationId xmlns:a16="http://schemas.microsoft.com/office/drawing/2014/main" id="{03E2C6BE-C52B-9AD4-A17C-48047487249E}"/>
+                <a16:creationId xmlns:a16="http://schemas.microsoft.com/office/drawing/2014/main" id="{E84FB7DE-FF3E-ADE3-9B26-F25C635D911C}"/>
               </a:ext>
             </a:extLst>
           </p:cNvPr>
@@ -3658,7 +3658,7 @@
           <a:bodyPr/>
           <a:lstStyle/>
           <a:p>
-            <a:fld id="{729F168C-9C9F-4A36-BFB6-942532E77215}" type="slidenum">
+            <a:fld id="{39330517-A617-4B46-A59A-9B1D4AB81A72}" type="slidenum">
               <a:rPr lang="ru-RU" smtClean="0"/>
               <a:t>‹#›</a:t>
             </a:fld>
@@ -3669,7 +3669,7 @@
     </p:spTree>
     <p:extLst>
       <p:ext uri="{BB962C8B-B14F-4D97-AF65-F5344CB8AC3E}">
-        <p14:creationId xmlns:p14="http://schemas.microsoft.com/office/powerpoint/2010/main" val="971621823"/>
+        <p14:creationId xmlns:p14="http://schemas.microsoft.com/office/powerpoint/2010/main" val="959616419"/>
       </p:ext>
     </p:extLst>
   </p:cSld>
@@ -3701,7 +3701,7 @@
           <p:cNvPr id="2" name="Заголовок 1">
             <a:extLst>
               <a:ext uri="{FF2B5EF4-FFF2-40B4-BE49-F238E27FC236}">
-                <a16:creationId xmlns:a16="http://schemas.microsoft.com/office/drawing/2014/main" id="{BA4789CB-37F7-DD91-2646-3DE8D34EB18A}"/>
+                <a16:creationId xmlns:a16="http://schemas.microsoft.com/office/drawing/2014/main" id="{7E698551-8CEB-9AA7-0DA7-77B3BC55A6C0}"/>
               </a:ext>
             </a:extLst>
           </p:cNvPr>
@@ -3738,7 +3738,7 @@
           <p:cNvPr id="3" name="Рисунок 2">
             <a:extLst>
               <a:ext uri="{FF2B5EF4-FFF2-40B4-BE49-F238E27FC236}">
-                <a16:creationId xmlns:a16="http://schemas.microsoft.com/office/drawing/2014/main" id="{5173F2BA-20EE-21F1-F04D-6A50C463CBFC}"/>
+                <a16:creationId xmlns:a16="http://schemas.microsoft.com/office/drawing/2014/main" id="{8C688411-5593-0DB0-9B54-E0B937E358F1}"/>
               </a:ext>
             </a:extLst>
           </p:cNvPr>
@@ -3805,7 +3805,7 @@
           <p:cNvPr id="4" name="Текст 3">
             <a:extLst>
               <a:ext uri="{FF2B5EF4-FFF2-40B4-BE49-F238E27FC236}">
-                <a16:creationId xmlns:a16="http://schemas.microsoft.com/office/drawing/2014/main" id="{B6A40C7C-55C7-3D7C-DB9C-0E6CBD9A2B01}"/>
+                <a16:creationId xmlns:a16="http://schemas.microsoft.com/office/drawing/2014/main" id="{7AB39250-6B7C-9C4D-2D44-FBF2CE780074}"/>
               </a:ext>
             </a:extLst>
           </p:cNvPr>
@@ -3876,7 +3876,7 @@
           <p:cNvPr id="5" name="Дата 4">
             <a:extLst>
               <a:ext uri="{FF2B5EF4-FFF2-40B4-BE49-F238E27FC236}">
-                <a16:creationId xmlns:a16="http://schemas.microsoft.com/office/drawing/2014/main" id="{770FED4C-1579-144B-E122-A5A9DAC65C7F}"/>
+                <a16:creationId xmlns:a16="http://schemas.microsoft.com/office/drawing/2014/main" id="{1DB06EAD-F63A-3B0C-931F-BC21296DF24E}"/>
               </a:ext>
             </a:extLst>
           </p:cNvPr>
@@ -3892,7 +3892,7 @@
           <a:bodyPr/>
           <a:lstStyle/>
           <a:p>
-            <a:fld id="{F8E9631C-2ACB-43F0-9F5F-E603512EFCD2}" type="datetimeFigureOut">
+            <a:fld id="{68FB7DD9-D72B-4689-B288-600E97991DA7}" type="datetimeFigureOut">
               <a:rPr lang="ru-RU" smtClean="0"/>
               <a:t>27.09.2026</a:t>
             </a:fld>
@@ -3905,7 +3905,7 @@
           <p:cNvPr id="6" name="Нижний колонтитул 5">
             <a:extLst>
               <a:ext uri="{FF2B5EF4-FFF2-40B4-BE49-F238E27FC236}">
-                <a16:creationId xmlns:a16="http://schemas.microsoft.com/office/drawing/2014/main" id="{5A07109C-7407-C1B8-B482-B87AACAAB5D6}"/>
+                <a16:creationId xmlns:a16="http://schemas.microsoft.com/office/drawing/2014/main" id="{47600C3A-66B8-0CC4-69AE-C7DD60D6F461}"/>
               </a:ext>
             </a:extLst>
           </p:cNvPr>
@@ -3930,7 +3930,7 @@
           <p:cNvPr id="7" name="Номер слайда 6">
             <a:extLst>
               <a:ext uri="{FF2B5EF4-FFF2-40B4-BE49-F238E27FC236}">
-                <a16:creationId xmlns:a16="http://schemas.microsoft.com/office/drawing/2014/main" id="{1371CA5A-E5B3-E2C9-CDA2-73A0E1AC05C5}"/>
+                <a16:creationId xmlns:a16="http://schemas.microsoft.com/office/drawing/2014/main" id="{75BF8691-712F-DE28-B3B0-C1B60548921F}"/>
               </a:ext>
             </a:extLst>
           </p:cNvPr>
@@ -3946,7 +3946,7 @@
           <a:bodyPr/>
           <a:lstStyle/>
           <a:p>
-            <a:fld id="{729F168C-9C9F-4A36-BFB6-942532E77215}" type="slidenum">
+            <a:fld id="{39330517-A617-4B46-A59A-9B1D4AB81A72}" type="slidenum">
               <a:rPr lang="ru-RU" smtClean="0"/>
               <a:t>‹#›</a:t>
             </a:fld>
@@ -3957,7 +3957,7 @@
     </p:spTree>
     <p:extLst>
       <p:ext uri="{BB962C8B-B14F-4D97-AF65-F5344CB8AC3E}">
-        <p14:creationId xmlns:p14="http://schemas.microsoft.com/office/powerpoint/2010/main" val="2662334396"/>
+        <p14:creationId xmlns:p14="http://schemas.microsoft.com/office/powerpoint/2010/main" val="1884154142"/>
       </p:ext>
     </p:extLst>
   </p:cSld>
@@ -3994,7 +3994,7 @@
           <p:cNvPr id="2" name="Заголовок 1">
             <a:extLst>
               <a:ext uri="{FF2B5EF4-FFF2-40B4-BE49-F238E27FC236}">
-                <a16:creationId xmlns:a16="http://schemas.microsoft.com/office/drawing/2014/main" id="{7FD20EB6-E57E-6D4B-15AC-D8F82818FC78}"/>
+                <a16:creationId xmlns:a16="http://schemas.microsoft.com/office/drawing/2014/main" id="{7C7BA4A8-DA76-60D3-C8C9-EC09CCC5EF9E}"/>
               </a:ext>
             </a:extLst>
           </p:cNvPr>
@@ -4032,7 +4032,7 @@
           <p:cNvPr id="3" name="Текст 2">
             <a:extLst>
               <a:ext uri="{FF2B5EF4-FFF2-40B4-BE49-F238E27FC236}">
-                <a16:creationId xmlns:a16="http://schemas.microsoft.com/office/drawing/2014/main" id="{DB02D1C7-74E2-1EF5-CF13-96693F89606D}"/>
+                <a16:creationId xmlns:a16="http://schemas.microsoft.com/office/drawing/2014/main" id="{43B95F5E-F8FD-550F-7641-823A2F23098B}"/>
               </a:ext>
             </a:extLst>
           </p:cNvPr>
@@ -4099,7 +4099,7 @@
           <p:cNvPr id="4" name="Дата 3">
             <a:extLst>
               <a:ext uri="{FF2B5EF4-FFF2-40B4-BE49-F238E27FC236}">
-                <a16:creationId xmlns:a16="http://schemas.microsoft.com/office/drawing/2014/main" id="{AE2CF58C-40C4-3E58-EB61-73D8ED009CF3}"/>
+                <a16:creationId xmlns:a16="http://schemas.microsoft.com/office/drawing/2014/main" id="{A1C36292-25F5-ABAA-DADB-A6D19C0EE396}"/>
               </a:ext>
             </a:extLst>
           </p:cNvPr>
@@ -4133,7 +4133,7 @@
             </a:lvl1pPr>
           </a:lstStyle>
           <a:p>
-            <a:fld id="{F8E9631C-2ACB-43F0-9F5F-E603512EFCD2}" type="datetimeFigureOut">
+            <a:fld id="{68FB7DD9-D72B-4689-B288-600E97991DA7}" type="datetimeFigureOut">
               <a:rPr lang="ru-RU" smtClean="0"/>
               <a:t>27.09.2026</a:t>
             </a:fld>
@@ -4146,7 +4146,7 @@
           <p:cNvPr id="5" name="Нижний колонтитул 4">
             <a:extLst>
               <a:ext uri="{FF2B5EF4-FFF2-40B4-BE49-F238E27FC236}">
-                <a16:creationId xmlns:a16="http://schemas.microsoft.com/office/drawing/2014/main" id="{09F8DB9B-EC24-5932-A744-3F9149BC19D5}"/>
+                <a16:creationId xmlns:a16="http://schemas.microsoft.com/office/drawing/2014/main" id="{67EC2475-60B5-3E1C-A9E8-A388885E57DD}"/>
               </a:ext>
             </a:extLst>
           </p:cNvPr>
@@ -4189,7 +4189,7 @@
           <p:cNvPr id="6" name="Номер слайда 5">
             <a:extLst>
               <a:ext uri="{FF2B5EF4-FFF2-40B4-BE49-F238E27FC236}">
-                <a16:creationId xmlns:a16="http://schemas.microsoft.com/office/drawing/2014/main" id="{29793F12-DE3B-B566-E9DC-2B9EA4898C2E}"/>
+                <a16:creationId xmlns:a16="http://schemas.microsoft.com/office/drawing/2014/main" id="{7B983CB5-1970-0D2C-D391-7DE08CBC4CAE}"/>
               </a:ext>
             </a:extLst>
           </p:cNvPr>
@@ -4223,7 +4223,7 @@
             </a:lvl1pPr>
           </a:lstStyle>
           <a:p>
-            <a:fld id="{729F168C-9C9F-4A36-BFB6-942532E77215}" type="slidenum">
+            <a:fld id="{39330517-A617-4B46-A59A-9B1D4AB81A72}" type="slidenum">
               <a:rPr lang="ru-RU" smtClean="0"/>
               <a:t>‹#›</a:t>
             </a:fld>
@@ -4234,7 +4234,7 @@
     </p:spTree>
     <p:extLst>
       <p:ext uri="{BB962C8B-B14F-4D97-AF65-F5344CB8AC3E}">
-        <p14:creationId xmlns:p14="http://schemas.microsoft.com/office/powerpoint/2010/main" val="2233764153"/>
+        <p14:creationId xmlns:p14="http://schemas.microsoft.com/office/powerpoint/2010/main" val="1028441229"/>
       </p:ext>
     </p:extLst>
   </p:cSld>
@@ -4565,7 +4565,7 @@
           <p:cNvPr id="2" name="TextBox 1">
             <a:extLst>
               <a:ext uri="{FF2B5EF4-FFF2-40B4-BE49-F238E27FC236}">
-                <a16:creationId xmlns:a16="http://schemas.microsoft.com/office/drawing/2014/main" id="{11389B13-A21F-58BD-0235-C61A79A20F38}"/>
+                <a16:creationId xmlns:a16="http://schemas.microsoft.com/office/drawing/2014/main" id="{A3C112B2-1DDF-D2CF-23AB-E39176CDBDE4}"/>
               </a:ext>
             </a:extLst>
           </p:cNvPr>
@@ -4605,7 +4605,7 @@
           <p:cNvPr id="3" name="TextBox 2">
             <a:extLst>
               <a:ext uri="{FF2B5EF4-FFF2-40B4-BE49-F238E27FC236}">
-                <a16:creationId xmlns:a16="http://schemas.microsoft.com/office/drawing/2014/main" id="{E5842E71-EFCC-89D7-1685-910D5480642A}"/>
+                <a16:creationId xmlns:a16="http://schemas.microsoft.com/office/drawing/2014/main" id="{AFBDEE0F-103B-EE37-BA36-5A4155E588DD}"/>
               </a:ext>
             </a:extLst>
           </p:cNvPr>
@@ -4645,7 +4645,7 @@
           <p:cNvPr id="4" name="TextBox 3">
             <a:extLst>
               <a:ext uri="{FF2B5EF4-FFF2-40B4-BE49-F238E27FC236}">
-                <a16:creationId xmlns:a16="http://schemas.microsoft.com/office/drawing/2014/main" id="{5740FB2D-EA6E-371D-F2B1-4D8D0ADFD83D}"/>
+                <a16:creationId xmlns:a16="http://schemas.microsoft.com/office/drawing/2014/main" id="{EF282C4F-32C4-AA02-DA7F-CD586A70A084}"/>
               </a:ext>
             </a:extLst>
           </p:cNvPr>
@@ -4685,7 +4685,7 @@
           <p:cNvPr id="5" name="TextBox 4">
             <a:extLst>
               <a:ext uri="{FF2B5EF4-FFF2-40B4-BE49-F238E27FC236}">
-                <a16:creationId xmlns:a16="http://schemas.microsoft.com/office/drawing/2014/main" id="{BEEED99F-FA7B-4933-B6C7-0DBDA009E3AF}"/>
+                <a16:creationId xmlns:a16="http://schemas.microsoft.com/office/drawing/2014/main" id="{EA96E4E4-C165-7C36-CB47-77FD5B5A7A3D}"/>
               </a:ext>
             </a:extLst>
           </p:cNvPr>
@@ -4725,7 +4725,7 @@
           <p:cNvPr id="6" name="Овал 5">
             <a:extLst>
               <a:ext uri="{FF2B5EF4-FFF2-40B4-BE49-F238E27FC236}">
-                <a16:creationId xmlns:a16="http://schemas.microsoft.com/office/drawing/2014/main" id="{98D1A766-A8A1-8644-66DB-2026C4C01D1A}"/>
+                <a16:creationId xmlns:a16="http://schemas.microsoft.com/office/drawing/2014/main" id="{F8658E36-6360-BD1F-8998-F4CD1D0AB0D6}"/>
               </a:ext>
             </a:extLst>
           </p:cNvPr>
@@ -4789,7 +4789,7 @@
           <p:cNvPr id="7" name="Равнобедренный треугольник 6">
             <a:extLst>
               <a:ext uri="{FF2B5EF4-FFF2-40B4-BE49-F238E27FC236}">
-                <a16:creationId xmlns:a16="http://schemas.microsoft.com/office/drawing/2014/main" id="{79A979A4-BBBD-B7E6-7994-88B598F1B362}"/>
+                <a16:creationId xmlns:a16="http://schemas.microsoft.com/office/drawing/2014/main" id="{6C081000-3C36-B3F3-82F2-1CF7BC233D79}"/>
               </a:ext>
             </a:extLst>
           </p:cNvPr>
@@ -4853,7 +4853,7 @@
           <p:cNvPr id="8" name="Овал 7">
             <a:extLst>
               <a:ext uri="{FF2B5EF4-FFF2-40B4-BE49-F238E27FC236}">
-                <a16:creationId xmlns:a16="http://schemas.microsoft.com/office/drawing/2014/main" id="{5692C47B-4C8C-3631-91DE-74B9270852B5}"/>
+                <a16:creationId xmlns:a16="http://schemas.microsoft.com/office/drawing/2014/main" id="{16C36BFC-D61B-E744-8A28-E6634C263C42}"/>
               </a:ext>
             </a:extLst>
           </p:cNvPr>
@@ -4917,7 +4917,7 @@
           <p:cNvPr id="9" name="Овал 8">
             <a:extLst>
               <a:ext uri="{FF2B5EF4-FFF2-40B4-BE49-F238E27FC236}">
-                <a16:creationId xmlns:a16="http://schemas.microsoft.com/office/drawing/2014/main" id="{5FB45F9E-56AA-F1FA-9B66-3FB1FA5E1FA8}"/>
+                <a16:creationId xmlns:a16="http://schemas.microsoft.com/office/drawing/2014/main" id="{5FA8AD42-C707-24E9-B5F2-8613C8F9D295}"/>
               </a:ext>
             </a:extLst>
           </p:cNvPr>
@@ -4981,7 +4981,7 @@
           <p:cNvPr id="10" name="Овал 9">
             <a:extLst>
               <a:ext uri="{FF2B5EF4-FFF2-40B4-BE49-F238E27FC236}">
-                <a16:creationId xmlns:a16="http://schemas.microsoft.com/office/drawing/2014/main" id="{0C4B1AB9-CB0F-06FF-AF44-38964EF8D1C1}"/>
+                <a16:creationId xmlns:a16="http://schemas.microsoft.com/office/drawing/2014/main" id="{39CA163A-A021-D489-0282-293FD262DDB0}"/>
               </a:ext>
             </a:extLst>
           </p:cNvPr>
@@ -5063,7 +5063,7 @@
           <p:cNvPr id="11" name="Овал 10">
             <a:extLst>
               <a:ext uri="{FF2B5EF4-FFF2-40B4-BE49-F238E27FC236}">
-                <a16:creationId xmlns:a16="http://schemas.microsoft.com/office/drawing/2014/main" id="{2B63AE95-8F98-9168-1947-965E57280B8D}"/>
+                <a16:creationId xmlns:a16="http://schemas.microsoft.com/office/drawing/2014/main" id="{A6800AAC-0542-9F09-4000-EBBE0DE73EE4}"/>
               </a:ext>
             </a:extLst>
           </p:cNvPr>
@@ -5145,7 +5145,7 @@
           <p:cNvPr id="12" name="Овал 11">
             <a:extLst>
               <a:ext uri="{FF2B5EF4-FFF2-40B4-BE49-F238E27FC236}">
-                <a16:creationId xmlns:a16="http://schemas.microsoft.com/office/drawing/2014/main" id="{F9FF4199-6062-5D9C-0FFB-7BAE0FE3799A}"/>
+                <a16:creationId xmlns:a16="http://schemas.microsoft.com/office/drawing/2014/main" id="{BF91C3EF-7578-C93A-C142-1ED9A30588D1}"/>
               </a:ext>
             </a:extLst>
           </p:cNvPr>
@@ -5227,7 +5227,7 @@
           <p:cNvPr id="13" name="Овал 12">
             <a:extLst>
               <a:ext uri="{FF2B5EF4-FFF2-40B4-BE49-F238E27FC236}">
-                <a16:creationId xmlns:a16="http://schemas.microsoft.com/office/drawing/2014/main" id="{D96AFB4C-813C-9BC0-A29F-7F57D4C4CA7A}"/>
+                <a16:creationId xmlns:a16="http://schemas.microsoft.com/office/drawing/2014/main" id="{B91317DC-FFC7-C1BC-FAEA-DD15EDFC64F2}"/>
               </a:ext>
             </a:extLst>
           </p:cNvPr>
@@ -5309,7 +5309,7 @@
           <p:cNvPr id="14" name="Овал 13">
             <a:extLst>
               <a:ext uri="{FF2B5EF4-FFF2-40B4-BE49-F238E27FC236}">
-                <a16:creationId xmlns:a16="http://schemas.microsoft.com/office/drawing/2014/main" id="{72E8993F-C0D8-461E-BFFE-F6F1C0BEAF23}"/>
+                <a16:creationId xmlns:a16="http://schemas.microsoft.com/office/drawing/2014/main" id="{CF2FA6C6-70AA-080D-0913-ABF10A93DEA9}"/>
               </a:ext>
             </a:extLst>
           </p:cNvPr>
@@ -5391,7 +5391,7 @@
           <p:cNvPr id="15" name="Овал 14">
             <a:extLst>
               <a:ext uri="{FF2B5EF4-FFF2-40B4-BE49-F238E27FC236}">
-                <a16:creationId xmlns:a16="http://schemas.microsoft.com/office/drawing/2014/main" id="{7C740885-15B2-B0BD-A09F-4EC9A6A89403}"/>
+                <a16:creationId xmlns:a16="http://schemas.microsoft.com/office/drawing/2014/main" id="{B76C9581-0822-92F3-66DA-78E19CB40750}"/>
               </a:ext>
             </a:extLst>
           </p:cNvPr>
@@ -5471,7 +5471,7 @@
     </p:spTree>
     <p:extLst>
       <p:ext uri="{BB962C8B-B14F-4D97-AF65-F5344CB8AC3E}">
-        <p14:creationId xmlns:p14="http://schemas.microsoft.com/office/powerpoint/2010/main" val="619252712"/>
+        <p14:creationId xmlns:p14="http://schemas.microsoft.com/office/powerpoint/2010/main" val="3284985139"/>
       </p:ext>
     </p:extLst>
   </p:cSld>
@@ -5511,7 +5511,7 @@
           <p:cNvPr id="2" name="TextBox 1">
             <a:extLst>
               <a:ext uri="{FF2B5EF4-FFF2-40B4-BE49-F238E27FC236}">
-                <a16:creationId xmlns:a16="http://schemas.microsoft.com/office/drawing/2014/main" id="{BE11A0C6-3676-5201-9891-A631660F2388}"/>
+                <a16:creationId xmlns:a16="http://schemas.microsoft.com/office/drawing/2014/main" id="{8F065B71-78CA-4599-7971-D22D63BD8419}"/>
               </a:ext>
             </a:extLst>
           </p:cNvPr>
@@ -5551,7 +5551,7 @@
           <p:cNvPr id="3" name="Овал 2">
             <a:extLst>
               <a:ext uri="{FF2B5EF4-FFF2-40B4-BE49-F238E27FC236}">
-                <a16:creationId xmlns:a16="http://schemas.microsoft.com/office/drawing/2014/main" id="{91170B9B-3F0E-88A0-ADB1-0BB216D5BD9A}"/>
+                <a16:creationId xmlns:a16="http://schemas.microsoft.com/office/drawing/2014/main" id="{327A308D-BB75-C626-6B11-A87261A609AC}"/>
               </a:ext>
             </a:extLst>
           </p:cNvPr>
@@ -5627,7 +5627,7 @@
           <p:cNvPr id="4" name="TextBox 3">
             <a:extLst>
               <a:ext uri="{FF2B5EF4-FFF2-40B4-BE49-F238E27FC236}">
-                <a16:creationId xmlns:a16="http://schemas.microsoft.com/office/drawing/2014/main" id="{B91AFD18-110E-5FD3-4806-6E621760567F}"/>
+                <a16:creationId xmlns:a16="http://schemas.microsoft.com/office/drawing/2014/main" id="{23523000-BD4F-29D5-3D02-C721433EC624}"/>
               </a:ext>
             </a:extLst>
           </p:cNvPr>
@@ -5667,7 +5667,7 @@
           <p:cNvPr id="5" name="TextBox 4">
             <a:extLst>
               <a:ext uri="{FF2B5EF4-FFF2-40B4-BE49-F238E27FC236}">
-                <a16:creationId xmlns:a16="http://schemas.microsoft.com/office/drawing/2014/main" id="{5DEAE501-6DC9-16A5-7092-7A8DB7763F4D}"/>
+                <a16:creationId xmlns:a16="http://schemas.microsoft.com/office/drawing/2014/main" id="{91FA3F93-0212-4C6D-3D88-10BABCC15CF8}"/>
               </a:ext>
             </a:extLst>
           </p:cNvPr>
@@ -5704,7 +5704,7 @@
                 </a:solidFill>
                 <a:latin typeface="Calibri" panose="020F0502020204030204" pitchFamily="34" charset="0"/>
               </a:rPr>
-              <a:t>AUC 0.84 вне выборки, чувствительность 0.80</a:t>
+              <a:t>AUC 0.86 вне выборки, чувствительность 0.84</a:t>
             </a:r>
           </a:p>
           <a:p>
@@ -5750,7 +5750,7 @@
           <p:cNvPr id="6" name="Овал 5">
             <a:extLst>
               <a:ext uri="{FF2B5EF4-FFF2-40B4-BE49-F238E27FC236}">
-                <a16:creationId xmlns:a16="http://schemas.microsoft.com/office/drawing/2014/main" id="{AE910172-4007-7D3A-9D6A-117FB1589C47}"/>
+                <a16:creationId xmlns:a16="http://schemas.microsoft.com/office/drawing/2014/main" id="{F30100AC-6469-7736-877A-08BF17A923BA}"/>
               </a:ext>
             </a:extLst>
           </p:cNvPr>
@@ -5826,7 +5826,7 @@
           <p:cNvPr id="7" name="TextBox 6">
             <a:extLst>
               <a:ext uri="{FF2B5EF4-FFF2-40B4-BE49-F238E27FC236}">
-                <a16:creationId xmlns:a16="http://schemas.microsoft.com/office/drawing/2014/main" id="{7F597E71-6AC4-E5A2-FF37-EAF3C8DE9E8C}"/>
+                <a16:creationId xmlns:a16="http://schemas.microsoft.com/office/drawing/2014/main" id="{8F2B82E8-AFC7-F3D0-657D-16B6435941A9}"/>
               </a:ext>
             </a:extLst>
           </p:cNvPr>
@@ -5866,7 +5866,7 @@
           <p:cNvPr id="8" name="TextBox 7">
             <a:extLst>
               <a:ext uri="{FF2B5EF4-FFF2-40B4-BE49-F238E27FC236}">
-                <a16:creationId xmlns:a16="http://schemas.microsoft.com/office/drawing/2014/main" id="{C0E06ED0-A3B7-A510-3A41-6AC9CCAEEF9E}"/>
+                <a16:creationId xmlns:a16="http://schemas.microsoft.com/office/drawing/2014/main" id="{22E8AB67-8301-23D2-B4A5-ADE73E12CF7E}"/>
               </a:ext>
             </a:extLst>
           </p:cNvPr>
@@ -5921,7 +5921,7 @@
                 </a:solidFill>
                 <a:latin typeface="Calibri" panose="020F0502020204030204" pitchFamily="34" charset="0"/>
               </a:rPr>
-              <a:t>соматоформные: специфичность 0.58</a:t>
+              <a:t>соматоформные: общий профиль, специфичность 0.61</a:t>
             </a:r>
           </a:p>
           <a:p>
@@ -5949,7 +5949,7 @@
           <p:cNvPr id="9" name="Овал 8">
             <a:extLst>
               <a:ext uri="{FF2B5EF4-FFF2-40B4-BE49-F238E27FC236}">
-                <a16:creationId xmlns:a16="http://schemas.microsoft.com/office/drawing/2014/main" id="{0A4969B1-FA71-BD5C-8B20-10B751EF11C8}"/>
+                <a16:creationId xmlns:a16="http://schemas.microsoft.com/office/drawing/2014/main" id="{27B32BED-EC52-9D4D-FF81-7C164655F217}"/>
               </a:ext>
             </a:extLst>
           </p:cNvPr>
@@ -6025,7 +6025,7 @@
           <p:cNvPr id="10" name="TextBox 9">
             <a:extLst>
               <a:ext uri="{FF2B5EF4-FFF2-40B4-BE49-F238E27FC236}">
-                <a16:creationId xmlns:a16="http://schemas.microsoft.com/office/drawing/2014/main" id="{16D3F6D4-7842-0053-7AF4-FAE0794AF7A0}"/>
+                <a16:creationId xmlns:a16="http://schemas.microsoft.com/office/drawing/2014/main" id="{A7E9914B-4614-08A5-52F8-057072D6AB15}"/>
               </a:ext>
             </a:extLst>
           </p:cNvPr>
@@ -6065,7 +6065,7 @@
           <p:cNvPr id="11" name="TextBox 10">
             <a:extLst>
               <a:ext uri="{FF2B5EF4-FFF2-40B4-BE49-F238E27FC236}">
-                <a16:creationId xmlns:a16="http://schemas.microsoft.com/office/drawing/2014/main" id="{38B5D6E4-F2AB-8BDA-B6BF-4284F7B5E332}"/>
+                <a16:creationId xmlns:a16="http://schemas.microsoft.com/office/drawing/2014/main" id="{A23F7731-8E80-A59C-D332-94FAC62DA023}"/>
               </a:ext>
             </a:extLst>
           </p:cNvPr>
@@ -6148,7 +6148,7 @@
           <p:cNvPr id="12" name="TextBox 11">
             <a:extLst>
               <a:ext uri="{FF2B5EF4-FFF2-40B4-BE49-F238E27FC236}">
-                <a16:creationId xmlns:a16="http://schemas.microsoft.com/office/drawing/2014/main" id="{D4D5B853-F199-CA52-4F15-07C5DE8BA7C4}"/>
+                <a16:creationId xmlns:a16="http://schemas.microsoft.com/office/drawing/2014/main" id="{7C5ADC56-FC7F-247E-004D-A1FEEE6DDE5F}"/>
               </a:ext>
             </a:extLst>
           </p:cNvPr>
@@ -6186,7 +6186,7 @@
     </p:spTree>
     <p:extLst>
       <p:ext uri="{BB962C8B-B14F-4D97-AF65-F5344CB8AC3E}">
-        <p14:creationId xmlns:p14="http://schemas.microsoft.com/office/powerpoint/2010/main" val="3174789098"/>
+        <p14:creationId xmlns:p14="http://schemas.microsoft.com/office/powerpoint/2010/main" val="2643831941"/>
       </p:ext>
     </p:extLst>
   </p:cSld>
@@ -6226,7 +6226,7 @@
           <p:cNvPr id="2" name="TextBox 1">
             <a:extLst>
               <a:ext uri="{FF2B5EF4-FFF2-40B4-BE49-F238E27FC236}">
-                <a16:creationId xmlns:a16="http://schemas.microsoft.com/office/drawing/2014/main" id="{78BBF426-328A-537B-FB29-1C22F2876875}"/>
+                <a16:creationId xmlns:a16="http://schemas.microsoft.com/office/drawing/2014/main" id="{023894F5-1789-29EE-FB75-C69401AF1FDA}"/>
               </a:ext>
             </a:extLst>
           </p:cNvPr>
@@ -6266,7 +6266,7 @@
           <p:cNvPr id="3" name="Прямоугольник: скругленные углы 2">
             <a:extLst>
               <a:ext uri="{FF2B5EF4-FFF2-40B4-BE49-F238E27FC236}">
-                <a16:creationId xmlns:a16="http://schemas.microsoft.com/office/drawing/2014/main" id="{78EBDC2D-A6D7-6150-6045-BBAE772E33F9}"/>
+                <a16:creationId xmlns:a16="http://schemas.microsoft.com/office/drawing/2014/main" id="{5F021AB8-CCC4-F3FB-0E1B-F0034469E3D4}"/>
               </a:ext>
             </a:extLst>
           </p:cNvPr>
@@ -6336,7 +6336,7 @@
           <p:cNvPr id="4" name="TextBox 3">
             <a:extLst>
               <a:ext uri="{FF2B5EF4-FFF2-40B4-BE49-F238E27FC236}">
-                <a16:creationId xmlns:a16="http://schemas.microsoft.com/office/drawing/2014/main" id="{383F06B1-91CD-10CE-1F45-5AD82B7B94CA}"/>
+                <a16:creationId xmlns:a16="http://schemas.microsoft.com/office/drawing/2014/main" id="{D70EECED-1420-E570-DE6A-900C4E94C704}"/>
               </a:ext>
             </a:extLst>
           </p:cNvPr>
@@ -6376,7 +6376,7 @@
           <p:cNvPr id="5" name="TextBox 4">
             <a:extLst>
               <a:ext uri="{FF2B5EF4-FFF2-40B4-BE49-F238E27FC236}">
-                <a16:creationId xmlns:a16="http://schemas.microsoft.com/office/drawing/2014/main" id="{2E4E8D23-BFD2-DF2C-4DB4-E2B3D767CA0F}"/>
+                <a16:creationId xmlns:a16="http://schemas.microsoft.com/office/drawing/2014/main" id="{78F466D5-A8BF-05F2-D189-D2450D4A2750}"/>
               </a:ext>
             </a:extLst>
           </p:cNvPr>
@@ -6427,7 +6427,7 @@
           <p:cNvPr id="6" name="TextBox 5">
             <a:extLst>
               <a:ext uri="{FF2B5EF4-FFF2-40B4-BE49-F238E27FC236}">
-                <a16:creationId xmlns:a16="http://schemas.microsoft.com/office/drawing/2014/main" id="{16A5410E-EE91-994D-D2D5-211244DB15AB}"/>
+                <a16:creationId xmlns:a16="http://schemas.microsoft.com/office/drawing/2014/main" id="{D9A68CF4-F886-6C99-1792-267D8E4C497A}"/>
               </a:ext>
             </a:extLst>
           </p:cNvPr>
@@ -6510,7 +6510,7 @@
           <p:cNvPr id="7" name="TextBox 6">
             <a:extLst>
               <a:ext uri="{FF2B5EF4-FFF2-40B4-BE49-F238E27FC236}">
-                <a16:creationId xmlns:a16="http://schemas.microsoft.com/office/drawing/2014/main" id="{59AE6151-BBE9-EA3A-37AD-1B01D619D14B}"/>
+                <a16:creationId xmlns:a16="http://schemas.microsoft.com/office/drawing/2014/main" id="{821686AA-3EFC-CE7C-490A-B0F1A146636F}"/>
               </a:ext>
             </a:extLst>
           </p:cNvPr>
@@ -6550,7 +6550,7 @@
           <p:cNvPr id="8" name="TextBox 7">
             <a:extLst>
               <a:ext uri="{FF2B5EF4-FFF2-40B4-BE49-F238E27FC236}">
-                <a16:creationId xmlns:a16="http://schemas.microsoft.com/office/drawing/2014/main" id="{4751F6B1-B8E6-D708-8889-7AC99A8A784F}"/>
+                <a16:creationId xmlns:a16="http://schemas.microsoft.com/office/drawing/2014/main" id="{7D01F3CD-D33D-47CA-3776-675AF8193EEF}"/>
               </a:ext>
             </a:extLst>
           </p:cNvPr>
@@ -6590,7 +6590,7 @@
           <p:cNvPr id="9" name="TextBox 8">
             <a:extLst>
               <a:ext uri="{FF2B5EF4-FFF2-40B4-BE49-F238E27FC236}">
-                <a16:creationId xmlns:a16="http://schemas.microsoft.com/office/drawing/2014/main" id="{7AE59B15-905F-632B-2DAF-7BDAE82DBF86}"/>
+                <a16:creationId xmlns:a16="http://schemas.microsoft.com/office/drawing/2014/main" id="{0393AE69-6A77-8384-075F-0CC574F896C8}"/>
               </a:ext>
             </a:extLst>
           </p:cNvPr>
@@ -6630,7 +6630,7 @@
           <p:cNvPr id="10" name="TextBox 9">
             <a:extLst>
               <a:ext uri="{FF2B5EF4-FFF2-40B4-BE49-F238E27FC236}">
-                <a16:creationId xmlns:a16="http://schemas.microsoft.com/office/drawing/2014/main" id="{F1B77BF5-27FE-EFB8-058C-FD52AE3CD9DE}"/>
+                <a16:creationId xmlns:a16="http://schemas.microsoft.com/office/drawing/2014/main" id="{E4BB6AF4-D7ED-CCCF-DB41-47E69EE72D01}"/>
               </a:ext>
             </a:extLst>
           </p:cNvPr>
@@ -6670,7 +6670,7 @@
           <p:cNvPr id="11" name="TextBox 10">
             <a:extLst>
               <a:ext uri="{FF2B5EF4-FFF2-40B4-BE49-F238E27FC236}">
-                <a16:creationId xmlns:a16="http://schemas.microsoft.com/office/drawing/2014/main" id="{A58D8BD2-8944-EB30-AA9D-7A06A02C11BF}"/>
+                <a16:creationId xmlns:a16="http://schemas.microsoft.com/office/drawing/2014/main" id="{7DECE8B7-1496-9349-BE92-30186A7E12E5}"/>
               </a:ext>
             </a:extLst>
           </p:cNvPr>
@@ -6710,7 +6710,7 @@
           <p:cNvPr id="12" name="TextBox 11">
             <a:extLst>
               <a:ext uri="{FF2B5EF4-FFF2-40B4-BE49-F238E27FC236}">
-                <a16:creationId xmlns:a16="http://schemas.microsoft.com/office/drawing/2014/main" id="{F78F0088-6E9B-3B5E-F904-8E0F1BAA2362}"/>
+                <a16:creationId xmlns:a16="http://schemas.microsoft.com/office/drawing/2014/main" id="{7DF495FE-B52C-E988-93E6-C94ACB9FFBEA}"/>
               </a:ext>
             </a:extLst>
           </p:cNvPr>
@@ -6750,7 +6750,7 @@
           <p:cNvPr id="13" name="TextBox 12">
             <a:extLst>
               <a:ext uri="{FF2B5EF4-FFF2-40B4-BE49-F238E27FC236}">
-                <a16:creationId xmlns:a16="http://schemas.microsoft.com/office/drawing/2014/main" id="{088DA7B5-2CFC-E2BB-2EAA-618CBC480E26}"/>
+                <a16:creationId xmlns:a16="http://schemas.microsoft.com/office/drawing/2014/main" id="{A42F82B3-CDFB-6AC8-3B92-25A12303C0A9}"/>
               </a:ext>
             </a:extLst>
           </p:cNvPr>
@@ -6788,7 +6788,7 @@
     </p:spTree>
     <p:extLst>
       <p:ext uri="{BB962C8B-B14F-4D97-AF65-F5344CB8AC3E}">
-        <p14:creationId xmlns:p14="http://schemas.microsoft.com/office/powerpoint/2010/main" val="695227680"/>
+        <p14:creationId xmlns:p14="http://schemas.microsoft.com/office/powerpoint/2010/main" val="1792404086"/>
       </p:ext>
     </p:extLst>
   </p:cSld>
@@ -6828,7 +6828,7 @@
           <p:cNvPr id="2" name="TextBox 1">
             <a:extLst>
               <a:ext uri="{FF2B5EF4-FFF2-40B4-BE49-F238E27FC236}">
-                <a16:creationId xmlns:a16="http://schemas.microsoft.com/office/drawing/2014/main" id="{F9517D80-A6CC-EC0B-91D1-FF3B5C1A9629}"/>
+                <a16:creationId xmlns:a16="http://schemas.microsoft.com/office/drawing/2014/main" id="{CAE823F3-901A-BB5D-7DFA-5D0CE5A84E94}"/>
               </a:ext>
             </a:extLst>
           </p:cNvPr>
@@ -6868,7 +6868,7 @@
           <p:cNvPr id="3" name="Прямоугольник: скругленные углы 2">
             <a:extLst>
               <a:ext uri="{FF2B5EF4-FFF2-40B4-BE49-F238E27FC236}">
-                <a16:creationId xmlns:a16="http://schemas.microsoft.com/office/drawing/2014/main" id="{EBCB55D0-1DB7-87C0-F89A-AD4AE7BAAA82}"/>
+                <a16:creationId xmlns:a16="http://schemas.microsoft.com/office/drawing/2014/main" id="{CB053632-CC99-1629-700D-8CE9369C8943}"/>
               </a:ext>
             </a:extLst>
           </p:cNvPr>
@@ -6938,7 +6938,7 @@
           <p:cNvPr id="4" name="Овал 3">
             <a:extLst>
               <a:ext uri="{FF2B5EF4-FFF2-40B4-BE49-F238E27FC236}">
-                <a16:creationId xmlns:a16="http://schemas.microsoft.com/office/drawing/2014/main" id="{3C609A99-5D04-288C-98B1-F1D7DC74468C}"/>
+                <a16:creationId xmlns:a16="http://schemas.microsoft.com/office/drawing/2014/main" id="{0030964F-9701-0894-CB73-AFA7DD5F0506}"/>
               </a:ext>
             </a:extLst>
           </p:cNvPr>
@@ -7014,7 +7014,7 @@
           <p:cNvPr id="5" name="TextBox 4">
             <a:extLst>
               <a:ext uri="{FF2B5EF4-FFF2-40B4-BE49-F238E27FC236}">
-                <a16:creationId xmlns:a16="http://schemas.microsoft.com/office/drawing/2014/main" id="{A5559BE0-4E74-DB6A-1054-0C588474DDB6}"/>
+                <a16:creationId xmlns:a16="http://schemas.microsoft.com/office/drawing/2014/main" id="{CE572C22-CF98-0B92-76E7-56E567CF9ED5}"/>
               </a:ext>
             </a:extLst>
           </p:cNvPr>
@@ -7060,7 +7060,7 @@
           <p:cNvPr id="6" name="TextBox 5">
             <a:extLst>
               <a:ext uri="{FF2B5EF4-FFF2-40B4-BE49-F238E27FC236}">
-                <a16:creationId xmlns:a16="http://schemas.microsoft.com/office/drawing/2014/main" id="{FD05B7EE-4E23-1597-D5BC-8203E2598C38}"/>
+                <a16:creationId xmlns:a16="http://schemas.microsoft.com/office/drawing/2014/main" id="{1E511EA9-C938-067E-7396-6546F9CF2852}"/>
               </a:ext>
             </a:extLst>
           </p:cNvPr>
@@ -7100,7 +7100,7 @@
           <p:cNvPr id="7" name="Прямоугольник: скругленные углы 6">
             <a:extLst>
               <a:ext uri="{FF2B5EF4-FFF2-40B4-BE49-F238E27FC236}">
-                <a16:creationId xmlns:a16="http://schemas.microsoft.com/office/drawing/2014/main" id="{06E77C42-1EC2-F8B0-2065-14E1E09D6C2A}"/>
+                <a16:creationId xmlns:a16="http://schemas.microsoft.com/office/drawing/2014/main" id="{B61E1785-D7EA-2362-80F8-C639CC4F6E16}"/>
               </a:ext>
             </a:extLst>
           </p:cNvPr>
@@ -7170,7 +7170,7 @@
           <p:cNvPr id="8" name="Овал 7">
             <a:extLst>
               <a:ext uri="{FF2B5EF4-FFF2-40B4-BE49-F238E27FC236}">
-                <a16:creationId xmlns:a16="http://schemas.microsoft.com/office/drawing/2014/main" id="{6850C4E3-00C4-48FD-5584-88D0224602C4}"/>
+                <a16:creationId xmlns:a16="http://schemas.microsoft.com/office/drawing/2014/main" id="{2FE1A82E-15D2-FE10-999E-01F6718A2E2D}"/>
               </a:ext>
             </a:extLst>
           </p:cNvPr>
@@ -7246,7 +7246,7 @@
           <p:cNvPr id="9" name="TextBox 8">
             <a:extLst>
               <a:ext uri="{FF2B5EF4-FFF2-40B4-BE49-F238E27FC236}">
-                <a16:creationId xmlns:a16="http://schemas.microsoft.com/office/drawing/2014/main" id="{7EA4B040-8186-8E41-5111-91BD752FF6DE}"/>
+                <a16:creationId xmlns:a16="http://schemas.microsoft.com/office/drawing/2014/main" id="{F0FEF026-3959-B9FB-8723-766AAD14AA23}"/>
               </a:ext>
             </a:extLst>
           </p:cNvPr>
@@ -7286,7 +7286,7 @@
           <p:cNvPr id="10" name="TextBox 9">
             <a:extLst>
               <a:ext uri="{FF2B5EF4-FFF2-40B4-BE49-F238E27FC236}">
-                <a16:creationId xmlns:a16="http://schemas.microsoft.com/office/drawing/2014/main" id="{33C8E0A7-E1B6-0506-8896-42DEDCCBC5BB}"/>
+                <a16:creationId xmlns:a16="http://schemas.microsoft.com/office/drawing/2014/main" id="{6188B5B1-F321-F280-5CD4-C09D0DE18D9D}"/>
               </a:ext>
             </a:extLst>
           </p:cNvPr>
@@ -7326,7 +7326,7 @@
           <p:cNvPr id="11" name="Прямоугольник: скругленные углы 10">
             <a:extLst>
               <a:ext uri="{FF2B5EF4-FFF2-40B4-BE49-F238E27FC236}">
-                <a16:creationId xmlns:a16="http://schemas.microsoft.com/office/drawing/2014/main" id="{A19AE4DB-D35F-3D83-3E78-C5E9F608F8AE}"/>
+                <a16:creationId xmlns:a16="http://schemas.microsoft.com/office/drawing/2014/main" id="{A3375E52-C9FA-CED6-D4C6-9E8E3CA8A12D}"/>
               </a:ext>
             </a:extLst>
           </p:cNvPr>
@@ -7396,7 +7396,7 @@
           <p:cNvPr id="12" name="Овал 11">
             <a:extLst>
               <a:ext uri="{FF2B5EF4-FFF2-40B4-BE49-F238E27FC236}">
-                <a16:creationId xmlns:a16="http://schemas.microsoft.com/office/drawing/2014/main" id="{6EC3C5D2-F6B5-0E3C-2D37-FE90D570A4C5}"/>
+                <a16:creationId xmlns:a16="http://schemas.microsoft.com/office/drawing/2014/main" id="{50CB57FB-3373-322E-94F9-38E645B81F5B}"/>
               </a:ext>
             </a:extLst>
           </p:cNvPr>
@@ -7472,7 +7472,7 @@
           <p:cNvPr id="13" name="TextBox 12">
             <a:extLst>
               <a:ext uri="{FF2B5EF4-FFF2-40B4-BE49-F238E27FC236}">
-                <a16:creationId xmlns:a16="http://schemas.microsoft.com/office/drawing/2014/main" id="{ADE4ED1B-BA13-26E6-4055-9ABA5F134086}"/>
+                <a16:creationId xmlns:a16="http://schemas.microsoft.com/office/drawing/2014/main" id="{4C0318F3-CF75-EC4E-214E-2A442238BA7D}"/>
               </a:ext>
             </a:extLst>
           </p:cNvPr>
@@ -7512,7 +7512,7 @@
           <p:cNvPr id="14" name="TextBox 13">
             <a:extLst>
               <a:ext uri="{FF2B5EF4-FFF2-40B4-BE49-F238E27FC236}">
-                <a16:creationId xmlns:a16="http://schemas.microsoft.com/office/drawing/2014/main" id="{EA905880-A9C0-BF4A-F2F9-306BCA3F5FD7}"/>
+                <a16:creationId xmlns:a16="http://schemas.microsoft.com/office/drawing/2014/main" id="{74F04913-E32A-8744-E13B-750DD87008D9}"/>
               </a:ext>
             </a:extLst>
           </p:cNvPr>
@@ -7552,7 +7552,7 @@
           <p:cNvPr id="15" name="Прямоугольник: скругленные углы 14">
             <a:extLst>
               <a:ext uri="{FF2B5EF4-FFF2-40B4-BE49-F238E27FC236}">
-                <a16:creationId xmlns:a16="http://schemas.microsoft.com/office/drawing/2014/main" id="{1D5F0FEF-F790-A4E5-94B7-EDF45E66B7BA}"/>
+                <a16:creationId xmlns:a16="http://schemas.microsoft.com/office/drawing/2014/main" id="{E84415DA-05C5-8D88-EA67-78A3E373653C}"/>
               </a:ext>
             </a:extLst>
           </p:cNvPr>
@@ -7622,7 +7622,7 @@
           <p:cNvPr id="16" name="Овал 15">
             <a:extLst>
               <a:ext uri="{FF2B5EF4-FFF2-40B4-BE49-F238E27FC236}">
-                <a16:creationId xmlns:a16="http://schemas.microsoft.com/office/drawing/2014/main" id="{1AFB63BE-41A3-7975-7CD1-D465E71D3413}"/>
+                <a16:creationId xmlns:a16="http://schemas.microsoft.com/office/drawing/2014/main" id="{A67836C2-6F5F-83F9-1CDB-D0223BD1600C}"/>
               </a:ext>
             </a:extLst>
           </p:cNvPr>
@@ -7698,7 +7698,7 @@
           <p:cNvPr id="17" name="TextBox 16">
             <a:extLst>
               <a:ext uri="{FF2B5EF4-FFF2-40B4-BE49-F238E27FC236}">
-                <a16:creationId xmlns:a16="http://schemas.microsoft.com/office/drawing/2014/main" id="{D86BFFA6-58A7-08D1-C5E8-8FE2A8C06EBC}"/>
+                <a16:creationId xmlns:a16="http://schemas.microsoft.com/office/drawing/2014/main" id="{CCA37616-4213-2067-6C8F-09B76376F1DE}"/>
               </a:ext>
             </a:extLst>
           </p:cNvPr>
@@ -7738,7 +7738,7 @@
           <p:cNvPr id="18" name="TextBox 17">
             <a:extLst>
               <a:ext uri="{FF2B5EF4-FFF2-40B4-BE49-F238E27FC236}">
-                <a16:creationId xmlns:a16="http://schemas.microsoft.com/office/drawing/2014/main" id="{DECD75BB-58C8-C1A9-BEB3-26F564EA4FFB}"/>
+                <a16:creationId xmlns:a16="http://schemas.microsoft.com/office/drawing/2014/main" id="{3A8230D9-1D2D-E694-8E89-F4D73F3DB821}"/>
               </a:ext>
             </a:extLst>
           </p:cNvPr>
@@ -7778,7 +7778,7 @@
           <p:cNvPr id="19" name="Прямоугольник: скругленные углы 18">
             <a:extLst>
               <a:ext uri="{FF2B5EF4-FFF2-40B4-BE49-F238E27FC236}">
-                <a16:creationId xmlns:a16="http://schemas.microsoft.com/office/drawing/2014/main" id="{AB31AAB1-4388-C305-1CBA-7C8AC23ECF55}"/>
+                <a16:creationId xmlns:a16="http://schemas.microsoft.com/office/drawing/2014/main" id="{6F4FB95E-1CB3-18F3-8175-5FA5507292AF}"/>
               </a:ext>
             </a:extLst>
           </p:cNvPr>
@@ -7848,7 +7848,7 @@
           <p:cNvPr id="20" name="Овал 19">
             <a:extLst>
               <a:ext uri="{FF2B5EF4-FFF2-40B4-BE49-F238E27FC236}">
-                <a16:creationId xmlns:a16="http://schemas.microsoft.com/office/drawing/2014/main" id="{9C71925F-1CBC-F501-888B-F437210EB8A5}"/>
+                <a16:creationId xmlns:a16="http://schemas.microsoft.com/office/drawing/2014/main" id="{637C9696-AE99-67C0-A1D1-D1CC1E80E3CA}"/>
               </a:ext>
             </a:extLst>
           </p:cNvPr>
@@ -7924,7 +7924,7 @@
           <p:cNvPr id="21" name="TextBox 20">
             <a:extLst>
               <a:ext uri="{FF2B5EF4-FFF2-40B4-BE49-F238E27FC236}">
-                <a16:creationId xmlns:a16="http://schemas.microsoft.com/office/drawing/2014/main" id="{9054226B-53AE-3326-D1CB-1931B092AB7C}"/>
+                <a16:creationId xmlns:a16="http://schemas.microsoft.com/office/drawing/2014/main" id="{4806DEBA-CB12-9A7A-E30D-6062118DB76C}"/>
               </a:ext>
             </a:extLst>
           </p:cNvPr>
@@ -7964,7 +7964,7 @@
           <p:cNvPr id="22" name="TextBox 21">
             <a:extLst>
               <a:ext uri="{FF2B5EF4-FFF2-40B4-BE49-F238E27FC236}">
-                <a16:creationId xmlns:a16="http://schemas.microsoft.com/office/drawing/2014/main" id="{8764C1E3-C3A5-8D95-DAA9-86BB5E3E1D41}"/>
+                <a16:creationId xmlns:a16="http://schemas.microsoft.com/office/drawing/2014/main" id="{3ECCF970-FB07-DF0D-B571-A1045527DAD8}"/>
               </a:ext>
             </a:extLst>
           </p:cNvPr>
@@ -8004,7 +8004,7 @@
           <p:cNvPr id="23" name="Прямоугольник: скругленные углы 22">
             <a:extLst>
               <a:ext uri="{FF2B5EF4-FFF2-40B4-BE49-F238E27FC236}">
-                <a16:creationId xmlns:a16="http://schemas.microsoft.com/office/drawing/2014/main" id="{8F863E0E-3C99-1577-9FEE-BAF3D5314B5F}"/>
+                <a16:creationId xmlns:a16="http://schemas.microsoft.com/office/drawing/2014/main" id="{9AC3CC49-2DE2-B5F9-8B6A-5BD45267B7D3}"/>
               </a:ext>
             </a:extLst>
           </p:cNvPr>
@@ -8074,7 +8074,7 @@
           <p:cNvPr id="24" name="Овал 23">
             <a:extLst>
               <a:ext uri="{FF2B5EF4-FFF2-40B4-BE49-F238E27FC236}">
-                <a16:creationId xmlns:a16="http://schemas.microsoft.com/office/drawing/2014/main" id="{B0D2F18E-D699-2FFD-D7D9-D3D1C4F80167}"/>
+                <a16:creationId xmlns:a16="http://schemas.microsoft.com/office/drawing/2014/main" id="{BC47410D-1BFE-D3F5-71A4-470385966E38}"/>
               </a:ext>
             </a:extLst>
           </p:cNvPr>
@@ -8150,7 +8150,7 @@
           <p:cNvPr id="25" name="TextBox 24">
             <a:extLst>
               <a:ext uri="{FF2B5EF4-FFF2-40B4-BE49-F238E27FC236}">
-                <a16:creationId xmlns:a16="http://schemas.microsoft.com/office/drawing/2014/main" id="{0F474E8F-E33B-D189-EAB7-26E57519E02A}"/>
+                <a16:creationId xmlns:a16="http://schemas.microsoft.com/office/drawing/2014/main" id="{F653B16A-1B68-8807-5FA5-2777CEDC3C6D}"/>
               </a:ext>
             </a:extLst>
           </p:cNvPr>
@@ -8190,7 +8190,7 @@
           <p:cNvPr id="26" name="TextBox 25">
             <a:extLst>
               <a:ext uri="{FF2B5EF4-FFF2-40B4-BE49-F238E27FC236}">
-                <a16:creationId xmlns:a16="http://schemas.microsoft.com/office/drawing/2014/main" id="{ACCF2EF3-1719-B67D-75A8-D6596DBBA1B2}"/>
+                <a16:creationId xmlns:a16="http://schemas.microsoft.com/office/drawing/2014/main" id="{83030B6C-DF76-8539-A924-68ED86BD1392}"/>
               </a:ext>
             </a:extLst>
           </p:cNvPr>
@@ -8248,7 +8248,7 @@
           <p:cNvPr id="27" name="Прямоугольник: скругленные углы 26">
             <a:extLst>
               <a:ext uri="{FF2B5EF4-FFF2-40B4-BE49-F238E27FC236}">
-                <a16:creationId xmlns:a16="http://schemas.microsoft.com/office/drawing/2014/main" id="{89421090-DBB4-1049-68AF-DF3091110716}"/>
+                <a16:creationId xmlns:a16="http://schemas.microsoft.com/office/drawing/2014/main" id="{7C3191E9-3E05-F045-A237-6A3ED91CA19D}"/>
               </a:ext>
             </a:extLst>
           </p:cNvPr>
@@ -8318,7 +8318,7 @@
           <p:cNvPr id="28" name="TextBox 27">
             <a:extLst>
               <a:ext uri="{FF2B5EF4-FFF2-40B4-BE49-F238E27FC236}">
-                <a16:creationId xmlns:a16="http://schemas.microsoft.com/office/drawing/2014/main" id="{2C0456F5-80BD-1B30-0D98-03006D003546}"/>
+                <a16:creationId xmlns:a16="http://schemas.microsoft.com/office/drawing/2014/main" id="{9E83F4B9-77F7-F05D-A3B9-A61E3289ECC4}"/>
               </a:ext>
             </a:extLst>
           </p:cNvPr>
@@ -8358,7 +8358,7 @@
           <p:cNvPr id="29" name="TextBox 28">
             <a:extLst>
               <a:ext uri="{FF2B5EF4-FFF2-40B4-BE49-F238E27FC236}">
-                <a16:creationId xmlns:a16="http://schemas.microsoft.com/office/drawing/2014/main" id="{B7393A97-EF74-C9E7-46F7-00B7E0269A8E}"/>
+                <a16:creationId xmlns:a16="http://schemas.microsoft.com/office/drawing/2014/main" id="{342BF1B5-13E9-49A7-A56C-2F274E5BFB3E}"/>
               </a:ext>
             </a:extLst>
           </p:cNvPr>
@@ -8457,7 +8457,7 @@
     </p:spTree>
     <p:extLst>
       <p:ext uri="{BB962C8B-B14F-4D97-AF65-F5344CB8AC3E}">
-        <p14:creationId xmlns:p14="http://schemas.microsoft.com/office/powerpoint/2010/main" val="1069507887"/>
+        <p14:creationId xmlns:p14="http://schemas.microsoft.com/office/powerpoint/2010/main" val="3047160395"/>
       </p:ext>
     </p:extLst>
   </p:cSld>
@@ -8497,7 +8497,7 @@
           <p:cNvPr id="2" name="TextBox 1">
             <a:extLst>
               <a:ext uri="{FF2B5EF4-FFF2-40B4-BE49-F238E27FC236}">
-                <a16:creationId xmlns:a16="http://schemas.microsoft.com/office/drawing/2014/main" id="{0DCEBA1C-D3BF-726F-A193-1C38804CD775}"/>
+                <a16:creationId xmlns:a16="http://schemas.microsoft.com/office/drawing/2014/main" id="{CC9A59A5-F8CD-3248-1ADD-D52D852D1E7A}"/>
               </a:ext>
             </a:extLst>
           </p:cNvPr>
@@ -8537,7 +8537,7 @@
           <p:cNvPr id="4" name="Рисунок 3">
             <a:extLst>
               <a:ext uri="{FF2B5EF4-FFF2-40B4-BE49-F238E27FC236}">
-                <a16:creationId xmlns:a16="http://schemas.microsoft.com/office/drawing/2014/main" id="{3E6B33B8-23E7-75D9-E00E-51E27046F57A}"/>
+                <a16:creationId xmlns:a16="http://schemas.microsoft.com/office/drawing/2014/main" id="{F898A362-895B-1D7D-4902-AB3C4B6B6A00}"/>
               </a:ext>
             </a:extLst>
           </p:cNvPr>
@@ -8573,7 +8573,7 @@
           <p:cNvPr id="5" name="Прямоугольник: скругленные углы 4">
             <a:extLst>
               <a:ext uri="{FF2B5EF4-FFF2-40B4-BE49-F238E27FC236}">
-                <a16:creationId xmlns:a16="http://schemas.microsoft.com/office/drawing/2014/main" id="{BAC6ED0F-DC11-EE2E-343D-071BE15480B0}"/>
+                <a16:creationId xmlns:a16="http://schemas.microsoft.com/office/drawing/2014/main" id="{8120BE52-FA46-969C-C6B7-3CD096C82BEF}"/>
               </a:ext>
             </a:extLst>
           </p:cNvPr>
@@ -8643,7 +8643,7 @@
           <p:cNvPr id="6" name="TextBox 5">
             <a:extLst>
               <a:ext uri="{FF2B5EF4-FFF2-40B4-BE49-F238E27FC236}">
-                <a16:creationId xmlns:a16="http://schemas.microsoft.com/office/drawing/2014/main" id="{00A0A6E0-B7AC-29F1-9FEC-9EAAA3CA737D}"/>
+                <a16:creationId xmlns:a16="http://schemas.microsoft.com/office/drawing/2014/main" id="{7C9829D9-7B57-EBAC-8706-959DCC5BB3E0}"/>
               </a:ext>
             </a:extLst>
           </p:cNvPr>
@@ -8683,7 +8683,7 @@
           <p:cNvPr id="7" name="TextBox 6">
             <a:extLst>
               <a:ext uri="{FF2B5EF4-FFF2-40B4-BE49-F238E27FC236}">
-                <a16:creationId xmlns:a16="http://schemas.microsoft.com/office/drawing/2014/main" id="{4573B67F-480C-AEB1-4271-05729BD8FD09}"/>
+                <a16:creationId xmlns:a16="http://schemas.microsoft.com/office/drawing/2014/main" id="{8C56145A-2808-5D08-C479-A021B01730B2}"/>
               </a:ext>
             </a:extLst>
           </p:cNvPr>
@@ -8723,7 +8723,7 @@
           <p:cNvPr id="8" name="Прямоугольник: скругленные углы 7">
             <a:extLst>
               <a:ext uri="{FF2B5EF4-FFF2-40B4-BE49-F238E27FC236}">
-                <a16:creationId xmlns:a16="http://schemas.microsoft.com/office/drawing/2014/main" id="{DD54A3D8-CD8E-579E-600C-62076FE38629}"/>
+                <a16:creationId xmlns:a16="http://schemas.microsoft.com/office/drawing/2014/main" id="{CA0F8CE0-2F95-30B4-C095-3C9DEB64E940}"/>
               </a:ext>
             </a:extLst>
           </p:cNvPr>
@@ -8793,7 +8793,7 @@
           <p:cNvPr id="9" name="TextBox 8">
             <a:extLst>
               <a:ext uri="{FF2B5EF4-FFF2-40B4-BE49-F238E27FC236}">
-                <a16:creationId xmlns:a16="http://schemas.microsoft.com/office/drawing/2014/main" id="{CA606D4E-2623-9B57-8F33-B64A1ED0D533}"/>
+                <a16:creationId xmlns:a16="http://schemas.microsoft.com/office/drawing/2014/main" id="{D462EDA6-953B-144B-4E98-AA89D57B6DEB}"/>
               </a:ext>
             </a:extLst>
           </p:cNvPr>
@@ -8833,7 +8833,7 @@
           <p:cNvPr id="10" name="TextBox 9">
             <a:extLst>
               <a:ext uri="{FF2B5EF4-FFF2-40B4-BE49-F238E27FC236}">
-                <a16:creationId xmlns:a16="http://schemas.microsoft.com/office/drawing/2014/main" id="{1C5B846D-609A-F209-11FD-201DF2D6EFB6}"/>
+                <a16:creationId xmlns:a16="http://schemas.microsoft.com/office/drawing/2014/main" id="{A79A8673-0751-401E-6BFB-487320F8F734}"/>
               </a:ext>
             </a:extLst>
           </p:cNvPr>
@@ -8873,7 +8873,7 @@
           <p:cNvPr id="11" name="Прямоугольник: скругленные углы 10">
             <a:extLst>
               <a:ext uri="{FF2B5EF4-FFF2-40B4-BE49-F238E27FC236}">
-                <a16:creationId xmlns:a16="http://schemas.microsoft.com/office/drawing/2014/main" id="{030E2D7B-9E56-594C-AB31-0C9FB7AD6BC9}"/>
+                <a16:creationId xmlns:a16="http://schemas.microsoft.com/office/drawing/2014/main" id="{2F1147DE-AB65-44B0-4E1E-F271F256D152}"/>
               </a:ext>
             </a:extLst>
           </p:cNvPr>
@@ -8943,7 +8943,7 @@
           <p:cNvPr id="12" name="TextBox 11">
             <a:extLst>
               <a:ext uri="{FF2B5EF4-FFF2-40B4-BE49-F238E27FC236}">
-                <a16:creationId xmlns:a16="http://schemas.microsoft.com/office/drawing/2014/main" id="{9D4A0DF8-F309-FE6F-1C46-02C9EB98A33A}"/>
+                <a16:creationId xmlns:a16="http://schemas.microsoft.com/office/drawing/2014/main" id="{73BF8E13-614F-151D-DB77-DAC517FEE56D}"/>
               </a:ext>
             </a:extLst>
           </p:cNvPr>
@@ -8983,7 +8983,7 @@
           <p:cNvPr id="13" name="TextBox 12">
             <a:extLst>
               <a:ext uri="{FF2B5EF4-FFF2-40B4-BE49-F238E27FC236}">
-                <a16:creationId xmlns:a16="http://schemas.microsoft.com/office/drawing/2014/main" id="{B7B07A75-7482-F955-7B96-E7394EF035CC}"/>
+                <a16:creationId xmlns:a16="http://schemas.microsoft.com/office/drawing/2014/main" id="{B5C7E3EF-E9BD-7D31-E891-2B9FB488EBF8}"/>
               </a:ext>
             </a:extLst>
           </p:cNvPr>
@@ -9021,7 +9021,7 @@
     </p:spTree>
     <p:extLst>
       <p:ext uri="{BB962C8B-B14F-4D97-AF65-F5344CB8AC3E}">
-        <p14:creationId xmlns:p14="http://schemas.microsoft.com/office/powerpoint/2010/main" val="696872649"/>
+        <p14:creationId xmlns:p14="http://schemas.microsoft.com/office/powerpoint/2010/main" val="1279128368"/>
       </p:ext>
     </p:extLst>
   </p:cSld>
@@ -9061,7 +9061,7 @@
           <p:cNvPr id="2" name="TextBox 1">
             <a:extLst>
               <a:ext uri="{FF2B5EF4-FFF2-40B4-BE49-F238E27FC236}">
-                <a16:creationId xmlns:a16="http://schemas.microsoft.com/office/drawing/2014/main" id="{B172141F-A55A-78C9-9B68-9E010E34E22E}"/>
+                <a16:creationId xmlns:a16="http://schemas.microsoft.com/office/drawing/2014/main" id="{C2EA87D0-8F46-9CFC-0E09-484E6EB34327}"/>
               </a:ext>
             </a:extLst>
           </p:cNvPr>
@@ -9101,7 +9101,7 @@
           <p:cNvPr id="4" name="Рисунок 3">
             <a:extLst>
               <a:ext uri="{FF2B5EF4-FFF2-40B4-BE49-F238E27FC236}">
-                <a16:creationId xmlns:a16="http://schemas.microsoft.com/office/drawing/2014/main" id="{C3E57106-F1B8-1D5C-E9FA-3B80C335004C}"/>
+                <a16:creationId xmlns:a16="http://schemas.microsoft.com/office/drawing/2014/main" id="{0D9414A0-4858-CB5A-2219-009A525E70EA}"/>
               </a:ext>
             </a:extLst>
           </p:cNvPr>
@@ -9137,7 +9137,7 @@
           <p:cNvPr id="5" name="TextBox 4">
             <a:extLst>
               <a:ext uri="{FF2B5EF4-FFF2-40B4-BE49-F238E27FC236}">
-                <a16:creationId xmlns:a16="http://schemas.microsoft.com/office/drawing/2014/main" id="{633C3050-9D76-1D9B-C729-B030C914E7CB}"/>
+                <a16:creationId xmlns:a16="http://schemas.microsoft.com/office/drawing/2014/main" id="{875CC146-50CA-5C75-7D7A-9F0B39062EFE}"/>
               </a:ext>
             </a:extLst>
           </p:cNvPr>
@@ -9167,7 +9167,7 @@
                 </a:solidFill>
                 <a:latin typeface="Cambria" panose="02040503050406030204" pitchFamily="18" charset="0"/>
               </a:rPr>
-              <a:t>0.84</a:t>
+              <a:t>0.86</a:t>
             </a:r>
           </a:p>
         </p:txBody>
@@ -9177,7 +9177,7 @@
           <p:cNvPr id="6" name="TextBox 5">
             <a:extLst>
               <a:ext uri="{FF2B5EF4-FFF2-40B4-BE49-F238E27FC236}">
-                <a16:creationId xmlns:a16="http://schemas.microsoft.com/office/drawing/2014/main" id="{69AEA672-57DF-011C-296F-1A34DC10C7E1}"/>
+                <a16:creationId xmlns:a16="http://schemas.microsoft.com/office/drawing/2014/main" id="{0473BD30-AA4A-D88F-6329-B25608FEB75D}"/>
               </a:ext>
             </a:extLst>
           </p:cNvPr>
@@ -9218,7 +9218,7 @@
                 </a:solidFill>
                 <a:latin typeface="Calibri" panose="020F0502020204030204" pitchFamily="34" charset="0"/>
               </a:rPr>
-              <a:t>95% ДИ 0.77–0.90</a:t>
+              <a:t>95% ДИ 0.80–0.92</a:t>
             </a:r>
           </a:p>
         </p:txBody>
@@ -9228,7 +9228,7 @@
           <p:cNvPr id="7" name="TextBox 6">
             <a:extLst>
               <a:ext uri="{FF2B5EF4-FFF2-40B4-BE49-F238E27FC236}">
-                <a16:creationId xmlns:a16="http://schemas.microsoft.com/office/drawing/2014/main" id="{A959D060-D1C9-0AF1-2F86-5C8D47CE29CA}"/>
+                <a16:creationId xmlns:a16="http://schemas.microsoft.com/office/drawing/2014/main" id="{DA0F291F-10EF-7379-18E0-7EEA795BCDE5}"/>
               </a:ext>
             </a:extLst>
           </p:cNvPr>
@@ -9258,7 +9258,7 @@
                 </a:solidFill>
                 <a:latin typeface="Cambria" panose="02040503050406030204" pitchFamily="18" charset="0"/>
               </a:rPr>
-              <a:t>0.72</a:t>
+              <a:t>0.77</a:t>
             </a:r>
           </a:p>
         </p:txBody>
@@ -9268,7 +9268,7 @@
           <p:cNvPr id="8" name="TextBox 7">
             <a:extLst>
               <a:ext uri="{FF2B5EF4-FFF2-40B4-BE49-F238E27FC236}">
-                <a16:creationId xmlns:a16="http://schemas.microsoft.com/office/drawing/2014/main" id="{61F42176-D7E4-F2A4-7A16-196D2B7B7098}"/>
+                <a16:creationId xmlns:a16="http://schemas.microsoft.com/office/drawing/2014/main" id="{1294976A-CA09-9E06-C919-8250B4D6711C}"/>
               </a:ext>
             </a:extLst>
           </p:cNvPr>
@@ -9308,7 +9308,7 @@
           <p:cNvPr id="9" name="TextBox 8">
             <a:extLst>
               <a:ext uri="{FF2B5EF4-FFF2-40B4-BE49-F238E27FC236}">
-                <a16:creationId xmlns:a16="http://schemas.microsoft.com/office/drawing/2014/main" id="{03F04541-2D4E-6353-447E-E98B3961A700}"/>
+                <a16:creationId xmlns:a16="http://schemas.microsoft.com/office/drawing/2014/main" id="{EE615F86-60D3-6E8A-27C1-B35470504C50}"/>
               </a:ext>
             </a:extLst>
           </p:cNvPr>
@@ -9338,7 +9338,7 @@
                 </a:solidFill>
                 <a:latin typeface="Cambria" panose="02040503050406030204" pitchFamily="18" charset="0"/>
               </a:rPr>
-              <a:t>0.80</a:t>
+              <a:t>0.84</a:t>
             </a:r>
           </a:p>
         </p:txBody>
@@ -9348,7 +9348,7 @@
           <p:cNvPr id="10" name="TextBox 9">
             <a:extLst>
               <a:ext uri="{FF2B5EF4-FFF2-40B4-BE49-F238E27FC236}">
-                <a16:creationId xmlns:a16="http://schemas.microsoft.com/office/drawing/2014/main" id="{7828AC58-7721-4F82-A868-0A771EA551B2}"/>
+                <a16:creationId xmlns:a16="http://schemas.microsoft.com/office/drawing/2014/main" id="{E7EA8C7F-0784-9FB4-F5A7-797E1556DFA7}"/>
               </a:ext>
             </a:extLst>
           </p:cNvPr>
@@ -9388,7 +9388,7 @@
           <p:cNvPr id="11" name="TextBox 10">
             <a:extLst>
               <a:ext uri="{FF2B5EF4-FFF2-40B4-BE49-F238E27FC236}">
-                <a16:creationId xmlns:a16="http://schemas.microsoft.com/office/drawing/2014/main" id="{3F3FD2FE-1AB0-CBCD-DDE7-F712A15C8CB4}"/>
+                <a16:creationId xmlns:a16="http://schemas.microsoft.com/office/drawing/2014/main" id="{6B5DE603-E244-A8EC-C0CF-B2724BB54958}"/>
               </a:ext>
             </a:extLst>
           </p:cNvPr>
@@ -9418,7 +9418,7 @@
                 </a:solidFill>
                 <a:latin typeface="Cambria" panose="02040503050406030204" pitchFamily="18" charset="0"/>
               </a:rPr>
-              <a:t>0.75</a:t>
+              <a:t>0.78</a:t>
             </a:r>
           </a:p>
         </p:txBody>
@@ -9428,7 +9428,7 @@
           <p:cNvPr id="12" name="TextBox 11">
             <a:extLst>
               <a:ext uri="{FF2B5EF4-FFF2-40B4-BE49-F238E27FC236}">
-                <a16:creationId xmlns:a16="http://schemas.microsoft.com/office/drawing/2014/main" id="{BB21D9F1-A21B-88A9-36E5-D06AC353145B}"/>
+                <a16:creationId xmlns:a16="http://schemas.microsoft.com/office/drawing/2014/main" id="{65480989-402D-5F18-FD5B-3E1DD2660FC8}"/>
               </a:ext>
             </a:extLst>
           </p:cNvPr>
@@ -9468,7 +9468,7 @@
           <p:cNvPr id="13" name="TextBox 12">
             <a:extLst>
               <a:ext uri="{FF2B5EF4-FFF2-40B4-BE49-F238E27FC236}">
-                <a16:creationId xmlns:a16="http://schemas.microsoft.com/office/drawing/2014/main" id="{91F5EF43-2155-A856-C937-95D4C29D927A}"/>
+                <a16:creationId xmlns:a16="http://schemas.microsoft.com/office/drawing/2014/main" id="{21208D4E-5EA3-AEFE-3021-25B0089FEFF3}"/>
               </a:ext>
             </a:extLst>
           </p:cNvPr>
@@ -9506,7 +9506,7 @@
     </p:spTree>
     <p:extLst>
       <p:ext uri="{BB962C8B-B14F-4D97-AF65-F5344CB8AC3E}">
-        <p14:creationId xmlns:p14="http://schemas.microsoft.com/office/powerpoint/2010/main" val="2903100853"/>
+        <p14:creationId xmlns:p14="http://schemas.microsoft.com/office/powerpoint/2010/main" val="1664137103"/>
       </p:ext>
     </p:extLst>
   </p:cSld>
@@ -9546,7 +9546,7 @@
           <p:cNvPr id="2" name="TextBox 1">
             <a:extLst>
               <a:ext uri="{FF2B5EF4-FFF2-40B4-BE49-F238E27FC236}">
-                <a16:creationId xmlns:a16="http://schemas.microsoft.com/office/drawing/2014/main" id="{AD63DD1D-0B4B-B4BD-2B88-38A04455557D}"/>
+                <a16:creationId xmlns:a16="http://schemas.microsoft.com/office/drawing/2014/main" id="{12CFA246-10E7-AC12-29BC-82F5FC380339}"/>
               </a:ext>
             </a:extLst>
           </p:cNvPr>
@@ -9586,7 +9586,7 @@
           <p:cNvPr id="4" name="Рисунок 3">
             <a:extLst>
               <a:ext uri="{FF2B5EF4-FFF2-40B4-BE49-F238E27FC236}">
-                <a16:creationId xmlns:a16="http://schemas.microsoft.com/office/drawing/2014/main" id="{B189DCE6-FFE7-CDE9-BBCE-1EBADA10D4CC}"/>
+                <a16:creationId xmlns:a16="http://schemas.microsoft.com/office/drawing/2014/main" id="{159C008E-0468-AADF-38B5-5359B9E43AB9}"/>
               </a:ext>
             </a:extLst>
           </p:cNvPr>
@@ -9622,7 +9622,7 @@
           <p:cNvPr id="5" name="TextBox 4">
             <a:extLst>
               <a:ext uri="{FF2B5EF4-FFF2-40B4-BE49-F238E27FC236}">
-                <a16:creationId xmlns:a16="http://schemas.microsoft.com/office/drawing/2014/main" id="{9652660E-66CD-7ED5-0624-5040DE5936C7}"/>
+                <a16:creationId xmlns:a16="http://schemas.microsoft.com/office/drawing/2014/main" id="{29DA28FA-ED18-F5B6-0925-91D635674D80}"/>
               </a:ext>
             </a:extLst>
           </p:cNvPr>
@@ -9652,7 +9652,7 @@
                 </a:solidFill>
                 <a:latin typeface="Cambria" panose="02040503050406030204" pitchFamily="18" charset="0"/>
               </a:rPr>
-              <a:t>0.78</a:t>
+              <a:t>0.87</a:t>
             </a:r>
           </a:p>
         </p:txBody>
@@ -9662,7 +9662,7 @@
           <p:cNvPr id="6" name="TextBox 5">
             <a:extLst>
               <a:ext uri="{FF2B5EF4-FFF2-40B4-BE49-F238E27FC236}">
-                <a16:creationId xmlns:a16="http://schemas.microsoft.com/office/drawing/2014/main" id="{95BC8E1E-AAFB-B1B3-038A-0E11699281B5}"/>
+                <a16:creationId xmlns:a16="http://schemas.microsoft.com/office/drawing/2014/main" id="{520A6AE5-06D9-D721-591B-0BD2929A58BE}"/>
               </a:ext>
             </a:extLst>
           </p:cNvPr>
@@ -9702,7 +9702,7 @@
           <p:cNvPr id="7" name="TextBox 6">
             <a:extLst>
               <a:ext uri="{FF2B5EF4-FFF2-40B4-BE49-F238E27FC236}">
-                <a16:creationId xmlns:a16="http://schemas.microsoft.com/office/drawing/2014/main" id="{99C89259-94C3-0EAC-7490-438A512ABA93}"/>
+                <a16:creationId xmlns:a16="http://schemas.microsoft.com/office/drawing/2014/main" id="{495C5F56-238C-248C-9555-F970AE93B305}"/>
               </a:ext>
             </a:extLst>
           </p:cNvPr>
@@ -9732,7 +9732,7 @@
                 </a:solidFill>
                 <a:latin typeface="Cambria" panose="02040503050406030204" pitchFamily="18" charset="0"/>
               </a:rPr>
-              <a:t>0.58</a:t>
+              <a:t>0.61</a:t>
             </a:r>
           </a:p>
         </p:txBody>
@@ -9742,7 +9742,7 @@
           <p:cNvPr id="8" name="TextBox 7">
             <a:extLst>
               <a:ext uri="{FF2B5EF4-FFF2-40B4-BE49-F238E27FC236}">
-                <a16:creationId xmlns:a16="http://schemas.microsoft.com/office/drawing/2014/main" id="{6F4560A5-BD46-21BF-5EC3-72844865B03B}"/>
+                <a16:creationId xmlns:a16="http://schemas.microsoft.com/office/drawing/2014/main" id="{2C10C1FD-B1A0-A67A-9314-F70C812480A2}"/>
               </a:ext>
             </a:extLst>
           </p:cNvPr>
@@ -9782,7 +9782,7 @@
           <p:cNvPr id="9" name="TextBox 8">
             <a:extLst>
               <a:ext uri="{FF2B5EF4-FFF2-40B4-BE49-F238E27FC236}">
-                <a16:creationId xmlns:a16="http://schemas.microsoft.com/office/drawing/2014/main" id="{DE1C54CB-B581-FE30-5B9E-76F49CEADBC8}"/>
+                <a16:creationId xmlns:a16="http://schemas.microsoft.com/office/drawing/2014/main" id="{5B643B4E-400B-DC05-2E64-A3C3142DDA49}"/>
               </a:ext>
             </a:extLst>
           </p:cNvPr>
@@ -9812,7 +9812,7 @@
                 </a:solidFill>
                 <a:latin typeface="Calibri" panose="020F0502020204030204" pitchFamily="34" charset="0"/>
               </a:rPr>
-              <a:t>Ложноположительные — с сохранной затылочной альфой: пожилые с «молодой» ЭЭГ и соматоформные, клинически близкие к ПТСР (тревога, соматическое возбуждение, травматический опыт).</a:t>
+              <a:t>У ПТСР и соматоформных общий профиль гипервозбуждения (плоский спектр и бета на T4). Ложноположительные — с сохранной затылочной альфой.</a:t>
             </a:r>
           </a:p>
         </p:txBody>
@@ -9820,7 +9820,7 @@
     </p:spTree>
     <p:extLst>
       <p:ext uri="{BB962C8B-B14F-4D97-AF65-F5344CB8AC3E}">
-        <p14:creationId xmlns:p14="http://schemas.microsoft.com/office/powerpoint/2010/main" val="243501477"/>
+        <p14:creationId xmlns:p14="http://schemas.microsoft.com/office/powerpoint/2010/main" val="1757457552"/>
       </p:ext>
     </p:extLst>
   </p:cSld>
@@ -9860,7 +9860,7 @@
           <p:cNvPr id="2" name="TextBox 1">
             <a:extLst>
               <a:ext uri="{FF2B5EF4-FFF2-40B4-BE49-F238E27FC236}">
-                <a16:creationId xmlns:a16="http://schemas.microsoft.com/office/drawing/2014/main" id="{0694D0A3-6B21-CA25-5E2E-00F699B432EB}"/>
+                <a16:creationId xmlns:a16="http://schemas.microsoft.com/office/drawing/2014/main" id="{1BD9469E-3A01-6D70-7083-BF498AB4CEBB}"/>
               </a:ext>
             </a:extLst>
           </p:cNvPr>
@@ -9900,7 +9900,7 @@
           <p:cNvPr id="4" name="Рисунок 3">
             <a:extLst>
               <a:ext uri="{FF2B5EF4-FFF2-40B4-BE49-F238E27FC236}">
-                <a16:creationId xmlns:a16="http://schemas.microsoft.com/office/drawing/2014/main" id="{255EBAB1-64B5-ADBD-5A27-E200889DAF5D}"/>
+                <a16:creationId xmlns:a16="http://schemas.microsoft.com/office/drawing/2014/main" id="{414790AD-2E5E-32FA-FC27-21647E5012D1}"/>
               </a:ext>
             </a:extLst>
           </p:cNvPr>
@@ -9936,7 +9936,7 @@
           <p:cNvPr id="5" name="Прямоугольник: скругленные углы 4">
             <a:extLst>
               <a:ext uri="{FF2B5EF4-FFF2-40B4-BE49-F238E27FC236}">
-                <a16:creationId xmlns:a16="http://schemas.microsoft.com/office/drawing/2014/main" id="{BD121533-B0BB-9A73-0811-E8D6CE1C969F}"/>
+                <a16:creationId xmlns:a16="http://schemas.microsoft.com/office/drawing/2014/main" id="{6EBDCEE1-D8D3-8BCF-6C6B-93B31A4DF08D}"/>
               </a:ext>
             </a:extLst>
           </p:cNvPr>
@@ -10006,7 +10006,7 @@
           <p:cNvPr id="6" name="Овал 5">
             <a:extLst>
               <a:ext uri="{FF2B5EF4-FFF2-40B4-BE49-F238E27FC236}">
-                <a16:creationId xmlns:a16="http://schemas.microsoft.com/office/drawing/2014/main" id="{88AD946F-CE71-BF85-29B7-51898A1B974B}"/>
+                <a16:creationId xmlns:a16="http://schemas.microsoft.com/office/drawing/2014/main" id="{E9EA9062-79B1-5B07-314B-53C29ADB376C}"/>
               </a:ext>
             </a:extLst>
           </p:cNvPr>
@@ -10082,7 +10082,7 @@
           <p:cNvPr id="7" name="TextBox 6">
             <a:extLst>
               <a:ext uri="{FF2B5EF4-FFF2-40B4-BE49-F238E27FC236}">
-                <a16:creationId xmlns:a16="http://schemas.microsoft.com/office/drawing/2014/main" id="{0AE47274-99B4-9E86-F074-95150193C6D2}"/>
+                <a16:creationId xmlns:a16="http://schemas.microsoft.com/office/drawing/2014/main" id="{D4C28F4C-88FE-1FA4-B9F0-AD4B0B0385C9}"/>
               </a:ext>
             </a:extLst>
           </p:cNvPr>
@@ -10122,7 +10122,7 @@
           <p:cNvPr id="8" name="TextBox 7">
             <a:extLst>
               <a:ext uri="{FF2B5EF4-FFF2-40B4-BE49-F238E27FC236}">
-                <a16:creationId xmlns:a16="http://schemas.microsoft.com/office/drawing/2014/main" id="{E8FAB439-299F-52E7-6F14-2B41BE037C0D}"/>
+                <a16:creationId xmlns:a16="http://schemas.microsoft.com/office/drawing/2014/main" id="{6BDE16D3-25A3-EECF-CB0C-6E29A428CBE5}"/>
               </a:ext>
             </a:extLst>
           </p:cNvPr>
@@ -10152,7 +10152,7 @@
                 </a:solidFill>
                 <a:latin typeface="Calibri" panose="020F0502020204030204" pitchFamily="34" charset="0"/>
               </a:rPr>
-              <a:t>внутри формата B AUC 0.81, метаданные — 0.00</a:t>
+              <a:t>внутри формата B AUC 0.84, метаданные — 0.00</a:t>
             </a:r>
           </a:p>
         </p:txBody>
@@ -10162,7 +10162,7 @@
           <p:cNvPr id="9" name="Прямоугольник: скругленные углы 8">
             <a:extLst>
               <a:ext uri="{FF2B5EF4-FFF2-40B4-BE49-F238E27FC236}">
-                <a16:creationId xmlns:a16="http://schemas.microsoft.com/office/drawing/2014/main" id="{3D8CE068-E3A0-D663-773B-A1E9321145EE}"/>
+                <a16:creationId xmlns:a16="http://schemas.microsoft.com/office/drawing/2014/main" id="{36B70634-741B-FB96-1D22-7323F8A6A702}"/>
               </a:ext>
             </a:extLst>
           </p:cNvPr>
@@ -10232,7 +10232,7 @@
           <p:cNvPr id="10" name="Овал 9">
             <a:extLst>
               <a:ext uri="{FF2B5EF4-FFF2-40B4-BE49-F238E27FC236}">
-                <a16:creationId xmlns:a16="http://schemas.microsoft.com/office/drawing/2014/main" id="{D4E15115-07F5-B16D-1ECA-0FDB0A81E0A1}"/>
+                <a16:creationId xmlns:a16="http://schemas.microsoft.com/office/drawing/2014/main" id="{9F7BFFF8-A063-7193-9959-B98509320DB3}"/>
               </a:ext>
             </a:extLst>
           </p:cNvPr>
@@ -10308,7 +10308,7 @@
           <p:cNvPr id="11" name="TextBox 10">
             <a:extLst>
               <a:ext uri="{FF2B5EF4-FFF2-40B4-BE49-F238E27FC236}">
-                <a16:creationId xmlns:a16="http://schemas.microsoft.com/office/drawing/2014/main" id="{88988CC7-74D3-1CC9-7E9D-C8A5B4AB27B2}"/>
+                <a16:creationId xmlns:a16="http://schemas.microsoft.com/office/drawing/2014/main" id="{42F9E6F8-AA5B-919F-576E-3D05145829F2}"/>
               </a:ext>
             </a:extLst>
           </p:cNvPr>
@@ -10348,7 +10348,7 @@
           <p:cNvPr id="12" name="TextBox 11">
             <a:extLst>
               <a:ext uri="{FF2B5EF4-FFF2-40B4-BE49-F238E27FC236}">
-                <a16:creationId xmlns:a16="http://schemas.microsoft.com/office/drawing/2014/main" id="{0E80D0F7-7F97-8CCC-04E3-B55ABB0AC9CA}"/>
+                <a16:creationId xmlns:a16="http://schemas.microsoft.com/office/drawing/2014/main" id="{50F32243-4EBB-0AE6-0BD0-3D5A79796215}"/>
               </a:ext>
             </a:extLst>
           </p:cNvPr>
@@ -10388,7 +10388,7 @@
           <p:cNvPr id="13" name="Прямоугольник: скругленные углы 12">
             <a:extLst>
               <a:ext uri="{FF2B5EF4-FFF2-40B4-BE49-F238E27FC236}">
-                <a16:creationId xmlns:a16="http://schemas.microsoft.com/office/drawing/2014/main" id="{15FE76F8-329C-6563-2C0D-D583C867E5AA}"/>
+                <a16:creationId xmlns:a16="http://schemas.microsoft.com/office/drawing/2014/main" id="{91B1E37B-F10D-A41E-B3BD-4D713C4F4BE7}"/>
               </a:ext>
             </a:extLst>
           </p:cNvPr>
@@ -10458,7 +10458,7 @@
           <p:cNvPr id="14" name="Овал 13">
             <a:extLst>
               <a:ext uri="{FF2B5EF4-FFF2-40B4-BE49-F238E27FC236}">
-                <a16:creationId xmlns:a16="http://schemas.microsoft.com/office/drawing/2014/main" id="{928801FC-4FB5-8B57-2498-C4BF98EC3D08}"/>
+                <a16:creationId xmlns:a16="http://schemas.microsoft.com/office/drawing/2014/main" id="{EA1DC2E5-E0DA-4A5B-1018-3DE3125270BD}"/>
               </a:ext>
             </a:extLst>
           </p:cNvPr>
@@ -10534,7 +10534,7 @@
           <p:cNvPr id="15" name="TextBox 14">
             <a:extLst>
               <a:ext uri="{FF2B5EF4-FFF2-40B4-BE49-F238E27FC236}">
-                <a16:creationId xmlns:a16="http://schemas.microsoft.com/office/drawing/2014/main" id="{F578FEBB-D4B8-A780-2481-0E17F60DA47E}"/>
+                <a16:creationId xmlns:a16="http://schemas.microsoft.com/office/drawing/2014/main" id="{12E4839C-2C91-302D-5ACD-9CE36A92B4CC}"/>
               </a:ext>
             </a:extLst>
           </p:cNvPr>
@@ -10574,7 +10574,7 @@
           <p:cNvPr id="16" name="TextBox 15">
             <a:extLst>
               <a:ext uri="{FF2B5EF4-FFF2-40B4-BE49-F238E27FC236}">
-                <a16:creationId xmlns:a16="http://schemas.microsoft.com/office/drawing/2014/main" id="{FD1A6829-735B-C203-B8B4-7B3F973C2404}"/>
+                <a16:creationId xmlns:a16="http://schemas.microsoft.com/office/drawing/2014/main" id="{E8A60354-1993-363E-291D-36FF4993F72B}"/>
               </a:ext>
             </a:extLst>
           </p:cNvPr>
@@ -10614,7 +10614,7 @@
           <p:cNvPr id="17" name="Прямоугольник: скругленные углы 16">
             <a:extLst>
               <a:ext uri="{FF2B5EF4-FFF2-40B4-BE49-F238E27FC236}">
-                <a16:creationId xmlns:a16="http://schemas.microsoft.com/office/drawing/2014/main" id="{209812AB-3AF7-3122-F4C4-E9DD66967E4B}"/>
+                <a16:creationId xmlns:a16="http://schemas.microsoft.com/office/drawing/2014/main" id="{D53DAAD4-563B-634B-BE6B-C110EA6DFBBF}"/>
               </a:ext>
             </a:extLst>
           </p:cNvPr>
@@ -10684,7 +10684,7 @@
           <p:cNvPr id="18" name="Овал 17">
             <a:extLst>
               <a:ext uri="{FF2B5EF4-FFF2-40B4-BE49-F238E27FC236}">
-                <a16:creationId xmlns:a16="http://schemas.microsoft.com/office/drawing/2014/main" id="{29662F62-5C86-FDDD-BF09-355FF5844D06}"/>
+                <a16:creationId xmlns:a16="http://schemas.microsoft.com/office/drawing/2014/main" id="{66359C7B-4FFC-CC24-4543-74A20175D946}"/>
               </a:ext>
             </a:extLst>
           </p:cNvPr>
@@ -10760,7 +10760,7 @@
           <p:cNvPr id="19" name="TextBox 18">
             <a:extLst>
               <a:ext uri="{FF2B5EF4-FFF2-40B4-BE49-F238E27FC236}">
-                <a16:creationId xmlns:a16="http://schemas.microsoft.com/office/drawing/2014/main" id="{8245C4F5-558B-3E5A-C0FF-B696F25B6308}"/>
+                <a16:creationId xmlns:a16="http://schemas.microsoft.com/office/drawing/2014/main" id="{EBCD0A92-25DF-A1AE-4845-5CF55FE004BA}"/>
               </a:ext>
             </a:extLst>
           </p:cNvPr>
@@ -10800,7 +10800,7 @@
           <p:cNvPr id="20" name="TextBox 19">
             <a:extLst>
               <a:ext uri="{FF2B5EF4-FFF2-40B4-BE49-F238E27FC236}">
-                <a16:creationId xmlns:a16="http://schemas.microsoft.com/office/drawing/2014/main" id="{1CCB0068-B2A2-3D66-25FD-5223B2683DD4}"/>
+                <a16:creationId xmlns:a16="http://schemas.microsoft.com/office/drawing/2014/main" id="{CF9521BE-30D1-4AFC-CB64-CAB328D633CB}"/>
               </a:ext>
             </a:extLst>
           </p:cNvPr>
@@ -10840,7 +10840,7 @@
           <p:cNvPr id="21" name="Прямоугольник: скругленные углы 20">
             <a:extLst>
               <a:ext uri="{FF2B5EF4-FFF2-40B4-BE49-F238E27FC236}">
-                <a16:creationId xmlns:a16="http://schemas.microsoft.com/office/drawing/2014/main" id="{B8DC24ED-845C-CEE2-B826-115612D92D16}"/>
+                <a16:creationId xmlns:a16="http://schemas.microsoft.com/office/drawing/2014/main" id="{9AFCA15C-8B26-6BB5-0367-2498F75CAC36}"/>
               </a:ext>
             </a:extLst>
           </p:cNvPr>
@@ -10910,7 +10910,7 @@
           <p:cNvPr id="22" name="Овал 21">
             <a:extLst>
               <a:ext uri="{FF2B5EF4-FFF2-40B4-BE49-F238E27FC236}">
-                <a16:creationId xmlns:a16="http://schemas.microsoft.com/office/drawing/2014/main" id="{B818A5D8-7B30-1AAF-CB47-E0545297126E}"/>
+                <a16:creationId xmlns:a16="http://schemas.microsoft.com/office/drawing/2014/main" id="{5B8E6471-198B-D2EB-A2C1-F9AEFCDF2548}"/>
               </a:ext>
             </a:extLst>
           </p:cNvPr>
@@ -10986,7 +10986,7 @@
           <p:cNvPr id="23" name="TextBox 22">
             <a:extLst>
               <a:ext uri="{FF2B5EF4-FFF2-40B4-BE49-F238E27FC236}">
-                <a16:creationId xmlns:a16="http://schemas.microsoft.com/office/drawing/2014/main" id="{5441341F-C7BC-70A8-3887-AC2057AB4573}"/>
+                <a16:creationId xmlns:a16="http://schemas.microsoft.com/office/drawing/2014/main" id="{FCAF8B7D-1EF4-45BD-6680-86DAEE2ACF1F}"/>
               </a:ext>
             </a:extLst>
           </p:cNvPr>
@@ -11026,7 +11026,7 @@
           <p:cNvPr id="24" name="TextBox 23">
             <a:extLst>
               <a:ext uri="{FF2B5EF4-FFF2-40B4-BE49-F238E27FC236}">
-                <a16:creationId xmlns:a16="http://schemas.microsoft.com/office/drawing/2014/main" id="{2021B347-BF28-B0E0-0037-BA94CC5F9B75}"/>
+                <a16:creationId xmlns:a16="http://schemas.microsoft.com/office/drawing/2014/main" id="{CAFF39E6-834C-EB87-0BE1-48EFE4F757CA}"/>
               </a:ext>
             </a:extLst>
           </p:cNvPr>
@@ -11056,7 +11056,7 @@
                 </a:solidFill>
                 <a:latin typeface="Calibri" panose="020F0502020204030204" pitchFamily="34" charset="0"/>
               </a:rPr>
-              <a:t>без T3/T4 AUC против молодых норм A/B — 0.56</a:t>
+              <a:t>без T3/T4 AUC против молодых норм A/B — 0.57</a:t>
             </a:r>
           </a:p>
         </p:txBody>
@@ -11064,7 +11064,7 @@
     </p:spTree>
     <p:extLst>
       <p:ext uri="{BB962C8B-B14F-4D97-AF65-F5344CB8AC3E}">
-        <p14:creationId xmlns:p14="http://schemas.microsoft.com/office/powerpoint/2010/main" val="1476942790"/>
+        <p14:creationId xmlns:p14="http://schemas.microsoft.com/office/powerpoint/2010/main" val="2743965295"/>
       </p:ext>
     </p:extLst>
   </p:cSld>
@@ -11104,7 +11104,7 @@
           <p:cNvPr id="2" name="TextBox 1">
             <a:extLst>
               <a:ext uri="{FF2B5EF4-FFF2-40B4-BE49-F238E27FC236}">
-                <a16:creationId xmlns:a16="http://schemas.microsoft.com/office/drawing/2014/main" id="{00BABDC2-E1A7-2407-822A-ED080CCC47A3}"/>
+                <a16:creationId xmlns:a16="http://schemas.microsoft.com/office/drawing/2014/main" id="{0096AF09-E522-3967-2604-A13F6CA582CB}"/>
               </a:ext>
             </a:extLst>
           </p:cNvPr>
@@ -11144,7 +11144,7 @@
           <p:cNvPr id="4" name="Рисунок 3">
             <a:extLst>
               <a:ext uri="{FF2B5EF4-FFF2-40B4-BE49-F238E27FC236}">
-                <a16:creationId xmlns:a16="http://schemas.microsoft.com/office/drawing/2014/main" id="{215FCE7E-15DB-B28F-8A4C-7EBC79B6240C}"/>
+                <a16:creationId xmlns:a16="http://schemas.microsoft.com/office/drawing/2014/main" id="{E1710C39-3149-002B-D6F6-512156D6C266}"/>
               </a:ext>
             </a:extLst>
           </p:cNvPr>
@@ -11180,7 +11180,7 @@
           <p:cNvPr id="5" name="TextBox 4">
             <a:extLst>
               <a:ext uri="{FF2B5EF4-FFF2-40B4-BE49-F238E27FC236}">
-                <a16:creationId xmlns:a16="http://schemas.microsoft.com/office/drawing/2014/main" id="{BAEE2F8C-61C5-BA16-B345-81DC63581F4F}"/>
+                <a16:creationId xmlns:a16="http://schemas.microsoft.com/office/drawing/2014/main" id="{25AC2071-CF94-1E0E-25AC-7ADA22689DEE}"/>
               </a:ext>
             </a:extLst>
           </p:cNvPr>
@@ -11220,7 +11220,7 @@
           <p:cNvPr id="6" name="TextBox 5">
             <a:extLst>
               <a:ext uri="{FF2B5EF4-FFF2-40B4-BE49-F238E27FC236}">
-                <a16:creationId xmlns:a16="http://schemas.microsoft.com/office/drawing/2014/main" id="{16896D81-1CC6-0533-AC5E-3088888887BA}"/>
+                <a16:creationId xmlns:a16="http://schemas.microsoft.com/office/drawing/2014/main" id="{A7C2BB25-408A-A754-F84A-01183FC144D9}"/>
               </a:ext>
             </a:extLst>
           </p:cNvPr>
@@ -11260,7 +11260,7 @@
           <p:cNvPr id="7" name="TextBox 6">
             <a:extLst>
               <a:ext uri="{FF2B5EF4-FFF2-40B4-BE49-F238E27FC236}">
-                <a16:creationId xmlns:a16="http://schemas.microsoft.com/office/drawing/2014/main" id="{9FE03F80-BAF9-7619-960D-6AAFE1A60676}"/>
+                <a16:creationId xmlns:a16="http://schemas.microsoft.com/office/drawing/2014/main" id="{D8361DF6-D13E-631C-54AD-BD98EB8C6214}"/>
               </a:ext>
             </a:extLst>
           </p:cNvPr>
@@ -11341,7 +11341,7 @@
     </p:spTree>
     <p:extLst>
       <p:ext uri="{BB962C8B-B14F-4D97-AF65-F5344CB8AC3E}">
-        <p14:creationId xmlns:p14="http://schemas.microsoft.com/office/powerpoint/2010/main" val="1886804134"/>
+        <p14:creationId xmlns:p14="http://schemas.microsoft.com/office/powerpoint/2010/main" val="269269110"/>
       </p:ext>
     </p:extLst>
   </p:cSld>
@@ -11381,7 +11381,7 @@
           <p:cNvPr id="2" name="TextBox 1">
             <a:extLst>
               <a:ext uri="{FF2B5EF4-FFF2-40B4-BE49-F238E27FC236}">
-                <a16:creationId xmlns:a16="http://schemas.microsoft.com/office/drawing/2014/main" id="{E3C83EDD-4FD9-B29B-C199-201E3C650DBB}"/>
+                <a16:creationId xmlns:a16="http://schemas.microsoft.com/office/drawing/2014/main" id="{7C4E9B1E-F13E-9311-DEB6-5F3AA3C38032}"/>
               </a:ext>
             </a:extLst>
           </p:cNvPr>
@@ -11421,7 +11421,7 @@
           <p:cNvPr id="4" name="Рисунок 3">
             <a:extLst>
               <a:ext uri="{FF2B5EF4-FFF2-40B4-BE49-F238E27FC236}">
-                <a16:creationId xmlns:a16="http://schemas.microsoft.com/office/drawing/2014/main" id="{2DD2E64C-FD71-D3E1-4418-64C247209D0B}"/>
+                <a16:creationId xmlns:a16="http://schemas.microsoft.com/office/drawing/2014/main" id="{A09D16C8-7A93-7781-7562-FC0F4FA26CA3}"/>
               </a:ext>
             </a:extLst>
           </p:cNvPr>
@@ -11457,7 +11457,7 @@
           <p:cNvPr id="5" name="Прямоугольник: скругленные углы 4">
             <a:extLst>
               <a:ext uri="{FF2B5EF4-FFF2-40B4-BE49-F238E27FC236}">
-                <a16:creationId xmlns:a16="http://schemas.microsoft.com/office/drawing/2014/main" id="{0B51D627-44B5-8DFE-E4AB-459F737C5CF6}"/>
+                <a16:creationId xmlns:a16="http://schemas.microsoft.com/office/drawing/2014/main" id="{D38AECE2-ED14-AF99-4F28-1B80B7CAAB88}"/>
               </a:ext>
             </a:extLst>
           </p:cNvPr>
@@ -11527,7 +11527,7 @@
           <p:cNvPr id="6" name="Прямоугольник: скругленные углы 5">
             <a:extLst>
               <a:ext uri="{FF2B5EF4-FFF2-40B4-BE49-F238E27FC236}">
-                <a16:creationId xmlns:a16="http://schemas.microsoft.com/office/drawing/2014/main" id="{29383A25-886D-D052-6955-5A6F4E3F45AF}"/>
+                <a16:creationId xmlns:a16="http://schemas.microsoft.com/office/drawing/2014/main" id="{2BD967AC-8AC7-EE29-24A9-8C5A9D8A4E40}"/>
               </a:ext>
             </a:extLst>
           </p:cNvPr>
@@ -11605,7 +11605,7 @@
           <p:cNvPr id="7" name="TextBox 6">
             <a:extLst>
               <a:ext uri="{FF2B5EF4-FFF2-40B4-BE49-F238E27FC236}">
-                <a16:creationId xmlns:a16="http://schemas.microsoft.com/office/drawing/2014/main" id="{8F130C6D-5304-BECA-C487-A5D8A6E590D5}"/>
+                <a16:creationId xmlns:a16="http://schemas.microsoft.com/office/drawing/2014/main" id="{22EDF930-C836-23AA-A2D9-4BD04E7F289F}"/>
               </a:ext>
             </a:extLst>
           </p:cNvPr>
@@ -11645,7 +11645,7 @@
           <p:cNvPr id="8" name="Прямоугольник: скругленные углы 7">
             <a:extLst>
               <a:ext uri="{FF2B5EF4-FFF2-40B4-BE49-F238E27FC236}">
-                <a16:creationId xmlns:a16="http://schemas.microsoft.com/office/drawing/2014/main" id="{9D6573A0-9D50-1B33-ACEA-A22E3198B883}"/>
+                <a16:creationId xmlns:a16="http://schemas.microsoft.com/office/drawing/2014/main" id="{DDB8E5AE-5847-9A1F-FD14-FCB9D7669EEA}"/>
               </a:ext>
             </a:extLst>
           </p:cNvPr>
@@ -11715,7 +11715,7 @@
           <p:cNvPr id="9" name="Прямоугольник: скругленные углы 8">
             <a:extLst>
               <a:ext uri="{FF2B5EF4-FFF2-40B4-BE49-F238E27FC236}">
-                <a16:creationId xmlns:a16="http://schemas.microsoft.com/office/drawing/2014/main" id="{0F7C75D0-9BD8-57C4-B50D-9C6205DD30BF}"/>
+                <a16:creationId xmlns:a16="http://schemas.microsoft.com/office/drawing/2014/main" id="{EDEEE039-3E28-7122-251B-E0139FAA6248}"/>
               </a:ext>
             </a:extLst>
           </p:cNvPr>
@@ -11793,7 +11793,7 @@
           <p:cNvPr id="10" name="TextBox 9">
             <a:extLst>
               <a:ext uri="{FF2B5EF4-FFF2-40B4-BE49-F238E27FC236}">
-                <a16:creationId xmlns:a16="http://schemas.microsoft.com/office/drawing/2014/main" id="{A33B1F36-B8A2-B59E-F211-8CF6AC8D22D5}"/>
+                <a16:creationId xmlns:a16="http://schemas.microsoft.com/office/drawing/2014/main" id="{E18C885D-9A1C-C235-49C6-63F8B757B327}"/>
               </a:ext>
             </a:extLst>
           </p:cNvPr>
@@ -11833,7 +11833,7 @@
           <p:cNvPr id="11" name="Прямоугольник: скругленные углы 10">
             <a:extLst>
               <a:ext uri="{FF2B5EF4-FFF2-40B4-BE49-F238E27FC236}">
-                <a16:creationId xmlns:a16="http://schemas.microsoft.com/office/drawing/2014/main" id="{A17C5310-D5E2-BE96-147D-BE26578988E2}"/>
+                <a16:creationId xmlns:a16="http://schemas.microsoft.com/office/drawing/2014/main" id="{C5A148AF-F535-DD98-48D6-8D6A852B4D05}"/>
               </a:ext>
             </a:extLst>
           </p:cNvPr>
@@ -11903,7 +11903,7 @@
           <p:cNvPr id="12" name="Прямоугольник: скругленные углы 11">
             <a:extLst>
               <a:ext uri="{FF2B5EF4-FFF2-40B4-BE49-F238E27FC236}">
-                <a16:creationId xmlns:a16="http://schemas.microsoft.com/office/drawing/2014/main" id="{00F11BCB-F4AE-DEAF-059C-9ED19A182959}"/>
+                <a16:creationId xmlns:a16="http://schemas.microsoft.com/office/drawing/2014/main" id="{B643183E-8E4F-D7FC-C693-FF7C2F8A3F29}"/>
               </a:ext>
             </a:extLst>
           </p:cNvPr>
@@ -11981,7 +11981,7 @@
           <p:cNvPr id="13" name="TextBox 12">
             <a:extLst>
               <a:ext uri="{FF2B5EF4-FFF2-40B4-BE49-F238E27FC236}">
-                <a16:creationId xmlns:a16="http://schemas.microsoft.com/office/drawing/2014/main" id="{BD20E54A-44C0-001C-D999-E555CF5B9746}"/>
+                <a16:creationId xmlns:a16="http://schemas.microsoft.com/office/drawing/2014/main" id="{BC4B38BF-36A8-6934-E920-1C8844275001}"/>
               </a:ext>
             </a:extLst>
           </p:cNvPr>
@@ -12019,7 +12019,7 @@
     </p:spTree>
     <p:extLst>
       <p:ext uri="{BB962C8B-B14F-4D97-AF65-F5344CB8AC3E}">
-        <p14:creationId xmlns:p14="http://schemas.microsoft.com/office/powerpoint/2010/main" val="3724007744"/>
+        <p14:creationId xmlns:p14="http://schemas.microsoft.com/office/powerpoint/2010/main" val="2018637725"/>
       </p:ext>
     </p:extLst>
   </p:cSld>

</xml_diff>

<commit_message>
docs: rebuild report and slides
</commit_message>
<xml_diff>
--- a/report/presentation.pptx
+++ b/report/presentation.pptx
@@ -200,7 +200,7 @@
             </a:lvl1pPr>
           </a:lstStyle>
           <a:p>
-            <a:fld id="{97AA1972-85C6-46E6-BCDC-0D282712E8F4}" type="datetimeFigureOut">
+            <a:fld id="{D01E26FC-69FF-4BCD-B43C-1CAF476BDC61}" type="datetimeFigureOut">
               <a:rPr lang="ru-RU" smtClean="0"/>
               <a:t>27.09.2026</a:t>
             </a:fld>
@@ -358,7 +358,7 @@
             </a:lvl1pPr>
           </a:lstStyle>
           <a:p>
-            <a:fld id="{2B0A806C-E4AA-4014-807C-EBAD5FEA3779}" type="slidenum">
+            <a:fld id="{89997A01-E33E-495B-A415-C74D1A0E1274}" type="slidenum">
               <a:rPr lang="ru-RU" smtClean="0"/>
               <a:t>‹#›</a:t>
             </a:fld>
@@ -369,7 +369,7 @@
     </p:spTree>
     <p:extLst>
       <p:ext uri="{BB962C8B-B14F-4D97-AF65-F5344CB8AC3E}">
-        <p14:creationId xmlns:p14="http://schemas.microsoft.com/office/powerpoint/2010/main" val="4191030480"/>
+        <p14:creationId xmlns:p14="http://schemas.microsoft.com/office/powerpoint/2010/main" val="2276381799"/>
       </p:ext>
     </p:extLst>
   </p:cSld>
@@ -535,7 +535,7 @@
           <a:bodyPr/>
           <a:lstStyle/>
           <a:p>
-            <a:fld id="{2B0A806C-E4AA-4014-807C-EBAD5FEA3779}" type="slidenum">
+            <a:fld id="{89997A01-E33E-495B-A415-C74D1A0E1274}" type="slidenum">
               <a:rPr lang="ru-RU" smtClean="0"/>
               <a:t>1</a:t>
             </a:fld>
@@ -546,7 +546,7 @@
     </p:spTree>
     <p:extLst>
       <p:ext uri="{BB962C8B-B14F-4D97-AF65-F5344CB8AC3E}">
-        <p14:creationId xmlns:p14="http://schemas.microsoft.com/office/powerpoint/2010/main" val="3169503504"/>
+        <p14:creationId xmlns:p14="http://schemas.microsoft.com/office/powerpoint/2010/main" val="3592623970"/>
       </p:ext>
     </p:extLst>
   </p:cSld>
@@ -622,7 +622,7 @@
           <a:bodyPr/>
           <a:lstStyle/>
           <a:p>
-            <a:fld id="{2B0A806C-E4AA-4014-807C-EBAD5FEA3779}" type="slidenum">
+            <a:fld id="{89997A01-E33E-495B-A415-C74D1A0E1274}" type="slidenum">
               <a:rPr lang="ru-RU" smtClean="0"/>
               <a:t>10</a:t>
             </a:fld>
@@ -633,7 +633,7 @@
     </p:spTree>
     <p:extLst>
       <p:ext uri="{BB962C8B-B14F-4D97-AF65-F5344CB8AC3E}">
-        <p14:creationId xmlns:p14="http://schemas.microsoft.com/office/powerpoint/2010/main" val="2734480051"/>
+        <p14:creationId xmlns:p14="http://schemas.microsoft.com/office/powerpoint/2010/main" val="344900675"/>
       </p:ext>
     </p:extLst>
   </p:cSld>
@@ -709,7 +709,7 @@
           <a:bodyPr/>
           <a:lstStyle/>
           <a:p>
-            <a:fld id="{2B0A806C-E4AA-4014-807C-EBAD5FEA3779}" type="slidenum">
+            <a:fld id="{89997A01-E33E-495B-A415-C74D1A0E1274}" type="slidenum">
               <a:rPr lang="ru-RU" smtClean="0"/>
               <a:t>11</a:t>
             </a:fld>
@@ -720,7 +720,7 @@
     </p:spTree>
     <p:extLst>
       <p:ext uri="{BB962C8B-B14F-4D97-AF65-F5344CB8AC3E}">
-        <p14:creationId xmlns:p14="http://schemas.microsoft.com/office/powerpoint/2010/main" val="580763874"/>
+        <p14:creationId xmlns:p14="http://schemas.microsoft.com/office/powerpoint/2010/main" val="4117601500"/>
       </p:ext>
     </p:extLst>
   </p:cSld>
@@ -776,7 +776,7 @@
           <a:p>
             <a:r>
               <a:rPr lang="ru-RU"/>
-              <a:t>Первое, что мы нашли: способ выгрузки почти совпадает с меткой. Все ПТСР в формате B, большинство норм — в формате C, который вообще не похож на типичную ЭЭГ. Правило «формат B — значит ПТСР» без единого признака сигнала даёт AUC 0.985. Поэтому высокий AUC мы не считаем доказательством и дальше всегда показываем результаты по стратам.</a:t>
+              <a:t>Первое, что мы нашли: способ выгрузки почти совпадает с меткой. Все ПТСР в формате B, большинство норм — в формате C, с нетипичным сигналом. Правило «формат B — значит ПТСР» без единого признака сигнала даёт AUC 0.985. Поэтому высокий AUC мы не считаем доказательством и дальше всегда показываем результаты по стратам.</a:t>
             </a:r>
           </a:p>
         </p:txBody>
@@ -796,7 +796,7 @@
           <a:bodyPr/>
           <a:lstStyle/>
           <a:p>
-            <a:fld id="{2B0A806C-E4AA-4014-807C-EBAD5FEA3779}" type="slidenum">
+            <a:fld id="{89997A01-E33E-495B-A415-C74D1A0E1274}" type="slidenum">
               <a:rPr lang="ru-RU" smtClean="0"/>
               <a:t>2</a:t>
             </a:fld>
@@ -807,7 +807,7 @@
     </p:spTree>
     <p:extLst>
       <p:ext uri="{BB962C8B-B14F-4D97-AF65-F5344CB8AC3E}">
-        <p14:creationId xmlns:p14="http://schemas.microsoft.com/office/powerpoint/2010/main" val="3055293739"/>
+        <p14:creationId xmlns:p14="http://schemas.microsoft.com/office/powerpoint/2010/main" val="742174405"/>
       </p:ext>
     </p:extLst>
   </p:cSld>
@@ -883,7 +883,7 @@
           <a:bodyPr/>
           <a:lstStyle/>
           <a:p>
-            <a:fld id="{2B0A806C-E4AA-4014-807C-EBAD5FEA3779}" type="slidenum">
+            <a:fld id="{89997A01-E33E-495B-A415-C74D1A0E1274}" type="slidenum">
               <a:rPr lang="ru-RU" smtClean="0"/>
               <a:t>3</a:t>
             </a:fld>
@@ -894,7 +894,7 @@
     </p:spTree>
     <p:extLst>
       <p:ext uri="{BB962C8B-B14F-4D97-AF65-F5344CB8AC3E}">
-        <p14:creationId xmlns:p14="http://schemas.microsoft.com/office/powerpoint/2010/main" val="3181683170"/>
+        <p14:creationId xmlns:p14="http://schemas.microsoft.com/office/powerpoint/2010/main" val="721064417"/>
       </p:ext>
     </p:extLst>
   </p:cSld>
@@ -970,7 +970,7 @@
           <a:bodyPr/>
           <a:lstStyle/>
           <a:p>
-            <a:fld id="{2B0A806C-E4AA-4014-807C-EBAD5FEA3779}" type="slidenum">
+            <a:fld id="{89997A01-E33E-495B-A415-C74D1A0E1274}" type="slidenum">
               <a:rPr lang="ru-RU" smtClean="0"/>
               <a:t>4</a:t>
             </a:fld>
@@ -981,7 +981,7 @@
     </p:spTree>
     <p:extLst>
       <p:ext uri="{BB962C8B-B14F-4D97-AF65-F5344CB8AC3E}">
-        <p14:creationId xmlns:p14="http://schemas.microsoft.com/office/powerpoint/2010/main" val="2675903988"/>
+        <p14:creationId xmlns:p14="http://schemas.microsoft.com/office/powerpoint/2010/main" val="1780786273"/>
       </p:ext>
     </p:extLst>
   </p:cSld>
@@ -1057,7 +1057,7 @@
           <a:bodyPr/>
           <a:lstStyle/>
           <a:p>
-            <a:fld id="{2B0A806C-E4AA-4014-807C-EBAD5FEA3779}" type="slidenum">
+            <a:fld id="{89997A01-E33E-495B-A415-C74D1A0E1274}" type="slidenum">
               <a:rPr lang="ru-RU" smtClean="0"/>
               <a:t>5</a:t>
             </a:fld>
@@ -1068,7 +1068,7 @@
     </p:spTree>
     <p:extLst>
       <p:ext uri="{BB962C8B-B14F-4D97-AF65-F5344CB8AC3E}">
-        <p14:creationId xmlns:p14="http://schemas.microsoft.com/office/powerpoint/2010/main" val="2163409199"/>
+        <p14:creationId xmlns:p14="http://schemas.microsoft.com/office/powerpoint/2010/main" val="1228197186"/>
       </p:ext>
     </p:extLst>
   </p:cSld>
@@ -1124,7 +1124,7 @@
           <a:p>
             <a:r>
               <a:rPr lang="ru-RU"/>
-              <a:t>Все метрики вне выборки: каждого испытуемого предсказывает модель, которая его не видела. AUC против норм моложе 65 — 0.86 с интервалом от 0.80 до 0.92. Если убрать нетипичный формат C — 0.77, а специфичность на этих сопоставимых нормах — всего 0.52; это честная цифра для практики. Чувствительность при пороге 0.5 — 0.84: порог стоит в точке, где чувствительность равна специфичности на группах проверки, а нормам 65+ и соматоформным при обучении можно давать повышенный вес — это подняло и специфичность, и AUC.</a:t>
+              <a:t>Все метрики вне выборки: каждого испытуемого предсказывает модель, которая его не видела. AUC против норм моложе 65 — 0.86 с интервалом от 0.80 до 0.92. Если убрать нетипичный формат C — 0.77. Специфичность на молодых нормах 0.72, но по партиям она разная: на норме A — 0.45. Чувствительность при пороге 0.5 — 0.84: порог стоит в точке, где чувствительность равна специфичности на группах проверки, а нормам 65+ и соматоформным при обучении можно давать повышенный вес — это подняло и специфичность, и AUC.</a:t>
             </a:r>
           </a:p>
         </p:txBody>
@@ -1144,7 +1144,7 @@
           <a:bodyPr/>
           <a:lstStyle/>
           <a:p>
-            <a:fld id="{2B0A806C-E4AA-4014-807C-EBAD5FEA3779}" type="slidenum">
+            <a:fld id="{89997A01-E33E-495B-A415-C74D1A0E1274}" type="slidenum">
               <a:rPr lang="ru-RU" smtClean="0"/>
               <a:t>6</a:t>
             </a:fld>
@@ -1155,7 +1155,7 @@
     </p:spTree>
     <p:extLst>
       <p:ext uri="{BB962C8B-B14F-4D97-AF65-F5344CB8AC3E}">
-        <p14:creationId xmlns:p14="http://schemas.microsoft.com/office/powerpoint/2010/main" val="3231754708"/>
+        <p14:creationId xmlns:p14="http://schemas.microsoft.com/office/powerpoint/2010/main" val="2514521472"/>
       </p:ext>
     </p:extLst>
   </p:cSld>
@@ -1231,7 +1231,7 @@
           <a:bodyPr/>
           <a:lstStyle/>
           <a:p>
-            <a:fld id="{2B0A806C-E4AA-4014-807C-EBAD5FEA3779}" type="slidenum">
+            <a:fld id="{89997A01-E33E-495B-A415-C74D1A0E1274}" type="slidenum">
               <a:rPr lang="ru-RU" smtClean="0"/>
               <a:t>7</a:t>
             </a:fld>
@@ -1242,7 +1242,7 @@
     </p:spTree>
     <p:extLst>
       <p:ext uri="{BB962C8B-B14F-4D97-AF65-F5344CB8AC3E}">
-        <p14:creationId xmlns:p14="http://schemas.microsoft.com/office/powerpoint/2010/main" val="1135201539"/>
+        <p14:creationId xmlns:p14="http://schemas.microsoft.com/office/powerpoint/2010/main" val="1819657882"/>
       </p:ext>
     </p:extLst>
   </p:cSld>
@@ -1318,7 +1318,7 @@
           <a:bodyPr/>
           <a:lstStyle/>
           <a:p>
-            <a:fld id="{2B0A806C-E4AA-4014-807C-EBAD5FEA3779}" type="slidenum">
+            <a:fld id="{89997A01-E33E-495B-A415-C74D1A0E1274}" type="slidenum">
               <a:rPr lang="ru-RU" smtClean="0"/>
               <a:t>8</a:t>
             </a:fld>
@@ -1329,7 +1329,7 @@
     </p:spTree>
     <p:extLst>
       <p:ext uri="{BB962C8B-B14F-4D97-AF65-F5344CB8AC3E}">
-        <p14:creationId xmlns:p14="http://schemas.microsoft.com/office/powerpoint/2010/main" val="2521772129"/>
+        <p14:creationId xmlns:p14="http://schemas.microsoft.com/office/powerpoint/2010/main" val="3771877434"/>
       </p:ext>
     </p:extLst>
   </p:cSld>
@@ -1405,7 +1405,7 @@
           <a:bodyPr/>
           <a:lstStyle/>
           <a:p>
-            <a:fld id="{2B0A806C-E4AA-4014-807C-EBAD5FEA3779}" type="slidenum">
+            <a:fld id="{89997A01-E33E-495B-A415-C74D1A0E1274}" type="slidenum">
               <a:rPr lang="ru-RU" smtClean="0"/>
               <a:t>9</a:t>
             </a:fld>
@@ -1416,7 +1416,7 @@
     </p:spTree>
     <p:extLst>
       <p:ext uri="{BB962C8B-B14F-4D97-AF65-F5344CB8AC3E}">
-        <p14:creationId xmlns:p14="http://schemas.microsoft.com/office/powerpoint/2010/main" val="3038076519"/>
+        <p14:creationId xmlns:p14="http://schemas.microsoft.com/office/powerpoint/2010/main" val="1175040234"/>
       </p:ext>
     </p:extLst>
   </p:cSld>
@@ -1448,7 +1448,7 @@
           <p:cNvPr id="2" name="Заголовок 1">
             <a:extLst>
               <a:ext uri="{FF2B5EF4-FFF2-40B4-BE49-F238E27FC236}">
-                <a16:creationId xmlns:a16="http://schemas.microsoft.com/office/drawing/2014/main" id="{813C1A63-B63F-6448-5FF9-7457E65DC73F}"/>
+                <a16:creationId xmlns:a16="http://schemas.microsoft.com/office/drawing/2014/main" id="{0609D5D4-F179-5BA4-395E-D6EE8FCD0934}"/>
               </a:ext>
             </a:extLst>
           </p:cNvPr>
@@ -1485,7 +1485,7 @@
           <p:cNvPr id="3" name="Подзаголовок 2">
             <a:extLst>
               <a:ext uri="{FF2B5EF4-FFF2-40B4-BE49-F238E27FC236}">
-                <a16:creationId xmlns:a16="http://schemas.microsoft.com/office/drawing/2014/main" id="{F947AD67-34D9-A031-770C-F40EB877F81E}"/>
+                <a16:creationId xmlns:a16="http://schemas.microsoft.com/office/drawing/2014/main" id="{E88C8689-6A91-CC32-DB23-5CBBA371E7BA}"/>
               </a:ext>
             </a:extLst>
           </p:cNvPr>
@@ -1555,7 +1555,7 @@
           <p:cNvPr id="4" name="Дата 3">
             <a:extLst>
               <a:ext uri="{FF2B5EF4-FFF2-40B4-BE49-F238E27FC236}">
-                <a16:creationId xmlns:a16="http://schemas.microsoft.com/office/drawing/2014/main" id="{821A3676-62B0-3B38-13FA-57C90FF022CF}"/>
+                <a16:creationId xmlns:a16="http://schemas.microsoft.com/office/drawing/2014/main" id="{157A4CF9-314E-8374-A58B-E820B0F036BD}"/>
               </a:ext>
             </a:extLst>
           </p:cNvPr>
@@ -1571,7 +1571,7 @@
           <a:bodyPr/>
           <a:lstStyle/>
           <a:p>
-            <a:fld id="{73F13BAB-2F40-4C9F-9315-0045E09C09F5}" type="datetimeFigureOut">
+            <a:fld id="{15A8FFEB-E879-4FDF-9D96-2182B35409E6}" type="datetimeFigureOut">
               <a:rPr lang="ru-RU" smtClean="0"/>
               <a:t>27.09.2026</a:t>
             </a:fld>
@@ -1584,7 +1584,7 @@
           <p:cNvPr id="5" name="Нижний колонтитул 4">
             <a:extLst>
               <a:ext uri="{FF2B5EF4-FFF2-40B4-BE49-F238E27FC236}">
-                <a16:creationId xmlns:a16="http://schemas.microsoft.com/office/drawing/2014/main" id="{D3D32EBD-C2DE-6B39-7A36-8EA2BD983350}"/>
+                <a16:creationId xmlns:a16="http://schemas.microsoft.com/office/drawing/2014/main" id="{DB0335FB-480F-ACF2-EE6C-CDD043D9A6D3}"/>
               </a:ext>
             </a:extLst>
           </p:cNvPr>
@@ -1609,7 +1609,7 @@
           <p:cNvPr id="6" name="Номер слайда 5">
             <a:extLst>
               <a:ext uri="{FF2B5EF4-FFF2-40B4-BE49-F238E27FC236}">
-                <a16:creationId xmlns:a16="http://schemas.microsoft.com/office/drawing/2014/main" id="{30A5FE08-5C5A-7726-6D92-D559BF05C2DF}"/>
+                <a16:creationId xmlns:a16="http://schemas.microsoft.com/office/drawing/2014/main" id="{99C0BCBB-4DE9-85F2-55A9-56FE4C92BC08}"/>
               </a:ext>
             </a:extLst>
           </p:cNvPr>
@@ -1625,7 +1625,7 @@
           <a:bodyPr/>
           <a:lstStyle/>
           <a:p>
-            <a:fld id="{7D6D9F5E-E54D-4DE1-B539-7084078D4CDE}" type="slidenum">
+            <a:fld id="{B11C1C88-F033-4FE0-A8AC-6BB6689B4121}" type="slidenum">
               <a:rPr lang="ru-RU" smtClean="0"/>
               <a:t>‹#›</a:t>
             </a:fld>
@@ -1636,7 +1636,7 @@
     </p:spTree>
     <p:extLst>
       <p:ext uri="{BB962C8B-B14F-4D97-AF65-F5344CB8AC3E}">
-        <p14:creationId xmlns:p14="http://schemas.microsoft.com/office/powerpoint/2010/main" val="3594270689"/>
+        <p14:creationId xmlns:p14="http://schemas.microsoft.com/office/powerpoint/2010/main" val="3255179179"/>
       </p:ext>
     </p:extLst>
   </p:cSld>
@@ -1668,7 +1668,7 @@
           <p:cNvPr id="2" name="Заголовок 1">
             <a:extLst>
               <a:ext uri="{FF2B5EF4-FFF2-40B4-BE49-F238E27FC236}">
-                <a16:creationId xmlns:a16="http://schemas.microsoft.com/office/drawing/2014/main" id="{26FFEE7C-6069-BFD2-862F-85CD1F70C806}"/>
+                <a16:creationId xmlns:a16="http://schemas.microsoft.com/office/drawing/2014/main" id="{C4F2BBC9-B6D2-8869-E87A-FE8DBEE77691}"/>
               </a:ext>
             </a:extLst>
           </p:cNvPr>
@@ -1696,7 +1696,7 @@
           <p:cNvPr id="3" name="Вертикальный текст 2">
             <a:extLst>
               <a:ext uri="{FF2B5EF4-FFF2-40B4-BE49-F238E27FC236}">
-                <a16:creationId xmlns:a16="http://schemas.microsoft.com/office/drawing/2014/main" id="{176174A8-3692-0BD2-1B1A-53FB51B4DF97}"/>
+                <a16:creationId xmlns:a16="http://schemas.microsoft.com/office/drawing/2014/main" id="{A599D561-134A-4ACB-6648-007B7340E9EF}"/>
               </a:ext>
             </a:extLst>
           </p:cNvPr>
@@ -1753,7 +1753,7 @@
           <p:cNvPr id="4" name="Дата 3">
             <a:extLst>
               <a:ext uri="{FF2B5EF4-FFF2-40B4-BE49-F238E27FC236}">
-                <a16:creationId xmlns:a16="http://schemas.microsoft.com/office/drawing/2014/main" id="{9E62ED52-D41C-6B80-3E73-B8AFA8729094}"/>
+                <a16:creationId xmlns:a16="http://schemas.microsoft.com/office/drawing/2014/main" id="{62EB702B-27A8-ED11-4917-2FE8FE9F8F9D}"/>
               </a:ext>
             </a:extLst>
           </p:cNvPr>
@@ -1769,7 +1769,7 @@
           <a:bodyPr/>
           <a:lstStyle/>
           <a:p>
-            <a:fld id="{73F13BAB-2F40-4C9F-9315-0045E09C09F5}" type="datetimeFigureOut">
+            <a:fld id="{15A8FFEB-E879-4FDF-9D96-2182B35409E6}" type="datetimeFigureOut">
               <a:rPr lang="ru-RU" smtClean="0"/>
               <a:t>27.09.2026</a:t>
             </a:fld>
@@ -1782,7 +1782,7 @@
           <p:cNvPr id="5" name="Нижний колонтитул 4">
             <a:extLst>
               <a:ext uri="{FF2B5EF4-FFF2-40B4-BE49-F238E27FC236}">
-                <a16:creationId xmlns:a16="http://schemas.microsoft.com/office/drawing/2014/main" id="{FE018328-99F7-BDD4-DF9C-F96FE66239F7}"/>
+                <a16:creationId xmlns:a16="http://schemas.microsoft.com/office/drawing/2014/main" id="{CA99F9E4-8AD4-842F-7EE5-B200F99CE762}"/>
               </a:ext>
             </a:extLst>
           </p:cNvPr>
@@ -1807,7 +1807,7 @@
           <p:cNvPr id="6" name="Номер слайда 5">
             <a:extLst>
               <a:ext uri="{FF2B5EF4-FFF2-40B4-BE49-F238E27FC236}">
-                <a16:creationId xmlns:a16="http://schemas.microsoft.com/office/drawing/2014/main" id="{2274399D-53AE-345F-886C-982C0297E4D7}"/>
+                <a16:creationId xmlns:a16="http://schemas.microsoft.com/office/drawing/2014/main" id="{A27BBFBD-AEF9-16CC-B321-29B36E79573F}"/>
               </a:ext>
             </a:extLst>
           </p:cNvPr>
@@ -1823,7 +1823,7 @@
           <a:bodyPr/>
           <a:lstStyle/>
           <a:p>
-            <a:fld id="{7D6D9F5E-E54D-4DE1-B539-7084078D4CDE}" type="slidenum">
+            <a:fld id="{B11C1C88-F033-4FE0-A8AC-6BB6689B4121}" type="slidenum">
               <a:rPr lang="ru-RU" smtClean="0"/>
               <a:t>‹#›</a:t>
             </a:fld>
@@ -1834,7 +1834,7 @@
     </p:spTree>
     <p:extLst>
       <p:ext uri="{BB962C8B-B14F-4D97-AF65-F5344CB8AC3E}">
-        <p14:creationId xmlns:p14="http://schemas.microsoft.com/office/powerpoint/2010/main" val="867161067"/>
+        <p14:creationId xmlns:p14="http://schemas.microsoft.com/office/powerpoint/2010/main" val="4096133293"/>
       </p:ext>
     </p:extLst>
   </p:cSld>
@@ -1866,7 +1866,7 @@
           <p:cNvPr id="2" name="Вертикальный заголовок 1">
             <a:extLst>
               <a:ext uri="{FF2B5EF4-FFF2-40B4-BE49-F238E27FC236}">
-                <a16:creationId xmlns:a16="http://schemas.microsoft.com/office/drawing/2014/main" id="{DBF1CE2A-5126-5DC3-9AAE-AC65947E26EB}"/>
+                <a16:creationId xmlns:a16="http://schemas.microsoft.com/office/drawing/2014/main" id="{70E7FA2A-6D4B-4754-5615-D34BD2510EED}"/>
               </a:ext>
             </a:extLst>
           </p:cNvPr>
@@ -1899,7 +1899,7 @@
           <p:cNvPr id="3" name="Вертикальный текст 2">
             <a:extLst>
               <a:ext uri="{FF2B5EF4-FFF2-40B4-BE49-F238E27FC236}">
-                <a16:creationId xmlns:a16="http://schemas.microsoft.com/office/drawing/2014/main" id="{01AD4938-2FD7-3F92-5FD8-A97DE263BEA9}"/>
+                <a16:creationId xmlns:a16="http://schemas.microsoft.com/office/drawing/2014/main" id="{2EE19824-6DE3-9D8E-1CAA-B9AB915397EC}"/>
               </a:ext>
             </a:extLst>
           </p:cNvPr>
@@ -1961,7 +1961,7 @@
           <p:cNvPr id="4" name="Дата 3">
             <a:extLst>
               <a:ext uri="{FF2B5EF4-FFF2-40B4-BE49-F238E27FC236}">
-                <a16:creationId xmlns:a16="http://schemas.microsoft.com/office/drawing/2014/main" id="{FF2A1FA8-8CD7-449D-A51C-5BE121254F62}"/>
+                <a16:creationId xmlns:a16="http://schemas.microsoft.com/office/drawing/2014/main" id="{718E40EB-B23D-F22F-1784-C22EDD5A4AC8}"/>
               </a:ext>
             </a:extLst>
           </p:cNvPr>
@@ -1977,7 +1977,7 @@
           <a:bodyPr/>
           <a:lstStyle/>
           <a:p>
-            <a:fld id="{73F13BAB-2F40-4C9F-9315-0045E09C09F5}" type="datetimeFigureOut">
+            <a:fld id="{15A8FFEB-E879-4FDF-9D96-2182B35409E6}" type="datetimeFigureOut">
               <a:rPr lang="ru-RU" smtClean="0"/>
               <a:t>27.09.2026</a:t>
             </a:fld>
@@ -1990,7 +1990,7 @@
           <p:cNvPr id="5" name="Нижний колонтитул 4">
             <a:extLst>
               <a:ext uri="{FF2B5EF4-FFF2-40B4-BE49-F238E27FC236}">
-                <a16:creationId xmlns:a16="http://schemas.microsoft.com/office/drawing/2014/main" id="{60DD2A7D-707E-62F2-1FC5-4D572E88FAFD}"/>
+                <a16:creationId xmlns:a16="http://schemas.microsoft.com/office/drawing/2014/main" id="{4F472256-D52A-7171-6FDB-349CFE1DC562}"/>
               </a:ext>
             </a:extLst>
           </p:cNvPr>
@@ -2015,7 +2015,7 @@
           <p:cNvPr id="6" name="Номер слайда 5">
             <a:extLst>
               <a:ext uri="{FF2B5EF4-FFF2-40B4-BE49-F238E27FC236}">
-                <a16:creationId xmlns:a16="http://schemas.microsoft.com/office/drawing/2014/main" id="{32A876C0-0BC6-7933-F8E6-7696B4256F62}"/>
+                <a16:creationId xmlns:a16="http://schemas.microsoft.com/office/drawing/2014/main" id="{30ADF3FC-15F7-8C96-5B9B-0F4FB8BBA1D6}"/>
               </a:ext>
             </a:extLst>
           </p:cNvPr>
@@ -2031,7 +2031,7 @@
           <a:bodyPr/>
           <a:lstStyle/>
           <a:p>
-            <a:fld id="{7D6D9F5E-E54D-4DE1-B539-7084078D4CDE}" type="slidenum">
+            <a:fld id="{B11C1C88-F033-4FE0-A8AC-6BB6689B4121}" type="slidenum">
               <a:rPr lang="ru-RU" smtClean="0"/>
               <a:t>‹#›</a:t>
             </a:fld>
@@ -2042,7 +2042,7 @@
     </p:spTree>
     <p:extLst>
       <p:ext uri="{BB962C8B-B14F-4D97-AF65-F5344CB8AC3E}">
-        <p14:creationId xmlns:p14="http://schemas.microsoft.com/office/powerpoint/2010/main" val="2546224379"/>
+        <p14:creationId xmlns:p14="http://schemas.microsoft.com/office/powerpoint/2010/main" val="3442178504"/>
       </p:ext>
     </p:extLst>
   </p:cSld>
@@ -2074,7 +2074,7 @@
           <p:cNvPr id="2" name="Заголовок 1">
             <a:extLst>
               <a:ext uri="{FF2B5EF4-FFF2-40B4-BE49-F238E27FC236}">
-                <a16:creationId xmlns:a16="http://schemas.microsoft.com/office/drawing/2014/main" id="{539CC642-AAC8-F0E9-54E6-5512EA65134F}"/>
+                <a16:creationId xmlns:a16="http://schemas.microsoft.com/office/drawing/2014/main" id="{12D5246C-DE97-ABF5-BB01-383C8B05C2E9}"/>
               </a:ext>
             </a:extLst>
           </p:cNvPr>
@@ -2102,7 +2102,7 @@
           <p:cNvPr id="3" name="Объект 2">
             <a:extLst>
               <a:ext uri="{FF2B5EF4-FFF2-40B4-BE49-F238E27FC236}">
-                <a16:creationId xmlns:a16="http://schemas.microsoft.com/office/drawing/2014/main" id="{32F4F33D-54C3-4289-CCDC-33593B1B7000}"/>
+                <a16:creationId xmlns:a16="http://schemas.microsoft.com/office/drawing/2014/main" id="{A3E5B778-AB24-E951-01BA-52BBA05C3365}"/>
               </a:ext>
             </a:extLst>
           </p:cNvPr>
@@ -2159,7 +2159,7 @@
           <p:cNvPr id="4" name="Дата 3">
             <a:extLst>
               <a:ext uri="{FF2B5EF4-FFF2-40B4-BE49-F238E27FC236}">
-                <a16:creationId xmlns:a16="http://schemas.microsoft.com/office/drawing/2014/main" id="{23B276FA-884F-9466-5552-512F0C1EC3E0}"/>
+                <a16:creationId xmlns:a16="http://schemas.microsoft.com/office/drawing/2014/main" id="{416CA64F-AFFB-D4A5-B966-81F0B0D4817B}"/>
               </a:ext>
             </a:extLst>
           </p:cNvPr>
@@ -2175,7 +2175,7 @@
           <a:bodyPr/>
           <a:lstStyle/>
           <a:p>
-            <a:fld id="{73F13BAB-2F40-4C9F-9315-0045E09C09F5}" type="datetimeFigureOut">
+            <a:fld id="{15A8FFEB-E879-4FDF-9D96-2182B35409E6}" type="datetimeFigureOut">
               <a:rPr lang="ru-RU" smtClean="0"/>
               <a:t>27.09.2026</a:t>
             </a:fld>
@@ -2188,7 +2188,7 @@
           <p:cNvPr id="5" name="Нижний колонтитул 4">
             <a:extLst>
               <a:ext uri="{FF2B5EF4-FFF2-40B4-BE49-F238E27FC236}">
-                <a16:creationId xmlns:a16="http://schemas.microsoft.com/office/drawing/2014/main" id="{F36BC054-73C6-AF05-8318-C7EFBE86AD0C}"/>
+                <a16:creationId xmlns:a16="http://schemas.microsoft.com/office/drawing/2014/main" id="{840E1B33-AC34-5C6D-83EF-4B80084B0712}"/>
               </a:ext>
             </a:extLst>
           </p:cNvPr>
@@ -2213,7 +2213,7 @@
           <p:cNvPr id="6" name="Номер слайда 5">
             <a:extLst>
               <a:ext uri="{FF2B5EF4-FFF2-40B4-BE49-F238E27FC236}">
-                <a16:creationId xmlns:a16="http://schemas.microsoft.com/office/drawing/2014/main" id="{1E4ED2D1-B0B9-D288-077E-44011168479D}"/>
+                <a16:creationId xmlns:a16="http://schemas.microsoft.com/office/drawing/2014/main" id="{115A2005-2D7F-F7CA-2608-CD196F3D5F44}"/>
               </a:ext>
             </a:extLst>
           </p:cNvPr>
@@ -2229,7 +2229,7 @@
           <a:bodyPr/>
           <a:lstStyle/>
           <a:p>
-            <a:fld id="{7D6D9F5E-E54D-4DE1-B539-7084078D4CDE}" type="slidenum">
+            <a:fld id="{B11C1C88-F033-4FE0-A8AC-6BB6689B4121}" type="slidenum">
               <a:rPr lang="ru-RU" smtClean="0"/>
               <a:t>‹#›</a:t>
             </a:fld>
@@ -2240,7 +2240,7 @@
     </p:spTree>
     <p:extLst>
       <p:ext uri="{BB962C8B-B14F-4D97-AF65-F5344CB8AC3E}">
-        <p14:creationId xmlns:p14="http://schemas.microsoft.com/office/powerpoint/2010/main" val="1807605878"/>
+        <p14:creationId xmlns:p14="http://schemas.microsoft.com/office/powerpoint/2010/main" val="1610421062"/>
       </p:ext>
     </p:extLst>
   </p:cSld>
@@ -2272,7 +2272,7 @@
           <p:cNvPr id="2" name="Заголовок 1">
             <a:extLst>
               <a:ext uri="{FF2B5EF4-FFF2-40B4-BE49-F238E27FC236}">
-                <a16:creationId xmlns:a16="http://schemas.microsoft.com/office/drawing/2014/main" id="{F06B06E4-1704-9359-0F27-100FB354FE5F}"/>
+                <a16:creationId xmlns:a16="http://schemas.microsoft.com/office/drawing/2014/main" id="{5AFC97E5-4344-BEDC-A166-2844794FB531}"/>
               </a:ext>
             </a:extLst>
           </p:cNvPr>
@@ -2309,7 +2309,7 @@
           <p:cNvPr id="3" name="Текст 2">
             <a:extLst>
               <a:ext uri="{FF2B5EF4-FFF2-40B4-BE49-F238E27FC236}">
-                <a16:creationId xmlns:a16="http://schemas.microsoft.com/office/drawing/2014/main" id="{39BC013F-F0C8-FDAB-9E03-E60511D4F7EB}"/>
+                <a16:creationId xmlns:a16="http://schemas.microsoft.com/office/drawing/2014/main" id="{583A9FA8-231E-C5C5-AFA8-5908D5EC13F5}"/>
               </a:ext>
             </a:extLst>
           </p:cNvPr>
@@ -2434,7 +2434,7 @@
           <p:cNvPr id="4" name="Дата 3">
             <a:extLst>
               <a:ext uri="{FF2B5EF4-FFF2-40B4-BE49-F238E27FC236}">
-                <a16:creationId xmlns:a16="http://schemas.microsoft.com/office/drawing/2014/main" id="{08B10CAC-AB1E-A4B4-5097-64DA4623934E}"/>
+                <a16:creationId xmlns:a16="http://schemas.microsoft.com/office/drawing/2014/main" id="{B5F8CC5F-01F9-1A8D-1C67-B94FD3C3FD21}"/>
               </a:ext>
             </a:extLst>
           </p:cNvPr>
@@ -2450,7 +2450,7 @@
           <a:bodyPr/>
           <a:lstStyle/>
           <a:p>
-            <a:fld id="{73F13BAB-2F40-4C9F-9315-0045E09C09F5}" type="datetimeFigureOut">
+            <a:fld id="{15A8FFEB-E879-4FDF-9D96-2182B35409E6}" type="datetimeFigureOut">
               <a:rPr lang="ru-RU" smtClean="0"/>
               <a:t>27.09.2026</a:t>
             </a:fld>
@@ -2463,7 +2463,7 @@
           <p:cNvPr id="5" name="Нижний колонтитул 4">
             <a:extLst>
               <a:ext uri="{FF2B5EF4-FFF2-40B4-BE49-F238E27FC236}">
-                <a16:creationId xmlns:a16="http://schemas.microsoft.com/office/drawing/2014/main" id="{DDFE90FD-323F-55DC-01C7-FA432E9FD0DA}"/>
+                <a16:creationId xmlns:a16="http://schemas.microsoft.com/office/drawing/2014/main" id="{40B0197A-6F77-4AF8-40B2-6EC420846379}"/>
               </a:ext>
             </a:extLst>
           </p:cNvPr>
@@ -2488,7 +2488,7 @@
           <p:cNvPr id="6" name="Номер слайда 5">
             <a:extLst>
               <a:ext uri="{FF2B5EF4-FFF2-40B4-BE49-F238E27FC236}">
-                <a16:creationId xmlns:a16="http://schemas.microsoft.com/office/drawing/2014/main" id="{D6A586D3-0E20-FB01-7965-46A2C17CA2F2}"/>
+                <a16:creationId xmlns:a16="http://schemas.microsoft.com/office/drawing/2014/main" id="{76209390-9C41-5528-8149-8884196C30D7}"/>
               </a:ext>
             </a:extLst>
           </p:cNvPr>
@@ -2504,7 +2504,7 @@
           <a:bodyPr/>
           <a:lstStyle/>
           <a:p>
-            <a:fld id="{7D6D9F5E-E54D-4DE1-B539-7084078D4CDE}" type="slidenum">
+            <a:fld id="{B11C1C88-F033-4FE0-A8AC-6BB6689B4121}" type="slidenum">
               <a:rPr lang="ru-RU" smtClean="0"/>
               <a:t>‹#›</a:t>
             </a:fld>
@@ -2515,7 +2515,7 @@
     </p:spTree>
     <p:extLst>
       <p:ext uri="{BB962C8B-B14F-4D97-AF65-F5344CB8AC3E}">
-        <p14:creationId xmlns:p14="http://schemas.microsoft.com/office/powerpoint/2010/main" val="3294071422"/>
+        <p14:creationId xmlns:p14="http://schemas.microsoft.com/office/powerpoint/2010/main" val="2260716657"/>
       </p:ext>
     </p:extLst>
   </p:cSld>
@@ -2547,7 +2547,7 @@
           <p:cNvPr id="2" name="Заголовок 1">
             <a:extLst>
               <a:ext uri="{FF2B5EF4-FFF2-40B4-BE49-F238E27FC236}">
-                <a16:creationId xmlns:a16="http://schemas.microsoft.com/office/drawing/2014/main" id="{2C366C15-40E6-C173-3D91-FDFF6510D428}"/>
+                <a16:creationId xmlns:a16="http://schemas.microsoft.com/office/drawing/2014/main" id="{BD4A2DFB-479E-25CE-7519-F9C6E9A9BA74}"/>
               </a:ext>
             </a:extLst>
           </p:cNvPr>
@@ -2575,7 +2575,7 @@
           <p:cNvPr id="3" name="Объект 2">
             <a:extLst>
               <a:ext uri="{FF2B5EF4-FFF2-40B4-BE49-F238E27FC236}">
-                <a16:creationId xmlns:a16="http://schemas.microsoft.com/office/drawing/2014/main" id="{84B3D70E-69A7-5745-1E01-F8D8785C35A7}"/>
+                <a16:creationId xmlns:a16="http://schemas.microsoft.com/office/drawing/2014/main" id="{E36B8B31-7C7C-41FC-F0FF-12BC6316E083}"/>
               </a:ext>
             </a:extLst>
           </p:cNvPr>
@@ -2637,7 +2637,7 @@
           <p:cNvPr id="4" name="Объект 3">
             <a:extLst>
               <a:ext uri="{FF2B5EF4-FFF2-40B4-BE49-F238E27FC236}">
-                <a16:creationId xmlns:a16="http://schemas.microsoft.com/office/drawing/2014/main" id="{9950E927-07F2-783F-0000-EC61EEA0E10E}"/>
+                <a16:creationId xmlns:a16="http://schemas.microsoft.com/office/drawing/2014/main" id="{A1F5980F-F4E3-3A3C-CA43-1E8047BF53C8}"/>
               </a:ext>
             </a:extLst>
           </p:cNvPr>
@@ -2699,7 +2699,7 @@
           <p:cNvPr id="5" name="Дата 4">
             <a:extLst>
               <a:ext uri="{FF2B5EF4-FFF2-40B4-BE49-F238E27FC236}">
-                <a16:creationId xmlns:a16="http://schemas.microsoft.com/office/drawing/2014/main" id="{5B47AD51-647F-7D91-5AF3-6DEC50C5BC39}"/>
+                <a16:creationId xmlns:a16="http://schemas.microsoft.com/office/drawing/2014/main" id="{50571402-F46D-3CA3-39B5-69D2629FCB88}"/>
               </a:ext>
             </a:extLst>
           </p:cNvPr>
@@ -2715,7 +2715,7 @@
           <a:bodyPr/>
           <a:lstStyle/>
           <a:p>
-            <a:fld id="{73F13BAB-2F40-4C9F-9315-0045E09C09F5}" type="datetimeFigureOut">
+            <a:fld id="{15A8FFEB-E879-4FDF-9D96-2182B35409E6}" type="datetimeFigureOut">
               <a:rPr lang="ru-RU" smtClean="0"/>
               <a:t>27.09.2026</a:t>
             </a:fld>
@@ -2728,7 +2728,7 @@
           <p:cNvPr id="6" name="Нижний колонтитул 5">
             <a:extLst>
               <a:ext uri="{FF2B5EF4-FFF2-40B4-BE49-F238E27FC236}">
-                <a16:creationId xmlns:a16="http://schemas.microsoft.com/office/drawing/2014/main" id="{916308B5-79BA-A6AA-C0BF-2553AC68DDA1}"/>
+                <a16:creationId xmlns:a16="http://schemas.microsoft.com/office/drawing/2014/main" id="{0CAF1FAC-F3F1-8634-7165-C25F0BC79786}"/>
               </a:ext>
             </a:extLst>
           </p:cNvPr>
@@ -2753,7 +2753,7 @@
           <p:cNvPr id="7" name="Номер слайда 6">
             <a:extLst>
               <a:ext uri="{FF2B5EF4-FFF2-40B4-BE49-F238E27FC236}">
-                <a16:creationId xmlns:a16="http://schemas.microsoft.com/office/drawing/2014/main" id="{72EC80F9-D752-A212-36C3-6FDE6696136A}"/>
+                <a16:creationId xmlns:a16="http://schemas.microsoft.com/office/drawing/2014/main" id="{D5CB6081-A246-4CA0-7BF0-24C8FED6A831}"/>
               </a:ext>
             </a:extLst>
           </p:cNvPr>
@@ -2769,7 +2769,7 @@
           <a:bodyPr/>
           <a:lstStyle/>
           <a:p>
-            <a:fld id="{7D6D9F5E-E54D-4DE1-B539-7084078D4CDE}" type="slidenum">
+            <a:fld id="{B11C1C88-F033-4FE0-A8AC-6BB6689B4121}" type="slidenum">
               <a:rPr lang="ru-RU" smtClean="0"/>
               <a:t>‹#›</a:t>
             </a:fld>
@@ -2780,7 +2780,7 @@
     </p:spTree>
     <p:extLst>
       <p:ext uri="{BB962C8B-B14F-4D97-AF65-F5344CB8AC3E}">
-        <p14:creationId xmlns:p14="http://schemas.microsoft.com/office/powerpoint/2010/main" val="951372408"/>
+        <p14:creationId xmlns:p14="http://schemas.microsoft.com/office/powerpoint/2010/main" val="1720814650"/>
       </p:ext>
     </p:extLst>
   </p:cSld>
@@ -2812,7 +2812,7 @@
           <p:cNvPr id="2" name="Заголовок 1">
             <a:extLst>
               <a:ext uri="{FF2B5EF4-FFF2-40B4-BE49-F238E27FC236}">
-                <a16:creationId xmlns:a16="http://schemas.microsoft.com/office/drawing/2014/main" id="{879852FF-07FE-1A47-B658-CD3B54EC6D30}"/>
+                <a16:creationId xmlns:a16="http://schemas.microsoft.com/office/drawing/2014/main" id="{C3404523-8531-822B-3E64-5C621A14CD12}"/>
               </a:ext>
             </a:extLst>
           </p:cNvPr>
@@ -2845,7 +2845,7 @@
           <p:cNvPr id="3" name="Текст 2">
             <a:extLst>
               <a:ext uri="{FF2B5EF4-FFF2-40B4-BE49-F238E27FC236}">
-                <a16:creationId xmlns:a16="http://schemas.microsoft.com/office/drawing/2014/main" id="{C91CDA91-8AC4-9269-AB30-F534E35AF4FE}"/>
+                <a16:creationId xmlns:a16="http://schemas.microsoft.com/office/drawing/2014/main" id="{92226CBF-F795-2E8D-F1BB-27636D6A8AFB}"/>
               </a:ext>
             </a:extLst>
           </p:cNvPr>
@@ -2916,7 +2916,7 @@
           <p:cNvPr id="4" name="Объект 3">
             <a:extLst>
               <a:ext uri="{FF2B5EF4-FFF2-40B4-BE49-F238E27FC236}">
-                <a16:creationId xmlns:a16="http://schemas.microsoft.com/office/drawing/2014/main" id="{638B72B0-8CF1-80F8-A790-FFEEB51C43E8}"/>
+                <a16:creationId xmlns:a16="http://schemas.microsoft.com/office/drawing/2014/main" id="{CC482B51-33DA-61AD-592B-8B3CC0579770}"/>
               </a:ext>
             </a:extLst>
           </p:cNvPr>
@@ -2978,7 +2978,7 @@
           <p:cNvPr id="5" name="Текст 4">
             <a:extLst>
               <a:ext uri="{FF2B5EF4-FFF2-40B4-BE49-F238E27FC236}">
-                <a16:creationId xmlns:a16="http://schemas.microsoft.com/office/drawing/2014/main" id="{A8E4E607-7C0E-A4A8-791D-C544C6C91E88}"/>
+                <a16:creationId xmlns:a16="http://schemas.microsoft.com/office/drawing/2014/main" id="{C58F23F7-78C7-7A46-125F-3D3AEE006F7E}"/>
               </a:ext>
             </a:extLst>
           </p:cNvPr>
@@ -3049,7 +3049,7 @@
           <p:cNvPr id="6" name="Объект 5">
             <a:extLst>
               <a:ext uri="{FF2B5EF4-FFF2-40B4-BE49-F238E27FC236}">
-                <a16:creationId xmlns:a16="http://schemas.microsoft.com/office/drawing/2014/main" id="{354C4EF6-6BAB-DDB7-4A93-32227B6E7604}"/>
+                <a16:creationId xmlns:a16="http://schemas.microsoft.com/office/drawing/2014/main" id="{BF99B467-AE88-C3B6-BF1D-EDC5BE4AFFFD}"/>
               </a:ext>
             </a:extLst>
           </p:cNvPr>
@@ -3111,7 +3111,7 @@
           <p:cNvPr id="7" name="Дата 6">
             <a:extLst>
               <a:ext uri="{FF2B5EF4-FFF2-40B4-BE49-F238E27FC236}">
-                <a16:creationId xmlns:a16="http://schemas.microsoft.com/office/drawing/2014/main" id="{77FA3C4D-0F35-F65F-1D5F-B8195962464B}"/>
+                <a16:creationId xmlns:a16="http://schemas.microsoft.com/office/drawing/2014/main" id="{4D8647CE-4650-2911-6519-244348CF328D}"/>
               </a:ext>
             </a:extLst>
           </p:cNvPr>
@@ -3127,7 +3127,7 @@
           <a:bodyPr/>
           <a:lstStyle/>
           <a:p>
-            <a:fld id="{73F13BAB-2F40-4C9F-9315-0045E09C09F5}" type="datetimeFigureOut">
+            <a:fld id="{15A8FFEB-E879-4FDF-9D96-2182B35409E6}" type="datetimeFigureOut">
               <a:rPr lang="ru-RU" smtClean="0"/>
               <a:t>27.09.2026</a:t>
             </a:fld>
@@ -3140,7 +3140,7 @@
           <p:cNvPr id="8" name="Нижний колонтитул 7">
             <a:extLst>
               <a:ext uri="{FF2B5EF4-FFF2-40B4-BE49-F238E27FC236}">
-                <a16:creationId xmlns:a16="http://schemas.microsoft.com/office/drawing/2014/main" id="{AE7FEA32-D177-E7B6-2AB0-A7A2C6516AAD}"/>
+                <a16:creationId xmlns:a16="http://schemas.microsoft.com/office/drawing/2014/main" id="{E002A4AC-C228-7978-898D-A1E2CBAF9206}"/>
               </a:ext>
             </a:extLst>
           </p:cNvPr>
@@ -3165,7 +3165,7 @@
           <p:cNvPr id="9" name="Номер слайда 8">
             <a:extLst>
               <a:ext uri="{FF2B5EF4-FFF2-40B4-BE49-F238E27FC236}">
-                <a16:creationId xmlns:a16="http://schemas.microsoft.com/office/drawing/2014/main" id="{41CC88C2-3131-0D27-C9B1-A2EF4AB225CA}"/>
+                <a16:creationId xmlns:a16="http://schemas.microsoft.com/office/drawing/2014/main" id="{FB7FBD64-FBF3-D1C2-319F-9700419935D2}"/>
               </a:ext>
             </a:extLst>
           </p:cNvPr>
@@ -3181,7 +3181,7 @@
           <a:bodyPr/>
           <a:lstStyle/>
           <a:p>
-            <a:fld id="{7D6D9F5E-E54D-4DE1-B539-7084078D4CDE}" type="slidenum">
+            <a:fld id="{B11C1C88-F033-4FE0-A8AC-6BB6689B4121}" type="slidenum">
               <a:rPr lang="ru-RU" smtClean="0"/>
               <a:t>‹#›</a:t>
             </a:fld>
@@ -3192,7 +3192,7 @@
     </p:spTree>
     <p:extLst>
       <p:ext uri="{BB962C8B-B14F-4D97-AF65-F5344CB8AC3E}">
-        <p14:creationId xmlns:p14="http://schemas.microsoft.com/office/powerpoint/2010/main" val="2217450216"/>
+        <p14:creationId xmlns:p14="http://schemas.microsoft.com/office/powerpoint/2010/main" val="476830531"/>
       </p:ext>
     </p:extLst>
   </p:cSld>
@@ -3224,7 +3224,7 @@
           <p:cNvPr id="2" name="Заголовок 1">
             <a:extLst>
               <a:ext uri="{FF2B5EF4-FFF2-40B4-BE49-F238E27FC236}">
-                <a16:creationId xmlns:a16="http://schemas.microsoft.com/office/drawing/2014/main" id="{3A631F34-7C59-D984-A696-3B47C08081AD}"/>
+                <a16:creationId xmlns:a16="http://schemas.microsoft.com/office/drawing/2014/main" id="{F19BFF19-EE3C-BABE-CE13-91B78467D4DF}"/>
               </a:ext>
             </a:extLst>
           </p:cNvPr>
@@ -3252,7 +3252,7 @@
           <p:cNvPr id="3" name="Дата 2">
             <a:extLst>
               <a:ext uri="{FF2B5EF4-FFF2-40B4-BE49-F238E27FC236}">
-                <a16:creationId xmlns:a16="http://schemas.microsoft.com/office/drawing/2014/main" id="{617E4BE2-243C-6438-9F8F-3EF50A9FDF22}"/>
+                <a16:creationId xmlns:a16="http://schemas.microsoft.com/office/drawing/2014/main" id="{9A9871B4-4F8E-F3FF-C3DE-A5552DAA0BEB}"/>
               </a:ext>
             </a:extLst>
           </p:cNvPr>
@@ -3268,7 +3268,7 @@
           <a:bodyPr/>
           <a:lstStyle/>
           <a:p>
-            <a:fld id="{73F13BAB-2F40-4C9F-9315-0045E09C09F5}" type="datetimeFigureOut">
+            <a:fld id="{15A8FFEB-E879-4FDF-9D96-2182B35409E6}" type="datetimeFigureOut">
               <a:rPr lang="ru-RU" smtClean="0"/>
               <a:t>27.09.2026</a:t>
             </a:fld>
@@ -3281,7 +3281,7 @@
           <p:cNvPr id="4" name="Нижний колонтитул 3">
             <a:extLst>
               <a:ext uri="{FF2B5EF4-FFF2-40B4-BE49-F238E27FC236}">
-                <a16:creationId xmlns:a16="http://schemas.microsoft.com/office/drawing/2014/main" id="{CA70B225-2C7D-4151-4058-CE84DBCF530D}"/>
+                <a16:creationId xmlns:a16="http://schemas.microsoft.com/office/drawing/2014/main" id="{0A8B771A-6C53-760F-B104-954D2C5DCBAB}"/>
               </a:ext>
             </a:extLst>
           </p:cNvPr>
@@ -3306,7 +3306,7 @@
           <p:cNvPr id="5" name="Номер слайда 4">
             <a:extLst>
               <a:ext uri="{FF2B5EF4-FFF2-40B4-BE49-F238E27FC236}">
-                <a16:creationId xmlns:a16="http://schemas.microsoft.com/office/drawing/2014/main" id="{C4B2ABB6-4EFB-4281-075F-EAEEAA297A91}"/>
+                <a16:creationId xmlns:a16="http://schemas.microsoft.com/office/drawing/2014/main" id="{5C4A6113-4B1F-8933-4210-E74BF1B179C3}"/>
               </a:ext>
             </a:extLst>
           </p:cNvPr>
@@ -3322,7 +3322,7 @@
           <a:bodyPr/>
           <a:lstStyle/>
           <a:p>
-            <a:fld id="{7D6D9F5E-E54D-4DE1-B539-7084078D4CDE}" type="slidenum">
+            <a:fld id="{B11C1C88-F033-4FE0-A8AC-6BB6689B4121}" type="slidenum">
               <a:rPr lang="ru-RU" smtClean="0"/>
               <a:t>‹#›</a:t>
             </a:fld>
@@ -3333,7 +3333,7 @@
     </p:spTree>
     <p:extLst>
       <p:ext uri="{BB962C8B-B14F-4D97-AF65-F5344CB8AC3E}">
-        <p14:creationId xmlns:p14="http://schemas.microsoft.com/office/powerpoint/2010/main" val="3230163439"/>
+        <p14:creationId xmlns:p14="http://schemas.microsoft.com/office/powerpoint/2010/main" val="1978524703"/>
       </p:ext>
     </p:extLst>
   </p:cSld>
@@ -3365,7 +3365,7 @@
           <p:cNvPr id="2" name="Дата 1">
             <a:extLst>
               <a:ext uri="{FF2B5EF4-FFF2-40B4-BE49-F238E27FC236}">
-                <a16:creationId xmlns:a16="http://schemas.microsoft.com/office/drawing/2014/main" id="{28E6CEA6-296D-B7C8-DF86-1FB60807E797}"/>
+                <a16:creationId xmlns:a16="http://schemas.microsoft.com/office/drawing/2014/main" id="{A0B09CFB-302C-3225-3567-5408A2E36DAC}"/>
               </a:ext>
             </a:extLst>
           </p:cNvPr>
@@ -3381,7 +3381,7 @@
           <a:bodyPr/>
           <a:lstStyle/>
           <a:p>
-            <a:fld id="{73F13BAB-2F40-4C9F-9315-0045E09C09F5}" type="datetimeFigureOut">
+            <a:fld id="{15A8FFEB-E879-4FDF-9D96-2182B35409E6}" type="datetimeFigureOut">
               <a:rPr lang="ru-RU" smtClean="0"/>
               <a:t>27.09.2026</a:t>
             </a:fld>
@@ -3394,7 +3394,7 @@
           <p:cNvPr id="3" name="Нижний колонтитул 2">
             <a:extLst>
               <a:ext uri="{FF2B5EF4-FFF2-40B4-BE49-F238E27FC236}">
-                <a16:creationId xmlns:a16="http://schemas.microsoft.com/office/drawing/2014/main" id="{F9FDFA67-0AF2-6B71-91B1-65A6A46EDF18}"/>
+                <a16:creationId xmlns:a16="http://schemas.microsoft.com/office/drawing/2014/main" id="{B2E5CE70-D195-A4E2-BCF0-4AE4AF6F7463}"/>
               </a:ext>
             </a:extLst>
           </p:cNvPr>
@@ -3419,7 +3419,7 @@
           <p:cNvPr id="4" name="Номер слайда 3">
             <a:extLst>
               <a:ext uri="{FF2B5EF4-FFF2-40B4-BE49-F238E27FC236}">
-                <a16:creationId xmlns:a16="http://schemas.microsoft.com/office/drawing/2014/main" id="{F0D4E505-5B91-CCD7-D225-5CE72640418D}"/>
+                <a16:creationId xmlns:a16="http://schemas.microsoft.com/office/drawing/2014/main" id="{462C73F1-F072-976D-6EE9-6C11A00F0FFF}"/>
               </a:ext>
             </a:extLst>
           </p:cNvPr>
@@ -3435,7 +3435,7 @@
           <a:bodyPr/>
           <a:lstStyle/>
           <a:p>
-            <a:fld id="{7D6D9F5E-E54D-4DE1-B539-7084078D4CDE}" type="slidenum">
+            <a:fld id="{B11C1C88-F033-4FE0-A8AC-6BB6689B4121}" type="slidenum">
               <a:rPr lang="ru-RU" smtClean="0"/>
               <a:t>‹#›</a:t>
             </a:fld>
@@ -3446,7 +3446,7 @@
     </p:spTree>
     <p:extLst>
       <p:ext uri="{BB962C8B-B14F-4D97-AF65-F5344CB8AC3E}">
-        <p14:creationId xmlns:p14="http://schemas.microsoft.com/office/powerpoint/2010/main" val="1579066557"/>
+        <p14:creationId xmlns:p14="http://schemas.microsoft.com/office/powerpoint/2010/main" val="925459088"/>
       </p:ext>
     </p:extLst>
   </p:cSld>
@@ -3478,7 +3478,7 @@
           <p:cNvPr id="2" name="Заголовок 1">
             <a:extLst>
               <a:ext uri="{FF2B5EF4-FFF2-40B4-BE49-F238E27FC236}">
-                <a16:creationId xmlns:a16="http://schemas.microsoft.com/office/drawing/2014/main" id="{62E8B5AA-6485-2A48-2711-899BAFC2D94C}"/>
+                <a16:creationId xmlns:a16="http://schemas.microsoft.com/office/drawing/2014/main" id="{22ECA47D-E3DA-1AAE-D437-D1CF36B4E477}"/>
               </a:ext>
             </a:extLst>
           </p:cNvPr>
@@ -3515,7 +3515,7 @@
           <p:cNvPr id="3" name="Объект 2">
             <a:extLst>
               <a:ext uri="{FF2B5EF4-FFF2-40B4-BE49-F238E27FC236}">
-                <a16:creationId xmlns:a16="http://schemas.microsoft.com/office/drawing/2014/main" id="{C8FF94D9-EE68-DC1F-C41A-09D92A935937}"/>
+                <a16:creationId xmlns:a16="http://schemas.microsoft.com/office/drawing/2014/main" id="{B7F78904-E390-2895-C674-0C5D6A06BC7C}"/>
               </a:ext>
             </a:extLst>
           </p:cNvPr>
@@ -3605,7 +3605,7 @@
           <p:cNvPr id="4" name="Текст 3">
             <a:extLst>
               <a:ext uri="{FF2B5EF4-FFF2-40B4-BE49-F238E27FC236}">
-                <a16:creationId xmlns:a16="http://schemas.microsoft.com/office/drawing/2014/main" id="{64545C9A-491A-E83B-CD37-7914BF67E5CA}"/>
+                <a16:creationId xmlns:a16="http://schemas.microsoft.com/office/drawing/2014/main" id="{C2BA94E8-C1D9-8456-79B6-F13B79571422}"/>
               </a:ext>
             </a:extLst>
           </p:cNvPr>
@@ -3676,7 +3676,7 @@
           <p:cNvPr id="5" name="Дата 4">
             <a:extLst>
               <a:ext uri="{FF2B5EF4-FFF2-40B4-BE49-F238E27FC236}">
-                <a16:creationId xmlns:a16="http://schemas.microsoft.com/office/drawing/2014/main" id="{C8DF9BFA-DA51-7B8B-4E72-A6650CE93A6B}"/>
+                <a16:creationId xmlns:a16="http://schemas.microsoft.com/office/drawing/2014/main" id="{E2C16C10-8A21-9D76-CD0D-98CEE967FE9B}"/>
               </a:ext>
             </a:extLst>
           </p:cNvPr>
@@ -3692,7 +3692,7 @@
           <a:bodyPr/>
           <a:lstStyle/>
           <a:p>
-            <a:fld id="{73F13BAB-2F40-4C9F-9315-0045E09C09F5}" type="datetimeFigureOut">
+            <a:fld id="{15A8FFEB-E879-4FDF-9D96-2182B35409E6}" type="datetimeFigureOut">
               <a:rPr lang="ru-RU" smtClean="0"/>
               <a:t>27.09.2026</a:t>
             </a:fld>
@@ -3705,7 +3705,7 @@
           <p:cNvPr id="6" name="Нижний колонтитул 5">
             <a:extLst>
               <a:ext uri="{FF2B5EF4-FFF2-40B4-BE49-F238E27FC236}">
-                <a16:creationId xmlns:a16="http://schemas.microsoft.com/office/drawing/2014/main" id="{66310784-0FA9-DFB7-7E13-D63D3E9E6966}"/>
+                <a16:creationId xmlns:a16="http://schemas.microsoft.com/office/drawing/2014/main" id="{F6775494-6FE1-B397-5357-A799C11FDCA0}"/>
               </a:ext>
             </a:extLst>
           </p:cNvPr>
@@ -3730,7 +3730,7 @@
           <p:cNvPr id="7" name="Номер слайда 6">
             <a:extLst>
               <a:ext uri="{FF2B5EF4-FFF2-40B4-BE49-F238E27FC236}">
-                <a16:creationId xmlns:a16="http://schemas.microsoft.com/office/drawing/2014/main" id="{980236B5-F430-E112-4E40-729FABA68E42}"/>
+                <a16:creationId xmlns:a16="http://schemas.microsoft.com/office/drawing/2014/main" id="{6CD31864-C14C-3843-56C5-382DF0A0A05F}"/>
               </a:ext>
             </a:extLst>
           </p:cNvPr>
@@ -3746,7 +3746,7 @@
           <a:bodyPr/>
           <a:lstStyle/>
           <a:p>
-            <a:fld id="{7D6D9F5E-E54D-4DE1-B539-7084078D4CDE}" type="slidenum">
+            <a:fld id="{B11C1C88-F033-4FE0-A8AC-6BB6689B4121}" type="slidenum">
               <a:rPr lang="ru-RU" smtClean="0"/>
               <a:t>‹#›</a:t>
             </a:fld>
@@ -3757,7 +3757,7 @@
     </p:spTree>
     <p:extLst>
       <p:ext uri="{BB962C8B-B14F-4D97-AF65-F5344CB8AC3E}">
-        <p14:creationId xmlns:p14="http://schemas.microsoft.com/office/powerpoint/2010/main" val="1159887587"/>
+        <p14:creationId xmlns:p14="http://schemas.microsoft.com/office/powerpoint/2010/main" val="2756287586"/>
       </p:ext>
     </p:extLst>
   </p:cSld>
@@ -3789,7 +3789,7 @@
           <p:cNvPr id="2" name="Заголовок 1">
             <a:extLst>
               <a:ext uri="{FF2B5EF4-FFF2-40B4-BE49-F238E27FC236}">
-                <a16:creationId xmlns:a16="http://schemas.microsoft.com/office/drawing/2014/main" id="{09D3C79B-3BAF-C547-173E-9AA3E62CDD8A}"/>
+                <a16:creationId xmlns:a16="http://schemas.microsoft.com/office/drawing/2014/main" id="{665E2526-F7D7-724F-2450-2798B37DC58C}"/>
               </a:ext>
             </a:extLst>
           </p:cNvPr>
@@ -3826,7 +3826,7 @@
           <p:cNvPr id="3" name="Рисунок 2">
             <a:extLst>
               <a:ext uri="{FF2B5EF4-FFF2-40B4-BE49-F238E27FC236}">
-                <a16:creationId xmlns:a16="http://schemas.microsoft.com/office/drawing/2014/main" id="{FE102200-3A85-138D-F2DC-FAD7E07DD442}"/>
+                <a16:creationId xmlns:a16="http://schemas.microsoft.com/office/drawing/2014/main" id="{75BF8137-DCB0-F471-2B49-67DC8B296CA2}"/>
               </a:ext>
             </a:extLst>
           </p:cNvPr>
@@ -3893,7 +3893,7 @@
           <p:cNvPr id="4" name="Текст 3">
             <a:extLst>
               <a:ext uri="{FF2B5EF4-FFF2-40B4-BE49-F238E27FC236}">
-                <a16:creationId xmlns:a16="http://schemas.microsoft.com/office/drawing/2014/main" id="{B5B13C52-3857-4E0B-1FFD-2FDB8D604DDD}"/>
+                <a16:creationId xmlns:a16="http://schemas.microsoft.com/office/drawing/2014/main" id="{936581C6-D9F0-1CA8-EC2A-DE6712B4DF55}"/>
               </a:ext>
             </a:extLst>
           </p:cNvPr>
@@ -3964,7 +3964,7 @@
           <p:cNvPr id="5" name="Дата 4">
             <a:extLst>
               <a:ext uri="{FF2B5EF4-FFF2-40B4-BE49-F238E27FC236}">
-                <a16:creationId xmlns:a16="http://schemas.microsoft.com/office/drawing/2014/main" id="{540BE715-22D6-6675-D678-196ED4C9A6A9}"/>
+                <a16:creationId xmlns:a16="http://schemas.microsoft.com/office/drawing/2014/main" id="{6C100A6C-6CF8-5AF5-C6CB-0DECCE1DF927}"/>
               </a:ext>
             </a:extLst>
           </p:cNvPr>
@@ -3980,7 +3980,7 @@
           <a:bodyPr/>
           <a:lstStyle/>
           <a:p>
-            <a:fld id="{73F13BAB-2F40-4C9F-9315-0045E09C09F5}" type="datetimeFigureOut">
+            <a:fld id="{15A8FFEB-E879-4FDF-9D96-2182B35409E6}" type="datetimeFigureOut">
               <a:rPr lang="ru-RU" smtClean="0"/>
               <a:t>27.09.2026</a:t>
             </a:fld>
@@ -3993,7 +3993,7 @@
           <p:cNvPr id="6" name="Нижний колонтитул 5">
             <a:extLst>
               <a:ext uri="{FF2B5EF4-FFF2-40B4-BE49-F238E27FC236}">
-                <a16:creationId xmlns:a16="http://schemas.microsoft.com/office/drawing/2014/main" id="{9ACCB8B2-DEA5-C007-3C7C-0DFE5169D9E9}"/>
+                <a16:creationId xmlns:a16="http://schemas.microsoft.com/office/drawing/2014/main" id="{6B914347-BBE4-E3AF-8676-05C118F84968}"/>
               </a:ext>
             </a:extLst>
           </p:cNvPr>
@@ -4018,7 +4018,7 @@
           <p:cNvPr id="7" name="Номер слайда 6">
             <a:extLst>
               <a:ext uri="{FF2B5EF4-FFF2-40B4-BE49-F238E27FC236}">
-                <a16:creationId xmlns:a16="http://schemas.microsoft.com/office/drawing/2014/main" id="{763DBF68-461B-EB16-CA7F-3538FEEE8C36}"/>
+                <a16:creationId xmlns:a16="http://schemas.microsoft.com/office/drawing/2014/main" id="{EA89EA60-E393-1ED3-7255-997E47EF28F4}"/>
               </a:ext>
             </a:extLst>
           </p:cNvPr>
@@ -4034,7 +4034,7 @@
           <a:bodyPr/>
           <a:lstStyle/>
           <a:p>
-            <a:fld id="{7D6D9F5E-E54D-4DE1-B539-7084078D4CDE}" type="slidenum">
+            <a:fld id="{B11C1C88-F033-4FE0-A8AC-6BB6689B4121}" type="slidenum">
               <a:rPr lang="ru-RU" smtClean="0"/>
               <a:t>‹#›</a:t>
             </a:fld>
@@ -4045,7 +4045,7 @@
     </p:spTree>
     <p:extLst>
       <p:ext uri="{BB962C8B-B14F-4D97-AF65-F5344CB8AC3E}">
-        <p14:creationId xmlns:p14="http://schemas.microsoft.com/office/powerpoint/2010/main" val="2781324900"/>
+        <p14:creationId xmlns:p14="http://schemas.microsoft.com/office/powerpoint/2010/main" val="4222564825"/>
       </p:ext>
     </p:extLst>
   </p:cSld>
@@ -4082,7 +4082,7 @@
           <p:cNvPr id="2" name="Заголовок 1">
             <a:extLst>
               <a:ext uri="{FF2B5EF4-FFF2-40B4-BE49-F238E27FC236}">
-                <a16:creationId xmlns:a16="http://schemas.microsoft.com/office/drawing/2014/main" id="{F2B4EAB2-8D60-87A0-8EEB-22BAE6F407D4}"/>
+                <a16:creationId xmlns:a16="http://schemas.microsoft.com/office/drawing/2014/main" id="{4D258E95-4E84-241D-18BB-9A31B110B161}"/>
               </a:ext>
             </a:extLst>
           </p:cNvPr>
@@ -4120,7 +4120,7 @@
           <p:cNvPr id="3" name="Текст 2">
             <a:extLst>
               <a:ext uri="{FF2B5EF4-FFF2-40B4-BE49-F238E27FC236}">
-                <a16:creationId xmlns:a16="http://schemas.microsoft.com/office/drawing/2014/main" id="{47B58AFC-FDBD-F60C-ED39-FFB7005A3B02}"/>
+                <a16:creationId xmlns:a16="http://schemas.microsoft.com/office/drawing/2014/main" id="{7A98DDC6-D2A5-E747-1915-87282200C4DC}"/>
               </a:ext>
             </a:extLst>
           </p:cNvPr>
@@ -4187,7 +4187,7 @@
           <p:cNvPr id="4" name="Дата 3">
             <a:extLst>
               <a:ext uri="{FF2B5EF4-FFF2-40B4-BE49-F238E27FC236}">
-                <a16:creationId xmlns:a16="http://schemas.microsoft.com/office/drawing/2014/main" id="{145E4400-E46D-C10A-873D-11C1256087CB}"/>
+                <a16:creationId xmlns:a16="http://schemas.microsoft.com/office/drawing/2014/main" id="{A257EAE2-5AF7-8AB4-5D46-888F3DB8C7AB}"/>
               </a:ext>
             </a:extLst>
           </p:cNvPr>
@@ -4221,7 +4221,7 @@
             </a:lvl1pPr>
           </a:lstStyle>
           <a:p>
-            <a:fld id="{73F13BAB-2F40-4C9F-9315-0045E09C09F5}" type="datetimeFigureOut">
+            <a:fld id="{15A8FFEB-E879-4FDF-9D96-2182B35409E6}" type="datetimeFigureOut">
               <a:rPr lang="ru-RU" smtClean="0"/>
               <a:t>27.09.2026</a:t>
             </a:fld>
@@ -4234,7 +4234,7 @@
           <p:cNvPr id="5" name="Нижний колонтитул 4">
             <a:extLst>
               <a:ext uri="{FF2B5EF4-FFF2-40B4-BE49-F238E27FC236}">
-                <a16:creationId xmlns:a16="http://schemas.microsoft.com/office/drawing/2014/main" id="{26133D19-E48D-B4F9-597F-128245F0ED04}"/>
+                <a16:creationId xmlns:a16="http://schemas.microsoft.com/office/drawing/2014/main" id="{5186ED23-BAD2-D98A-DD45-6BF426344F6E}"/>
               </a:ext>
             </a:extLst>
           </p:cNvPr>
@@ -4277,7 +4277,7 @@
           <p:cNvPr id="6" name="Номер слайда 5">
             <a:extLst>
               <a:ext uri="{FF2B5EF4-FFF2-40B4-BE49-F238E27FC236}">
-                <a16:creationId xmlns:a16="http://schemas.microsoft.com/office/drawing/2014/main" id="{19FE1AEC-7113-09D7-A043-DE47F9647A66}"/>
+                <a16:creationId xmlns:a16="http://schemas.microsoft.com/office/drawing/2014/main" id="{B09B0583-CFCE-64FD-9ADE-358EEA7662C4}"/>
               </a:ext>
             </a:extLst>
           </p:cNvPr>
@@ -4311,7 +4311,7 @@
             </a:lvl1pPr>
           </a:lstStyle>
           <a:p>
-            <a:fld id="{7D6D9F5E-E54D-4DE1-B539-7084078D4CDE}" type="slidenum">
+            <a:fld id="{B11C1C88-F033-4FE0-A8AC-6BB6689B4121}" type="slidenum">
               <a:rPr lang="ru-RU" smtClean="0"/>
               <a:t>‹#›</a:t>
             </a:fld>
@@ -4322,7 +4322,7 @@
     </p:spTree>
     <p:extLst>
       <p:ext uri="{BB962C8B-B14F-4D97-AF65-F5344CB8AC3E}">
-        <p14:creationId xmlns:p14="http://schemas.microsoft.com/office/powerpoint/2010/main" val="3180847840"/>
+        <p14:creationId xmlns:p14="http://schemas.microsoft.com/office/powerpoint/2010/main" val="4255779004"/>
       </p:ext>
     </p:extLst>
   </p:cSld>
@@ -4653,7 +4653,7 @@
           <p:cNvPr id="2" name="TextBox 1">
             <a:extLst>
               <a:ext uri="{FF2B5EF4-FFF2-40B4-BE49-F238E27FC236}">
-                <a16:creationId xmlns:a16="http://schemas.microsoft.com/office/drawing/2014/main" id="{215CFB45-0A47-2F09-E55E-06FDDA872D36}"/>
+                <a16:creationId xmlns:a16="http://schemas.microsoft.com/office/drawing/2014/main" id="{30B61710-DCAA-EF30-A22E-7727E120F645}"/>
               </a:ext>
             </a:extLst>
           </p:cNvPr>
@@ -4693,7 +4693,7 @@
           <p:cNvPr id="3" name="TextBox 2">
             <a:extLst>
               <a:ext uri="{FF2B5EF4-FFF2-40B4-BE49-F238E27FC236}">
-                <a16:creationId xmlns:a16="http://schemas.microsoft.com/office/drawing/2014/main" id="{7DB743A1-426A-9DE3-0D9E-DC64E2DB5EDD}"/>
+                <a16:creationId xmlns:a16="http://schemas.microsoft.com/office/drawing/2014/main" id="{ECAB9CE4-1DD7-7F62-26A5-FF65A0771999}"/>
               </a:ext>
             </a:extLst>
           </p:cNvPr>
@@ -4733,7 +4733,7 @@
           <p:cNvPr id="4" name="TextBox 3">
             <a:extLst>
               <a:ext uri="{FF2B5EF4-FFF2-40B4-BE49-F238E27FC236}">
-                <a16:creationId xmlns:a16="http://schemas.microsoft.com/office/drawing/2014/main" id="{6CF6E962-44A7-987C-AD07-59CD93386051}"/>
+                <a16:creationId xmlns:a16="http://schemas.microsoft.com/office/drawing/2014/main" id="{37E299B8-FACA-8D18-AEB1-95A0B39C8243}"/>
               </a:ext>
             </a:extLst>
           </p:cNvPr>
@@ -4773,7 +4773,7 @@
           <p:cNvPr id="5" name="TextBox 4">
             <a:extLst>
               <a:ext uri="{FF2B5EF4-FFF2-40B4-BE49-F238E27FC236}">
-                <a16:creationId xmlns:a16="http://schemas.microsoft.com/office/drawing/2014/main" id="{E51AA8E3-85E3-C153-93FB-B03F7CA40620}"/>
+                <a16:creationId xmlns:a16="http://schemas.microsoft.com/office/drawing/2014/main" id="{D486C5F5-EC75-4FF1-8FAC-E9C15AB4779A}"/>
               </a:ext>
             </a:extLst>
           </p:cNvPr>
@@ -4813,7 +4813,7 @@
           <p:cNvPr id="6" name="Овал 5">
             <a:extLst>
               <a:ext uri="{FF2B5EF4-FFF2-40B4-BE49-F238E27FC236}">
-                <a16:creationId xmlns:a16="http://schemas.microsoft.com/office/drawing/2014/main" id="{97FF39BA-4B17-2995-4898-F0FFC6D50DCB}"/>
+                <a16:creationId xmlns:a16="http://schemas.microsoft.com/office/drawing/2014/main" id="{E258BAD7-E8FC-34C6-409F-4BFFC2327FF5}"/>
               </a:ext>
             </a:extLst>
           </p:cNvPr>
@@ -4877,7 +4877,7 @@
           <p:cNvPr id="7" name="Равнобедренный треугольник 6">
             <a:extLst>
               <a:ext uri="{FF2B5EF4-FFF2-40B4-BE49-F238E27FC236}">
-                <a16:creationId xmlns:a16="http://schemas.microsoft.com/office/drawing/2014/main" id="{20E7BA2E-5F27-BA28-CF97-C84B0AB036B6}"/>
+                <a16:creationId xmlns:a16="http://schemas.microsoft.com/office/drawing/2014/main" id="{C7F0800D-2657-5B16-BCC8-4B65CBC61979}"/>
               </a:ext>
             </a:extLst>
           </p:cNvPr>
@@ -4941,7 +4941,7 @@
           <p:cNvPr id="8" name="Овал 7">
             <a:extLst>
               <a:ext uri="{FF2B5EF4-FFF2-40B4-BE49-F238E27FC236}">
-                <a16:creationId xmlns:a16="http://schemas.microsoft.com/office/drawing/2014/main" id="{877A6323-5125-28D4-471A-1E9CE3CEB1E2}"/>
+                <a16:creationId xmlns:a16="http://schemas.microsoft.com/office/drawing/2014/main" id="{F263A5D2-ADEC-2286-5151-9E502101D411}"/>
               </a:ext>
             </a:extLst>
           </p:cNvPr>
@@ -5005,7 +5005,7 @@
           <p:cNvPr id="9" name="Овал 8">
             <a:extLst>
               <a:ext uri="{FF2B5EF4-FFF2-40B4-BE49-F238E27FC236}">
-                <a16:creationId xmlns:a16="http://schemas.microsoft.com/office/drawing/2014/main" id="{789A9BBD-C65D-8767-124C-C203BF97FE20}"/>
+                <a16:creationId xmlns:a16="http://schemas.microsoft.com/office/drawing/2014/main" id="{FDE2DC66-372A-5BE7-526F-D44FCADA6509}"/>
               </a:ext>
             </a:extLst>
           </p:cNvPr>
@@ -5069,7 +5069,7 @@
           <p:cNvPr id="10" name="Овал 9">
             <a:extLst>
               <a:ext uri="{FF2B5EF4-FFF2-40B4-BE49-F238E27FC236}">
-                <a16:creationId xmlns:a16="http://schemas.microsoft.com/office/drawing/2014/main" id="{99EB3632-073E-D152-DA06-7B120EDFC22D}"/>
+                <a16:creationId xmlns:a16="http://schemas.microsoft.com/office/drawing/2014/main" id="{3DF45ACB-335C-B734-C189-8603B663B08F}"/>
               </a:ext>
             </a:extLst>
           </p:cNvPr>
@@ -5151,7 +5151,7 @@
           <p:cNvPr id="11" name="Овал 10">
             <a:extLst>
               <a:ext uri="{FF2B5EF4-FFF2-40B4-BE49-F238E27FC236}">
-                <a16:creationId xmlns:a16="http://schemas.microsoft.com/office/drawing/2014/main" id="{87003849-33A3-6E20-0832-469DE572C591}"/>
+                <a16:creationId xmlns:a16="http://schemas.microsoft.com/office/drawing/2014/main" id="{BD5C3B98-DAD5-88B9-4F73-CE6C93F99C52}"/>
               </a:ext>
             </a:extLst>
           </p:cNvPr>
@@ -5233,7 +5233,7 @@
           <p:cNvPr id="12" name="Овал 11">
             <a:extLst>
               <a:ext uri="{FF2B5EF4-FFF2-40B4-BE49-F238E27FC236}">
-                <a16:creationId xmlns:a16="http://schemas.microsoft.com/office/drawing/2014/main" id="{95BC7A9E-0136-79D8-77AB-71138B52F3B6}"/>
+                <a16:creationId xmlns:a16="http://schemas.microsoft.com/office/drawing/2014/main" id="{7657425E-A39D-4CDA-022B-067AC390C24F}"/>
               </a:ext>
             </a:extLst>
           </p:cNvPr>
@@ -5315,7 +5315,7 @@
           <p:cNvPr id="13" name="Овал 12">
             <a:extLst>
               <a:ext uri="{FF2B5EF4-FFF2-40B4-BE49-F238E27FC236}">
-                <a16:creationId xmlns:a16="http://schemas.microsoft.com/office/drawing/2014/main" id="{7819C63C-12F1-50F2-95D7-26B472CE5107}"/>
+                <a16:creationId xmlns:a16="http://schemas.microsoft.com/office/drawing/2014/main" id="{49202A97-D9B4-E3C7-C38E-7E38B00ABC67}"/>
               </a:ext>
             </a:extLst>
           </p:cNvPr>
@@ -5397,7 +5397,7 @@
           <p:cNvPr id="14" name="Овал 13">
             <a:extLst>
               <a:ext uri="{FF2B5EF4-FFF2-40B4-BE49-F238E27FC236}">
-                <a16:creationId xmlns:a16="http://schemas.microsoft.com/office/drawing/2014/main" id="{646C8E81-ED18-4748-849E-750D9169BEDC}"/>
+                <a16:creationId xmlns:a16="http://schemas.microsoft.com/office/drawing/2014/main" id="{C7C6BFCA-1060-E79E-986F-4FFBD21866DD}"/>
               </a:ext>
             </a:extLst>
           </p:cNvPr>
@@ -5479,7 +5479,7 @@
           <p:cNvPr id="15" name="Овал 14">
             <a:extLst>
               <a:ext uri="{FF2B5EF4-FFF2-40B4-BE49-F238E27FC236}">
-                <a16:creationId xmlns:a16="http://schemas.microsoft.com/office/drawing/2014/main" id="{D8532372-5113-DA95-9831-A4C554893795}"/>
+                <a16:creationId xmlns:a16="http://schemas.microsoft.com/office/drawing/2014/main" id="{5D9504A3-80D2-4CC7-8652-123A7B5E3085}"/>
               </a:ext>
             </a:extLst>
           </p:cNvPr>
@@ -5559,7 +5559,7 @@
     </p:spTree>
     <p:extLst>
       <p:ext uri="{BB962C8B-B14F-4D97-AF65-F5344CB8AC3E}">
-        <p14:creationId xmlns:p14="http://schemas.microsoft.com/office/powerpoint/2010/main" val="1642796646"/>
+        <p14:creationId xmlns:p14="http://schemas.microsoft.com/office/powerpoint/2010/main" val="2886681459"/>
       </p:ext>
     </p:extLst>
   </p:cSld>
@@ -5599,7 +5599,7 @@
           <p:cNvPr id="2" name="TextBox 1">
             <a:extLst>
               <a:ext uri="{FF2B5EF4-FFF2-40B4-BE49-F238E27FC236}">
-                <a16:creationId xmlns:a16="http://schemas.microsoft.com/office/drawing/2014/main" id="{493A4145-F277-2688-57B8-0B25BC541A81}"/>
+                <a16:creationId xmlns:a16="http://schemas.microsoft.com/office/drawing/2014/main" id="{2F8D4B64-1ACC-4C06-3046-45B7B18B3C06}"/>
               </a:ext>
             </a:extLst>
           </p:cNvPr>
@@ -5639,7 +5639,7 @@
           <p:cNvPr id="4" name="Рисунок 3">
             <a:extLst>
               <a:ext uri="{FF2B5EF4-FFF2-40B4-BE49-F238E27FC236}">
-                <a16:creationId xmlns:a16="http://schemas.microsoft.com/office/drawing/2014/main" id="{47E2EF35-A1E8-3E5C-FDB3-0E69C48BEEF3}"/>
+                <a16:creationId xmlns:a16="http://schemas.microsoft.com/office/drawing/2014/main" id="{A3976B44-FD59-BDF1-8459-9EC6335241E5}"/>
               </a:ext>
             </a:extLst>
           </p:cNvPr>
@@ -5675,7 +5675,7 @@
           <p:cNvPr id="5" name="Прямоугольник: скругленные углы 4">
             <a:extLst>
               <a:ext uri="{FF2B5EF4-FFF2-40B4-BE49-F238E27FC236}">
-                <a16:creationId xmlns:a16="http://schemas.microsoft.com/office/drawing/2014/main" id="{D438111A-BB3D-CCFC-1F5A-DA5187C5E050}"/>
+                <a16:creationId xmlns:a16="http://schemas.microsoft.com/office/drawing/2014/main" id="{1E1672FE-48ED-FA4B-4B24-67B7642EC83B}"/>
               </a:ext>
             </a:extLst>
           </p:cNvPr>
@@ -5745,7 +5745,7 @@
           <p:cNvPr id="6" name="Прямоугольник: скругленные углы 5">
             <a:extLst>
               <a:ext uri="{FF2B5EF4-FFF2-40B4-BE49-F238E27FC236}">
-                <a16:creationId xmlns:a16="http://schemas.microsoft.com/office/drawing/2014/main" id="{B3FD9EEB-F8E0-7DBC-B68B-685D7FA4DF55}"/>
+                <a16:creationId xmlns:a16="http://schemas.microsoft.com/office/drawing/2014/main" id="{C2B8D6B6-3DFD-577B-3996-8C52D0381A35}"/>
               </a:ext>
             </a:extLst>
           </p:cNvPr>
@@ -5823,7 +5823,7 @@
           <p:cNvPr id="7" name="TextBox 6">
             <a:extLst>
               <a:ext uri="{FF2B5EF4-FFF2-40B4-BE49-F238E27FC236}">
-                <a16:creationId xmlns:a16="http://schemas.microsoft.com/office/drawing/2014/main" id="{C3599924-D22A-A2E2-D836-32F958296D25}"/>
+                <a16:creationId xmlns:a16="http://schemas.microsoft.com/office/drawing/2014/main" id="{4B20B320-6341-0DAA-B9C9-48C7C2145BF9}"/>
               </a:ext>
             </a:extLst>
           </p:cNvPr>
@@ -5863,7 +5863,7 @@
           <p:cNvPr id="8" name="Прямоугольник: скругленные углы 7">
             <a:extLst>
               <a:ext uri="{FF2B5EF4-FFF2-40B4-BE49-F238E27FC236}">
-                <a16:creationId xmlns:a16="http://schemas.microsoft.com/office/drawing/2014/main" id="{90946725-C99D-4C74-67A9-845E0F99E879}"/>
+                <a16:creationId xmlns:a16="http://schemas.microsoft.com/office/drawing/2014/main" id="{B60A93A1-F27B-67AC-2E9C-EEF3CD1B576D}"/>
               </a:ext>
             </a:extLst>
           </p:cNvPr>
@@ -5933,7 +5933,7 @@
           <p:cNvPr id="9" name="Прямоугольник: скругленные углы 8">
             <a:extLst>
               <a:ext uri="{FF2B5EF4-FFF2-40B4-BE49-F238E27FC236}">
-                <a16:creationId xmlns:a16="http://schemas.microsoft.com/office/drawing/2014/main" id="{1339E05C-2545-93B5-996C-D256867C74B9}"/>
+                <a16:creationId xmlns:a16="http://schemas.microsoft.com/office/drawing/2014/main" id="{EFE5AD85-3FC8-A7BE-FE13-8C4C31A217A8}"/>
               </a:ext>
             </a:extLst>
           </p:cNvPr>
@@ -6011,7 +6011,7 @@
           <p:cNvPr id="10" name="TextBox 9">
             <a:extLst>
               <a:ext uri="{FF2B5EF4-FFF2-40B4-BE49-F238E27FC236}">
-                <a16:creationId xmlns:a16="http://schemas.microsoft.com/office/drawing/2014/main" id="{05EA09DC-3BDC-E800-0A11-462EE184FC32}"/>
+                <a16:creationId xmlns:a16="http://schemas.microsoft.com/office/drawing/2014/main" id="{A57D76E9-9ED3-BC10-A61D-C1990916DE4C}"/>
               </a:ext>
             </a:extLst>
           </p:cNvPr>
@@ -6051,7 +6051,7 @@
           <p:cNvPr id="11" name="Прямоугольник: скругленные углы 10">
             <a:extLst>
               <a:ext uri="{FF2B5EF4-FFF2-40B4-BE49-F238E27FC236}">
-                <a16:creationId xmlns:a16="http://schemas.microsoft.com/office/drawing/2014/main" id="{F2CD3F32-715C-057F-9170-DE188D2FAB5A}"/>
+                <a16:creationId xmlns:a16="http://schemas.microsoft.com/office/drawing/2014/main" id="{1C228E6D-1947-18CD-6937-A50621B6E3D4}"/>
               </a:ext>
             </a:extLst>
           </p:cNvPr>
@@ -6121,7 +6121,7 @@
           <p:cNvPr id="12" name="Прямоугольник: скругленные углы 11">
             <a:extLst>
               <a:ext uri="{FF2B5EF4-FFF2-40B4-BE49-F238E27FC236}">
-                <a16:creationId xmlns:a16="http://schemas.microsoft.com/office/drawing/2014/main" id="{91B03528-D4A5-A1DE-B632-AA03C9470B40}"/>
+                <a16:creationId xmlns:a16="http://schemas.microsoft.com/office/drawing/2014/main" id="{7DF96373-9F40-1A84-CEBC-70B6BDE3EB08}"/>
               </a:ext>
             </a:extLst>
           </p:cNvPr>
@@ -6199,7 +6199,7 @@
           <p:cNvPr id="13" name="TextBox 12">
             <a:extLst>
               <a:ext uri="{FF2B5EF4-FFF2-40B4-BE49-F238E27FC236}">
-                <a16:creationId xmlns:a16="http://schemas.microsoft.com/office/drawing/2014/main" id="{C623C6C6-A95B-BAC8-6262-99AD3E963673}"/>
+                <a16:creationId xmlns:a16="http://schemas.microsoft.com/office/drawing/2014/main" id="{E7A30F72-F101-27AB-282E-CCEC6A3DC6C8}"/>
               </a:ext>
             </a:extLst>
           </p:cNvPr>
@@ -6237,7 +6237,7 @@
     </p:spTree>
     <p:extLst>
       <p:ext uri="{BB962C8B-B14F-4D97-AF65-F5344CB8AC3E}">
-        <p14:creationId xmlns:p14="http://schemas.microsoft.com/office/powerpoint/2010/main" val="1538803099"/>
+        <p14:creationId xmlns:p14="http://schemas.microsoft.com/office/powerpoint/2010/main" val="4096878568"/>
       </p:ext>
     </p:extLst>
   </p:cSld>
@@ -6277,7 +6277,7 @@
           <p:cNvPr id="2" name="TextBox 1">
             <a:extLst>
               <a:ext uri="{FF2B5EF4-FFF2-40B4-BE49-F238E27FC236}">
-                <a16:creationId xmlns:a16="http://schemas.microsoft.com/office/drawing/2014/main" id="{A63F8390-1B2F-B3DC-BF6E-6ABF30C52A6C}"/>
+                <a16:creationId xmlns:a16="http://schemas.microsoft.com/office/drawing/2014/main" id="{1190A15D-15AE-5F2F-1F74-B8B279B10F7B}"/>
               </a:ext>
             </a:extLst>
           </p:cNvPr>
@@ -6317,7 +6317,7 @@
           <p:cNvPr id="3" name="Овал 2">
             <a:extLst>
               <a:ext uri="{FF2B5EF4-FFF2-40B4-BE49-F238E27FC236}">
-                <a16:creationId xmlns:a16="http://schemas.microsoft.com/office/drawing/2014/main" id="{F6E3E787-0741-003C-4E5C-F6D248036A82}"/>
+                <a16:creationId xmlns:a16="http://schemas.microsoft.com/office/drawing/2014/main" id="{91802568-8DAC-C123-DF7D-819CC70B4734}"/>
               </a:ext>
             </a:extLst>
           </p:cNvPr>
@@ -6393,7 +6393,7 @@
           <p:cNvPr id="4" name="TextBox 3">
             <a:extLst>
               <a:ext uri="{FF2B5EF4-FFF2-40B4-BE49-F238E27FC236}">
-                <a16:creationId xmlns:a16="http://schemas.microsoft.com/office/drawing/2014/main" id="{8EFAEFD6-1852-D452-54F4-CE810142A118}"/>
+                <a16:creationId xmlns:a16="http://schemas.microsoft.com/office/drawing/2014/main" id="{8F5EBDE8-9DC9-9EBB-FC39-A688EF7945DC}"/>
               </a:ext>
             </a:extLst>
           </p:cNvPr>
@@ -6433,7 +6433,7 @@
           <p:cNvPr id="5" name="TextBox 4">
             <a:extLst>
               <a:ext uri="{FF2B5EF4-FFF2-40B4-BE49-F238E27FC236}">
-                <a16:creationId xmlns:a16="http://schemas.microsoft.com/office/drawing/2014/main" id="{9EB3031A-12A4-313B-30ED-877035EC131E}"/>
+                <a16:creationId xmlns:a16="http://schemas.microsoft.com/office/drawing/2014/main" id="{A9F3814A-0C14-EF53-E293-4D6B8C77330B}"/>
               </a:ext>
             </a:extLst>
           </p:cNvPr>
@@ -6516,7 +6516,7 @@
           <p:cNvPr id="6" name="Овал 5">
             <a:extLst>
               <a:ext uri="{FF2B5EF4-FFF2-40B4-BE49-F238E27FC236}">
-                <a16:creationId xmlns:a16="http://schemas.microsoft.com/office/drawing/2014/main" id="{6F8F5F7F-C29D-397D-949C-F9E4EC086558}"/>
+                <a16:creationId xmlns:a16="http://schemas.microsoft.com/office/drawing/2014/main" id="{AEC52232-6671-6082-0805-8E2992364832}"/>
               </a:ext>
             </a:extLst>
           </p:cNvPr>
@@ -6592,7 +6592,7 @@
           <p:cNvPr id="7" name="TextBox 6">
             <a:extLst>
               <a:ext uri="{FF2B5EF4-FFF2-40B4-BE49-F238E27FC236}">
-                <a16:creationId xmlns:a16="http://schemas.microsoft.com/office/drawing/2014/main" id="{77F8E7BC-33FD-B9AF-9C47-95DF558A1CEC}"/>
+                <a16:creationId xmlns:a16="http://schemas.microsoft.com/office/drawing/2014/main" id="{28E47E48-B1A0-87D5-B453-E14610090802}"/>
               </a:ext>
             </a:extLst>
           </p:cNvPr>
@@ -6632,7 +6632,7 @@
           <p:cNvPr id="8" name="TextBox 7">
             <a:extLst>
               <a:ext uri="{FF2B5EF4-FFF2-40B4-BE49-F238E27FC236}">
-                <a16:creationId xmlns:a16="http://schemas.microsoft.com/office/drawing/2014/main" id="{FF81E5E7-B4F7-C2F8-7616-FF61F884F3B2}"/>
+                <a16:creationId xmlns:a16="http://schemas.microsoft.com/office/drawing/2014/main" id="{1B99E3C1-C60A-B0AC-AB09-926B0B0AF78D}"/>
               </a:ext>
             </a:extLst>
           </p:cNvPr>
@@ -6669,7 +6669,7 @@
                 </a:solidFill>
                 <a:latin typeface="Calibri" panose="020F0502020204030204" pitchFamily="34" charset="0"/>
               </a:rPr>
-              <a:t>молодые нормы: опора на T3/T4, специфичность 0.52</a:t>
+              <a:t>молодые нормы A/B: опора на T3/T4</a:t>
             </a:r>
           </a:p>
           <a:p>
@@ -6715,7 +6715,7 @@
           <p:cNvPr id="9" name="Овал 8">
             <a:extLst>
               <a:ext uri="{FF2B5EF4-FFF2-40B4-BE49-F238E27FC236}">
-                <a16:creationId xmlns:a16="http://schemas.microsoft.com/office/drawing/2014/main" id="{9A979A59-F34C-9BE4-91C1-F762357C0663}"/>
+                <a16:creationId xmlns:a16="http://schemas.microsoft.com/office/drawing/2014/main" id="{E91658B5-966E-D956-9572-94A156C09557}"/>
               </a:ext>
             </a:extLst>
           </p:cNvPr>
@@ -6791,7 +6791,7 @@
           <p:cNvPr id="10" name="TextBox 9">
             <a:extLst>
               <a:ext uri="{FF2B5EF4-FFF2-40B4-BE49-F238E27FC236}">
-                <a16:creationId xmlns:a16="http://schemas.microsoft.com/office/drawing/2014/main" id="{238C393F-7E1E-5CA9-3DA2-562B051C2ABB}"/>
+                <a16:creationId xmlns:a16="http://schemas.microsoft.com/office/drawing/2014/main" id="{1186A681-B74A-76F2-9150-CB3E908F560C}"/>
               </a:ext>
             </a:extLst>
           </p:cNvPr>
@@ -6831,7 +6831,7 @@
           <p:cNvPr id="11" name="TextBox 10">
             <a:extLst>
               <a:ext uri="{FF2B5EF4-FFF2-40B4-BE49-F238E27FC236}">
-                <a16:creationId xmlns:a16="http://schemas.microsoft.com/office/drawing/2014/main" id="{53FF6DEC-78B0-758A-55F8-A20AC85B358B}"/>
+                <a16:creationId xmlns:a16="http://schemas.microsoft.com/office/drawing/2014/main" id="{F89456F8-18D6-83BE-901D-DE2B88BEC4B9}"/>
               </a:ext>
             </a:extLst>
           </p:cNvPr>
@@ -6914,7 +6914,7 @@
           <p:cNvPr id="12" name="TextBox 11">
             <a:extLst>
               <a:ext uri="{FF2B5EF4-FFF2-40B4-BE49-F238E27FC236}">
-                <a16:creationId xmlns:a16="http://schemas.microsoft.com/office/drawing/2014/main" id="{E8DB9901-2770-6563-5E23-F02ADD56DECA}"/>
+                <a16:creationId xmlns:a16="http://schemas.microsoft.com/office/drawing/2014/main" id="{1D49790C-480B-DEFC-59E5-0C41280BB450}"/>
               </a:ext>
             </a:extLst>
           </p:cNvPr>
@@ -6952,7 +6952,7 @@
     </p:spTree>
     <p:extLst>
       <p:ext uri="{BB962C8B-B14F-4D97-AF65-F5344CB8AC3E}">
-        <p14:creationId xmlns:p14="http://schemas.microsoft.com/office/powerpoint/2010/main" val="572381456"/>
+        <p14:creationId xmlns:p14="http://schemas.microsoft.com/office/powerpoint/2010/main" val="4119413162"/>
       </p:ext>
     </p:extLst>
   </p:cSld>
@@ -6992,7 +6992,7 @@
           <p:cNvPr id="2" name="TextBox 1">
             <a:extLst>
               <a:ext uri="{FF2B5EF4-FFF2-40B4-BE49-F238E27FC236}">
-                <a16:creationId xmlns:a16="http://schemas.microsoft.com/office/drawing/2014/main" id="{3C16AD30-FDDB-3AC9-05F1-0EBA6615972F}"/>
+                <a16:creationId xmlns:a16="http://schemas.microsoft.com/office/drawing/2014/main" id="{F2E1C4AF-D9AF-2245-C1E0-6ADB9D8C88E5}"/>
               </a:ext>
             </a:extLst>
           </p:cNvPr>
@@ -7032,7 +7032,7 @@
           <p:cNvPr id="3" name="Прямоугольник: скругленные углы 2">
             <a:extLst>
               <a:ext uri="{FF2B5EF4-FFF2-40B4-BE49-F238E27FC236}">
-                <a16:creationId xmlns:a16="http://schemas.microsoft.com/office/drawing/2014/main" id="{8BCCC534-9EC5-61A0-6B73-5F561FC8D0B7}"/>
+                <a16:creationId xmlns:a16="http://schemas.microsoft.com/office/drawing/2014/main" id="{0DF226E1-093E-C420-64C9-0768A69F5EE7}"/>
               </a:ext>
             </a:extLst>
           </p:cNvPr>
@@ -7102,7 +7102,7 @@
           <p:cNvPr id="4" name="TextBox 3">
             <a:extLst>
               <a:ext uri="{FF2B5EF4-FFF2-40B4-BE49-F238E27FC236}">
-                <a16:creationId xmlns:a16="http://schemas.microsoft.com/office/drawing/2014/main" id="{6721D235-8FC8-407A-F0E8-C96139686B12}"/>
+                <a16:creationId xmlns:a16="http://schemas.microsoft.com/office/drawing/2014/main" id="{A63EED2B-D579-A251-D249-6F88F9CC2681}"/>
               </a:ext>
             </a:extLst>
           </p:cNvPr>
@@ -7142,7 +7142,7 @@
           <p:cNvPr id="5" name="TextBox 4">
             <a:extLst>
               <a:ext uri="{FF2B5EF4-FFF2-40B4-BE49-F238E27FC236}">
-                <a16:creationId xmlns:a16="http://schemas.microsoft.com/office/drawing/2014/main" id="{2C621D45-03EF-55EF-3A55-A3B2F51D2070}"/>
+                <a16:creationId xmlns:a16="http://schemas.microsoft.com/office/drawing/2014/main" id="{C44EA277-C124-E0FB-5F3F-98797BF5F7AB}"/>
               </a:ext>
             </a:extLst>
           </p:cNvPr>
@@ -7193,7 +7193,7 @@
           <p:cNvPr id="6" name="TextBox 5">
             <a:extLst>
               <a:ext uri="{FF2B5EF4-FFF2-40B4-BE49-F238E27FC236}">
-                <a16:creationId xmlns:a16="http://schemas.microsoft.com/office/drawing/2014/main" id="{8326828C-A464-D577-60F1-2887E39E4106}"/>
+                <a16:creationId xmlns:a16="http://schemas.microsoft.com/office/drawing/2014/main" id="{319425BB-353D-05FB-E38A-0884AC6CFAA7}"/>
               </a:ext>
             </a:extLst>
           </p:cNvPr>
@@ -7276,7 +7276,7 @@
           <p:cNvPr id="7" name="TextBox 6">
             <a:extLst>
               <a:ext uri="{FF2B5EF4-FFF2-40B4-BE49-F238E27FC236}">
-                <a16:creationId xmlns:a16="http://schemas.microsoft.com/office/drawing/2014/main" id="{DD87FF7E-9B6C-8971-3159-D1AA72AEEBE9}"/>
+                <a16:creationId xmlns:a16="http://schemas.microsoft.com/office/drawing/2014/main" id="{F5FBDCF0-A694-6FE2-B9CE-4EEA1757A019}"/>
               </a:ext>
             </a:extLst>
           </p:cNvPr>
@@ -7316,7 +7316,7 @@
           <p:cNvPr id="8" name="TextBox 7">
             <a:extLst>
               <a:ext uri="{FF2B5EF4-FFF2-40B4-BE49-F238E27FC236}">
-                <a16:creationId xmlns:a16="http://schemas.microsoft.com/office/drawing/2014/main" id="{D09C7559-C2A2-27B4-8033-5AF6F895BDBA}"/>
+                <a16:creationId xmlns:a16="http://schemas.microsoft.com/office/drawing/2014/main" id="{3590D69E-7E60-6451-18CB-5398681AF26B}"/>
               </a:ext>
             </a:extLst>
           </p:cNvPr>
@@ -7356,7 +7356,7 @@
           <p:cNvPr id="9" name="TextBox 8">
             <a:extLst>
               <a:ext uri="{FF2B5EF4-FFF2-40B4-BE49-F238E27FC236}">
-                <a16:creationId xmlns:a16="http://schemas.microsoft.com/office/drawing/2014/main" id="{F125146E-2FE2-816C-76B2-8B305C2C9C18}"/>
+                <a16:creationId xmlns:a16="http://schemas.microsoft.com/office/drawing/2014/main" id="{A49975A0-113A-3980-1B6E-8FBD67EF75A2}"/>
               </a:ext>
             </a:extLst>
           </p:cNvPr>
@@ -7396,7 +7396,7 @@
           <p:cNvPr id="10" name="TextBox 9">
             <a:extLst>
               <a:ext uri="{FF2B5EF4-FFF2-40B4-BE49-F238E27FC236}">
-                <a16:creationId xmlns:a16="http://schemas.microsoft.com/office/drawing/2014/main" id="{760A3887-1E9F-5B91-3799-2BB5996BBD3D}"/>
+                <a16:creationId xmlns:a16="http://schemas.microsoft.com/office/drawing/2014/main" id="{A626A39A-CBF0-17A8-D563-AE434F6513EC}"/>
               </a:ext>
             </a:extLst>
           </p:cNvPr>
@@ -7436,7 +7436,7 @@
           <p:cNvPr id="11" name="TextBox 10">
             <a:extLst>
               <a:ext uri="{FF2B5EF4-FFF2-40B4-BE49-F238E27FC236}">
-                <a16:creationId xmlns:a16="http://schemas.microsoft.com/office/drawing/2014/main" id="{F6D3086C-E38A-BB20-3A4D-40252137E733}"/>
+                <a16:creationId xmlns:a16="http://schemas.microsoft.com/office/drawing/2014/main" id="{0360BAF4-0AB3-D949-1DF3-819AF0A9C529}"/>
               </a:ext>
             </a:extLst>
           </p:cNvPr>
@@ -7476,7 +7476,7 @@
           <p:cNvPr id="12" name="TextBox 11">
             <a:extLst>
               <a:ext uri="{FF2B5EF4-FFF2-40B4-BE49-F238E27FC236}">
-                <a16:creationId xmlns:a16="http://schemas.microsoft.com/office/drawing/2014/main" id="{0310432A-AF53-AF80-23AB-47864C09BD85}"/>
+                <a16:creationId xmlns:a16="http://schemas.microsoft.com/office/drawing/2014/main" id="{FC72F0BB-4953-B8C6-4989-0C64F73525D2}"/>
               </a:ext>
             </a:extLst>
           </p:cNvPr>
@@ -7516,7 +7516,7 @@
           <p:cNvPr id="13" name="TextBox 12">
             <a:extLst>
               <a:ext uri="{FF2B5EF4-FFF2-40B4-BE49-F238E27FC236}">
-                <a16:creationId xmlns:a16="http://schemas.microsoft.com/office/drawing/2014/main" id="{60599B3C-4B82-A6A0-170F-727EC78EE57E}"/>
+                <a16:creationId xmlns:a16="http://schemas.microsoft.com/office/drawing/2014/main" id="{4575A779-7833-4EC7-013D-AEB1F09588FF}"/>
               </a:ext>
             </a:extLst>
           </p:cNvPr>
@@ -7554,7 +7554,7 @@
     </p:spTree>
     <p:extLst>
       <p:ext uri="{BB962C8B-B14F-4D97-AF65-F5344CB8AC3E}">
-        <p14:creationId xmlns:p14="http://schemas.microsoft.com/office/powerpoint/2010/main" val="298523202"/>
+        <p14:creationId xmlns:p14="http://schemas.microsoft.com/office/powerpoint/2010/main" val="524155257"/>
       </p:ext>
     </p:extLst>
   </p:cSld>
@@ -7594,7 +7594,7 @@
           <p:cNvPr id="2" name="TextBox 1">
             <a:extLst>
               <a:ext uri="{FF2B5EF4-FFF2-40B4-BE49-F238E27FC236}">
-                <a16:creationId xmlns:a16="http://schemas.microsoft.com/office/drawing/2014/main" id="{68EFCF7E-BCA7-89C0-72C9-8E4A309F2152}"/>
+                <a16:creationId xmlns:a16="http://schemas.microsoft.com/office/drawing/2014/main" id="{3D342418-5649-2506-054E-4CAE30B735BC}"/>
               </a:ext>
             </a:extLst>
           </p:cNvPr>
@@ -7634,7 +7634,7 @@
           <p:cNvPr id="3" name="Прямоугольник: скругленные углы 2">
             <a:extLst>
               <a:ext uri="{FF2B5EF4-FFF2-40B4-BE49-F238E27FC236}">
-                <a16:creationId xmlns:a16="http://schemas.microsoft.com/office/drawing/2014/main" id="{7238F9B3-F5DE-B723-569A-C7C057FFE9F4}"/>
+                <a16:creationId xmlns:a16="http://schemas.microsoft.com/office/drawing/2014/main" id="{42712A30-E59F-1E02-2312-F59F4EBFBCCB}"/>
               </a:ext>
             </a:extLst>
           </p:cNvPr>
@@ -7704,7 +7704,7 @@
           <p:cNvPr id="4" name="Овал 3">
             <a:extLst>
               <a:ext uri="{FF2B5EF4-FFF2-40B4-BE49-F238E27FC236}">
-                <a16:creationId xmlns:a16="http://schemas.microsoft.com/office/drawing/2014/main" id="{D3F0CFA3-3A8A-3118-08EF-5D3BDCF62A0A}"/>
+                <a16:creationId xmlns:a16="http://schemas.microsoft.com/office/drawing/2014/main" id="{67690691-AC7F-0590-4FC2-46910CA3F28B}"/>
               </a:ext>
             </a:extLst>
           </p:cNvPr>
@@ -7780,7 +7780,7 @@
           <p:cNvPr id="5" name="TextBox 4">
             <a:extLst>
               <a:ext uri="{FF2B5EF4-FFF2-40B4-BE49-F238E27FC236}">
-                <a16:creationId xmlns:a16="http://schemas.microsoft.com/office/drawing/2014/main" id="{E39E37D8-8085-B8D0-AD96-1858DC0F4301}"/>
+                <a16:creationId xmlns:a16="http://schemas.microsoft.com/office/drawing/2014/main" id="{ADE01C6A-01BE-5476-3BA6-14F9C0E73055}"/>
               </a:ext>
             </a:extLst>
           </p:cNvPr>
@@ -7826,7 +7826,7 @@
           <p:cNvPr id="6" name="TextBox 5">
             <a:extLst>
               <a:ext uri="{FF2B5EF4-FFF2-40B4-BE49-F238E27FC236}">
-                <a16:creationId xmlns:a16="http://schemas.microsoft.com/office/drawing/2014/main" id="{97081BF6-8319-7C1C-1F6C-B878587FFA61}"/>
+                <a16:creationId xmlns:a16="http://schemas.microsoft.com/office/drawing/2014/main" id="{85BF0840-5071-7528-F174-815A6A3980F5}"/>
               </a:ext>
             </a:extLst>
           </p:cNvPr>
@@ -7866,7 +7866,7 @@
           <p:cNvPr id="7" name="Прямоугольник: скругленные углы 6">
             <a:extLst>
               <a:ext uri="{FF2B5EF4-FFF2-40B4-BE49-F238E27FC236}">
-                <a16:creationId xmlns:a16="http://schemas.microsoft.com/office/drawing/2014/main" id="{9E5E2F43-D23A-ADF9-2E27-52C00281613A}"/>
+                <a16:creationId xmlns:a16="http://schemas.microsoft.com/office/drawing/2014/main" id="{B69A7875-8AD2-39C6-EF58-DEB3572A39E2}"/>
               </a:ext>
             </a:extLst>
           </p:cNvPr>
@@ -7936,7 +7936,7 @@
           <p:cNvPr id="8" name="Овал 7">
             <a:extLst>
               <a:ext uri="{FF2B5EF4-FFF2-40B4-BE49-F238E27FC236}">
-                <a16:creationId xmlns:a16="http://schemas.microsoft.com/office/drawing/2014/main" id="{1B780208-9753-585E-0E97-9B54AA58429D}"/>
+                <a16:creationId xmlns:a16="http://schemas.microsoft.com/office/drawing/2014/main" id="{95186EEF-B7C9-09FE-CE19-07C92376D9BB}"/>
               </a:ext>
             </a:extLst>
           </p:cNvPr>
@@ -8012,7 +8012,7 @@
           <p:cNvPr id="9" name="TextBox 8">
             <a:extLst>
               <a:ext uri="{FF2B5EF4-FFF2-40B4-BE49-F238E27FC236}">
-                <a16:creationId xmlns:a16="http://schemas.microsoft.com/office/drawing/2014/main" id="{1787685D-4D8A-3EBB-6C08-598E7C8959D4}"/>
+                <a16:creationId xmlns:a16="http://schemas.microsoft.com/office/drawing/2014/main" id="{F44564DE-64A6-B6C0-0D7E-AD99309C7DB8}"/>
               </a:ext>
             </a:extLst>
           </p:cNvPr>
@@ -8052,7 +8052,7 @@
           <p:cNvPr id="10" name="TextBox 9">
             <a:extLst>
               <a:ext uri="{FF2B5EF4-FFF2-40B4-BE49-F238E27FC236}">
-                <a16:creationId xmlns:a16="http://schemas.microsoft.com/office/drawing/2014/main" id="{E5CED64B-C56E-3FC2-5EF6-A827922D6C44}"/>
+                <a16:creationId xmlns:a16="http://schemas.microsoft.com/office/drawing/2014/main" id="{5BE1ADB6-82AA-6C1E-DA2C-6B3DEE2724D5}"/>
               </a:ext>
             </a:extLst>
           </p:cNvPr>
@@ -8092,7 +8092,7 @@
           <p:cNvPr id="11" name="Прямоугольник: скругленные углы 10">
             <a:extLst>
               <a:ext uri="{FF2B5EF4-FFF2-40B4-BE49-F238E27FC236}">
-                <a16:creationId xmlns:a16="http://schemas.microsoft.com/office/drawing/2014/main" id="{E971CA12-D25B-F858-8F8A-A56BA68C3DE8}"/>
+                <a16:creationId xmlns:a16="http://schemas.microsoft.com/office/drawing/2014/main" id="{AB786A4D-96DC-D7DD-FE42-CCBF77F82DAC}"/>
               </a:ext>
             </a:extLst>
           </p:cNvPr>
@@ -8162,7 +8162,7 @@
           <p:cNvPr id="12" name="Овал 11">
             <a:extLst>
               <a:ext uri="{FF2B5EF4-FFF2-40B4-BE49-F238E27FC236}">
-                <a16:creationId xmlns:a16="http://schemas.microsoft.com/office/drawing/2014/main" id="{7D373C01-F908-2C69-D962-F40D88282006}"/>
+                <a16:creationId xmlns:a16="http://schemas.microsoft.com/office/drawing/2014/main" id="{0F74791E-811A-976D-1DB5-866728B62132}"/>
               </a:ext>
             </a:extLst>
           </p:cNvPr>
@@ -8238,7 +8238,7 @@
           <p:cNvPr id="13" name="TextBox 12">
             <a:extLst>
               <a:ext uri="{FF2B5EF4-FFF2-40B4-BE49-F238E27FC236}">
-                <a16:creationId xmlns:a16="http://schemas.microsoft.com/office/drawing/2014/main" id="{DA97C617-DEA4-D40F-758F-D0ACCA320933}"/>
+                <a16:creationId xmlns:a16="http://schemas.microsoft.com/office/drawing/2014/main" id="{8567C42B-EE5F-9E38-049E-7BA4928AB572}"/>
               </a:ext>
             </a:extLst>
           </p:cNvPr>
@@ -8278,7 +8278,7 @@
           <p:cNvPr id="14" name="TextBox 13">
             <a:extLst>
               <a:ext uri="{FF2B5EF4-FFF2-40B4-BE49-F238E27FC236}">
-                <a16:creationId xmlns:a16="http://schemas.microsoft.com/office/drawing/2014/main" id="{5CC98442-0A18-CBB3-8F21-02DE51D0FAD0}"/>
+                <a16:creationId xmlns:a16="http://schemas.microsoft.com/office/drawing/2014/main" id="{E490E002-F704-5CC5-AB09-ADA929DD483F}"/>
               </a:ext>
             </a:extLst>
           </p:cNvPr>
@@ -8318,7 +8318,7 @@
           <p:cNvPr id="15" name="Прямоугольник: скругленные углы 14">
             <a:extLst>
               <a:ext uri="{FF2B5EF4-FFF2-40B4-BE49-F238E27FC236}">
-                <a16:creationId xmlns:a16="http://schemas.microsoft.com/office/drawing/2014/main" id="{245FFBC9-F1CE-BCC8-D526-364E20711B79}"/>
+                <a16:creationId xmlns:a16="http://schemas.microsoft.com/office/drawing/2014/main" id="{9DF9F4A5-E0D2-92C0-9FF1-610ED0151C37}"/>
               </a:ext>
             </a:extLst>
           </p:cNvPr>
@@ -8388,7 +8388,7 @@
           <p:cNvPr id="16" name="Овал 15">
             <a:extLst>
               <a:ext uri="{FF2B5EF4-FFF2-40B4-BE49-F238E27FC236}">
-                <a16:creationId xmlns:a16="http://schemas.microsoft.com/office/drawing/2014/main" id="{94105B85-D85C-999A-0A0F-9112D548F197}"/>
+                <a16:creationId xmlns:a16="http://schemas.microsoft.com/office/drawing/2014/main" id="{72F0F59D-8B0E-8CBE-84BF-AC156C249944}"/>
               </a:ext>
             </a:extLst>
           </p:cNvPr>
@@ -8464,7 +8464,7 @@
           <p:cNvPr id="17" name="TextBox 16">
             <a:extLst>
               <a:ext uri="{FF2B5EF4-FFF2-40B4-BE49-F238E27FC236}">
-                <a16:creationId xmlns:a16="http://schemas.microsoft.com/office/drawing/2014/main" id="{EF65782F-BB19-818D-9E3E-0803D2E565AB}"/>
+                <a16:creationId xmlns:a16="http://schemas.microsoft.com/office/drawing/2014/main" id="{79974C61-FFE3-FEF7-F0E2-DCC58587B034}"/>
               </a:ext>
             </a:extLst>
           </p:cNvPr>
@@ -8504,7 +8504,7 @@
           <p:cNvPr id="18" name="TextBox 17">
             <a:extLst>
               <a:ext uri="{FF2B5EF4-FFF2-40B4-BE49-F238E27FC236}">
-                <a16:creationId xmlns:a16="http://schemas.microsoft.com/office/drawing/2014/main" id="{AC1A0872-B8D3-F7C1-C6A2-25D758BFB1D9}"/>
+                <a16:creationId xmlns:a16="http://schemas.microsoft.com/office/drawing/2014/main" id="{5B82D69B-0FB9-C81B-C0EA-FCBD46E2A0AB}"/>
               </a:ext>
             </a:extLst>
           </p:cNvPr>
@@ -8544,7 +8544,7 @@
           <p:cNvPr id="19" name="Прямоугольник: скругленные углы 18">
             <a:extLst>
               <a:ext uri="{FF2B5EF4-FFF2-40B4-BE49-F238E27FC236}">
-                <a16:creationId xmlns:a16="http://schemas.microsoft.com/office/drawing/2014/main" id="{72572D47-8D66-B492-7D8D-AEFB9BB82133}"/>
+                <a16:creationId xmlns:a16="http://schemas.microsoft.com/office/drawing/2014/main" id="{66244A4B-67A7-B369-8C2B-AD8A15A5506C}"/>
               </a:ext>
             </a:extLst>
           </p:cNvPr>
@@ -8614,7 +8614,7 @@
           <p:cNvPr id="20" name="Овал 19">
             <a:extLst>
               <a:ext uri="{FF2B5EF4-FFF2-40B4-BE49-F238E27FC236}">
-                <a16:creationId xmlns:a16="http://schemas.microsoft.com/office/drawing/2014/main" id="{3B5DEF59-AB29-1A35-AC76-C84606D73DE2}"/>
+                <a16:creationId xmlns:a16="http://schemas.microsoft.com/office/drawing/2014/main" id="{E8F86056-CB64-FD4E-74EA-48FC0F03590F}"/>
               </a:ext>
             </a:extLst>
           </p:cNvPr>
@@ -8690,7 +8690,7 @@
           <p:cNvPr id="21" name="TextBox 20">
             <a:extLst>
               <a:ext uri="{FF2B5EF4-FFF2-40B4-BE49-F238E27FC236}">
-                <a16:creationId xmlns:a16="http://schemas.microsoft.com/office/drawing/2014/main" id="{DEC58DC2-B06E-9751-75FB-928AD2D26BF9}"/>
+                <a16:creationId xmlns:a16="http://schemas.microsoft.com/office/drawing/2014/main" id="{23744D8E-383C-01EA-1529-F1FEDD0F060C}"/>
               </a:ext>
             </a:extLst>
           </p:cNvPr>
@@ -8730,7 +8730,7 @@
           <p:cNvPr id="22" name="TextBox 21">
             <a:extLst>
               <a:ext uri="{FF2B5EF4-FFF2-40B4-BE49-F238E27FC236}">
-                <a16:creationId xmlns:a16="http://schemas.microsoft.com/office/drawing/2014/main" id="{45F2CC27-E5F2-0071-A493-7247D7C425AD}"/>
+                <a16:creationId xmlns:a16="http://schemas.microsoft.com/office/drawing/2014/main" id="{A8835E12-7B52-5DD7-D066-C05BBAFED793}"/>
               </a:ext>
             </a:extLst>
           </p:cNvPr>
@@ -8770,7 +8770,7 @@
           <p:cNvPr id="23" name="Прямоугольник: скругленные углы 22">
             <a:extLst>
               <a:ext uri="{FF2B5EF4-FFF2-40B4-BE49-F238E27FC236}">
-                <a16:creationId xmlns:a16="http://schemas.microsoft.com/office/drawing/2014/main" id="{ED7E5935-1E2F-9458-4361-0C149A294450}"/>
+                <a16:creationId xmlns:a16="http://schemas.microsoft.com/office/drawing/2014/main" id="{6BF5F4DB-FF97-6D7A-8A04-56EC4E7BEFF4}"/>
               </a:ext>
             </a:extLst>
           </p:cNvPr>
@@ -8840,7 +8840,7 @@
           <p:cNvPr id="24" name="Овал 23">
             <a:extLst>
               <a:ext uri="{FF2B5EF4-FFF2-40B4-BE49-F238E27FC236}">
-                <a16:creationId xmlns:a16="http://schemas.microsoft.com/office/drawing/2014/main" id="{80F3C566-1A07-572D-A17C-15C8EF52E554}"/>
+                <a16:creationId xmlns:a16="http://schemas.microsoft.com/office/drawing/2014/main" id="{FCD17F70-94F3-2076-1FF2-9EACB7127B84}"/>
               </a:ext>
             </a:extLst>
           </p:cNvPr>
@@ -8916,7 +8916,7 @@
           <p:cNvPr id="25" name="TextBox 24">
             <a:extLst>
               <a:ext uri="{FF2B5EF4-FFF2-40B4-BE49-F238E27FC236}">
-                <a16:creationId xmlns:a16="http://schemas.microsoft.com/office/drawing/2014/main" id="{6922C742-9E87-EC9E-8781-35DEA6D404C5}"/>
+                <a16:creationId xmlns:a16="http://schemas.microsoft.com/office/drawing/2014/main" id="{E915050C-1F50-F641-41E8-BC34FD859351}"/>
               </a:ext>
             </a:extLst>
           </p:cNvPr>
@@ -8956,7 +8956,7 @@
           <p:cNvPr id="26" name="TextBox 25">
             <a:extLst>
               <a:ext uri="{FF2B5EF4-FFF2-40B4-BE49-F238E27FC236}">
-                <a16:creationId xmlns:a16="http://schemas.microsoft.com/office/drawing/2014/main" id="{21689912-58BE-31BE-DA57-55D4864357E1}"/>
+                <a16:creationId xmlns:a16="http://schemas.microsoft.com/office/drawing/2014/main" id="{655A8D60-0808-4CE6-103D-9D7721844D8B}"/>
               </a:ext>
             </a:extLst>
           </p:cNvPr>
@@ -9014,7 +9014,7 @@
           <p:cNvPr id="27" name="Прямоугольник: скругленные углы 26">
             <a:extLst>
               <a:ext uri="{FF2B5EF4-FFF2-40B4-BE49-F238E27FC236}">
-                <a16:creationId xmlns:a16="http://schemas.microsoft.com/office/drawing/2014/main" id="{F9C82DC6-E784-0985-B873-64EA1AD9A8E8}"/>
+                <a16:creationId xmlns:a16="http://schemas.microsoft.com/office/drawing/2014/main" id="{61F81C21-D2A3-8FAC-C515-5D55C5324279}"/>
               </a:ext>
             </a:extLst>
           </p:cNvPr>
@@ -9084,7 +9084,7 @@
           <p:cNvPr id="28" name="TextBox 27">
             <a:extLst>
               <a:ext uri="{FF2B5EF4-FFF2-40B4-BE49-F238E27FC236}">
-                <a16:creationId xmlns:a16="http://schemas.microsoft.com/office/drawing/2014/main" id="{49811D96-57E9-5806-63D7-C4CF98A70266}"/>
+                <a16:creationId xmlns:a16="http://schemas.microsoft.com/office/drawing/2014/main" id="{A7F13DD6-534E-B8BD-33F7-07C97C7DE546}"/>
               </a:ext>
             </a:extLst>
           </p:cNvPr>
@@ -9124,7 +9124,7 @@
           <p:cNvPr id="29" name="TextBox 28">
             <a:extLst>
               <a:ext uri="{FF2B5EF4-FFF2-40B4-BE49-F238E27FC236}">
-                <a16:creationId xmlns:a16="http://schemas.microsoft.com/office/drawing/2014/main" id="{7AF346C9-20D8-A064-F376-2B5E65C29533}"/>
+                <a16:creationId xmlns:a16="http://schemas.microsoft.com/office/drawing/2014/main" id="{5C5A5E96-933D-B481-3EDE-8584910EACBB}"/>
               </a:ext>
             </a:extLst>
           </p:cNvPr>
@@ -9223,7 +9223,7 @@
     </p:spTree>
     <p:extLst>
       <p:ext uri="{BB962C8B-B14F-4D97-AF65-F5344CB8AC3E}">
-        <p14:creationId xmlns:p14="http://schemas.microsoft.com/office/powerpoint/2010/main" val="1446469746"/>
+        <p14:creationId xmlns:p14="http://schemas.microsoft.com/office/powerpoint/2010/main" val="3116972696"/>
       </p:ext>
     </p:extLst>
   </p:cSld>
@@ -9263,7 +9263,7 @@
           <p:cNvPr id="2" name="TextBox 1">
             <a:extLst>
               <a:ext uri="{FF2B5EF4-FFF2-40B4-BE49-F238E27FC236}">
-                <a16:creationId xmlns:a16="http://schemas.microsoft.com/office/drawing/2014/main" id="{5721987D-97DF-91ED-7B44-1BE0E81E32CF}"/>
+                <a16:creationId xmlns:a16="http://schemas.microsoft.com/office/drawing/2014/main" id="{F26E4CA4-2459-F5E0-EEA4-5A736EEE6175}"/>
               </a:ext>
             </a:extLst>
           </p:cNvPr>
@@ -9303,7 +9303,7 @@
           <p:cNvPr id="4" name="Рисунок 3">
             <a:extLst>
               <a:ext uri="{FF2B5EF4-FFF2-40B4-BE49-F238E27FC236}">
-                <a16:creationId xmlns:a16="http://schemas.microsoft.com/office/drawing/2014/main" id="{E355FF18-4C9C-4BE3-58F1-EB600EF5E752}"/>
+                <a16:creationId xmlns:a16="http://schemas.microsoft.com/office/drawing/2014/main" id="{69A57D8A-93AD-A002-1189-63A6189D3408}"/>
               </a:ext>
             </a:extLst>
           </p:cNvPr>
@@ -9339,7 +9339,7 @@
           <p:cNvPr id="5" name="Прямоугольник: скругленные углы 4">
             <a:extLst>
               <a:ext uri="{FF2B5EF4-FFF2-40B4-BE49-F238E27FC236}">
-                <a16:creationId xmlns:a16="http://schemas.microsoft.com/office/drawing/2014/main" id="{F847AFE5-7EE0-2F76-FF45-BE8AA935535D}"/>
+                <a16:creationId xmlns:a16="http://schemas.microsoft.com/office/drawing/2014/main" id="{93A9FE0F-A89B-EC57-0C56-84917E70056C}"/>
               </a:ext>
             </a:extLst>
           </p:cNvPr>
@@ -9409,7 +9409,7 @@
           <p:cNvPr id="6" name="TextBox 5">
             <a:extLst>
               <a:ext uri="{FF2B5EF4-FFF2-40B4-BE49-F238E27FC236}">
-                <a16:creationId xmlns:a16="http://schemas.microsoft.com/office/drawing/2014/main" id="{50F805DE-DBD4-32E4-C07A-2D32083BD851}"/>
+                <a16:creationId xmlns:a16="http://schemas.microsoft.com/office/drawing/2014/main" id="{5CCACC40-33A6-2424-78E5-4646F0E4AABF}"/>
               </a:ext>
             </a:extLst>
           </p:cNvPr>
@@ -9449,7 +9449,7 @@
           <p:cNvPr id="7" name="TextBox 6">
             <a:extLst>
               <a:ext uri="{FF2B5EF4-FFF2-40B4-BE49-F238E27FC236}">
-                <a16:creationId xmlns:a16="http://schemas.microsoft.com/office/drawing/2014/main" id="{A5A38616-C139-7527-C2EA-9DDB521D9E3C}"/>
+                <a16:creationId xmlns:a16="http://schemas.microsoft.com/office/drawing/2014/main" id="{EAA8758A-74B8-9E21-2D48-FCD98AA8F6C6}"/>
               </a:ext>
             </a:extLst>
           </p:cNvPr>
@@ -9489,7 +9489,7 @@
           <p:cNvPr id="8" name="Прямоугольник: скругленные углы 7">
             <a:extLst>
               <a:ext uri="{FF2B5EF4-FFF2-40B4-BE49-F238E27FC236}">
-                <a16:creationId xmlns:a16="http://schemas.microsoft.com/office/drawing/2014/main" id="{587C4E60-7F1F-0151-A243-7FB6F3326C05}"/>
+                <a16:creationId xmlns:a16="http://schemas.microsoft.com/office/drawing/2014/main" id="{1A2462F1-AE41-6B8D-820F-4F765C3AE571}"/>
               </a:ext>
             </a:extLst>
           </p:cNvPr>
@@ -9559,7 +9559,7 @@
           <p:cNvPr id="9" name="TextBox 8">
             <a:extLst>
               <a:ext uri="{FF2B5EF4-FFF2-40B4-BE49-F238E27FC236}">
-                <a16:creationId xmlns:a16="http://schemas.microsoft.com/office/drawing/2014/main" id="{7922788B-D163-5C28-CF0C-C2BB92EE1B36}"/>
+                <a16:creationId xmlns:a16="http://schemas.microsoft.com/office/drawing/2014/main" id="{2103A703-C57C-23DC-01F6-96DF1AF7B5E2}"/>
               </a:ext>
             </a:extLst>
           </p:cNvPr>
@@ -9599,7 +9599,7 @@
           <p:cNvPr id="10" name="TextBox 9">
             <a:extLst>
               <a:ext uri="{FF2B5EF4-FFF2-40B4-BE49-F238E27FC236}">
-                <a16:creationId xmlns:a16="http://schemas.microsoft.com/office/drawing/2014/main" id="{1A6DE0AA-AD60-1332-594A-6769A43095A9}"/>
+                <a16:creationId xmlns:a16="http://schemas.microsoft.com/office/drawing/2014/main" id="{B8308020-4E44-B1E2-C3A6-F5E8222CDA30}"/>
               </a:ext>
             </a:extLst>
           </p:cNvPr>
@@ -9639,7 +9639,7 @@
           <p:cNvPr id="11" name="Прямоугольник: скругленные углы 10">
             <a:extLst>
               <a:ext uri="{FF2B5EF4-FFF2-40B4-BE49-F238E27FC236}">
-                <a16:creationId xmlns:a16="http://schemas.microsoft.com/office/drawing/2014/main" id="{F9B3AB64-BE00-852A-E976-3A595C9D0CE6}"/>
+                <a16:creationId xmlns:a16="http://schemas.microsoft.com/office/drawing/2014/main" id="{1DC13A53-FE8F-508B-2821-C7E21A079441}"/>
               </a:ext>
             </a:extLst>
           </p:cNvPr>
@@ -9709,7 +9709,7 @@
           <p:cNvPr id="12" name="TextBox 11">
             <a:extLst>
               <a:ext uri="{FF2B5EF4-FFF2-40B4-BE49-F238E27FC236}">
-                <a16:creationId xmlns:a16="http://schemas.microsoft.com/office/drawing/2014/main" id="{223E72C2-7862-8E83-F665-A67BBF4FF35F}"/>
+                <a16:creationId xmlns:a16="http://schemas.microsoft.com/office/drawing/2014/main" id="{38F234CD-DB54-2C7D-A20C-FB32ADFDCCE6}"/>
               </a:ext>
             </a:extLst>
           </p:cNvPr>
@@ -9749,7 +9749,7 @@
           <p:cNvPr id="13" name="TextBox 12">
             <a:extLst>
               <a:ext uri="{FF2B5EF4-FFF2-40B4-BE49-F238E27FC236}">
-                <a16:creationId xmlns:a16="http://schemas.microsoft.com/office/drawing/2014/main" id="{57DD7B8F-5FC0-13B5-0B91-806CD8E5B5C0}"/>
+                <a16:creationId xmlns:a16="http://schemas.microsoft.com/office/drawing/2014/main" id="{37649D03-34B7-9634-0FB5-6017C52D7036}"/>
               </a:ext>
             </a:extLst>
           </p:cNvPr>
@@ -9787,7 +9787,7 @@
     </p:spTree>
     <p:extLst>
       <p:ext uri="{BB962C8B-B14F-4D97-AF65-F5344CB8AC3E}">
-        <p14:creationId xmlns:p14="http://schemas.microsoft.com/office/powerpoint/2010/main" val="3182678958"/>
+        <p14:creationId xmlns:p14="http://schemas.microsoft.com/office/powerpoint/2010/main" val="1356182858"/>
       </p:ext>
     </p:extLst>
   </p:cSld>
@@ -9827,7 +9827,7 @@
           <p:cNvPr id="2" name="TextBox 1">
             <a:extLst>
               <a:ext uri="{FF2B5EF4-FFF2-40B4-BE49-F238E27FC236}">
-                <a16:creationId xmlns:a16="http://schemas.microsoft.com/office/drawing/2014/main" id="{551DE721-876A-6BAB-4CEA-2233E07D0C83}"/>
+                <a16:creationId xmlns:a16="http://schemas.microsoft.com/office/drawing/2014/main" id="{91F3FD9D-502A-BDF7-D14B-14288260D96C}"/>
               </a:ext>
             </a:extLst>
           </p:cNvPr>
@@ -9867,7 +9867,7 @@
           <p:cNvPr id="3" name="Таблица 2">
             <a:extLst>
               <a:ext uri="{FF2B5EF4-FFF2-40B4-BE49-F238E27FC236}">
-                <a16:creationId xmlns:a16="http://schemas.microsoft.com/office/drawing/2014/main" id="{7CA42CC5-BB0F-CC51-7DDF-83D66787BB01}"/>
+                <a16:creationId xmlns:a16="http://schemas.microsoft.com/office/drawing/2014/main" id="{D37B7E16-1AEF-1CFA-31A0-DEE93B272C9E}"/>
               </a:ext>
             </a:extLst>
           </p:cNvPr>
@@ -9877,7 +9877,7 @@
           <p:nvPr>
             <p:extLst>
               <p:ext uri="{D42A27DB-BD31-4B8C-83A1-F6EECF244321}">
-                <p14:modId xmlns:p14="http://schemas.microsoft.com/office/powerpoint/2010/main" val="4062083566"/>
+                <p14:modId xmlns:p14="http://schemas.microsoft.com/office/powerpoint/2010/main" val="3208845791"/>
               </p:ext>
             </p:extLst>
           </p:nvPr>
@@ -9896,28 +9896,28 @@
                 <a:gridCol w="1905000">
                   <a:extLst>
                     <a:ext uri="{9D8B030D-6E8A-4147-A177-3AD203B41FA5}">
-                      <a16:colId xmlns:a16="http://schemas.microsoft.com/office/drawing/2014/main" val="264119150"/>
+                      <a16:colId xmlns:a16="http://schemas.microsoft.com/office/drawing/2014/main" val="2125847109"/>
                     </a:ext>
                   </a:extLst>
                 </a:gridCol>
                 <a:gridCol w="2413000">
                   <a:extLst>
                     <a:ext uri="{9D8B030D-6E8A-4147-A177-3AD203B41FA5}">
-                      <a16:colId xmlns:a16="http://schemas.microsoft.com/office/drawing/2014/main" val="1467808906"/>
+                      <a16:colId xmlns:a16="http://schemas.microsoft.com/office/drawing/2014/main" val="4110871411"/>
                     </a:ext>
                   </a:extLst>
                 </a:gridCol>
                 <a:gridCol w="2159000">
                   <a:extLst>
                     <a:ext uri="{9D8B030D-6E8A-4147-A177-3AD203B41FA5}">
-                      <a16:colId xmlns:a16="http://schemas.microsoft.com/office/drawing/2014/main" val="792973550"/>
+                      <a16:colId xmlns:a16="http://schemas.microsoft.com/office/drawing/2014/main" val="1957644847"/>
                     </a:ext>
                   </a:extLst>
                 </a:gridCol>
                 <a:gridCol w="4699000">
                   <a:extLst>
                     <a:ext uri="{9D8B030D-6E8A-4147-A177-3AD203B41FA5}">
-                      <a16:colId xmlns:a16="http://schemas.microsoft.com/office/drawing/2014/main" val="1246222988"/>
+                      <a16:colId xmlns:a16="http://schemas.microsoft.com/office/drawing/2014/main" val="3344666406"/>
                     </a:ext>
                   </a:extLst>
                 </a:gridCol>
@@ -10013,7 +10013,7 @@
                 </a:tc>
                 <a:extLst>
                   <a:ext uri="{0D108BD9-81ED-4DB2-BD59-A6C34878D82A}">
-                    <a16:rowId xmlns:a16="http://schemas.microsoft.com/office/drawing/2014/main" val="3896590549"/>
+                    <a16:rowId xmlns:a16="http://schemas.microsoft.com/office/drawing/2014/main" val="3095755780"/>
                   </a:ext>
                 </a:extLst>
               </a:tr>
@@ -10117,7 +10117,7 @@
                 </a:tc>
                 <a:extLst>
                   <a:ext uri="{0D108BD9-81ED-4DB2-BD59-A6C34878D82A}">
-                    <a16:rowId xmlns:a16="http://schemas.microsoft.com/office/drawing/2014/main" val="1518734099"/>
+                    <a16:rowId xmlns:a16="http://schemas.microsoft.com/office/drawing/2014/main" val="4117763729"/>
                   </a:ext>
                 </a:extLst>
               </a:tr>
@@ -10227,7 +10227,7 @@
                 </a:tc>
                 <a:extLst>
                   <a:ext uri="{0D108BD9-81ED-4DB2-BD59-A6C34878D82A}">
-                    <a16:rowId xmlns:a16="http://schemas.microsoft.com/office/drawing/2014/main" val="641367513"/>
+                    <a16:rowId xmlns:a16="http://schemas.microsoft.com/office/drawing/2014/main" val="3241586307"/>
                   </a:ext>
                 </a:extLst>
               </a:tr>
@@ -10331,7 +10331,7 @@
                 </a:tc>
                 <a:extLst>
                   <a:ext uri="{0D108BD9-81ED-4DB2-BD59-A6C34878D82A}">
-                    <a16:rowId xmlns:a16="http://schemas.microsoft.com/office/drawing/2014/main" val="2814597151"/>
+                    <a16:rowId xmlns:a16="http://schemas.microsoft.com/office/drawing/2014/main" val="577385169"/>
                   </a:ext>
                 </a:extLst>
               </a:tr>
@@ -10435,7 +10435,7 @@
                 </a:tc>
                 <a:extLst>
                   <a:ext uri="{0D108BD9-81ED-4DB2-BD59-A6C34878D82A}">
-                    <a16:rowId xmlns:a16="http://schemas.microsoft.com/office/drawing/2014/main" val="2893429817"/>
+                    <a16:rowId xmlns:a16="http://schemas.microsoft.com/office/drawing/2014/main" val="2444174500"/>
                   </a:ext>
                 </a:extLst>
               </a:tr>
@@ -10539,7 +10539,7 @@
                 </a:tc>
                 <a:extLst>
                   <a:ext uri="{0D108BD9-81ED-4DB2-BD59-A6C34878D82A}">
-                    <a16:rowId xmlns:a16="http://schemas.microsoft.com/office/drawing/2014/main" val="3329224938"/>
+                    <a16:rowId xmlns:a16="http://schemas.microsoft.com/office/drawing/2014/main" val="2018537623"/>
                   </a:ext>
                 </a:extLst>
               </a:tr>
@@ -10643,7 +10643,7 @@
                 </a:tc>
                 <a:extLst>
                   <a:ext uri="{0D108BD9-81ED-4DB2-BD59-A6C34878D82A}">
-                    <a16:rowId xmlns:a16="http://schemas.microsoft.com/office/drawing/2014/main" val="4108827459"/>
+                    <a16:rowId xmlns:a16="http://schemas.microsoft.com/office/drawing/2014/main" val="2059611893"/>
                   </a:ext>
                 </a:extLst>
               </a:tr>
@@ -10747,7 +10747,7 @@
                 </a:tc>
                 <a:extLst>
                   <a:ext uri="{0D108BD9-81ED-4DB2-BD59-A6C34878D82A}">
-                    <a16:rowId xmlns:a16="http://schemas.microsoft.com/office/drawing/2014/main" val="2094198332"/>
+                    <a16:rowId xmlns:a16="http://schemas.microsoft.com/office/drawing/2014/main" val="1041556109"/>
                   </a:ext>
                 </a:extLst>
               </a:tr>
@@ -10760,7 +10760,7 @@
           <p:cNvPr id="4" name="TextBox 3">
             <a:extLst>
               <a:ext uri="{FF2B5EF4-FFF2-40B4-BE49-F238E27FC236}">
-                <a16:creationId xmlns:a16="http://schemas.microsoft.com/office/drawing/2014/main" id="{3469AF84-65BD-1570-7880-9618B39C2A6F}"/>
+                <a16:creationId xmlns:a16="http://schemas.microsoft.com/office/drawing/2014/main" id="{ECEDD479-F123-AECE-6419-380B28381972}"/>
               </a:ext>
             </a:extLst>
           </p:cNvPr>
@@ -10798,7 +10798,7 @@
     </p:spTree>
     <p:extLst>
       <p:ext uri="{BB962C8B-B14F-4D97-AF65-F5344CB8AC3E}">
-        <p14:creationId xmlns:p14="http://schemas.microsoft.com/office/powerpoint/2010/main" val="3233817662"/>
+        <p14:creationId xmlns:p14="http://schemas.microsoft.com/office/powerpoint/2010/main" val="1193902725"/>
       </p:ext>
     </p:extLst>
   </p:cSld>
@@ -10838,7 +10838,7 @@
           <p:cNvPr id="2" name="TextBox 1">
             <a:extLst>
               <a:ext uri="{FF2B5EF4-FFF2-40B4-BE49-F238E27FC236}">
-                <a16:creationId xmlns:a16="http://schemas.microsoft.com/office/drawing/2014/main" id="{234633CB-12BB-3505-7DF7-58198AE47875}"/>
+                <a16:creationId xmlns:a16="http://schemas.microsoft.com/office/drawing/2014/main" id="{6FA93B3B-C375-AE4C-B234-3B9F3AB481FC}"/>
               </a:ext>
             </a:extLst>
           </p:cNvPr>
@@ -10878,7 +10878,7 @@
           <p:cNvPr id="4" name="Рисунок 3">
             <a:extLst>
               <a:ext uri="{FF2B5EF4-FFF2-40B4-BE49-F238E27FC236}">
-                <a16:creationId xmlns:a16="http://schemas.microsoft.com/office/drawing/2014/main" id="{5565BC06-713A-916E-B07D-B2CAF8D1709E}"/>
+                <a16:creationId xmlns:a16="http://schemas.microsoft.com/office/drawing/2014/main" id="{A74546B8-670A-3A42-9295-503D735EB2B2}"/>
               </a:ext>
             </a:extLst>
           </p:cNvPr>
@@ -10914,7 +10914,7 @@
           <p:cNvPr id="5" name="TextBox 4">
             <a:extLst>
               <a:ext uri="{FF2B5EF4-FFF2-40B4-BE49-F238E27FC236}">
-                <a16:creationId xmlns:a16="http://schemas.microsoft.com/office/drawing/2014/main" id="{E525FD20-3DD4-427E-4366-501702DEE2A1}"/>
+                <a16:creationId xmlns:a16="http://schemas.microsoft.com/office/drawing/2014/main" id="{DFE17E0B-AEA2-8959-A303-9C5709FDBED5}"/>
               </a:ext>
             </a:extLst>
           </p:cNvPr>
@@ -10954,7 +10954,7 @@
           <p:cNvPr id="6" name="TextBox 5">
             <a:extLst>
               <a:ext uri="{FF2B5EF4-FFF2-40B4-BE49-F238E27FC236}">
-                <a16:creationId xmlns:a16="http://schemas.microsoft.com/office/drawing/2014/main" id="{E364826E-25C6-82C1-E495-D219A80D5933}"/>
+                <a16:creationId xmlns:a16="http://schemas.microsoft.com/office/drawing/2014/main" id="{6A534DFC-12C1-A676-460F-32BF4107C977}"/>
               </a:ext>
             </a:extLst>
           </p:cNvPr>
@@ -11005,7 +11005,7 @@
           <p:cNvPr id="7" name="TextBox 6">
             <a:extLst>
               <a:ext uri="{FF2B5EF4-FFF2-40B4-BE49-F238E27FC236}">
-                <a16:creationId xmlns:a16="http://schemas.microsoft.com/office/drawing/2014/main" id="{83AF27C4-2769-B960-FFB1-9DC87E8EBA95}"/>
+                <a16:creationId xmlns:a16="http://schemas.microsoft.com/office/drawing/2014/main" id="{45DC42D4-8A5B-2C8F-C288-8CF2574301B8}"/>
               </a:ext>
             </a:extLst>
           </p:cNvPr>
@@ -11045,7 +11045,7 @@
           <p:cNvPr id="8" name="TextBox 7">
             <a:extLst>
               <a:ext uri="{FF2B5EF4-FFF2-40B4-BE49-F238E27FC236}">
-                <a16:creationId xmlns:a16="http://schemas.microsoft.com/office/drawing/2014/main" id="{76FF86AF-01A2-A435-541A-C0139AE6EC25}"/>
+                <a16:creationId xmlns:a16="http://schemas.microsoft.com/office/drawing/2014/main" id="{21A2363F-985D-21F7-580B-F81F5D46D7A2}"/>
               </a:ext>
             </a:extLst>
           </p:cNvPr>
@@ -11085,7 +11085,7 @@
           <p:cNvPr id="9" name="TextBox 8">
             <a:extLst>
               <a:ext uri="{FF2B5EF4-FFF2-40B4-BE49-F238E27FC236}">
-                <a16:creationId xmlns:a16="http://schemas.microsoft.com/office/drawing/2014/main" id="{4C2D82C3-2714-8AE2-8859-0109376FDFD4}"/>
+                <a16:creationId xmlns:a16="http://schemas.microsoft.com/office/drawing/2014/main" id="{22E84DB6-412A-27E8-5207-DF9C96FC053D}"/>
               </a:ext>
             </a:extLst>
           </p:cNvPr>
@@ -11125,7 +11125,7 @@
           <p:cNvPr id="10" name="TextBox 9">
             <a:extLst>
               <a:ext uri="{FF2B5EF4-FFF2-40B4-BE49-F238E27FC236}">
-                <a16:creationId xmlns:a16="http://schemas.microsoft.com/office/drawing/2014/main" id="{F551EEBC-F0AE-7E48-1489-ACB09BAD2E77}"/>
+                <a16:creationId xmlns:a16="http://schemas.microsoft.com/office/drawing/2014/main" id="{72F381D1-E623-D22F-77EA-54308F4B67CE}"/>
               </a:ext>
             </a:extLst>
           </p:cNvPr>
@@ -11165,7 +11165,7 @@
           <p:cNvPr id="11" name="TextBox 10">
             <a:extLst>
               <a:ext uri="{FF2B5EF4-FFF2-40B4-BE49-F238E27FC236}">
-                <a16:creationId xmlns:a16="http://schemas.microsoft.com/office/drawing/2014/main" id="{8D8949F6-E99C-A764-738E-0AB2451FBA50}"/>
+                <a16:creationId xmlns:a16="http://schemas.microsoft.com/office/drawing/2014/main" id="{46F8F8F9-E9B8-2795-9539-1C15887474E5}"/>
               </a:ext>
             </a:extLst>
           </p:cNvPr>
@@ -11205,7 +11205,7 @@
           <p:cNvPr id="12" name="TextBox 11">
             <a:extLst>
               <a:ext uri="{FF2B5EF4-FFF2-40B4-BE49-F238E27FC236}">
-                <a16:creationId xmlns:a16="http://schemas.microsoft.com/office/drawing/2014/main" id="{1685D8BE-080C-B3AD-2C03-0011691D3349}"/>
+                <a16:creationId xmlns:a16="http://schemas.microsoft.com/office/drawing/2014/main" id="{1A6DA026-5D02-6E29-BB2B-800546429C37}"/>
               </a:ext>
             </a:extLst>
           </p:cNvPr>
@@ -11245,7 +11245,7 @@
           <p:cNvPr id="13" name="TextBox 12">
             <a:extLst>
               <a:ext uri="{FF2B5EF4-FFF2-40B4-BE49-F238E27FC236}">
-                <a16:creationId xmlns:a16="http://schemas.microsoft.com/office/drawing/2014/main" id="{149BF282-5BC6-79F6-F6FD-F37227CD354E}"/>
+                <a16:creationId xmlns:a16="http://schemas.microsoft.com/office/drawing/2014/main" id="{5394F838-1A91-0563-62FD-96494F043BEE}"/>
               </a:ext>
             </a:extLst>
           </p:cNvPr>
@@ -11275,7 +11275,7 @@
                 </a:solidFill>
                 <a:latin typeface="Calibri" panose="020F0502020204030204" pitchFamily="34" charset="0"/>
               </a:rPr>
-              <a:t>Специфичность на сопоставимых молодых нормах (без формата C) — 0.52, LR+ 1.7. Бутстрэп групп, 2000 повторов; на обучающих данных AUC 0.92 — поэтому только вне выборки.</a:t>
+              <a:t>Специфичность на нормах &lt; 65 — 0.72 (C 1.00, доп. партия 0.58, A 0.45). Бутстрэп групп, 2000 повторов; на обучающих данных AUC 0.92 — поэтому только вне выборки.</a:t>
             </a:r>
           </a:p>
         </p:txBody>
@@ -11283,7 +11283,7 @@
     </p:spTree>
     <p:extLst>
       <p:ext uri="{BB962C8B-B14F-4D97-AF65-F5344CB8AC3E}">
-        <p14:creationId xmlns:p14="http://schemas.microsoft.com/office/powerpoint/2010/main" val="1496734750"/>
+        <p14:creationId xmlns:p14="http://schemas.microsoft.com/office/powerpoint/2010/main" val="3807489485"/>
       </p:ext>
     </p:extLst>
   </p:cSld>
@@ -11323,7 +11323,7 @@
           <p:cNvPr id="2" name="TextBox 1">
             <a:extLst>
               <a:ext uri="{FF2B5EF4-FFF2-40B4-BE49-F238E27FC236}">
-                <a16:creationId xmlns:a16="http://schemas.microsoft.com/office/drawing/2014/main" id="{AB7FC293-A6B2-704D-46BC-B1FEA9AD4365}"/>
+                <a16:creationId xmlns:a16="http://schemas.microsoft.com/office/drawing/2014/main" id="{57980B2C-15EC-36EC-337C-B121943A015A}"/>
               </a:ext>
             </a:extLst>
           </p:cNvPr>
@@ -11363,7 +11363,7 @@
           <p:cNvPr id="4" name="Рисунок 3">
             <a:extLst>
               <a:ext uri="{FF2B5EF4-FFF2-40B4-BE49-F238E27FC236}">
-                <a16:creationId xmlns:a16="http://schemas.microsoft.com/office/drawing/2014/main" id="{F3586E34-41F5-832F-F2FE-BFB493576576}"/>
+                <a16:creationId xmlns:a16="http://schemas.microsoft.com/office/drawing/2014/main" id="{235EF1A7-AC89-E0F8-777D-B79CCAE7E4F2}"/>
               </a:ext>
             </a:extLst>
           </p:cNvPr>
@@ -11399,7 +11399,7 @@
           <p:cNvPr id="5" name="TextBox 4">
             <a:extLst>
               <a:ext uri="{FF2B5EF4-FFF2-40B4-BE49-F238E27FC236}">
-                <a16:creationId xmlns:a16="http://schemas.microsoft.com/office/drawing/2014/main" id="{79A171FE-666E-DE7C-5C04-BD4C841B3B42}"/>
+                <a16:creationId xmlns:a16="http://schemas.microsoft.com/office/drawing/2014/main" id="{B7FCD42D-1460-9528-3662-CEFCA4280CA5}"/>
               </a:ext>
             </a:extLst>
           </p:cNvPr>
@@ -11439,7 +11439,7 @@
           <p:cNvPr id="6" name="TextBox 5">
             <a:extLst>
               <a:ext uri="{FF2B5EF4-FFF2-40B4-BE49-F238E27FC236}">
-                <a16:creationId xmlns:a16="http://schemas.microsoft.com/office/drawing/2014/main" id="{A27DA065-05D9-036D-547A-53014B84FF76}"/>
+                <a16:creationId xmlns:a16="http://schemas.microsoft.com/office/drawing/2014/main" id="{8B7D9F01-83C8-4958-36A6-4726ECDDE98A}"/>
               </a:ext>
             </a:extLst>
           </p:cNvPr>
@@ -11479,7 +11479,7 @@
           <p:cNvPr id="7" name="TextBox 6">
             <a:extLst>
               <a:ext uri="{FF2B5EF4-FFF2-40B4-BE49-F238E27FC236}">
-                <a16:creationId xmlns:a16="http://schemas.microsoft.com/office/drawing/2014/main" id="{6C6D993C-9DA4-4887-FFC6-FFC8F165267A}"/>
+                <a16:creationId xmlns:a16="http://schemas.microsoft.com/office/drawing/2014/main" id="{EC0A59C5-01D7-EBBE-B8AA-B82D3C9E9254}"/>
               </a:ext>
             </a:extLst>
           </p:cNvPr>
@@ -11519,7 +11519,7 @@
           <p:cNvPr id="8" name="TextBox 7">
             <a:extLst>
               <a:ext uri="{FF2B5EF4-FFF2-40B4-BE49-F238E27FC236}">
-                <a16:creationId xmlns:a16="http://schemas.microsoft.com/office/drawing/2014/main" id="{DBD56066-70EF-2F51-1059-1A1305E67E99}"/>
+                <a16:creationId xmlns:a16="http://schemas.microsoft.com/office/drawing/2014/main" id="{0E676848-BD1F-E65F-FDC9-BCED9FE16035}"/>
               </a:ext>
             </a:extLst>
           </p:cNvPr>
@@ -11559,7 +11559,7 @@
           <p:cNvPr id="9" name="TextBox 8">
             <a:extLst>
               <a:ext uri="{FF2B5EF4-FFF2-40B4-BE49-F238E27FC236}">
-                <a16:creationId xmlns:a16="http://schemas.microsoft.com/office/drawing/2014/main" id="{B8864A66-B25E-5D5B-B377-0B237E446403}"/>
+                <a16:creationId xmlns:a16="http://schemas.microsoft.com/office/drawing/2014/main" id="{0762DC4A-7A1D-0136-5CF6-6009C45D17E8}"/>
               </a:ext>
             </a:extLst>
           </p:cNvPr>
@@ -11597,7 +11597,7 @@
     </p:spTree>
     <p:extLst>
       <p:ext uri="{BB962C8B-B14F-4D97-AF65-F5344CB8AC3E}">
-        <p14:creationId xmlns:p14="http://schemas.microsoft.com/office/powerpoint/2010/main" val="1380711517"/>
+        <p14:creationId xmlns:p14="http://schemas.microsoft.com/office/powerpoint/2010/main" val="1325797250"/>
       </p:ext>
     </p:extLst>
   </p:cSld>
@@ -11637,7 +11637,7 @@
           <p:cNvPr id="2" name="TextBox 1">
             <a:extLst>
               <a:ext uri="{FF2B5EF4-FFF2-40B4-BE49-F238E27FC236}">
-                <a16:creationId xmlns:a16="http://schemas.microsoft.com/office/drawing/2014/main" id="{165FEDB1-9E51-E9CD-AA78-F8C95F692FB0}"/>
+                <a16:creationId xmlns:a16="http://schemas.microsoft.com/office/drawing/2014/main" id="{7ABFB000-C4DD-2608-8E7D-0676009201D1}"/>
               </a:ext>
             </a:extLst>
           </p:cNvPr>
@@ -11677,7 +11677,7 @@
           <p:cNvPr id="4" name="Рисунок 3">
             <a:extLst>
               <a:ext uri="{FF2B5EF4-FFF2-40B4-BE49-F238E27FC236}">
-                <a16:creationId xmlns:a16="http://schemas.microsoft.com/office/drawing/2014/main" id="{A87FE12A-4B9D-A52F-3420-BA135044AFE5}"/>
+                <a16:creationId xmlns:a16="http://schemas.microsoft.com/office/drawing/2014/main" id="{6FBB9394-2FB6-414D-469C-E34F8AD89356}"/>
               </a:ext>
             </a:extLst>
           </p:cNvPr>
@@ -11713,7 +11713,7 @@
           <p:cNvPr id="5" name="Прямоугольник: скругленные углы 4">
             <a:extLst>
               <a:ext uri="{FF2B5EF4-FFF2-40B4-BE49-F238E27FC236}">
-                <a16:creationId xmlns:a16="http://schemas.microsoft.com/office/drawing/2014/main" id="{4D96C3F0-20D5-35B8-690A-25426EF0A2A6}"/>
+                <a16:creationId xmlns:a16="http://schemas.microsoft.com/office/drawing/2014/main" id="{DF57A7CD-C713-9F50-9F93-FCB5BE0985D7}"/>
               </a:ext>
             </a:extLst>
           </p:cNvPr>
@@ -11783,7 +11783,7 @@
           <p:cNvPr id="6" name="Овал 5">
             <a:extLst>
               <a:ext uri="{FF2B5EF4-FFF2-40B4-BE49-F238E27FC236}">
-                <a16:creationId xmlns:a16="http://schemas.microsoft.com/office/drawing/2014/main" id="{9898ED02-94E0-A8C8-8C0F-BBCD303096C8}"/>
+                <a16:creationId xmlns:a16="http://schemas.microsoft.com/office/drawing/2014/main" id="{C8EAD1F6-108D-B2C4-7CC2-598197659210}"/>
               </a:ext>
             </a:extLst>
           </p:cNvPr>
@@ -11859,7 +11859,7 @@
           <p:cNvPr id="7" name="TextBox 6">
             <a:extLst>
               <a:ext uri="{FF2B5EF4-FFF2-40B4-BE49-F238E27FC236}">
-                <a16:creationId xmlns:a16="http://schemas.microsoft.com/office/drawing/2014/main" id="{DE08B141-13D0-4FB8-56FC-758903F80679}"/>
+                <a16:creationId xmlns:a16="http://schemas.microsoft.com/office/drawing/2014/main" id="{573751CA-8A35-C8A0-DC54-D096AC1DA613}"/>
               </a:ext>
             </a:extLst>
           </p:cNvPr>
@@ -11899,7 +11899,7 @@
           <p:cNvPr id="8" name="TextBox 7">
             <a:extLst>
               <a:ext uri="{FF2B5EF4-FFF2-40B4-BE49-F238E27FC236}">
-                <a16:creationId xmlns:a16="http://schemas.microsoft.com/office/drawing/2014/main" id="{9C1E73B4-E813-9CF5-A595-50CBBC75389C}"/>
+                <a16:creationId xmlns:a16="http://schemas.microsoft.com/office/drawing/2014/main" id="{EC395816-5A3C-48EE-08FF-201AFA8401EF}"/>
               </a:ext>
             </a:extLst>
           </p:cNvPr>
@@ -11939,7 +11939,7 @@
           <p:cNvPr id="9" name="Прямоугольник: скругленные углы 8">
             <a:extLst>
               <a:ext uri="{FF2B5EF4-FFF2-40B4-BE49-F238E27FC236}">
-                <a16:creationId xmlns:a16="http://schemas.microsoft.com/office/drawing/2014/main" id="{C7527511-576E-5934-27F0-27A4A2758F05}"/>
+                <a16:creationId xmlns:a16="http://schemas.microsoft.com/office/drawing/2014/main" id="{D7C9F542-043E-7071-9285-5B9D847CC567}"/>
               </a:ext>
             </a:extLst>
           </p:cNvPr>
@@ -12009,7 +12009,7 @@
           <p:cNvPr id="10" name="Овал 9">
             <a:extLst>
               <a:ext uri="{FF2B5EF4-FFF2-40B4-BE49-F238E27FC236}">
-                <a16:creationId xmlns:a16="http://schemas.microsoft.com/office/drawing/2014/main" id="{6C206B70-8F91-B68C-47F1-F278A8F87701}"/>
+                <a16:creationId xmlns:a16="http://schemas.microsoft.com/office/drawing/2014/main" id="{FCD16798-FF9B-8CA5-09FC-D653A8F1A635}"/>
               </a:ext>
             </a:extLst>
           </p:cNvPr>
@@ -12085,7 +12085,7 @@
           <p:cNvPr id="11" name="TextBox 10">
             <a:extLst>
               <a:ext uri="{FF2B5EF4-FFF2-40B4-BE49-F238E27FC236}">
-                <a16:creationId xmlns:a16="http://schemas.microsoft.com/office/drawing/2014/main" id="{57D0D685-AD60-9ECE-E92E-83C52E69D050}"/>
+                <a16:creationId xmlns:a16="http://schemas.microsoft.com/office/drawing/2014/main" id="{6C280068-3960-3BB7-B3D6-F3F90C84F5E8}"/>
               </a:ext>
             </a:extLst>
           </p:cNvPr>
@@ -12125,7 +12125,7 @@
           <p:cNvPr id="12" name="TextBox 11">
             <a:extLst>
               <a:ext uri="{FF2B5EF4-FFF2-40B4-BE49-F238E27FC236}">
-                <a16:creationId xmlns:a16="http://schemas.microsoft.com/office/drawing/2014/main" id="{5B966E1B-C5E5-51EF-3C53-68B582F69716}"/>
+                <a16:creationId xmlns:a16="http://schemas.microsoft.com/office/drawing/2014/main" id="{4644CADF-1663-3ED3-1A26-D4540BB16164}"/>
               </a:ext>
             </a:extLst>
           </p:cNvPr>
@@ -12165,7 +12165,7 @@
           <p:cNvPr id="13" name="Прямоугольник: скругленные углы 12">
             <a:extLst>
               <a:ext uri="{FF2B5EF4-FFF2-40B4-BE49-F238E27FC236}">
-                <a16:creationId xmlns:a16="http://schemas.microsoft.com/office/drawing/2014/main" id="{AC4403C1-B191-7871-7D19-E7DFE64603BB}"/>
+                <a16:creationId xmlns:a16="http://schemas.microsoft.com/office/drawing/2014/main" id="{7E97F003-60CC-18EF-7D2F-0884B352770D}"/>
               </a:ext>
             </a:extLst>
           </p:cNvPr>
@@ -12235,7 +12235,7 @@
           <p:cNvPr id="14" name="Овал 13">
             <a:extLst>
               <a:ext uri="{FF2B5EF4-FFF2-40B4-BE49-F238E27FC236}">
-                <a16:creationId xmlns:a16="http://schemas.microsoft.com/office/drawing/2014/main" id="{A048B278-42FA-A184-F5D8-62936F2ED26B}"/>
+                <a16:creationId xmlns:a16="http://schemas.microsoft.com/office/drawing/2014/main" id="{C32C14BD-60C7-7986-97A0-A22532872B78}"/>
               </a:ext>
             </a:extLst>
           </p:cNvPr>
@@ -12311,7 +12311,7 @@
           <p:cNvPr id="15" name="TextBox 14">
             <a:extLst>
               <a:ext uri="{FF2B5EF4-FFF2-40B4-BE49-F238E27FC236}">
-                <a16:creationId xmlns:a16="http://schemas.microsoft.com/office/drawing/2014/main" id="{65FC6ADB-9474-501E-0A4E-A990AC3E1D45}"/>
+                <a16:creationId xmlns:a16="http://schemas.microsoft.com/office/drawing/2014/main" id="{2004E6F7-60B2-AEC0-EFFC-F8387B492A6B}"/>
               </a:ext>
             </a:extLst>
           </p:cNvPr>
@@ -12351,7 +12351,7 @@
           <p:cNvPr id="16" name="TextBox 15">
             <a:extLst>
               <a:ext uri="{FF2B5EF4-FFF2-40B4-BE49-F238E27FC236}">
-                <a16:creationId xmlns:a16="http://schemas.microsoft.com/office/drawing/2014/main" id="{A15CED49-D707-5754-3342-D4A8E03F0253}"/>
+                <a16:creationId xmlns:a16="http://schemas.microsoft.com/office/drawing/2014/main" id="{0EF05421-836F-935B-46DB-885DF6797C72}"/>
               </a:ext>
             </a:extLst>
           </p:cNvPr>
@@ -12391,7 +12391,7 @@
           <p:cNvPr id="17" name="Прямоугольник: скругленные углы 16">
             <a:extLst>
               <a:ext uri="{FF2B5EF4-FFF2-40B4-BE49-F238E27FC236}">
-                <a16:creationId xmlns:a16="http://schemas.microsoft.com/office/drawing/2014/main" id="{DF4D0A56-9DE6-09AC-DC0E-9C36491F0389}"/>
+                <a16:creationId xmlns:a16="http://schemas.microsoft.com/office/drawing/2014/main" id="{CC00B1A6-F91C-E94A-A0AA-33D59000262C}"/>
               </a:ext>
             </a:extLst>
           </p:cNvPr>
@@ -12461,7 +12461,7 @@
           <p:cNvPr id="18" name="Овал 17">
             <a:extLst>
               <a:ext uri="{FF2B5EF4-FFF2-40B4-BE49-F238E27FC236}">
-                <a16:creationId xmlns:a16="http://schemas.microsoft.com/office/drawing/2014/main" id="{7418D3E9-C429-3063-9163-52B2F0309BB3}"/>
+                <a16:creationId xmlns:a16="http://schemas.microsoft.com/office/drawing/2014/main" id="{CCBD7A25-4CB7-0A29-78DA-EFE003962078}"/>
               </a:ext>
             </a:extLst>
           </p:cNvPr>
@@ -12537,7 +12537,7 @@
           <p:cNvPr id="19" name="TextBox 18">
             <a:extLst>
               <a:ext uri="{FF2B5EF4-FFF2-40B4-BE49-F238E27FC236}">
-                <a16:creationId xmlns:a16="http://schemas.microsoft.com/office/drawing/2014/main" id="{6D5B147C-40F8-BF81-CD6A-DF31E92C9662}"/>
+                <a16:creationId xmlns:a16="http://schemas.microsoft.com/office/drawing/2014/main" id="{F867B6D5-FBE0-B2E7-DC4E-0DB87FF86179}"/>
               </a:ext>
             </a:extLst>
           </p:cNvPr>
@@ -12577,7 +12577,7 @@
           <p:cNvPr id="20" name="TextBox 19">
             <a:extLst>
               <a:ext uri="{FF2B5EF4-FFF2-40B4-BE49-F238E27FC236}">
-                <a16:creationId xmlns:a16="http://schemas.microsoft.com/office/drawing/2014/main" id="{96A6EA67-4647-D520-EE2F-46DF57A5EEEA}"/>
+                <a16:creationId xmlns:a16="http://schemas.microsoft.com/office/drawing/2014/main" id="{ADDB0C8A-9B67-CF8A-1874-FA51BE9E9342}"/>
               </a:ext>
             </a:extLst>
           </p:cNvPr>
@@ -12617,7 +12617,7 @@
           <p:cNvPr id="21" name="Прямоугольник: скругленные углы 20">
             <a:extLst>
               <a:ext uri="{FF2B5EF4-FFF2-40B4-BE49-F238E27FC236}">
-                <a16:creationId xmlns:a16="http://schemas.microsoft.com/office/drawing/2014/main" id="{B846F8CF-8113-B4B0-0079-D317E076CCFA}"/>
+                <a16:creationId xmlns:a16="http://schemas.microsoft.com/office/drawing/2014/main" id="{345D76C8-55FE-92A8-554C-F775BF0B2898}"/>
               </a:ext>
             </a:extLst>
           </p:cNvPr>
@@ -12687,7 +12687,7 @@
           <p:cNvPr id="22" name="Овал 21">
             <a:extLst>
               <a:ext uri="{FF2B5EF4-FFF2-40B4-BE49-F238E27FC236}">
-                <a16:creationId xmlns:a16="http://schemas.microsoft.com/office/drawing/2014/main" id="{70D3A477-5EDF-B112-539A-8745FD58DB34}"/>
+                <a16:creationId xmlns:a16="http://schemas.microsoft.com/office/drawing/2014/main" id="{3F439AC2-7FE7-0C9C-14D3-62B745F80222}"/>
               </a:ext>
             </a:extLst>
           </p:cNvPr>
@@ -12763,7 +12763,7 @@
           <p:cNvPr id="23" name="TextBox 22">
             <a:extLst>
               <a:ext uri="{FF2B5EF4-FFF2-40B4-BE49-F238E27FC236}">
-                <a16:creationId xmlns:a16="http://schemas.microsoft.com/office/drawing/2014/main" id="{F520697C-9FE1-DCCE-ECFF-CA81D46BA1D2}"/>
+                <a16:creationId xmlns:a16="http://schemas.microsoft.com/office/drawing/2014/main" id="{5BE2CEF8-D708-4CED-A2AC-E62110BED555}"/>
               </a:ext>
             </a:extLst>
           </p:cNvPr>
@@ -12803,7 +12803,7 @@
           <p:cNvPr id="24" name="TextBox 23">
             <a:extLst>
               <a:ext uri="{FF2B5EF4-FFF2-40B4-BE49-F238E27FC236}">
-                <a16:creationId xmlns:a16="http://schemas.microsoft.com/office/drawing/2014/main" id="{6C9F0818-3109-C818-0995-DD4496B6A2DC}"/>
+                <a16:creationId xmlns:a16="http://schemas.microsoft.com/office/drawing/2014/main" id="{FBA0B28F-F33C-D760-6126-095C017EEB2E}"/>
               </a:ext>
             </a:extLst>
           </p:cNvPr>
@@ -12841,7 +12841,7 @@
     </p:spTree>
     <p:extLst>
       <p:ext uri="{BB962C8B-B14F-4D97-AF65-F5344CB8AC3E}">
-        <p14:creationId xmlns:p14="http://schemas.microsoft.com/office/powerpoint/2010/main" val="3364014451"/>
+        <p14:creationId xmlns:p14="http://schemas.microsoft.com/office/powerpoint/2010/main" val="2423870694"/>
       </p:ext>
     </p:extLst>
   </p:cSld>
@@ -12881,7 +12881,7 @@
           <p:cNvPr id="2" name="TextBox 1">
             <a:extLst>
               <a:ext uri="{FF2B5EF4-FFF2-40B4-BE49-F238E27FC236}">
-                <a16:creationId xmlns:a16="http://schemas.microsoft.com/office/drawing/2014/main" id="{7B02BD4A-E075-81DC-9536-093EEDD83FC7}"/>
+                <a16:creationId xmlns:a16="http://schemas.microsoft.com/office/drawing/2014/main" id="{5D153913-A957-F803-B4E3-2FA46EDF5BEB}"/>
               </a:ext>
             </a:extLst>
           </p:cNvPr>
@@ -12921,7 +12921,7 @@
           <p:cNvPr id="4" name="Рисунок 3">
             <a:extLst>
               <a:ext uri="{FF2B5EF4-FFF2-40B4-BE49-F238E27FC236}">
-                <a16:creationId xmlns:a16="http://schemas.microsoft.com/office/drawing/2014/main" id="{6A869E7F-D30E-D605-4A19-9CC51E705404}"/>
+                <a16:creationId xmlns:a16="http://schemas.microsoft.com/office/drawing/2014/main" id="{19CAD027-8B81-C586-1DF2-1770D038355E}"/>
               </a:ext>
             </a:extLst>
           </p:cNvPr>
@@ -12957,7 +12957,7 @@
           <p:cNvPr id="5" name="TextBox 4">
             <a:extLst>
               <a:ext uri="{FF2B5EF4-FFF2-40B4-BE49-F238E27FC236}">
-                <a16:creationId xmlns:a16="http://schemas.microsoft.com/office/drawing/2014/main" id="{EBA38E51-7872-AFE6-420A-6CDC900E15A7}"/>
+                <a16:creationId xmlns:a16="http://schemas.microsoft.com/office/drawing/2014/main" id="{D1103D1F-467B-6FFA-5DA8-ADDF9C6A91B0}"/>
               </a:ext>
             </a:extLst>
           </p:cNvPr>
@@ -12997,7 +12997,7 @@
           <p:cNvPr id="6" name="TextBox 5">
             <a:extLst>
               <a:ext uri="{FF2B5EF4-FFF2-40B4-BE49-F238E27FC236}">
-                <a16:creationId xmlns:a16="http://schemas.microsoft.com/office/drawing/2014/main" id="{A46664F1-321C-1089-DE02-E810B503C356}"/>
+                <a16:creationId xmlns:a16="http://schemas.microsoft.com/office/drawing/2014/main" id="{45DC1E14-4CD5-421E-8E15-62C7B750A3D0}"/>
               </a:ext>
             </a:extLst>
           </p:cNvPr>
@@ -13037,7 +13037,7 @@
           <p:cNvPr id="7" name="TextBox 6">
             <a:extLst>
               <a:ext uri="{FF2B5EF4-FFF2-40B4-BE49-F238E27FC236}">
-                <a16:creationId xmlns:a16="http://schemas.microsoft.com/office/drawing/2014/main" id="{2CD2F4DB-75C3-10E1-1F94-19767ACF2FA3}"/>
+                <a16:creationId xmlns:a16="http://schemas.microsoft.com/office/drawing/2014/main" id="{A4F4E83C-AF1C-A154-C2E4-73304CFD28CD}"/>
               </a:ext>
             </a:extLst>
           </p:cNvPr>
@@ -13118,7 +13118,7 @@
     </p:spTree>
     <p:extLst>
       <p:ext uri="{BB962C8B-B14F-4D97-AF65-F5344CB8AC3E}">
-        <p14:creationId xmlns:p14="http://schemas.microsoft.com/office/powerpoint/2010/main" val="428882029"/>
+        <p14:creationId xmlns:p14="http://schemas.microsoft.com/office/powerpoint/2010/main" val="1689997217"/>
       </p:ext>
     </p:extLst>
   </p:cSld>

</xml_diff>

<commit_message>
docs: translate presentation to english
</commit_message>
<xml_diff>
--- a/report/presentation.pptx
+++ b/report/presentation.pptx
@@ -135,7 +135,7 @@
           <p:cNvPr id="2" name="Заголовок 1">
             <a:extLst>
               <a:ext uri="{FF2B5EF4-FFF2-40B4-BE49-F238E27FC236}">
-                <a16:creationId xmlns:a16="http://schemas.microsoft.com/office/drawing/2014/main" id="{97412BFF-2002-D34A-2697-97AA9BBCA663}"/>
+                <a16:creationId xmlns:a16="http://schemas.microsoft.com/office/drawing/2014/main" id="{F04FC693-7FCD-E235-6FA7-74C156D92DCC}"/>
               </a:ext>
             </a:extLst>
           </p:cNvPr>
@@ -172,7 +172,7 @@
           <p:cNvPr id="3" name="Подзаголовок 2">
             <a:extLst>
               <a:ext uri="{FF2B5EF4-FFF2-40B4-BE49-F238E27FC236}">
-                <a16:creationId xmlns:a16="http://schemas.microsoft.com/office/drawing/2014/main" id="{363C4930-EDA4-EA9E-C93E-0EEAC1CB9039}"/>
+                <a16:creationId xmlns:a16="http://schemas.microsoft.com/office/drawing/2014/main" id="{86A5386E-0558-D268-9310-5DB249A6893A}"/>
               </a:ext>
             </a:extLst>
           </p:cNvPr>
@@ -242,7 +242,7 @@
           <p:cNvPr id="4" name="Дата 3">
             <a:extLst>
               <a:ext uri="{FF2B5EF4-FFF2-40B4-BE49-F238E27FC236}">
-                <a16:creationId xmlns:a16="http://schemas.microsoft.com/office/drawing/2014/main" id="{860A4C64-403E-1983-EEA8-F539822DF493}"/>
+                <a16:creationId xmlns:a16="http://schemas.microsoft.com/office/drawing/2014/main" id="{1B2EFD09-7BAE-F7D3-7EDA-A3E01C8AD46F}"/>
               </a:ext>
             </a:extLst>
           </p:cNvPr>
@@ -258,9 +258,9 @@
           <a:bodyPr/>
           <a:lstStyle/>
           <a:p>
-            <a:fld id="{03721B2E-DCCE-4706-B678-5EB51971E16A}" type="datetimeFigureOut">
+            <a:fld id="{5A01C869-0FFD-4EC5-B2A6-53D2B155137E}" type="datetimeFigureOut">
               <a:rPr lang="ru-RU" smtClean="0"/>
-              <a:t>29.09.2026</a:t>
+              <a:t>01.10.2026</a:t>
             </a:fld>
             <a:endParaRPr lang="ru-RU"/>
           </a:p>
@@ -271,7 +271,7 @@
           <p:cNvPr id="5" name="Нижний колонтитул 4">
             <a:extLst>
               <a:ext uri="{FF2B5EF4-FFF2-40B4-BE49-F238E27FC236}">
-                <a16:creationId xmlns:a16="http://schemas.microsoft.com/office/drawing/2014/main" id="{34BBCD49-663F-4A98-179F-A3728D85D020}"/>
+                <a16:creationId xmlns:a16="http://schemas.microsoft.com/office/drawing/2014/main" id="{3A6E5588-0B7B-B0DB-0096-87D33033C8DD}"/>
               </a:ext>
             </a:extLst>
           </p:cNvPr>
@@ -296,7 +296,7 @@
           <p:cNvPr id="6" name="Номер слайда 5">
             <a:extLst>
               <a:ext uri="{FF2B5EF4-FFF2-40B4-BE49-F238E27FC236}">
-                <a16:creationId xmlns:a16="http://schemas.microsoft.com/office/drawing/2014/main" id="{B719D050-CD3F-88B0-AD71-ACBFC37B2F80}"/>
+                <a16:creationId xmlns:a16="http://schemas.microsoft.com/office/drawing/2014/main" id="{785A4767-0EC8-90C0-77FC-A495634E6FE7}"/>
               </a:ext>
             </a:extLst>
           </p:cNvPr>
@@ -312,7 +312,7 @@
           <a:bodyPr/>
           <a:lstStyle/>
           <a:p>
-            <a:fld id="{269FBB89-E2CC-4301-AA56-FBEDB15D679F}" type="slidenum">
+            <a:fld id="{A60DA2E9-18B7-4EDB-9385-3CDA23019443}" type="slidenum">
               <a:rPr lang="ru-RU" smtClean="0"/>
               <a:t>‹#›</a:t>
             </a:fld>
@@ -323,7 +323,7 @@
     </p:spTree>
     <p:extLst>
       <p:ext uri="{BB962C8B-B14F-4D97-AF65-F5344CB8AC3E}">
-        <p14:creationId xmlns:p14="http://schemas.microsoft.com/office/powerpoint/2010/main" val="2628471014"/>
+        <p14:creationId xmlns:p14="http://schemas.microsoft.com/office/powerpoint/2010/main" val="1229337735"/>
       </p:ext>
     </p:extLst>
   </p:cSld>
@@ -355,7 +355,7 @@
           <p:cNvPr id="2" name="Заголовок 1">
             <a:extLst>
               <a:ext uri="{FF2B5EF4-FFF2-40B4-BE49-F238E27FC236}">
-                <a16:creationId xmlns:a16="http://schemas.microsoft.com/office/drawing/2014/main" id="{C1904A16-67E4-9D10-F206-F0133B3352EF}"/>
+                <a16:creationId xmlns:a16="http://schemas.microsoft.com/office/drawing/2014/main" id="{77157D42-1E09-1B5C-B6D9-61817CA60B4F}"/>
               </a:ext>
             </a:extLst>
           </p:cNvPr>
@@ -383,7 +383,7 @@
           <p:cNvPr id="3" name="Вертикальный текст 2">
             <a:extLst>
               <a:ext uri="{FF2B5EF4-FFF2-40B4-BE49-F238E27FC236}">
-                <a16:creationId xmlns:a16="http://schemas.microsoft.com/office/drawing/2014/main" id="{90CD55FB-379D-A4E4-7623-B3FF7C2CAB21}"/>
+                <a16:creationId xmlns:a16="http://schemas.microsoft.com/office/drawing/2014/main" id="{E2AECDAA-B194-75BD-F8E3-1002621E972E}"/>
               </a:ext>
             </a:extLst>
           </p:cNvPr>
@@ -440,7 +440,7 @@
           <p:cNvPr id="4" name="Дата 3">
             <a:extLst>
               <a:ext uri="{FF2B5EF4-FFF2-40B4-BE49-F238E27FC236}">
-                <a16:creationId xmlns:a16="http://schemas.microsoft.com/office/drawing/2014/main" id="{85AE6EE6-9D3D-27A8-C5F5-59209943ACA1}"/>
+                <a16:creationId xmlns:a16="http://schemas.microsoft.com/office/drawing/2014/main" id="{B174AB71-7315-8A95-0ED9-37F376B30359}"/>
               </a:ext>
             </a:extLst>
           </p:cNvPr>
@@ -456,9 +456,9 @@
           <a:bodyPr/>
           <a:lstStyle/>
           <a:p>
-            <a:fld id="{03721B2E-DCCE-4706-B678-5EB51971E16A}" type="datetimeFigureOut">
+            <a:fld id="{5A01C869-0FFD-4EC5-B2A6-53D2B155137E}" type="datetimeFigureOut">
               <a:rPr lang="ru-RU" smtClean="0"/>
-              <a:t>29.09.2026</a:t>
+              <a:t>01.10.2026</a:t>
             </a:fld>
             <a:endParaRPr lang="ru-RU"/>
           </a:p>
@@ -469,7 +469,7 @@
           <p:cNvPr id="5" name="Нижний колонтитул 4">
             <a:extLst>
               <a:ext uri="{FF2B5EF4-FFF2-40B4-BE49-F238E27FC236}">
-                <a16:creationId xmlns:a16="http://schemas.microsoft.com/office/drawing/2014/main" id="{94C4F331-1AE6-D93A-8144-E82F5D4EE641}"/>
+                <a16:creationId xmlns:a16="http://schemas.microsoft.com/office/drawing/2014/main" id="{2B889D21-74BB-ACE2-1B2F-70204FEC3877}"/>
               </a:ext>
             </a:extLst>
           </p:cNvPr>
@@ -494,7 +494,7 @@
           <p:cNvPr id="6" name="Номер слайда 5">
             <a:extLst>
               <a:ext uri="{FF2B5EF4-FFF2-40B4-BE49-F238E27FC236}">
-                <a16:creationId xmlns:a16="http://schemas.microsoft.com/office/drawing/2014/main" id="{F0133B77-12EA-4CC7-D813-ABFC3CC26D3A}"/>
+                <a16:creationId xmlns:a16="http://schemas.microsoft.com/office/drawing/2014/main" id="{F38A692F-2BC4-097C-E108-9A18946A6675}"/>
               </a:ext>
             </a:extLst>
           </p:cNvPr>
@@ -510,7 +510,7 @@
           <a:bodyPr/>
           <a:lstStyle/>
           <a:p>
-            <a:fld id="{269FBB89-E2CC-4301-AA56-FBEDB15D679F}" type="slidenum">
+            <a:fld id="{A60DA2E9-18B7-4EDB-9385-3CDA23019443}" type="slidenum">
               <a:rPr lang="ru-RU" smtClean="0"/>
               <a:t>‹#›</a:t>
             </a:fld>
@@ -521,7 +521,7 @@
     </p:spTree>
     <p:extLst>
       <p:ext uri="{BB962C8B-B14F-4D97-AF65-F5344CB8AC3E}">
-        <p14:creationId xmlns:p14="http://schemas.microsoft.com/office/powerpoint/2010/main" val="3081973376"/>
+        <p14:creationId xmlns:p14="http://schemas.microsoft.com/office/powerpoint/2010/main" val="3933487083"/>
       </p:ext>
     </p:extLst>
   </p:cSld>
@@ -553,7 +553,7 @@
           <p:cNvPr id="2" name="Вертикальный заголовок 1">
             <a:extLst>
               <a:ext uri="{FF2B5EF4-FFF2-40B4-BE49-F238E27FC236}">
-                <a16:creationId xmlns:a16="http://schemas.microsoft.com/office/drawing/2014/main" id="{F5913403-E462-D0C9-0B89-0C5609217F76}"/>
+                <a16:creationId xmlns:a16="http://schemas.microsoft.com/office/drawing/2014/main" id="{EB1BF433-43BB-0D28-ED75-C76454C33789}"/>
               </a:ext>
             </a:extLst>
           </p:cNvPr>
@@ -586,7 +586,7 @@
           <p:cNvPr id="3" name="Вертикальный текст 2">
             <a:extLst>
               <a:ext uri="{FF2B5EF4-FFF2-40B4-BE49-F238E27FC236}">
-                <a16:creationId xmlns:a16="http://schemas.microsoft.com/office/drawing/2014/main" id="{DE4A95AE-75D2-2EFA-F707-47121E5CA81C}"/>
+                <a16:creationId xmlns:a16="http://schemas.microsoft.com/office/drawing/2014/main" id="{D97458E4-FD8E-D4C6-2DC5-C17FD926C58A}"/>
               </a:ext>
             </a:extLst>
           </p:cNvPr>
@@ -648,7 +648,7 @@
           <p:cNvPr id="4" name="Дата 3">
             <a:extLst>
               <a:ext uri="{FF2B5EF4-FFF2-40B4-BE49-F238E27FC236}">
-                <a16:creationId xmlns:a16="http://schemas.microsoft.com/office/drawing/2014/main" id="{6AF6A1A3-6349-6C51-C23E-D63AFF5C94C7}"/>
+                <a16:creationId xmlns:a16="http://schemas.microsoft.com/office/drawing/2014/main" id="{56518A7C-8C39-5F4D-8335-A8A7EE8E615F}"/>
               </a:ext>
             </a:extLst>
           </p:cNvPr>
@@ -664,9 +664,9 @@
           <a:bodyPr/>
           <a:lstStyle/>
           <a:p>
-            <a:fld id="{03721B2E-DCCE-4706-B678-5EB51971E16A}" type="datetimeFigureOut">
+            <a:fld id="{5A01C869-0FFD-4EC5-B2A6-53D2B155137E}" type="datetimeFigureOut">
               <a:rPr lang="ru-RU" smtClean="0"/>
-              <a:t>29.09.2026</a:t>
+              <a:t>01.10.2026</a:t>
             </a:fld>
             <a:endParaRPr lang="ru-RU"/>
           </a:p>
@@ -677,7 +677,7 @@
           <p:cNvPr id="5" name="Нижний колонтитул 4">
             <a:extLst>
               <a:ext uri="{FF2B5EF4-FFF2-40B4-BE49-F238E27FC236}">
-                <a16:creationId xmlns:a16="http://schemas.microsoft.com/office/drawing/2014/main" id="{73132341-0B9D-46BA-0E82-5CDF3F997218}"/>
+                <a16:creationId xmlns:a16="http://schemas.microsoft.com/office/drawing/2014/main" id="{91F8FAD4-0976-6F24-AA32-A47B01A1A48E}"/>
               </a:ext>
             </a:extLst>
           </p:cNvPr>
@@ -702,7 +702,7 @@
           <p:cNvPr id="6" name="Номер слайда 5">
             <a:extLst>
               <a:ext uri="{FF2B5EF4-FFF2-40B4-BE49-F238E27FC236}">
-                <a16:creationId xmlns:a16="http://schemas.microsoft.com/office/drawing/2014/main" id="{59AA292E-13AF-34AC-C405-4409B0023488}"/>
+                <a16:creationId xmlns:a16="http://schemas.microsoft.com/office/drawing/2014/main" id="{BF52C3DB-6505-BF77-AC97-FF26197FA941}"/>
               </a:ext>
             </a:extLst>
           </p:cNvPr>
@@ -718,7 +718,7 @@
           <a:bodyPr/>
           <a:lstStyle/>
           <a:p>
-            <a:fld id="{269FBB89-E2CC-4301-AA56-FBEDB15D679F}" type="slidenum">
+            <a:fld id="{A60DA2E9-18B7-4EDB-9385-3CDA23019443}" type="slidenum">
               <a:rPr lang="ru-RU" smtClean="0"/>
               <a:t>‹#›</a:t>
             </a:fld>
@@ -729,7 +729,7 @@
     </p:spTree>
     <p:extLst>
       <p:ext uri="{BB962C8B-B14F-4D97-AF65-F5344CB8AC3E}">
-        <p14:creationId xmlns:p14="http://schemas.microsoft.com/office/powerpoint/2010/main" val="3681993737"/>
+        <p14:creationId xmlns:p14="http://schemas.microsoft.com/office/powerpoint/2010/main" val="2869188660"/>
       </p:ext>
     </p:extLst>
   </p:cSld>
@@ -761,7 +761,7 @@
           <p:cNvPr id="2" name="Заголовок 1">
             <a:extLst>
               <a:ext uri="{FF2B5EF4-FFF2-40B4-BE49-F238E27FC236}">
-                <a16:creationId xmlns:a16="http://schemas.microsoft.com/office/drawing/2014/main" id="{D7AC878A-7BC2-08AF-49C0-D19DFE29A0D9}"/>
+                <a16:creationId xmlns:a16="http://schemas.microsoft.com/office/drawing/2014/main" id="{359429BE-8683-778C-B7EF-E47E9DE13B7C}"/>
               </a:ext>
             </a:extLst>
           </p:cNvPr>
@@ -789,7 +789,7 @@
           <p:cNvPr id="3" name="Объект 2">
             <a:extLst>
               <a:ext uri="{FF2B5EF4-FFF2-40B4-BE49-F238E27FC236}">
-                <a16:creationId xmlns:a16="http://schemas.microsoft.com/office/drawing/2014/main" id="{C437A85B-1F0D-95D4-C9FA-F7B102512A14}"/>
+                <a16:creationId xmlns:a16="http://schemas.microsoft.com/office/drawing/2014/main" id="{C595451D-0464-6555-A034-2FA9F9DFC638}"/>
               </a:ext>
             </a:extLst>
           </p:cNvPr>
@@ -846,7 +846,7 @@
           <p:cNvPr id="4" name="Дата 3">
             <a:extLst>
               <a:ext uri="{FF2B5EF4-FFF2-40B4-BE49-F238E27FC236}">
-                <a16:creationId xmlns:a16="http://schemas.microsoft.com/office/drawing/2014/main" id="{05999F85-197B-A071-4CD0-DFA0BEE5C491}"/>
+                <a16:creationId xmlns:a16="http://schemas.microsoft.com/office/drawing/2014/main" id="{F3F37719-B2BF-C0C2-8531-35CF2938C984}"/>
               </a:ext>
             </a:extLst>
           </p:cNvPr>
@@ -862,9 +862,9 @@
           <a:bodyPr/>
           <a:lstStyle/>
           <a:p>
-            <a:fld id="{03721B2E-DCCE-4706-B678-5EB51971E16A}" type="datetimeFigureOut">
+            <a:fld id="{5A01C869-0FFD-4EC5-B2A6-53D2B155137E}" type="datetimeFigureOut">
               <a:rPr lang="ru-RU" smtClean="0"/>
-              <a:t>29.09.2026</a:t>
+              <a:t>01.10.2026</a:t>
             </a:fld>
             <a:endParaRPr lang="ru-RU"/>
           </a:p>
@@ -875,7 +875,7 @@
           <p:cNvPr id="5" name="Нижний колонтитул 4">
             <a:extLst>
               <a:ext uri="{FF2B5EF4-FFF2-40B4-BE49-F238E27FC236}">
-                <a16:creationId xmlns:a16="http://schemas.microsoft.com/office/drawing/2014/main" id="{04F7B8A7-36BA-A29D-F54C-A0D00FD0E6DC}"/>
+                <a16:creationId xmlns:a16="http://schemas.microsoft.com/office/drawing/2014/main" id="{264D54F4-CD83-E3D3-5053-57A39CB4BB95}"/>
               </a:ext>
             </a:extLst>
           </p:cNvPr>
@@ -900,7 +900,7 @@
           <p:cNvPr id="6" name="Номер слайда 5">
             <a:extLst>
               <a:ext uri="{FF2B5EF4-FFF2-40B4-BE49-F238E27FC236}">
-                <a16:creationId xmlns:a16="http://schemas.microsoft.com/office/drawing/2014/main" id="{9611AB8D-61E9-5727-33BB-7581F1BA0DF1}"/>
+                <a16:creationId xmlns:a16="http://schemas.microsoft.com/office/drawing/2014/main" id="{EB1F515B-F381-FCC0-5681-F508D5A54224}"/>
               </a:ext>
             </a:extLst>
           </p:cNvPr>
@@ -916,7 +916,7 @@
           <a:bodyPr/>
           <a:lstStyle/>
           <a:p>
-            <a:fld id="{269FBB89-E2CC-4301-AA56-FBEDB15D679F}" type="slidenum">
+            <a:fld id="{A60DA2E9-18B7-4EDB-9385-3CDA23019443}" type="slidenum">
               <a:rPr lang="ru-RU" smtClean="0"/>
               <a:t>‹#›</a:t>
             </a:fld>
@@ -927,7 +927,7 @@
     </p:spTree>
     <p:extLst>
       <p:ext uri="{BB962C8B-B14F-4D97-AF65-F5344CB8AC3E}">
-        <p14:creationId xmlns:p14="http://schemas.microsoft.com/office/powerpoint/2010/main" val="876135938"/>
+        <p14:creationId xmlns:p14="http://schemas.microsoft.com/office/powerpoint/2010/main" val="3079176367"/>
       </p:ext>
     </p:extLst>
   </p:cSld>
@@ -959,7 +959,7 @@
           <p:cNvPr id="2" name="Заголовок 1">
             <a:extLst>
               <a:ext uri="{FF2B5EF4-FFF2-40B4-BE49-F238E27FC236}">
-                <a16:creationId xmlns:a16="http://schemas.microsoft.com/office/drawing/2014/main" id="{BD96759D-7DE8-5A8A-6A15-D19027EB2D90}"/>
+                <a16:creationId xmlns:a16="http://schemas.microsoft.com/office/drawing/2014/main" id="{8B4D36BA-67E6-57A9-92DA-613A77C7BCEC}"/>
               </a:ext>
             </a:extLst>
           </p:cNvPr>
@@ -996,7 +996,7 @@
           <p:cNvPr id="3" name="Текст 2">
             <a:extLst>
               <a:ext uri="{FF2B5EF4-FFF2-40B4-BE49-F238E27FC236}">
-                <a16:creationId xmlns:a16="http://schemas.microsoft.com/office/drawing/2014/main" id="{97E95DB8-B8EF-E5A9-F2D3-BB7ECECDDCE5}"/>
+                <a16:creationId xmlns:a16="http://schemas.microsoft.com/office/drawing/2014/main" id="{3A82C586-BD41-FA03-3507-36933EE7CCB5}"/>
               </a:ext>
             </a:extLst>
           </p:cNvPr>
@@ -1121,7 +1121,7 @@
           <p:cNvPr id="4" name="Дата 3">
             <a:extLst>
               <a:ext uri="{FF2B5EF4-FFF2-40B4-BE49-F238E27FC236}">
-                <a16:creationId xmlns:a16="http://schemas.microsoft.com/office/drawing/2014/main" id="{8258019B-157C-4D37-8B92-6BF88FBA02B7}"/>
+                <a16:creationId xmlns:a16="http://schemas.microsoft.com/office/drawing/2014/main" id="{5EB77CA7-EF12-18EA-549C-E295E636FAE7}"/>
               </a:ext>
             </a:extLst>
           </p:cNvPr>
@@ -1137,9 +1137,9 @@
           <a:bodyPr/>
           <a:lstStyle/>
           <a:p>
-            <a:fld id="{03721B2E-DCCE-4706-B678-5EB51971E16A}" type="datetimeFigureOut">
+            <a:fld id="{5A01C869-0FFD-4EC5-B2A6-53D2B155137E}" type="datetimeFigureOut">
               <a:rPr lang="ru-RU" smtClean="0"/>
-              <a:t>29.09.2026</a:t>
+              <a:t>01.10.2026</a:t>
             </a:fld>
             <a:endParaRPr lang="ru-RU"/>
           </a:p>
@@ -1150,7 +1150,7 @@
           <p:cNvPr id="5" name="Нижний колонтитул 4">
             <a:extLst>
               <a:ext uri="{FF2B5EF4-FFF2-40B4-BE49-F238E27FC236}">
-                <a16:creationId xmlns:a16="http://schemas.microsoft.com/office/drawing/2014/main" id="{3A48C7A1-E918-8223-0EB7-13C808A24BDD}"/>
+                <a16:creationId xmlns:a16="http://schemas.microsoft.com/office/drawing/2014/main" id="{3B3860FC-0D98-37BA-7C32-2D3F4A77268C}"/>
               </a:ext>
             </a:extLst>
           </p:cNvPr>
@@ -1175,7 +1175,7 @@
           <p:cNvPr id="6" name="Номер слайда 5">
             <a:extLst>
               <a:ext uri="{FF2B5EF4-FFF2-40B4-BE49-F238E27FC236}">
-                <a16:creationId xmlns:a16="http://schemas.microsoft.com/office/drawing/2014/main" id="{7CFBDE5E-1CE1-DA84-68F4-BC3E11D52029}"/>
+                <a16:creationId xmlns:a16="http://schemas.microsoft.com/office/drawing/2014/main" id="{4A96562F-AC8A-B4CA-5189-80F20F5D66A8}"/>
               </a:ext>
             </a:extLst>
           </p:cNvPr>
@@ -1191,7 +1191,7 @@
           <a:bodyPr/>
           <a:lstStyle/>
           <a:p>
-            <a:fld id="{269FBB89-E2CC-4301-AA56-FBEDB15D679F}" type="slidenum">
+            <a:fld id="{A60DA2E9-18B7-4EDB-9385-3CDA23019443}" type="slidenum">
               <a:rPr lang="ru-RU" smtClean="0"/>
               <a:t>‹#›</a:t>
             </a:fld>
@@ -1202,7 +1202,7 @@
     </p:spTree>
     <p:extLst>
       <p:ext uri="{BB962C8B-B14F-4D97-AF65-F5344CB8AC3E}">
-        <p14:creationId xmlns:p14="http://schemas.microsoft.com/office/powerpoint/2010/main" val="2216197217"/>
+        <p14:creationId xmlns:p14="http://schemas.microsoft.com/office/powerpoint/2010/main" val="3906236568"/>
       </p:ext>
     </p:extLst>
   </p:cSld>
@@ -1234,7 +1234,7 @@
           <p:cNvPr id="2" name="Заголовок 1">
             <a:extLst>
               <a:ext uri="{FF2B5EF4-FFF2-40B4-BE49-F238E27FC236}">
-                <a16:creationId xmlns:a16="http://schemas.microsoft.com/office/drawing/2014/main" id="{F382D723-994A-3A69-EDEC-1EFB45E4ABFF}"/>
+                <a16:creationId xmlns:a16="http://schemas.microsoft.com/office/drawing/2014/main" id="{4912F64D-C0CD-1441-76EB-9587FF766807}"/>
               </a:ext>
             </a:extLst>
           </p:cNvPr>
@@ -1262,7 +1262,7 @@
           <p:cNvPr id="3" name="Объект 2">
             <a:extLst>
               <a:ext uri="{FF2B5EF4-FFF2-40B4-BE49-F238E27FC236}">
-                <a16:creationId xmlns:a16="http://schemas.microsoft.com/office/drawing/2014/main" id="{68C42255-F5BE-8C4E-8E9F-28ABF1FA0DFE}"/>
+                <a16:creationId xmlns:a16="http://schemas.microsoft.com/office/drawing/2014/main" id="{ECE1231A-1736-8655-BC9D-B8D977B84DDB}"/>
               </a:ext>
             </a:extLst>
           </p:cNvPr>
@@ -1324,7 +1324,7 @@
           <p:cNvPr id="4" name="Объект 3">
             <a:extLst>
               <a:ext uri="{FF2B5EF4-FFF2-40B4-BE49-F238E27FC236}">
-                <a16:creationId xmlns:a16="http://schemas.microsoft.com/office/drawing/2014/main" id="{2C7EF4CD-978C-B000-B817-1B28B100E9C1}"/>
+                <a16:creationId xmlns:a16="http://schemas.microsoft.com/office/drawing/2014/main" id="{89445CF6-CF0A-0527-F1FF-42367F6DADCB}"/>
               </a:ext>
             </a:extLst>
           </p:cNvPr>
@@ -1386,7 +1386,7 @@
           <p:cNvPr id="5" name="Дата 4">
             <a:extLst>
               <a:ext uri="{FF2B5EF4-FFF2-40B4-BE49-F238E27FC236}">
-                <a16:creationId xmlns:a16="http://schemas.microsoft.com/office/drawing/2014/main" id="{B04930F8-0E2B-CB94-A0F2-8959BDB38E91}"/>
+                <a16:creationId xmlns:a16="http://schemas.microsoft.com/office/drawing/2014/main" id="{AB826EC3-8CA8-33B5-1DF5-E6EFC6CF4A59}"/>
               </a:ext>
             </a:extLst>
           </p:cNvPr>
@@ -1402,9 +1402,9 @@
           <a:bodyPr/>
           <a:lstStyle/>
           <a:p>
-            <a:fld id="{03721B2E-DCCE-4706-B678-5EB51971E16A}" type="datetimeFigureOut">
+            <a:fld id="{5A01C869-0FFD-4EC5-B2A6-53D2B155137E}" type="datetimeFigureOut">
               <a:rPr lang="ru-RU" smtClean="0"/>
-              <a:t>29.09.2026</a:t>
+              <a:t>01.10.2026</a:t>
             </a:fld>
             <a:endParaRPr lang="ru-RU"/>
           </a:p>
@@ -1415,7 +1415,7 @@
           <p:cNvPr id="6" name="Нижний колонтитул 5">
             <a:extLst>
               <a:ext uri="{FF2B5EF4-FFF2-40B4-BE49-F238E27FC236}">
-                <a16:creationId xmlns:a16="http://schemas.microsoft.com/office/drawing/2014/main" id="{3DCD5AB0-0268-48C7-3F51-138FD994BD45}"/>
+                <a16:creationId xmlns:a16="http://schemas.microsoft.com/office/drawing/2014/main" id="{66EA665B-44C4-246C-3322-D7A03BC7F3F4}"/>
               </a:ext>
             </a:extLst>
           </p:cNvPr>
@@ -1440,7 +1440,7 @@
           <p:cNvPr id="7" name="Номер слайда 6">
             <a:extLst>
               <a:ext uri="{FF2B5EF4-FFF2-40B4-BE49-F238E27FC236}">
-                <a16:creationId xmlns:a16="http://schemas.microsoft.com/office/drawing/2014/main" id="{C817227F-5894-68CF-C23E-0A5FA99AC04E}"/>
+                <a16:creationId xmlns:a16="http://schemas.microsoft.com/office/drawing/2014/main" id="{A6237537-26A7-8A1F-7C66-8BDAF4519A2D}"/>
               </a:ext>
             </a:extLst>
           </p:cNvPr>
@@ -1456,7 +1456,7 @@
           <a:bodyPr/>
           <a:lstStyle/>
           <a:p>
-            <a:fld id="{269FBB89-E2CC-4301-AA56-FBEDB15D679F}" type="slidenum">
+            <a:fld id="{A60DA2E9-18B7-4EDB-9385-3CDA23019443}" type="slidenum">
               <a:rPr lang="ru-RU" smtClean="0"/>
               <a:t>‹#›</a:t>
             </a:fld>
@@ -1467,7 +1467,7 @@
     </p:spTree>
     <p:extLst>
       <p:ext uri="{BB962C8B-B14F-4D97-AF65-F5344CB8AC3E}">
-        <p14:creationId xmlns:p14="http://schemas.microsoft.com/office/powerpoint/2010/main" val="1014564028"/>
+        <p14:creationId xmlns:p14="http://schemas.microsoft.com/office/powerpoint/2010/main" val="4005568649"/>
       </p:ext>
     </p:extLst>
   </p:cSld>
@@ -1499,7 +1499,7 @@
           <p:cNvPr id="2" name="Заголовок 1">
             <a:extLst>
               <a:ext uri="{FF2B5EF4-FFF2-40B4-BE49-F238E27FC236}">
-                <a16:creationId xmlns:a16="http://schemas.microsoft.com/office/drawing/2014/main" id="{4A78D667-C799-0332-AE30-5F63C8F8A9A3}"/>
+                <a16:creationId xmlns:a16="http://schemas.microsoft.com/office/drawing/2014/main" id="{1024DA39-45C9-DDA2-3822-0477B6BAA977}"/>
               </a:ext>
             </a:extLst>
           </p:cNvPr>
@@ -1532,7 +1532,7 @@
           <p:cNvPr id="3" name="Текст 2">
             <a:extLst>
               <a:ext uri="{FF2B5EF4-FFF2-40B4-BE49-F238E27FC236}">
-                <a16:creationId xmlns:a16="http://schemas.microsoft.com/office/drawing/2014/main" id="{62AB4330-A59B-E662-023A-1B6F52370E66}"/>
+                <a16:creationId xmlns:a16="http://schemas.microsoft.com/office/drawing/2014/main" id="{DD969AC5-E339-A7C0-35A3-753B5036647D}"/>
               </a:ext>
             </a:extLst>
           </p:cNvPr>
@@ -1603,7 +1603,7 @@
           <p:cNvPr id="4" name="Объект 3">
             <a:extLst>
               <a:ext uri="{FF2B5EF4-FFF2-40B4-BE49-F238E27FC236}">
-                <a16:creationId xmlns:a16="http://schemas.microsoft.com/office/drawing/2014/main" id="{6722AD97-73BC-333F-4260-FCC35A4D9231}"/>
+                <a16:creationId xmlns:a16="http://schemas.microsoft.com/office/drawing/2014/main" id="{C5A9AF99-A7EA-02F1-7348-A29D4B8032DD}"/>
               </a:ext>
             </a:extLst>
           </p:cNvPr>
@@ -1665,7 +1665,7 @@
           <p:cNvPr id="5" name="Текст 4">
             <a:extLst>
               <a:ext uri="{FF2B5EF4-FFF2-40B4-BE49-F238E27FC236}">
-                <a16:creationId xmlns:a16="http://schemas.microsoft.com/office/drawing/2014/main" id="{26418EE7-527B-8ADF-6468-AF5862864671}"/>
+                <a16:creationId xmlns:a16="http://schemas.microsoft.com/office/drawing/2014/main" id="{993D164E-F8D2-DE66-44CF-33D96559D262}"/>
               </a:ext>
             </a:extLst>
           </p:cNvPr>
@@ -1736,7 +1736,7 @@
           <p:cNvPr id="6" name="Объект 5">
             <a:extLst>
               <a:ext uri="{FF2B5EF4-FFF2-40B4-BE49-F238E27FC236}">
-                <a16:creationId xmlns:a16="http://schemas.microsoft.com/office/drawing/2014/main" id="{3F5262E9-398B-9552-D0ED-15190F36E1AA}"/>
+                <a16:creationId xmlns:a16="http://schemas.microsoft.com/office/drawing/2014/main" id="{C1235B1B-1EAB-4DF8-2618-CBF5C1074831}"/>
               </a:ext>
             </a:extLst>
           </p:cNvPr>
@@ -1798,7 +1798,7 @@
           <p:cNvPr id="7" name="Дата 6">
             <a:extLst>
               <a:ext uri="{FF2B5EF4-FFF2-40B4-BE49-F238E27FC236}">
-                <a16:creationId xmlns:a16="http://schemas.microsoft.com/office/drawing/2014/main" id="{A0AC83ED-BABA-7292-2AB7-FA933DCC7068}"/>
+                <a16:creationId xmlns:a16="http://schemas.microsoft.com/office/drawing/2014/main" id="{05DAC640-31B6-8705-566A-6BA9868AE04C}"/>
               </a:ext>
             </a:extLst>
           </p:cNvPr>
@@ -1814,9 +1814,9 @@
           <a:bodyPr/>
           <a:lstStyle/>
           <a:p>
-            <a:fld id="{03721B2E-DCCE-4706-B678-5EB51971E16A}" type="datetimeFigureOut">
+            <a:fld id="{5A01C869-0FFD-4EC5-B2A6-53D2B155137E}" type="datetimeFigureOut">
               <a:rPr lang="ru-RU" smtClean="0"/>
-              <a:t>29.09.2026</a:t>
+              <a:t>01.10.2026</a:t>
             </a:fld>
             <a:endParaRPr lang="ru-RU"/>
           </a:p>
@@ -1827,7 +1827,7 @@
           <p:cNvPr id="8" name="Нижний колонтитул 7">
             <a:extLst>
               <a:ext uri="{FF2B5EF4-FFF2-40B4-BE49-F238E27FC236}">
-                <a16:creationId xmlns:a16="http://schemas.microsoft.com/office/drawing/2014/main" id="{34BF76E2-08A2-7EF4-4291-1F9DE56E02A0}"/>
+                <a16:creationId xmlns:a16="http://schemas.microsoft.com/office/drawing/2014/main" id="{D6041472-8487-5850-DCDD-7A185D8DA380}"/>
               </a:ext>
             </a:extLst>
           </p:cNvPr>
@@ -1852,7 +1852,7 @@
           <p:cNvPr id="9" name="Номер слайда 8">
             <a:extLst>
               <a:ext uri="{FF2B5EF4-FFF2-40B4-BE49-F238E27FC236}">
-                <a16:creationId xmlns:a16="http://schemas.microsoft.com/office/drawing/2014/main" id="{EA44BC9D-2F9A-060E-F02F-6E1A5DF716B5}"/>
+                <a16:creationId xmlns:a16="http://schemas.microsoft.com/office/drawing/2014/main" id="{8CCDE09F-9D18-A0A8-18CE-E6400199A2F3}"/>
               </a:ext>
             </a:extLst>
           </p:cNvPr>
@@ -1868,7 +1868,7 @@
           <a:bodyPr/>
           <a:lstStyle/>
           <a:p>
-            <a:fld id="{269FBB89-E2CC-4301-AA56-FBEDB15D679F}" type="slidenum">
+            <a:fld id="{A60DA2E9-18B7-4EDB-9385-3CDA23019443}" type="slidenum">
               <a:rPr lang="ru-RU" smtClean="0"/>
               <a:t>‹#›</a:t>
             </a:fld>
@@ -1879,7 +1879,7 @@
     </p:spTree>
     <p:extLst>
       <p:ext uri="{BB962C8B-B14F-4D97-AF65-F5344CB8AC3E}">
-        <p14:creationId xmlns:p14="http://schemas.microsoft.com/office/powerpoint/2010/main" val="4077026593"/>
+        <p14:creationId xmlns:p14="http://schemas.microsoft.com/office/powerpoint/2010/main" val="3097533580"/>
       </p:ext>
     </p:extLst>
   </p:cSld>
@@ -1911,7 +1911,7 @@
           <p:cNvPr id="2" name="Заголовок 1">
             <a:extLst>
               <a:ext uri="{FF2B5EF4-FFF2-40B4-BE49-F238E27FC236}">
-                <a16:creationId xmlns:a16="http://schemas.microsoft.com/office/drawing/2014/main" id="{0D373161-A7C8-EB79-0392-273CBA3DFE81}"/>
+                <a16:creationId xmlns:a16="http://schemas.microsoft.com/office/drawing/2014/main" id="{F125266D-F1B6-1C9D-A7A2-2AF385BBFDB7}"/>
               </a:ext>
             </a:extLst>
           </p:cNvPr>
@@ -1939,7 +1939,7 @@
           <p:cNvPr id="3" name="Дата 2">
             <a:extLst>
               <a:ext uri="{FF2B5EF4-FFF2-40B4-BE49-F238E27FC236}">
-                <a16:creationId xmlns:a16="http://schemas.microsoft.com/office/drawing/2014/main" id="{40FF028A-56F3-F1C3-F50B-BAB72F1B1590}"/>
+                <a16:creationId xmlns:a16="http://schemas.microsoft.com/office/drawing/2014/main" id="{8B4416CF-7F51-1EC0-429E-B398F2E9B704}"/>
               </a:ext>
             </a:extLst>
           </p:cNvPr>
@@ -1955,9 +1955,9 @@
           <a:bodyPr/>
           <a:lstStyle/>
           <a:p>
-            <a:fld id="{03721B2E-DCCE-4706-B678-5EB51971E16A}" type="datetimeFigureOut">
+            <a:fld id="{5A01C869-0FFD-4EC5-B2A6-53D2B155137E}" type="datetimeFigureOut">
               <a:rPr lang="ru-RU" smtClean="0"/>
-              <a:t>29.09.2026</a:t>
+              <a:t>01.10.2026</a:t>
             </a:fld>
             <a:endParaRPr lang="ru-RU"/>
           </a:p>
@@ -1968,7 +1968,7 @@
           <p:cNvPr id="4" name="Нижний колонтитул 3">
             <a:extLst>
               <a:ext uri="{FF2B5EF4-FFF2-40B4-BE49-F238E27FC236}">
-                <a16:creationId xmlns:a16="http://schemas.microsoft.com/office/drawing/2014/main" id="{B9BEC32C-0575-75A1-1BAB-203883C71169}"/>
+                <a16:creationId xmlns:a16="http://schemas.microsoft.com/office/drawing/2014/main" id="{DD8AE8A9-7EDC-65D6-E15A-164D8D45845F}"/>
               </a:ext>
             </a:extLst>
           </p:cNvPr>
@@ -1993,7 +1993,7 @@
           <p:cNvPr id="5" name="Номер слайда 4">
             <a:extLst>
               <a:ext uri="{FF2B5EF4-FFF2-40B4-BE49-F238E27FC236}">
-                <a16:creationId xmlns:a16="http://schemas.microsoft.com/office/drawing/2014/main" id="{B1A8ED1D-0F31-A4F9-FA2E-102F116C75CF}"/>
+                <a16:creationId xmlns:a16="http://schemas.microsoft.com/office/drawing/2014/main" id="{FD31C21C-1D99-914E-7587-B671E416693E}"/>
               </a:ext>
             </a:extLst>
           </p:cNvPr>
@@ -2009,7 +2009,7 @@
           <a:bodyPr/>
           <a:lstStyle/>
           <a:p>
-            <a:fld id="{269FBB89-E2CC-4301-AA56-FBEDB15D679F}" type="slidenum">
+            <a:fld id="{A60DA2E9-18B7-4EDB-9385-3CDA23019443}" type="slidenum">
               <a:rPr lang="ru-RU" smtClean="0"/>
               <a:t>‹#›</a:t>
             </a:fld>
@@ -2020,7 +2020,7 @@
     </p:spTree>
     <p:extLst>
       <p:ext uri="{BB962C8B-B14F-4D97-AF65-F5344CB8AC3E}">
-        <p14:creationId xmlns:p14="http://schemas.microsoft.com/office/powerpoint/2010/main" val="677117321"/>
+        <p14:creationId xmlns:p14="http://schemas.microsoft.com/office/powerpoint/2010/main" val="2902144299"/>
       </p:ext>
     </p:extLst>
   </p:cSld>
@@ -2052,7 +2052,7 @@
           <p:cNvPr id="2" name="Дата 1">
             <a:extLst>
               <a:ext uri="{FF2B5EF4-FFF2-40B4-BE49-F238E27FC236}">
-                <a16:creationId xmlns:a16="http://schemas.microsoft.com/office/drawing/2014/main" id="{5AAEE2BB-0DC7-64D3-C074-7B7A06814FFB}"/>
+                <a16:creationId xmlns:a16="http://schemas.microsoft.com/office/drawing/2014/main" id="{5DBE25E5-5B21-305E-4F46-6946E5D668D6}"/>
               </a:ext>
             </a:extLst>
           </p:cNvPr>
@@ -2068,9 +2068,9 @@
           <a:bodyPr/>
           <a:lstStyle/>
           <a:p>
-            <a:fld id="{03721B2E-DCCE-4706-B678-5EB51971E16A}" type="datetimeFigureOut">
+            <a:fld id="{5A01C869-0FFD-4EC5-B2A6-53D2B155137E}" type="datetimeFigureOut">
               <a:rPr lang="ru-RU" smtClean="0"/>
-              <a:t>29.09.2026</a:t>
+              <a:t>01.10.2026</a:t>
             </a:fld>
             <a:endParaRPr lang="ru-RU"/>
           </a:p>
@@ -2081,7 +2081,7 @@
           <p:cNvPr id="3" name="Нижний колонтитул 2">
             <a:extLst>
               <a:ext uri="{FF2B5EF4-FFF2-40B4-BE49-F238E27FC236}">
-                <a16:creationId xmlns:a16="http://schemas.microsoft.com/office/drawing/2014/main" id="{7F2AD0B6-E604-056B-5261-55027CF1F2DA}"/>
+                <a16:creationId xmlns:a16="http://schemas.microsoft.com/office/drawing/2014/main" id="{2924FBD9-A74B-399D-AFE2-82BE48916FA2}"/>
               </a:ext>
             </a:extLst>
           </p:cNvPr>
@@ -2106,7 +2106,7 @@
           <p:cNvPr id="4" name="Номер слайда 3">
             <a:extLst>
               <a:ext uri="{FF2B5EF4-FFF2-40B4-BE49-F238E27FC236}">
-                <a16:creationId xmlns:a16="http://schemas.microsoft.com/office/drawing/2014/main" id="{6CB4152B-18D6-6BD2-8929-A35BB3B5F30B}"/>
+                <a16:creationId xmlns:a16="http://schemas.microsoft.com/office/drawing/2014/main" id="{ACBF4DD1-D533-E792-92F5-9A8DB7C6B564}"/>
               </a:ext>
             </a:extLst>
           </p:cNvPr>
@@ -2122,7 +2122,7 @@
           <a:bodyPr/>
           <a:lstStyle/>
           <a:p>
-            <a:fld id="{269FBB89-E2CC-4301-AA56-FBEDB15D679F}" type="slidenum">
+            <a:fld id="{A60DA2E9-18B7-4EDB-9385-3CDA23019443}" type="slidenum">
               <a:rPr lang="ru-RU" smtClean="0"/>
               <a:t>‹#›</a:t>
             </a:fld>
@@ -2133,7 +2133,7 @@
     </p:spTree>
     <p:extLst>
       <p:ext uri="{BB962C8B-B14F-4D97-AF65-F5344CB8AC3E}">
-        <p14:creationId xmlns:p14="http://schemas.microsoft.com/office/powerpoint/2010/main" val="1292334844"/>
+        <p14:creationId xmlns:p14="http://schemas.microsoft.com/office/powerpoint/2010/main" val="4161629407"/>
       </p:ext>
     </p:extLst>
   </p:cSld>
@@ -2165,7 +2165,7 @@
           <p:cNvPr id="2" name="Заголовок 1">
             <a:extLst>
               <a:ext uri="{FF2B5EF4-FFF2-40B4-BE49-F238E27FC236}">
-                <a16:creationId xmlns:a16="http://schemas.microsoft.com/office/drawing/2014/main" id="{3A9F614F-B70F-B500-7FA2-071F9D85E8D9}"/>
+                <a16:creationId xmlns:a16="http://schemas.microsoft.com/office/drawing/2014/main" id="{323A16DA-26FB-B06C-2BBF-C29073E8D04C}"/>
               </a:ext>
             </a:extLst>
           </p:cNvPr>
@@ -2202,7 +2202,7 @@
           <p:cNvPr id="3" name="Объект 2">
             <a:extLst>
               <a:ext uri="{FF2B5EF4-FFF2-40B4-BE49-F238E27FC236}">
-                <a16:creationId xmlns:a16="http://schemas.microsoft.com/office/drawing/2014/main" id="{5466CAF6-3A9A-18EF-10AF-63AB93ACC118}"/>
+                <a16:creationId xmlns:a16="http://schemas.microsoft.com/office/drawing/2014/main" id="{7A0578DF-6D0F-EBB7-490C-1C9EC8564930}"/>
               </a:ext>
             </a:extLst>
           </p:cNvPr>
@@ -2292,7 +2292,7 @@
           <p:cNvPr id="4" name="Текст 3">
             <a:extLst>
               <a:ext uri="{FF2B5EF4-FFF2-40B4-BE49-F238E27FC236}">
-                <a16:creationId xmlns:a16="http://schemas.microsoft.com/office/drawing/2014/main" id="{506FA154-DECB-990E-0E06-33F59756619B}"/>
+                <a16:creationId xmlns:a16="http://schemas.microsoft.com/office/drawing/2014/main" id="{5A8CAD0A-3EC3-5CAF-1F10-065931B25A27}"/>
               </a:ext>
             </a:extLst>
           </p:cNvPr>
@@ -2363,7 +2363,7 @@
           <p:cNvPr id="5" name="Дата 4">
             <a:extLst>
               <a:ext uri="{FF2B5EF4-FFF2-40B4-BE49-F238E27FC236}">
-                <a16:creationId xmlns:a16="http://schemas.microsoft.com/office/drawing/2014/main" id="{F8F850BE-B470-5A12-268B-697761FE8A92}"/>
+                <a16:creationId xmlns:a16="http://schemas.microsoft.com/office/drawing/2014/main" id="{FEF84121-3C5D-CEE5-D2FB-621D2734AE79}"/>
               </a:ext>
             </a:extLst>
           </p:cNvPr>
@@ -2379,9 +2379,9 @@
           <a:bodyPr/>
           <a:lstStyle/>
           <a:p>
-            <a:fld id="{03721B2E-DCCE-4706-B678-5EB51971E16A}" type="datetimeFigureOut">
+            <a:fld id="{5A01C869-0FFD-4EC5-B2A6-53D2B155137E}" type="datetimeFigureOut">
               <a:rPr lang="ru-RU" smtClean="0"/>
-              <a:t>29.09.2026</a:t>
+              <a:t>01.10.2026</a:t>
             </a:fld>
             <a:endParaRPr lang="ru-RU"/>
           </a:p>
@@ -2392,7 +2392,7 @@
           <p:cNvPr id="6" name="Нижний колонтитул 5">
             <a:extLst>
               <a:ext uri="{FF2B5EF4-FFF2-40B4-BE49-F238E27FC236}">
-                <a16:creationId xmlns:a16="http://schemas.microsoft.com/office/drawing/2014/main" id="{B27C5B5D-AB7A-D255-F3FD-2F37F766F2CC}"/>
+                <a16:creationId xmlns:a16="http://schemas.microsoft.com/office/drawing/2014/main" id="{4C454C2C-52EC-5E41-EB6C-EE3E1EE440C6}"/>
               </a:ext>
             </a:extLst>
           </p:cNvPr>
@@ -2417,7 +2417,7 @@
           <p:cNvPr id="7" name="Номер слайда 6">
             <a:extLst>
               <a:ext uri="{FF2B5EF4-FFF2-40B4-BE49-F238E27FC236}">
-                <a16:creationId xmlns:a16="http://schemas.microsoft.com/office/drawing/2014/main" id="{859258E7-0898-9040-D607-D6A1B0CB0C6B}"/>
+                <a16:creationId xmlns:a16="http://schemas.microsoft.com/office/drawing/2014/main" id="{871AACF5-1AE0-6210-44C4-E607C3BE15D2}"/>
               </a:ext>
             </a:extLst>
           </p:cNvPr>
@@ -2433,7 +2433,7 @@
           <a:bodyPr/>
           <a:lstStyle/>
           <a:p>
-            <a:fld id="{269FBB89-E2CC-4301-AA56-FBEDB15D679F}" type="slidenum">
+            <a:fld id="{A60DA2E9-18B7-4EDB-9385-3CDA23019443}" type="slidenum">
               <a:rPr lang="ru-RU" smtClean="0"/>
               <a:t>‹#›</a:t>
             </a:fld>
@@ -2444,7 +2444,7 @@
     </p:spTree>
     <p:extLst>
       <p:ext uri="{BB962C8B-B14F-4D97-AF65-F5344CB8AC3E}">
-        <p14:creationId xmlns:p14="http://schemas.microsoft.com/office/powerpoint/2010/main" val="1000408407"/>
+        <p14:creationId xmlns:p14="http://schemas.microsoft.com/office/powerpoint/2010/main" val="3663089200"/>
       </p:ext>
     </p:extLst>
   </p:cSld>
@@ -2476,7 +2476,7 @@
           <p:cNvPr id="2" name="Заголовок 1">
             <a:extLst>
               <a:ext uri="{FF2B5EF4-FFF2-40B4-BE49-F238E27FC236}">
-                <a16:creationId xmlns:a16="http://schemas.microsoft.com/office/drawing/2014/main" id="{0A380ED1-7ADA-5E9F-4B31-B89B144C401C}"/>
+                <a16:creationId xmlns:a16="http://schemas.microsoft.com/office/drawing/2014/main" id="{3C3884AB-66DE-C7B9-F2D3-063070ACCAA5}"/>
               </a:ext>
             </a:extLst>
           </p:cNvPr>
@@ -2513,12 +2513,12 @@
           <p:cNvPr id="3" name="Рисунок 2">
             <a:extLst>
               <a:ext uri="{FF2B5EF4-FFF2-40B4-BE49-F238E27FC236}">
-                <a16:creationId xmlns:a16="http://schemas.microsoft.com/office/drawing/2014/main" id="{F56A0856-DF14-9B5D-6C31-43021DE71E80}"/>
+                <a16:creationId xmlns:a16="http://schemas.microsoft.com/office/drawing/2014/main" id="{B94AFD79-7BD1-BD33-8F1A-378A6FE35DB6}"/>
               </a:ext>
             </a:extLst>
           </p:cNvPr>
           <p:cNvSpPr>
-            <a:spLocks noGrp="1"/>
+            <a:spLocks noGrp="1" noChangeAspect="1"/>
           </p:cNvSpPr>
           <p:nvPr>
             <p:ph type="pic" idx="1"/>
@@ -2580,7 +2580,7 @@
           <p:cNvPr id="4" name="Текст 3">
             <a:extLst>
               <a:ext uri="{FF2B5EF4-FFF2-40B4-BE49-F238E27FC236}">
-                <a16:creationId xmlns:a16="http://schemas.microsoft.com/office/drawing/2014/main" id="{B80EA323-388D-F24E-19A4-CEABCE8D89AD}"/>
+                <a16:creationId xmlns:a16="http://schemas.microsoft.com/office/drawing/2014/main" id="{B49A8E62-84AB-FBA8-647F-7E3B4C6FB729}"/>
               </a:ext>
             </a:extLst>
           </p:cNvPr>
@@ -2651,7 +2651,7 @@
           <p:cNvPr id="5" name="Дата 4">
             <a:extLst>
               <a:ext uri="{FF2B5EF4-FFF2-40B4-BE49-F238E27FC236}">
-                <a16:creationId xmlns:a16="http://schemas.microsoft.com/office/drawing/2014/main" id="{5E749815-E629-C611-3E72-95284D50D7F7}"/>
+                <a16:creationId xmlns:a16="http://schemas.microsoft.com/office/drawing/2014/main" id="{94F4204B-79A1-32E3-C2B5-B5BCD3C3FE7B}"/>
               </a:ext>
             </a:extLst>
           </p:cNvPr>
@@ -2667,9 +2667,9 @@
           <a:bodyPr/>
           <a:lstStyle/>
           <a:p>
-            <a:fld id="{03721B2E-DCCE-4706-B678-5EB51971E16A}" type="datetimeFigureOut">
+            <a:fld id="{5A01C869-0FFD-4EC5-B2A6-53D2B155137E}" type="datetimeFigureOut">
               <a:rPr lang="ru-RU" smtClean="0"/>
-              <a:t>29.09.2026</a:t>
+              <a:t>01.10.2026</a:t>
             </a:fld>
             <a:endParaRPr lang="ru-RU"/>
           </a:p>
@@ -2680,7 +2680,7 @@
           <p:cNvPr id="6" name="Нижний колонтитул 5">
             <a:extLst>
               <a:ext uri="{FF2B5EF4-FFF2-40B4-BE49-F238E27FC236}">
-                <a16:creationId xmlns:a16="http://schemas.microsoft.com/office/drawing/2014/main" id="{11B04EED-6E78-ABB0-7DF7-E64361A1BD0C}"/>
+                <a16:creationId xmlns:a16="http://schemas.microsoft.com/office/drawing/2014/main" id="{4A13DA52-DCB3-FD5A-2841-9F308348F8C9}"/>
               </a:ext>
             </a:extLst>
           </p:cNvPr>
@@ -2705,7 +2705,7 @@
           <p:cNvPr id="7" name="Номер слайда 6">
             <a:extLst>
               <a:ext uri="{FF2B5EF4-FFF2-40B4-BE49-F238E27FC236}">
-                <a16:creationId xmlns:a16="http://schemas.microsoft.com/office/drawing/2014/main" id="{752603D2-16BE-C5E1-AD4C-B3E83A1FA826}"/>
+                <a16:creationId xmlns:a16="http://schemas.microsoft.com/office/drawing/2014/main" id="{0005FC33-5AEE-9706-520D-E67F6085E909}"/>
               </a:ext>
             </a:extLst>
           </p:cNvPr>
@@ -2721,7 +2721,7 @@
           <a:bodyPr/>
           <a:lstStyle/>
           <a:p>
-            <a:fld id="{269FBB89-E2CC-4301-AA56-FBEDB15D679F}" type="slidenum">
+            <a:fld id="{A60DA2E9-18B7-4EDB-9385-3CDA23019443}" type="slidenum">
               <a:rPr lang="ru-RU" smtClean="0"/>
               <a:t>‹#›</a:t>
             </a:fld>
@@ -2732,7 +2732,7 @@
     </p:spTree>
     <p:extLst>
       <p:ext uri="{BB962C8B-B14F-4D97-AF65-F5344CB8AC3E}">
-        <p14:creationId xmlns:p14="http://schemas.microsoft.com/office/powerpoint/2010/main" val="460356551"/>
+        <p14:creationId xmlns:p14="http://schemas.microsoft.com/office/powerpoint/2010/main" val="1743557954"/>
       </p:ext>
     </p:extLst>
   </p:cSld>
@@ -2769,7 +2769,7 @@
           <p:cNvPr id="2" name="Заголовок 1">
             <a:extLst>
               <a:ext uri="{FF2B5EF4-FFF2-40B4-BE49-F238E27FC236}">
-                <a16:creationId xmlns:a16="http://schemas.microsoft.com/office/drawing/2014/main" id="{F2FC36CD-EEB6-7D41-213A-B286C6D09F02}"/>
+                <a16:creationId xmlns:a16="http://schemas.microsoft.com/office/drawing/2014/main" id="{CC82852F-4D0A-4E2F-3AC4-4235B04F5482}"/>
               </a:ext>
             </a:extLst>
           </p:cNvPr>
@@ -2807,7 +2807,7 @@
           <p:cNvPr id="3" name="Текст 2">
             <a:extLst>
               <a:ext uri="{FF2B5EF4-FFF2-40B4-BE49-F238E27FC236}">
-                <a16:creationId xmlns:a16="http://schemas.microsoft.com/office/drawing/2014/main" id="{BAC5A87B-2F7E-C356-2EFD-00F3925B0311}"/>
+                <a16:creationId xmlns:a16="http://schemas.microsoft.com/office/drawing/2014/main" id="{5CAEE580-47F0-F6A9-EA55-67B89B056E86}"/>
               </a:ext>
             </a:extLst>
           </p:cNvPr>
@@ -2874,7 +2874,7 @@
           <p:cNvPr id="4" name="Дата 3">
             <a:extLst>
               <a:ext uri="{FF2B5EF4-FFF2-40B4-BE49-F238E27FC236}">
-                <a16:creationId xmlns:a16="http://schemas.microsoft.com/office/drawing/2014/main" id="{7509D999-1A54-7FC8-A0F0-B4757DC5A2E2}"/>
+                <a16:creationId xmlns:a16="http://schemas.microsoft.com/office/drawing/2014/main" id="{8AC3C4A9-063B-D9AC-7571-6EC70B64FB51}"/>
               </a:ext>
             </a:extLst>
           </p:cNvPr>
@@ -2908,9 +2908,9 @@
             </a:lvl1pPr>
           </a:lstStyle>
           <a:p>
-            <a:fld id="{03721B2E-DCCE-4706-B678-5EB51971E16A}" type="datetimeFigureOut">
+            <a:fld id="{5A01C869-0FFD-4EC5-B2A6-53D2B155137E}" type="datetimeFigureOut">
               <a:rPr lang="ru-RU" smtClean="0"/>
-              <a:t>29.09.2026</a:t>
+              <a:t>01.10.2026</a:t>
             </a:fld>
             <a:endParaRPr lang="ru-RU"/>
           </a:p>
@@ -2921,7 +2921,7 @@
           <p:cNvPr id="5" name="Нижний колонтитул 4">
             <a:extLst>
               <a:ext uri="{FF2B5EF4-FFF2-40B4-BE49-F238E27FC236}">
-                <a16:creationId xmlns:a16="http://schemas.microsoft.com/office/drawing/2014/main" id="{6CB34EF6-226D-1B90-0E39-AA42A45D58A5}"/>
+                <a16:creationId xmlns:a16="http://schemas.microsoft.com/office/drawing/2014/main" id="{0B0ABDD1-5B6E-57D5-ACA2-8AD178BE9E1F}"/>
               </a:ext>
             </a:extLst>
           </p:cNvPr>
@@ -2964,7 +2964,7 @@
           <p:cNvPr id="6" name="Номер слайда 5">
             <a:extLst>
               <a:ext uri="{FF2B5EF4-FFF2-40B4-BE49-F238E27FC236}">
-                <a16:creationId xmlns:a16="http://schemas.microsoft.com/office/drawing/2014/main" id="{99FF456D-B005-4185-15CF-BC964116FEC7}"/>
+                <a16:creationId xmlns:a16="http://schemas.microsoft.com/office/drawing/2014/main" id="{A32BA4B6-E06C-8898-9DC4-572F3A4AF014}"/>
               </a:ext>
             </a:extLst>
           </p:cNvPr>
@@ -2998,7 +2998,7 @@
             </a:lvl1pPr>
           </a:lstStyle>
           <a:p>
-            <a:fld id="{269FBB89-E2CC-4301-AA56-FBEDB15D679F}" type="slidenum">
+            <a:fld id="{A60DA2E9-18B7-4EDB-9385-3CDA23019443}" type="slidenum">
               <a:rPr lang="ru-RU" smtClean="0"/>
               <a:t>‹#›</a:t>
             </a:fld>
@@ -3009,7 +3009,7 @@
     </p:spTree>
     <p:extLst>
       <p:ext uri="{BB962C8B-B14F-4D97-AF65-F5344CB8AC3E}">
-        <p14:creationId xmlns:p14="http://schemas.microsoft.com/office/powerpoint/2010/main" val="3839257548"/>
+        <p14:creationId xmlns:p14="http://schemas.microsoft.com/office/powerpoint/2010/main" val="772026873"/>
       </p:ext>
     </p:extLst>
   </p:cSld>
@@ -3340,7 +3340,7 @@
           <p:cNvPr id="2" name="TextBox 1">
             <a:extLst>
               <a:ext uri="{FF2B5EF4-FFF2-40B4-BE49-F238E27FC236}">
-                <a16:creationId xmlns:a16="http://schemas.microsoft.com/office/drawing/2014/main" id="{BEBE61EF-51E8-D47F-206F-5791CCCEA11E}"/>
+                <a16:creationId xmlns:a16="http://schemas.microsoft.com/office/drawing/2014/main" id="{7F478CC5-EFF5-6B02-6A2C-190C0ABB22DA}"/>
               </a:ext>
             </a:extLst>
           </p:cNvPr>
@@ -3364,22 +3364,13 @@
           <a:lstStyle/>
           <a:p>
             <a:r>
-              <a:rPr lang="ru-RU" sz="1400">
+              <a:rPr lang="en-US" sz="1400">
                 <a:solidFill>
                   <a:srgbClr val="C9D3E3"/>
                 </a:solidFill>
                 <a:latin typeface="Calibri" panose="020F0502020204030204" pitchFamily="34" charset="0"/>
               </a:rPr>
-              <a:t>Хакатон · команда </a:t>
-            </a:r>
-            <a:r>
-              <a:rPr lang="en-US" sz="1400">
-                <a:solidFill>
-                  <a:srgbClr val="C9D3E3"/>
-                </a:solidFill>
-                <a:latin typeface="Calibri" panose="020F0502020204030204" pitchFamily="34" charset="0"/>
-              </a:rPr>
-              <a:t>bokom-m</a:t>
+              <a:t>Hackathon · team bokom-m</a:t>
             </a:r>
             <a:endParaRPr lang="ru-RU" sz="1400">
               <a:solidFill>
@@ -3395,7 +3386,7 @@
           <p:cNvPr id="3" name="TextBox 2">
             <a:extLst>
               <a:ext uri="{FF2B5EF4-FFF2-40B4-BE49-F238E27FC236}">
-                <a16:creationId xmlns:a16="http://schemas.microsoft.com/office/drawing/2014/main" id="{F527A568-41FD-C464-7217-6E688F56504A}"/>
+                <a16:creationId xmlns:a16="http://schemas.microsoft.com/office/drawing/2014/main" id="{3B636A4A-00BC-FA68-9513-E4CACF41B536}"/>
               </a:ext>
             </a:extLst>
           </p:cNvPr>
@@ -3419,14 +3410,20 @@
           <a:lstStyle/>
           <a:p>
             <a:r>
-              <a:rPr lang="ru-RU" sz="4000" b="1">
+              <a:rPr lang="en-US" sz="3600" b="1">
                 <a:solidFill>
                   <a:srgbClr val="FFFFFF"/>
                 </a:solidFill>
                 <a:latin typeface="Cambria" panose="02040503050406030204" pitchFamily="18" charset="0"/>
               </a:rPr>
-              <a:t>Нейрофизиологическая диагностика ПТСР</a:t>
-            </a:r>
+              <a:t>Neurophysiological diagnosis of PTSD</a:t>
+            </a:r>
+            <a:endParaRPr lang="ru-RU" sz="3600" b="1">
+              <a:solidFill>
+                <a:srgbClr val="FFFFFF"/>
+              </a:solidFill>
+              <a:latin typeface="Cambria" panose="02040503050406030204" pitchFamily="18" charset="0"/>
+            </a:endParaRPr>
           </a:p>
         </p:txBody>
       </p:sp>
@@ -3435,7 +3432,7 @@
           <p:cNvPr id="4" name="TextBox 3">
             <a:extLst>
               <a:ext uri="{FF2B5EF4-FFF2-40B4-BE49-F238E27FC236}">
-                <a16:creationId xmlns:a16="http://schemas.microsoft.com/office/drawing/2014/main" id="{187F1C4D-0DC9-8FCB-5EEE-C177C2F9379C}"/>
+                <a16:creationId xmlns:a16="http://schemas.microsoft.com/office/drawing/2014/main" id="{EEE6E16A-6E2D-2734-2B70-9345730AE605}"/>
               </a:ext>
             </a:extLst>
           </p:cNvPr>
@@ -3459,14 +3456,20 @@
           <a:lstStyle/>
           <a:p>
             <a:r>
-              <a:rPr lang="ru-RU" sz="2200">
+              <a:rPr lang="en-US" sz="2200">
                 <a:solidFill>
                   <a:srgbClr val="C9D3E3"/>
                 </a:solidFill>
                 <a:latin typeface="Calibri" panose="020F0502020204030204" pitchFamily="34" charset="0"/>
               </a:rPr>
-              <a:t>по данным малоканальной сухой ЭЭГ</a:t>
-            </a:r>
+              <a:t>from few-channel dry EEG</a:t>
+            </a:r>
+            <a:endParaRPr lang="ru-RU" sz="2200">
+              <a:solidFill>
+                <a:srgbClr val="C9D3E3"/>
+              </a:solidFill>
+              <a:latin typeface="Calibri" panose="020F0502020204030204" pitchFamily="34" charset="0"/>
+            </a:endParaRPr>
           </a:p>
         </p:txBody>
       </p:sp>
@@ -3475,7 +3478,7 @@
           <p:cNvPr id="5" name="Овал 4">
             <a:extLst>
               <a:ext uri="{FF2B5EF4-FFF2-40B4-BE49-F238E27FC236}">
-                <a16:creationId xmlns:a16="http://schemas.microsoft.com/office/drawing/2014/main" id="{E5BD9D9A-F242-A4A7-7864-ACCF57621CCA}"/>
+                <a16:creationId xmlns:a16="http://schemas.microsoft.com/office/drawing/2014/main" id="{49391BBA-3117-0BFE-FCE4-EDD600DB5067}"/>
               </a:ext>
             </a:extLst>
           </p:cNvPr>
@@ -3539,7 +3542,7 @@
           <p:cNvPr id="6" name="Равнобедренный треугольник 5">
             <a:extLst>
               <a:ext uri="{FF2B5EF4-FFF2-40B4-BE49-F238E27FC236}">
-                <a16:creationId xmlns:a16="http://schemas.microsoft.com/office/drawing/2014/main" id="{3407AB1D-48C1-6D9E-AA32-740EFE774084}"/>
+                <a16:creationId xmlns:a16="http://schemas.microsoft.com/office/drawing/2014/main" id="{4E34BB3F-FEB1-1EA3-ECA9-7DA299672277}"/>
               </a:ext>
             </a:extLst>
           </p:cNvPr>
@@ -3603,7 +3606,7 @@
           <p:cNvPr id="7" name="Овал 6">
             <a:extLst>
               <a:ext uri="{FF2B5EF4-FFF2-40B4-BE49-F238E27FC236}">
-                <a16:creationId xmlns:a16="http://schemas.microsoft.com/office/drawing/2014/main" id="{C3643962-4155-A199-A663-CCDBC8C6A9D9}"/>
+                <a16:creationId xmlns:a16="http://schemas.microsoft.com/office/drawing/2014/main" id="{E0687A73-1111-0127-8F8B-A6278AD5B042}"/>
               </a:ext>
             </a:extLst>
           </p:cNvPr>
@@ -3667,7 +3670,7 @@
           <p:cNvPr id="8" name="Овал 7">
             <a:extLst>
               <a:ext uri="{FF2B5EF4-FFF2-40B4-BE49-F238E27FC236}">
-                <a16:creationId xmlns:a16="http://schemas.microsoft.com/office/drawing/2014/main" id="{410BC3F4-132C-DA5F-9FED-39069538AEA6}"/>
+                <a16:creationId xmlns:a16="http://schemas.microsoft.com/office/drawing/2014/main" id="{E68D7815-8BC1-A52E-7D1B-250E5720957E}"/>
               </a:ext>
             </a:extLst>
           </p:cNvPr>
@@ -3731,7 +3734,7 @@
           <p:cNvPr id="9" name="Овал 8">
             <a:extLst>
               <a:ext uri="{FF2B5EF4-FFF2-40B4-BE49-F238E27FC236}">
-                <a16:creationId xmlns:a16="http://schemas.microsoft.com/office/drawing/2014/main" id="{582F573C-E6F0-F559-EC22-34F02203CD50}"/>
+                <a16:creationId xmlns:a16="http://schemas.microsoft.com/office/drawing/2014/main" id="{EE79DF0A-FA02-8CE1-0B9D-F344BE0424DB}"/>
               </a:ext>
             </a:extLst>
           </p:cNvPr>
@@ -3813,7 +3816,7 @@
           <p:cNvPr id="10" name="Овал 9">
             <a:extLst>
               <a:ext uri="{FF2B5EF4-FFF2-40B4-BE49-F238E27FC236}">
-                <a16:creationId xmlns:a16="http://schemas.microsoft.com/office/drawing/2014/main" id="{6A28E5BB-F6A4-F91D-7B72-C57C48E29F81}"/>
+                <a16:creationId xmlns:a16="http://schemas.microsoft.com/office/drawing/2014/main" id="{E78ACA37-B4E8-47A0-8707-197CFCE7C894}"/>
               </a:ext>
             </a:extLst>
           </p:cNvPr>
@@ -3895,7 +3898,7 @@
           <p:cNvPr id="11" name="Овал 10">
             <a:extLst>
               <a:ext uri="{FF2B5EF4-FFF2-40B4-BE49-F238E27FC236}">
-                <a16:creationId xmlns:a16="http://schemas.microsoft.com/office/drawing/2014/main" id="{B566353D-A098-9DBE-0B39-9D6DC8D45A37}"/>
+                <a16:creationId xmlns:a16="http://schemas.microsoft.com/office/drawing/2014/main" id="{52588F5D-CCD4-6855-4F4C-1CA245F7B704}"/>
               </a:ext>
             </a:extLst>
           </p:cNvPr>
@@ -3977,7 +3980,7 @@
           <p:cNvPr id="12" name="Овал 11">
             <a:extLst>
               <a:ext uri="{FF2B5EF4-FFF2-40B4-BE49-F238E27FC236}">
-                <a16:creationId xmlns:a16="http://schemas.microsoft.com/office/drawing/2014/main" id="{58CB8046-C09F-20CA-6CFF-153E5AF77853}"/>
+                <a16:creationId xmlns:a16="http://schemas.microsoft.com/office/drawing/2014/main" id="{B2F6733F-999E-434C-63F0-F5351249DC53}"/>
               </a:ext>
             </a:extLst>
           </p:cNvPr>
@@ -4059,7 +4062,7 @@
           <p:cNvPr id="13" name="Овал 12">
             <a:extLst>
               <a:ext uri="{FF2B5EF4-FFF2-40B4-BE49-F238E27FC236}">
-                <a16:creationId xmlns:a16="http://schemas.microsoft.com/office/drawing/2014/main" id="{977E289B-4FA3-CC08-F8BB-9B0BAF9AF8CF}"/>
+                <a16:creationId xmlns:a16="http://schemas.microsoft.com/office/drawing/2014/main" id="{EB25C23A-5CF1-FB77-6862-B715FE98D44E}"/>
               </a:ext>
             </a:extLst>
           </p:cNvPr>
@@ -4141,7 +4144,7 @@
           <p:cNvPr id="14" name="Овал 13">
             <a:extLst>
               <a:ext uri="{FF2B5EF4-FFF2-40B4-BE49-F238E27FC236}">
-                <a16:creationId xmlns:a16="http://schemas.microsoft.com/office/drawing/2014/main" id="{294562AE-8545-AA32-8598-335C1C726711}"/>
+                <a16:creationId xmlns:a16="http://schemas.microsoft.com/office/drawing/2014/main" id="{7E6E1298-D52C-3C1B-6A5F-68D970133EE0}"/>
               </a:ext>
             </a:extLst>
           </p:cNvPr>
@@ -4221,7 +4224,7 @@
     </p:spTree>
     <p:extLst>
       <p:ext uri="{BB962C8B-B14F-4D97-AF65-F5344CB8AC3E}">
-        <p14:creationId xmlns:p14="http://schemas.microsoft.com/office/powerpoint/2010/main" val="3283410672"/>
+        <p14:creationId xmlns:p14="http://schemas.microsoft.com/office/powerpoint/2010/main" val="4082731639"/>
       </p:ext>
     </p:extLst>
   </p:cSld>
@@ -4261,7 +4264,7 @@
           <p:cNvPr id="2" name="TextBox 1">
             <a:extLst>
               <a:ext uri="{FF2B5EF4-FFF2-40B4-BE49-F238E27FC236}">
-                <a16:creationId xmlns:a16="http://schemas.microsoft.com/office/drawing/2014/main" id="{C9CA9C38-CA7F-BF4B-B1AC-FDD1338DED32}"/>
+                <a16:creationId xmlns:a16="http://schemas.microsoft.com/office/drawing/2014/main" id="{2544EA81-3663-50D5-1808-C7AB12C71CE2}"/>
               </a:ext>
             </a:extLst>
           </p:cNvPr>
@@ -4285,14 +4288,20 @@
           <a:lstStyle/>
           <a:p>
             <a:r>
-              <a:rPr lang="ru-RU" sz="3000" b="1">
+              <a:rPr lang="en-US" sz="3000" b="1">
                 <a:solidFill>
                   <a:srgbClr val="14213D"/>
                 </a:solidFill>
                 <a:latin typeface="Cambria" panose="02040503050406030204" pitchFamily="18" charset="0"/>
               </a:rPr>
-              <a:t>Данные подсказывают ответ — и это ловушка</a:t>
-            </a:r>
+              <a:t>The data give the answer away, and that is a trap</a:t>
+            </a:r>
+            <a:endParaRPr lang="ru-RU" sz="3000" b="1">
+              <a:solidFill>
+                <a:srgbClr val="14213D"/>
+              </a:solidFill>
+              <a:latin typeface="Cambria" panose="02040503050406030204" pitchFamily="18" charset="0"/>
+            </a:endParaRPr>
           </a:p>
         </p:txBody>
       </p:sp>
@@ -4301,7 +4310,7 @@
           <p:cNvPr id="3" name="Прямоугольник: скругленные углы 2">
             <a:extLst>
               <a:ext uri="{FF2B5EF4-FFF2-40B4-BE49-F238E27FC236}">
-                <a16:creationId xmlns:a16="http://schemas.microsoft.com/office/drawing/2014/main" id="{E5FBC4CD-FB84-BDA1-C2D2-D23CB4A1C9FD}"/>
+                <a16:creationId xmlns:a16="http://schemas.microsoft.com/office/drawing/2014/main" id="{3641F7C6-7DE8-6AD6-9E21-C09302CD8CA3}"/>
               </a:ext>
             </a:extLst>
           </p:cNvPr>
@@ -4371,7 +4380,7 @@
           <p:cNvPr id="4" name="TextBox 3">
             <a:extLst>
               <a:ext uri="{FF2B5EF4-FFF2-40B4-BE49-F238E27FC236}">
-                <a16:creationId xmlns:a16="http://schemas.microsoft.com/office/drawing/2014/main" id="{9C56FD21-D291-1847-55CE-933C08B29ED8}"/>
+                <a16:creationId xmlns:a16="http://schemas.microsoft.com/office/drawing/2014/main" id="{52ED9C5A-2FA4-74E2-2001-14F6C990DAD5}"/>
               </a:ext>
             </a:extLst>
           </p:cNvPr>
@@ -4411,7 +4420,7 @@
           <p:cNvPr id="5" name="TextBox 4">
             <a:extLst>
               <a:ext uri="{FF2B5EF4-FFF2-40B4-BE49-F238E27FC236}">
-                <a16:creationId xmlns:a16="http://schemas.microsoft.com/office/drawing/2014/main" id="{E737C36A-5E37-1EBF-B5F5-87A55C7C07FF}"/>
+                <a16:creationId xmlns:a16="http://schemas.microsoft.com/office/drawing/2014/main" id="{B8CD19CD-20DA-5BB3-56BD-B18904BB6395}"/>
               </a:ext>
             </a:extLst>
           </p:cNvPr>
@@ -4435,25 +4444,31 @@
           <a:lstStyle/>
           <a:p>
             <a:r>
-              <a:rPr lang="ru-RU" sz="1300">
+              <a:rPr lang="en-US" sz="1300">
                 <a:solidFill>
                   <a:srgbClr val="52514E"/>
                 </a:solidFill>
                 <a:latin typeface="Calibri" panose="020F0502020204030204" pitchFamily="34" charset="0"/>
               </a:rPr>
-              <a:t>AUC правила «формат B → ПТСР»</a:t>
-            </a:r>
-          </a:p>
-          <a:p>
-            <a:r>
-              <a:rPr lang="ru-RU" sz="1300">
+              <a:t>AUC of the rule 'format B means PTSD'</a:t>
+            </a:r>
+          </a:p>
+          <a:p>
+            <a:r>
+              <a:rPr lang="en-US" sz="1300">
                 <a:solidFill>
                   <a:srgbClr val="52514E"/>
                 </a:solidFill>
                 <a:latin typeface="Calibri" panose="020F0502020204030204" pitchFamily="34" charset="0"/>
               </a:rPr>
-              <a:t>без анализа сигнала</a:t>
-            </a:r>
+              <a:t>without looking at the signal</a:t>
+            </a:r>
+            <a:endParaRPr lang="ru-RU" sz="1300">
+              <a:solidFill>
+                <a:srgbClr val="52514E"/>
+              </a:solidFill>
+              <a:latin typeface="Calibri" panose="020F0502020204030204" pitchFamily="34" charset="0"/>
+            </a:endParaRPr>
           </a:p>
         </p:txBody>
       </p:sp>
@@ -4462,7 +4477,7 @@
           <p:cNvPr id="6" name="TextBox 5">
             <a:extLst>
               <a:ext uri="{FF2B5EF4-FFF2-40B4-BE49-F238E27FC236}">
-                <a16:creationId xmlns:a16="http://schemas.microsoft.com/office/drawing/2014/main" id="{73B36BD9-8823-A0B9-AFA0-B601D342BF46}"/>
+                <a16:creationId xmlns:a16="http://schemas.microsoft.com/office/drawing/2014/main" id="{1EBADD7A-43EA-F1DA-33A5-5919A2F53AA7}"/>
               </a:ext>
             </a:extLst>
           </p:cNvPr>
@@ -4493,13 +4508,13 @@
               <a:buChar char="•"/>
             </a:pPr>
             <a:r>
-              <a:rPr lang="ru-RU" sz="1700">
+              <a:rPr lang="en-US" sz="1700">
                 <a:solidFill>
                   <a:srgbClr val="1B1B1B"/>
                 </a:solidFill>
                 <a:latin typeface="Calibri" panose="020F0502020204030204" pitchFamily="34" charset="0"/>
               </a:rPr>
-              <a:t>все 25 ПТСР выгружены в формате B</a:t>
+              <a:t>all 25 PTSD patients were exported in format B</a:t>
             </a:r>
           </a:p>
           <a:p>
@@ -4511,13 +4526,13 @@
               <a:buChar char="•"/>
             </a:pPr>
             <a:r>
-              <a:rPr lang="ru-RU" sz="1700">
+              <a:rPr lang="en-US" sz="1700">
                 <a:solidFill>
                   <a:srgbClr val="1B1B1B"/>
                 </a:solidFill>
                 <a:latin typeface="Calibri" panose="020F0502020204030204" pitchFamily="34" charset="0"/>
               </a:rPr>
-              <a:t>45 из 67 норм — формат C: нет межканальной связи и альфы</a:t>
+              <a:t>45 of 67 controls are format C, with no channel correlation and no alpha</a:t>
             </a:r>
           </a:p>
           <a:p>
@@ -4529,14 +4544,20 @@
               <a:buChar char="•"/>
             </a:pPr>
             <a:r>
-              <a:rPr lang="ru-RU" sz="1700">
+              <a:rPr lang="en-US" sz="1700">
                 <a:solidFill>
                   <a:srgbClr val="1B1B1B"/>
                 </a:solidFill>
                 <a:latin typeface="Calibri" panose="020F0502020204030204" pitchFamily="34" charset="0"/>
               </a:rPr>
-              <a:t>229 испытуемых → 221 группа: копии записей объединены</a:t>
-            </a:r>
+              <a:t>229 subjects form 221 groups once copied recordings are merged</a:t>
+            </a:r>
+            <a:endParaRPr lang="ru-RU" sz="1700">
+              <a:solidFill>
+                <a:srgbClr val="1B1B1B"/>
+              </a:solidFill>
+              <a:latin typeface="Calibri" panose="020F0502020204030204" pitchFamily="34" charset="0"/>
+            </a:endParaRPr>
           </a:p>
         </p:txBody>
       </p:sp>
@@ -4545,7 +4566,7 @@
           <p:cNvPr id="7" name="Прямоугольник: скругленные углы 6">
             <a:extLst>
               <a:ext uri="{FF2B5EF4-FFF2-40B4-BE49-F238E27FC236}">
-                <a16:creationId xmlns:a16="http://schemas.microsoft.com/office/drawing/2014/main" id="{21616DC1-1DB9-3FC6-5DC9-D01E702D77A0}"/>
+                <a16:creationId xmlns:a16="http://schemas.microsoft.com/office/drawing/2014/main" id="{EC0D8914-486C-F8E8-B769-76E1A1A5C649}"/>
               </a:ext>
             </a:extLst>
           </p:cNvPr>
@@ -4615,7 +4636,7 @@
           <p:cNvPr id="8" name="TextBox 7">
             <a:extLst>
               <a:ext uri="{FF2B5EF4-FFF2-40B4-BE49-F238E27FC236}">
-                <a16:creationId xmlns:a16="http://schemas.microsoft.com/office/drawing/2014/main" id="{1BCD8435-A50F-0A7C-547D-954DBA2AE5A1}"/>
+                <a16:creationId xmlns:a16="http://schemas.microsoft.com/office/drawing/2014/main" id="{57D362C5-2A0C-B831-26CA-FA3C2C33A9B9}"/>
               </a:ext>
             </a:extLst>
           </p:cNvPr>
@@ -4639,14 +4660,20 @@
           <a:lstStyle/>
           <a:p>
             <a:r>
-              <a:rPr lang="ru-RU" sz="2000" b="1">
+              <a:rPr lang="en-US" sz="2000" b="1">
                 <a:solidFill>
                   <a:srgbClr val="FFFFFF"/>
                 </a:solidFill>
                 <a:latin typeface="Cambria" panose="02040503050406030204" pitchFamily="18" charset="0"/>
               </a:rPr>
-              <a:t>Как мы это обходим</a:t>
-            </a:r>
+              <a:t>How we handle it</a:t>
+            </a:r>
+            <a:endParaRPr lang="ru-RU" sz="2000" b="1">
+              <a:solidFill>
+                <a:srgbClr val="FFFFFF"/>
+              </a:solidFill>
+              <a:latin typeface="Cambria" panose="02040503050406030204" pitchFamily="18" charset="0"/>
+            </a:endParaRPr>
           </a:p>
         </p:txBody>
       </p:sp>
@@ -4655,7 +4682,7 @@
           <p:cNvPr id="9" name="TextBox 8">
             <a:extLst>
               <a:ext uri="{FF2B5EF4-FFF2-40B4-BE49-F238E27FC236}">
-                <a16:creationId xmlns:a16="http://schemas.microsoft.com/office/drawing/2014/main" id="{05AB42EE-14E4-00EE-358D-2F1F6E2728B5}"/>
+                <a16:creationId xmlns:a16="http://schemas.microsoft.com/office/drawing/2014/main" id="{28C58A88-4CBB-8589-18D5-DDE3D33E0127}"/>
               </a:ext>
             </a:extLst>
           </p:cNvPr>
@@ -4686,13 +4713,13 @@
               <a:buChar char="•"/>
             </a:pPr>
             <a:r>
-              <a:rPr lang="ru-RU" sz="1700">
+              <a:rPr lang="en-US" sz="1700">
                 <a:solidFill>
                   <a:srgbClr val="FFFFFF"/>
                 </a:solidFill>
                 <a:latin typeface="Calibri" panose="020F0502020204030204" pitchFamily="34" charset="0"/>
               </a:rPr>
-              <a:t>23 признака покоя: доли ритмов, альфа-пик, наклон спектра; не зависят от усиления канала</a:t>
+              <a:t>23 resting features: band power, alpha peak, spectral slope; independent of channel gain</a:t>
             </a:r>
           </a:p>
           <a:p>
@@ -4704,13 +4731,13 @@
               <a:buChar char="•"/>
             </a:pPr>
             <a:r>
-              <a:rPr lang="ru-RU" sz="1700">
+              <a:rPr lang="en-US" sz="1700">
                 <a:solidFill>
                   <a:srgbClr val="FFFFFF"/>
                 </a:solidFill>
                 <a:latin typeface="Calibri" panose="020F0502020204030204" pitchFamily="34" charset="0"/>
               </a:rPr>
-              <a:t>логистическая регрессия L2 + калибровка Платта</a:t>
+              <a:t>L2 logistic regression with Platt calibration</a:t>
             </a:r>
           </a:p>
           <a:p>
@@ -4722,13 +4749,13 @@
               <a:buChar char="•"/>
             </a:pPr>
             <a:r>
-              <a:rPr lang="ru-RU" sz="1700">
+              <a:rPr lang="en-US" sz="1700">
                 <a:solidFill>
                   <a:srgbClr val="FFFFFF"/>
                 </a:solidFill>
                 <a:latin typeface="Calibri" panose="020F0502020204030204" pitchFamily="34" charset="0"/>
               </a:rPr>
-              <a:t>leave-one-group-out, весь выбор — только внутри фолда</a:t>
+              <a:t>leave-one-group-out, every choice made inside the fold</a:t>
             </a:r>
           </a:p>
           <a:p>
@@ -4740,13 +4767,13 @@
               <a:buChar char="•"/>
             </a:pPr>
             <a:r>
-              <a:rPr lang="ru-RU" sz="1700">
+              <a:rPr lang="en-US" sz="1700">
                 <a:solidFill>
                   <a:srgbClr val="FFFFFF"/>
                 </a:solidFill>
                 <a:latin typeface="Calibri" panose="020F0502020204030204" pitchFamily="34" charset="0"/>
               </a:rPr>
-              <a:t>критерий выбора повторяет формулу оценки ТЗ</a:t>
+              <a:t>selection criterion mirrors the official score</a:t>
             </a:r>
           </a:p>
           <a:p>
@@ -4758,21 +4785,27 @@
               <a:buChar char="•"/>
             </a:pPr>
             <a:r>
-              <a:rPr lang="ru-RU" sz="1700">
+              <a:rPr lang="en-US" sz="1700">
                 <a:solidFill>
                   <a:srgbClr val="FFFFFF"/>
                 </a:solidFill>
                 <a:latin typeface="Calibri" panose="020F0502020204030204" pitchFamily="34" charset="0"/>
               </a:rPr>
-              <a:t>8 протоколов зафиксированы до запуска, включая неудачные</a:t>
-            </a:r>
+              <a:t>8 protocols fixed in advance, failed ones included</a:t>
+            </a:r>
+            <a:endParaRPr lang="ru-RU" sz="1700">
+              <a:solidFill>
+                <a:srgbClr val="FFFFFF"/>
+              </a:solidFill>
+              <a:latin typeface="Calibri" panose="020F0502020204030204" pitchFamily="34" charset="0"/>
+            </a:endParaRPr>
           </a:p>
         </p:txBody>
       </p:sp>
     </p:spTree>
     <p:extLst>
       <p:ext uri="{BB962C8B-B14F-4D97-AF65-F5344CB8AC3E}">
-        <p14:creationId xmlns:p14="http://schemas.microsoft.com/office/powerpoint/2010/main" val="433683782"/>
+        <p14:creationId xmlns:p14="http://schemas.microsoft.com/office/powerpoint/2010/main" val="3651849301"/>
       </p:ext>
     </p:extLst>
   </p:cSld>
@@ -4812,7 +4845,7 @@
           <p:cNvPr id="2" name="TextBox 1">
             <a:extLst>
               <a:ext uri="{FF2B5EF4-FFF2-40B4-BE49-F238E27FC236}">
-                <a16:creationId xmlns:a16="http://schemas.microsoft.com/office/drawing/2014/main" id="{2CEFA4FB-CA41-D010-FE19-FF5AE992C2D5}"/>
+                <a16:creationId xmlns:a16="http://schemas.microsoft.com/office/drawing/2014/main" id="{066B60C2-712C-4553-B2EA-8AFDCC33D99A}"/>
               </a:ext>
             </a:extLst>
           </p:cNvPr>
@@ -4836,14 +4869,20 @@
           <a:lstStyle/>
           <a:p>
             <a:r>
-              <a:rPr lang="ru-RU" sz="3000" b="1">
+              <a:rPr lang="en-US" sz="3000" b="1">
                 <a:solidFill>
                   <a:srgbClr val="14213D"/>
                 </a:solidFill>
                 <a:latin typeface="Cambria" panose="02040503050406030204" pitchFamily="18" charset="0"/>
               </a:rPr>
-              <a:t>Результат вне выборки</a:t>
-            </a:r>
+              <a:t>Out-of-sample result</a:t>
+            </a:r>
+            <a:endParaRPr lang="ru-RU" sz="3000" b="1">
+              <a:solidFill>
+                <a:srgbClr val="14213D"/>
+              </a:solidFill>
+              <a:latin typeface="Cambria" panose="02040503050406030204" pitchFamily="18" charset="0"/>
+            </a:endParaRPr>
           </a:p>
         </p:txBody>
       </p:sp>
@@ -4852,7 +4891,7 @@
           <p:cNvPr id="4" name="Рисунок 3">
             <a:extLst>
               <a:ext uri="{FF2B5EF4-FFF2-40B4-BE49-F238E27FC236}">
-                <a16:creationId xmlns:a16="http://schemas.microsoft.com/office/drawing/2014/main" id="{1670F726-F5B8-F4FA-225E-33FD51697FA4}"/>
+                <a16:creationId xmlns:a16="http://schemas.microsoft.com/office/drawing/2014/main" id="{8CF36C91-B235-C916-7BAB-80D9A49594A0}"/>
               </a:ext>
             </a:extLst>
           </p:cNvPr>
@@ -4875,8 +4914,8 @@
         </p:blipFill>
         <p:spPr>
           <a:xfrm>
-            <a:off x="1538508" y="1066799"/>
-            <a:ext cx="9114985" cy="3810000"/>
+            <a:off x="1541661" y="1066800"/>
+            <a:ext cx="9108677" cy="3810000"/>
           </a:xfrm>
           <a:prstGeom prst="rect">
             <a:avLst/>
@@ -4888,7 +4927,7 @@
           <p:cNvPr id="5" name="TextBox 4">
             <a:extLst>
               <a:ext uri="{FF2B5EF4-FFF2-40B4-BE49-F238E27FC236}">
-                <a16:creationId xmlns:a16="http://schemas.microsoft.com/office/drawing/2014/main" id="{B1A18DC1-30E6-1E31-1D80-34C54B757821}"/>
+                <a16:creationId xmlns:a16="http://schemas.microsoft.com/office/drawing/2014/main" id="{09BFCF95-5C61-B55C-9027-0DAEC65A214F}"/>
               </a:ext>
             </a:extLst>
           </p:cNvPr>
@@ -4928,7 +4967,7 @@
           <p:cNvPr id="6" name="TextBox 5">
             <a:extLst>
               <a:ext uri="{FF2B5EF4-FFF2-40B4-BE49-F238E27FC236}">
-                <a16:creationId xmlns:a16="http://schemas.microsoft.com/office/drawing/2014/main" id="{E055F8AA-BCF2-C3D2-8A1F-198BFF7217B2}"/>
+                <a16:creationId xmlns:a16="http://schemas.microsoft.com/office/drawing/2014/main" id="{59CD9552-D73D-8067-0969-9EF691C7AE70}"/>
               </a:ext>
             </a:extLst>
           </p:cNvPr>
@@ -4952,25 +4991,31 @@
           <a:lstStyle/>
           <a:p>
             <a:r>
-              <a:rPr lang="ru-RU" sz="1300">
+              <a:rPr lang="fr-FR" sz="1300">
                 <a:solidFill>
                   <a:srgbClr val="52514E"/>
                 </a:solidFill>
                 <a:latin typeface="Calibri" panose="020F0502020204030204" pitchFamily="34" charset="0"/>
               </a:rPr>
-              <a:t>AUC ПТСР / нормы &lt; 65</a:t>
-            </a:r>
-          </a:p>
-          <a:p>
-            <a:r>
-              <a:rPr lang="ru-RU" sz="1300">
+              <a:t>AUC, PTSD vs controls &lt; 65</a:t>
+            </a:r>
+          </a:p>
+          <a:p>
+            <a:r>
+              <a:rPr lang="fr-FR" sz="1300">
                 <a:solidFill>
                   <a:srgbClr val="52514E"/>
                 </a:solidFill>
                 <a:latin typeface="Calibri" panose="020F0502020204030204" pitchFamily="34" charset="0"/>
               </a:rPr>
-              <a:t>95% ДИ 0.80–0.92</a:t>
-            </a:r>
+              <a:t>95% CI 0.80–0.92</a:t>
+            </a:r>
+            <a:endParaRPr lang="ru-RU" sz="1300">
+              <a:solidFill>
+                <a:srgbClr val="52514E"/>
+              </a:solidFill>
+              <a:latin typeface="Calibri" panose="020F0502020204030204" pitchFamily="34" charset="0"/>
+            </a:endParaRPr>
           </a:p>
         </p:txBody>
       </p:sp>
@@ -4979,7 +5024,7 @@
           <p:cNvPr id="7" name="TextBox 6">
             <a:extLst>
               <a:ext uri="{FF2B5EF4-FFF2-40B4-BE49-F238E27FC236}">
-                <a16:creationId xmlns:a16="http://schemas.microsoft.com/office/drawing/2014/main" id="{2E37982B-9A03-93E2-98C4-43F2F179598B}"/>
+                <a16:creationId xmlns:a16="http://schemas.microsoft.com/office/drawing/2014/main" id="{EA071909-141A-BAC7-D140-D046CB39F86D}"/>
               </a:ext>
             </a:extLst>
           </p:cNvPr>
@@ -5019,7 +5064,7 @@
           <p:cNvPr id="8" name="TextBox 7">
             <a:extLst>
               <a:ext uri="{FF2B5EF4-FFF2-40B4-BE49-F238E27FC236}">
-                <a16:creationId xmlns:a16="http://schemas.microsoft.com/office/drawing/2014/main" id="{51454363-9BD6-617A-B3BD-D6796668FC7D}"/>
+                <a16:creationId xmlns:a16="http://schemas.microsoft.com/office/drawing/2014/main" id="{0A2709CC-2E66-4647-D7E7-41C7063E227D}"/>
               </a:ext>
             </a:extLst>
           </p:cNvPr>
@@ -5043,25 +5088,31 @@
           <a:lstStyle/>
           <a:p>
             <a:r>
-              <a:rPr lang="ru-RU" sz="1300">
+              <a:rPr lang="en-US" sz="1300">
                 <a:solidFill>
                   <a:srgbClr val="52514E"/>
                 </a:solidFill>
                 <a:latin typeface="Calibri" panose="020F0502020204030204" pitchFamily="34" charset="0"/>
               </a:rPr>
-              <a:t>чувствительность</a:t>
-            </a:r>
-          </a:p>
-          <a:p>
-            <a:r>
-              <a:rPr lang="ru-RU" sz="1300">
+              <a:t>sensitivity</a:t>
+            </a:r>
+          </a:p>
+          <a:p>
+            <a:r>
+              <a:rPr lang="en-US" sz="1300">
                 <a:solidFill>
                   <a:srgbClr val="52514E"/>
                 </a:solidFill>
                 <a:latin typeface="Calibri" panose="020F0502020204030204" pitchFamily="34" charset="0"/>
               </a:rPr>
-              <a:t>при пороге 0.5</a:t>
-            </a:r>
+              <a:t>at threshold 0.5</a:t>
+            </a:r>
+            <a:endParaRPr lang="ru-RU" sz="1300">
+              <a:solidFill>
+                <a:srgbClr val="52514E"/>
+              </a:solidFill>
+              <a:latin typeface="Calibri" panose="020F0502020204030204" pitchFamily="34" charset="0"/>
+            </a:endParaRPr>
           </a:p>
         </p:txBody>
       </p:sp>
@@ -5070,7 +5121,7 @@
           <p:cNvPr id="9" name="TextBox 8">
             <a:extLst>
               <a:ext uri="{FF2B5EF4-FFF2-40B4-BE49-F238E27FC236}">
-                <a16:creationId xmlns:a16="http://schemas.microsoft.com/office/drawing/2014/main" id="{F4A415D3-78CF-4987-9806-3C8C70617746}"/>
+                <a16:creationId xmlns:a16="http://schemas.microsoft.com/office/drawing/2014/main" id="{3771AD11-33A9-6A4D-B09A-F0527EDDF50C}"/>
               </a:ext>
             </a:extLst>
           </p:cNvPr>
@@ -5110,7 +5161,7 @@
           <p:cNvPr id="10" name="TextBox 9">
             <a:extLst>
               <a:ext uri="{FF2B5EF4-FFF2-40B4-BE49-F238E27FC236}">
-                <a16:creationId xmlns:a16="http://schemas.microsoft.com/office/drawing/2014/main" id="{906ADC8B-ED77-A08C-835E-BBEA79D46929}"/>
+                <a16:creationId xmlns:a16="http://schemas.microsoft.com/office/drawing/2014/main" id="{B0E69D69-E320-BAFB-9D59-B789A80D667E}"/>
               </a:ext>
             </a:extLst>
           </p:cNvPr>
@@ -5134,25 +5185,31 @@
           <a:lstStyle/>
           <a:p>
             <a:r>
-              <a:rPr lang="ru-RU" sz="1300">
+              <a:rPr lang="en-US" sz="1300">
                 <a:solidFill>
                   <a:srgbClr val="52514E"/>
                 </a:solidFill>
                 <a:latin typeface="Calibri" panose="020F0502020204030204" pitchFamily="34" charset="0"/>
               </a:rPr>
-              <a:t>специфичность,</a:t>
-            </a:r>
-          </a:p>
-          <a:p>
-            <a:r>
-              <a:rPr lang="ru-RU" sz="1300">
+              <a:t>specificity,</a:t>
+            </a:r>
+          </a:p>
+          <a:p>
+            <a:r>
+              <a:rPr lang="en-US" sz="1300">
                 <a:solidFill>
                   <a:srgbClr val="52514E"/>
                 </a:solidFill>
                 <a:latin typeface="Calibri" panose="020F0502020204030204" pitchFamily="34" charset="0"/>
               </a:rPr>
-              <a:t>нормы 65+</a:t>
-            </a:r>
+              <a:t>controls 65+</a:t>
+            </a:r>
+            <a:endParaRPr lang="ru-RU" sz="1300">
+              <a:solidFill>
+                <a:srgbClr val="52514E"/>
+              </a:solidFill>
+              <a:latin typeface="Calibri" panose="020F0502020204030204" pitchFamily="34" charset="0"/>
+            </a:endParaRPr>
           </a:p>
         </p:txBody>
       </p:sp>
@@ -5161,7 +5218,7 @@
           <p:cNvPr id="11" name="TextBox 10">
             <a:extLst>
               <a:ext uri="{FF2B5EF4-FFF2-40B4-BE49-F238E27FC236}">
-                <a16:creationId xmlns:a16="http://schemas.microsoft.com/office/drawing/2014/main" id="{8D6D7A13-32EF-0F52-C85F-C9A429D192CE}"/>
+                <a16:creationId xmlns:a16="http://schemas.microsoft.com/office/drawing/2014/main" id="{6BBB29C0-6BB6-F0EE-D92B-A2C10A8DBD87}"/>
               </a:ext>
             </a:extLst>
           </p:cNvPr>
@@ -5201,7 +5258,7 @@
           <p:cNvPr id="12" name="TextBox 11">
             <a:extLst>
               <a:ext uri="{FF2B5EF4-FFF2-40B4-BE49-F238E27FC236}">
-                <a16:creationId xmlns:a16="http://schemas.microsoft.com/office/drawing/2014/main" id="{9487A170-5DBA-725F-245F-D43E7F58A798}"/>
+                <a16:creationId xmlns:a16="http://schemas.microsoft.com/office/drawing/2014/main" id="{D3A14DEB-39AC-FB15-2076-63E699CFEE78}"/>
               </a:ext>
             </a:extLst>
           </p:cNvPr>
@@ -5225,32 +5282,38 @@
           <a:lstStyle/>
           <a:p>
             <a:r>
-              <a:rPr lang="ru-RU" sz="1300">
+              <a:rPr lang="en-US" sz="1300">
                 <a:solidFill>
                   <a:srgbClr val="52514E"/>
                 </a:solidFill>
                 <a:latin typeface="Calibri" panose="020F0502020204030204" pitchFamily="34" charset="0"/>
               </a:rPr>
-              <a:t>специфичность,</a:t>
-            </a:r>
-          </a:p>
-          <a:p>
-            <a:r>
-              <a:rPr lang="ru-RU" sz="1300">
+              <a:t>specificity,</a:t>
+            </a:r>
+          </a:p>
+          <a:p>
+            <a:r>
+              <a:rPr lang="en-US" sz="1300">
                 <a:solidFill>
                   <a:srgbClr val="52514E"/>
                 </a:solidFill>
                 <a:latin typeface="Calibri" panose="020F0502020204030204" pitchFamily="34" charset="0"/>
               </a:rPr>
-              <a:t>соматоформные</a:t>
-            </a:r>
+              <a:t>somatoform</a:t>
+            </a:r>
+            <a:endParaRPr lang="ru-RU" sz="1300">
+              <a:solidFill>
+                <a:srgbClr val="52514E"/>
+              </a:solidFill>
+              <a:latin typeface="Calibri" panose="020F0502020204030204" pitchFamily="34" charset="0"/>
+            </a:endParaRPr>
           </a:p>
         </p:txBody>
       </p:sp>
     </p:spTree>
     <p:extLst>
       <p:ext uri="{BB962C8B-B14F-4D97-AF65-F5344CB8AC3E}">
-        <p14:creationId xmlns:p14="http://schemas.microsoft.com/office/powerpoint/2010/main" val="1786732044"/>
+        <p14:creationId xmlns:p14="http://schemas.microsoft.com/office/powerpoint/2010/main" val="1811474482"/>
       </p:ext>
     </p:extLst>
   </p:cSld>
@@ -5290,7 +5353,7 @@
           <p:cNvPr id="2" name="TextBox 1">
             <a:extLst>
               <a:ext uri="{FF2B5EF4-FFF2-40B4-BE49-F238E27FC236}">
-                <a16:creationId xmlns:a16="http://schemas.microsoft.com/office/drawing/2014/main" id="{E8214749-9BD9-F63B-5342-C2DF5CF5CE45}"/>
+                <a16:creationId xmlns:a16="http://schemas.microsoft.com/office/drawing/2014/main" id="{2BB5F6A0-5659-9F97-4583-95A5D9B3A37C}"/>
               </a:ext>
             </a:extLst>
           </p:cNvPr>
@@ -5314,14 +5377,20 @@
           <a:lstStyle/>
           <a:p>
             <a:r>
-              <a:rPr lang="ru-RU" sz="3000" b="1">
+              <a:rPr lang="en-US" sz="3000" b="1">
                 <a:solidFill>
                   <a:srgbClr val="14213D"/>
                 </a:solidFill>
                 <a:latin typeface="Cambria" panose="02040503050406030204" pitchFamily="18" charset="0"/>
               </a:rPr>
-              <a:t>Признаки: направление и механизм</a:t>
-            </a:r>
+              <a:t>Features: direction and mechanism</a:t>
+            </a:r>
+            <a:endParaRPr lang="ru-RU" sz="3000" b="1">
+              <a:solidFill>
+                <a:srgbClr val="14213D"/>
+              </a:solidFill>
+              <a:latin typeface="Cambria" panose="02040503050406030204" pitchFamily="18" charset="0"/>
+            </a:endParaRPr>
           </a:p>
         </p:txBody>
       </p:sp>
@@ -5330,7 +5399,7 @@
           <p:cNvPr id="3" name="Таблица 2">
             <a:extLst>
               <a:ext uri="{FF2B5EF4-FFF2-40B4-BE49-F238E27FC236}">
-                <a16:creationId xmlns:a16="http://schemas.microsoft.com/office/drawing/2014/main" id="{5A43779D-9F17-4D39-2C8F-501D52A1F8B9}"/>
+                <a16:creationId xmlns:a16="http://schemas.microsoft.com/office/drawing/2014/main" id="{5D9654A7-4F54-FF3E-96EF-BF345FD531BA}"/>
               </a:ext>
             </a:extLst>
           </p:cNvPr>
@@ -5340,7 +5409,7 @@
           <p:nvPr>
             <p:extLst>
               <p:ext uri="{D42A27DB-BD31-4B8C-83A1-F6EECF244321}">
-                <p14:modId xmlns:p14="http://schemas.microsoft.com/office/powerpoint/2010/main" val="3384609561"/>
+                <p14:modId xmlns:p14="http://schemas.microsoft.com/office/powerpoint/2010/main" val="4117526436"/>
               </p:ext>
             </p:extLst>
           </p:nvPr>
@@ -5359,28 +5428,28 @@
                 <a:gridCol w="1905000">
                   <a:extLst>
                     <a:ext uri="{9D8B030D-6E8A-4147-A177-3AD203B41FA5}">
-                      <a16:colId xmlns:a16="http://schemas.microsoft.com/office/drawing/2014/main" val="2501987652"/>
+                      <a16:colId xmlns:a16="http://schemas.microsoft.com/office/drawing/2014/main" val="3788988918"/>
                     </a:ext>
                   </a:extLst>
                 </a:gridCol>
                 <a:gridCol w="2413000">
                   <a:extLst>
                     <a:ext uri="{9D8B030D-6E8A-4147-A177-3AD203B41FA5}">
-                      <a16:colId xmlns:a16="http://schemas.microsoft.com/office/drawing/2014/main" val="186115017"/>
+                      <a16:colId xmlns:a16="http://schemas.microsoft.com/office/drawing/2014/main" val="884170301"/>
                     </a:ext>
                   </a:extLst>
                 </a:gridCol>
                 <a:gridCol w="2159000">
                   <a:extLst>
                     <a:ext uri="{9D8B030D-6E8A-4147-A177-3AD203B41FA5}">
-                      <a16:colId xmlns:a16="http://schemas.microsoft.com/office/drawing/2014/main" val="1900133207"/>
+                      <a16:colId xmlns:a16="http://schemas.microsoft.com/office/drawing/2014/main" val="4160991389"/>
                     </a:ext>
                   </a:extLst>
                 </a:gridCol>
                 <a:gridCol w="4699000">
                   <a:extLst>
                     <a:ext uri="{9D8B030D-6E8A-4147-A177-3AD203B41FA5}">
-                      <a16:colId xmlns:a16="http://schemas.microsoft.com/office/drawing/2014/main" val="1566290137"/>
+                      <a16:colId xmlns:a16="http://schemas.microsoft.com/office/drawing/2014/main" val="2515489945"/>
                     </a:ext>
                   </a:extLst>
                 </a:gridCol>
@@ -5392,14 +5461,20 @@
                     <a:lstStyle/>
                     <a:p>
                       <a:r>
-                        <a:rPr lang="ru-RU" sz="1300" b="1">
+                        <a:rPr lang="en-US" sz="1300" b="1">
                           <a:solidFill>
                             <a:srgbClr val="FFFFFF"/>
                           </a:solidFill>
                           <a:latin typeface="Calibri" panose="020F0502020204030204" pitchFamily="34" charset="0"/>
                         </a:rPr>
-                        <a:t>Признак</a:t>
+                        <a:t>Feature</a:t>
                       </a:r>
+                      <a:endParaRPr lang="ru-RU" sz="1300" b="1">
+                        <a:solidFill>
+                          <a:srgbClr val="FFFFFF"/>
+                        </a:solidFill>
+                        <a:latin typeface="Calibri" panose="020F0502020204030204" pitchFamily="34" charset="0"/>
+                      </a:endParaRPr>
                     </a:p>
                   </a:txBody>
                   <a:tcPr marL="101600" marR="76200" marT="50800" marB="50800">
@@ -5414,14 +5489,20 @@
                     <a:lstStyle/>
                     <a:p>
                       <a:r>
-                        <a:rPr lang="ru-RU" sz="1300" b="1">
+                        <a:rPr lang="en-US" sz="1300" b="1">
                           <a:solidFill>
                             <a:srgbClr val="FFFFFF"/>
                           </a:solidFill>
                           <a:latin typeface="Calibri" panose="020F0502020204030204" pitchFamily="34" charset="0"/>
                         </a:rPr>
-                        <a:t>Отведение · диапазон</a:t>
+                        <a:t>Lead · band</a:t>
                       </a:r>
+                      <a:endParaRPr lang="ru-RU" sz="1300" b="1">
+                        <a:solidFill>
+                          <a:srgbClr val="FFFFFF"/>
+                        </a:solidFill>
+                        <a:latin typeface="Calibri" panose="020F0502020204030204" pitchFamily="34" charset="0"/>
+                      </a:endParaRPr>
                     </a:p>
                   </a:txBody>
                   <a:tcPr marL="101600" marR="76200" marT="50800" marB="50800">
@@ -5436,14 +5517,20 @@
                     <a:lstStyle/>
                     <a:p>
                       <a:r>
-                        <a:rPr lang="ru-RU" sz="1300" b="1">
+                        <a:rPr lang="en-US" sz="1300" b="1">
                           <a:solidFill>
                             <a:srgbClr val="FFFFFF"/>
                           </a:solidFill>
                           <a:latin typeface="Calibri" panose="020F0502020204030204" pitchFamily="34" charset="0"/>
                         </a:rPr>
-                        <a:t>При ПТСР*</a:t>
+                        <a:t>In PTSD*</a:t>
                       </a:r>
+                      <a:endParaRPr lang="ru-RU" sz="1300" b="1">
+                        <a:solidFill>
+                          <a:srgbClr val="FFFFFF"/>
+                        </a:solidFill>
+                        <a:latin typeface="Calibri" panose="020F0502020204030204" pitchFamily="34" charset="0"/>
+                      </a:endParaRPr>
                     </a:p>
                   </a:txBody>
                   <a:tcPr marL="101600" marR="76200" marT="50800" marB="50800">
@@ -5458,14 +5545,20 @@
                     <a:lstStyle/>
                     <a:p>
                       <a:r>
-                        <a:rPr lang="ru-RU" sz="1300" b="1">
+                        <a:rPr lang="en-US" sz="1300" b="1">
                           <a:solidFill>
                             <a:srgbClr val="FFFFFF"/>
                           </a:solidFill>
                           <a:latin typeface="Calibri" panose="020F0502020204030204" pitchFamily="34" charset="0"/>
                         </a:rPr>
-                        <a:t>Механизм и ограничения</a:t>
+                        <a:t>Mechanism and caveats</a:t>
                       </a:r>
+                      <a:endParaRPr lang="ru-RU" sz="1300" b="1">
+                        <a:solidFill>
+                          <a:srgbClr val="FFFFFF"/>
+                        </a:solidFill>
+                        <a:latin typeface="Calibri" panose="020F0502020204030204" pitchFamily="34" charset="0"/>
+                      </a:endParaRPr>
                     </a:p>
                   </a:txBody>
                   <a:tcPr marL="101600" marR="76200" marT="50800" marB="50800">
@@ -5476,7 +5569,7 @@
                 </a:tc>
                 <a:extLst>
                   <a:ext uri="{0D108BD9-81ED-4DB2-BD59-A6C34878D82A}">
-                    <a16:rowId xmlns:a16="http://schemas.microsoft.com/office/drawing/2014/main" val="882221188"/>
+                    <a16:rowId xmlns:a16="http://schemas.microsoft.com/office/drawing/2014/main" val="2109619231"/>
                   </a:ext>
                 </a:extLst>
               </a:tr>
@@ -5487,14 +5580,20 @@
                     <a:lstStyle/>
                     <a:p>
                       <a:r>
-                        <a:rPr lang="ru-RU" sz="1300" b="1">
+                        <a:rPr lang="en-US" sz="1300" b="1">
                           <a:solidFill>
                             <a:srgbClr val="1B1B1B"/>
                           </a:solidFill>
                           <a:latin typeface="Calibri" panose="020F0502020204030204" pitchFamily="34" charset="0"/>
                         </a:rPr>
-                        <a:t>наклон спектра</a:t>
+                        <a:t>spectral slope</a:t>
                       </a:r>
+                      <a:endParaRPr lang="ru-RU" sz="1300" b="1">
+                        <a:solidFill>
+                          <a:srgbClr val="1B1B1B"/>
+                        </a:solidFill>
+                        <a:latin typeface="Calibri" panose="020F0502020204030204" pitchFamily="34" charset="0"/>
+                      </a:endParaRPr>
                     </a:p>
                   </a:txBody>
                   <a:tcPr marL="101600" marR="76200" marT="50800" marB="50800">
@@ -5515,17 +5614,14 @@
                           </a:solidFill>
                           <a:latin typeface="Calibri" panose="020F0502020204030204" pitchFamily="34" charset="0"/>
                         </a:rPr>
-                        <a:t>T3, T4 · 3–30 </a:t>
+                        <a:t>T3, T4 · 3–30 Hz</a:t>
                       </a:r>
-                      <a:r>
-                        <a:rPr lang="ru-RU" sz="1300" b="0">
-                          <a:solidFill>
-                            <a:srgbClr val="1B1B1B"/>
-                          </a:solidFill>
-                          <a:latin typeface="Calibri" panose="020F0502020204030204" pitchFamily="34" charset="0"/>
-                        </a:rPr>
-                        <a:t>Гц</a:t>
-                      </a:r>
+                      <a:endParaRPr lang="ru-RU" sz="1300" b="0">
+                        <a:solidFill>
+                          <a:srgbClr val="1B1B1B"/>
+                        </a:solidFill>
+                        <a:latin typeface="Calibri" panose="020F0502020204030204" pitchFamily="34" charset="0"/>
+                      </a:endParaRPr>
                     </a:p>
                   </a:txBody>
                   <a:tcPr marL="101600" marR="76200" marT="50800" marB="50800">
@@ -5540,14 +5636,20 @@
                     <a:lstStyle/>
                     <a:p>
                       <a:r>
-                        <a:rPr lang="ru-RU" sz="1300" b="0">
+                        <a:rPr lang="en-US" sz="1300" b="0">
                           <a:solidFill>
                             <a:srgbClr val="1B1B1B"/>
                           </a:solidFill>
                           <a:latin typeface="Calibri" panose="020F0502020204030204" pitchFamily="34" charset="0"/>
                         </a:rPr>
-                        <a:t>↓ площе (0.90 / 0.96)</a:t>
+                        <a:t>↓ flatter (0.90 / 0.96)</a:t>
                       </a:r>
+                      <a:endParaRPr lang="ru-RU" sz="1300" b="0">
+                        <a:solidFill>
+                          <a:srgbClr val="1B1B1B"/>
+                        </a:solidFill>
+                        <a:latin typeface="Calibri" panose="020F0502020204030204" pitchFamily="34" charset="0"/>
+                      </a:endParaRPr>
                     </a:p>
                   </a:txBody>
                   <a:tcPr marL="101600" marR="76200" marT="50800" marB="50800">
@@ -5562,14 +5664,20 @@
                     <a:lstStyle/>
                     <a:p>
                       <a:r>
-                        <a:rPr lang="ru-RU" sz="1300" b="0">
+                        <a:rPr lang="en-US" sz="1300" b="0">
                           <a:solidFill>
                             <a:srgbClr val="1B1B1B"/>
                           </a:solidFill>
                           <a:latin typeface="Calibri" panose="020F0502020204030204" pitchFamily="34" charset="0"/>
                         </a:rPr>
-                        <a:t>уплощение при ПТСР (Kovacevic, 2025); на T3 зависит от партии</a:t>
+                        <a:t>flatter in PTSD (Kovacevic, 2025); batch-dependent at T3</a:t>
                       </a:r>
+                      <a:endParaRPr lang="ru-RU" sz="1300" b="0">
+                        <a:solidFill>
+                          <a:srgbClr val="1B1B1B"/>
+                        </a:solidFill>
+                        <a:latin typeface="Calibri" panose="020F0502020204030204" pitchFamily="34" charset="0"/>
+                      </a:endParaRPr>
                     </a:p>
                   </a:txBody>
                   <a:tcPr marL="101600" marR="76200" marT="50800" marB="50800">
@@ -5580,7 +5688,7 @@
                 </a:tc>
                 <a:extLst>
                   <a:ext uri="{0D108BD9-81ED-4DB2-BD59-A6C34878D82A}">
-                    <a16:rowId xmlns:a16="http://schemas.microsoft.com/office/drawing/2014/main" val="2018622101"/>
+                    <a16:rowId xmlns:a16="http://schemas.microsoft.com/office/drawing/2014/main" val="4023070725"/>
                   </a:ext>
                 </a:extLst>
               </a:tr>
@@ -5591,14 +5699,20 @@
                     <a:lstStyle/>
                     <a:p>
                       <a:r>
-                        <a:rPr lang="ru-RU" sz="1300" b="1">
+                        <a:rPr lang="en-US" sz="1300" b="1">
                           <a:solidFill>
                             <a:srgbClr val="1B1B1B"/>
                           </a:solidFill>
                           <a:latin typeface="Calibri" panose="020F0502020204030204" pitchFamily="34" charset="0"/>
                         </a:rPr>
-                        <a:t>доля беты</a:t>
+                        <a:t>beta share</a:t>
                       </a:r>
+                      <a:endParaRPr lang="ru-RU" sz="1300" b="1">
+                        <a:solidFill>
+                          <a:srgbClr val="1B1B1B"/>
+                        </a:solidFill>
+                        <a:latin typeface="Calibri" panose="020F0502020204030204" pitchFamily="34" charset="0"/>
+                      </a:endParaRPr>
                     </a:p>
                   </a:txBody>
                   <a:tcPr marL="101600" marR="76200" marT="50800" marB="50800">
@@ -5619,17 +5733,14 @@
                           </a:solidFill>
                           <a:latin typeface="Calibri" panose="020F0502020204030204" pitchFamily="34" charset="0"/>
                         </a:rPr>
-                        <a:t>T3, T4 · 13–30 </a:t>
+                        <a:t>T3, T4 · 13–30 Hz</a:t>
                       </a:r>
-                      <a:r>
-                        <a:rPr lang="ru-RU" sz="1300" b="0">
-                          <a:solidFill>
-                            <a:srgbClr val="1B1B1B"/>
-                          </a:solidFill>
-                          <a:latin typeface="Calibri" panose="020F0502020204030204" pitchFamily="34" charset="0"/>
-                        </a:rPr>
-                        <a:t>Гц</a:t>
-                      </a:r>
+                      <a:endParaRPr lang="ru-RU" sz="1300" b="0">
+                        <a:solidFill>
+                          <a:srgbClr val="1B1B1B"/>
+                        </a:solidFill>
+                        <a:latin typeface="Calibri" panose="020F0502020204030204" pitchFamily="34" charset="0"/>
+                      </a:endParaRPr>
                     </a:p>
                   </a:txBody>
                   <a:tcPr marL="101600" marR="76200" marT="50800" marB="50800">
@@ -5672,14 +5783,20 @@
                     <a:lstStyle/>
                     <a:p>
                       <a:r>
-                        <a:rPr lang="ru-RU" sz="1300" b="0">
+                        <a:rPr lang="en-US" sz="1300" b="0">
                           <a:solidFill>
                             <a:srgbClr val="1B1B1B"/>
                           </a:solidFill>
                           <a:latin typeface="Calibri" panose="020F0502020204030204" pitchFamily="34" charset="0"/>
                         </a:rPr>
-                        <a:t>T4 — общий с соматоформными; возможен след бензодиазепинов</a:t>
+                        <a:t>T4 shared with somatoform; possible benzodiazepine effect</a:t>
                       </a:r>
+                      <a:endParaRPr lang="ru-RU" sz="1300" b="0">
+                        <a:solidFill>
+                          <a:srgbClr val="1B1B1B"/>
+                        </a:solidFill>
+                        <a:latin typeface="Calibri" panose="020F0502020204030204" pitchFamily="34" charset="0"/>
+                      </a:endParaRPr>
                     </a:p>
                   </a:txBody>
                   <a:tcPr marL="101600" marR="76200" marT="50800" marB="50800">
@@ -5690,7 +5807,7 @@
                 </a:tc>
                 <a:extLst>
                   <a:ext uri="{0D108BD9-81ED-4DB2-BD59-A6C34878D82A}">
-                    <a16:rowId xmlns:a16="http://schemas.microsoft.com/office/drawing/2014/main" val="2557270699"/>
+                    <a16:rowId xmlns:a16="http://schemas.microsoft.com/office/drawing/2014/main" val="3978763277"/>
                   </a:ext>
                 </a:extLst>
               </a:tr>
@@ -5701,14 +5818,20 @@
                     <a:lstStyle/>
                     <a:p>
                       <a:r>
-                        <a:rPr lang="ru-RU" sz="1300" b="1">
+                        <a:rPr lang="en-US" sz="1300" b="1">
                           <a:solidFill>
                             <a:srgbClr val="1B1B1B"/>
                           </a:solidFill>
                           <a:latin typeface="Calibri" panose="020F0502020204030204" pitchFamily="34" charset="0"/>
                         </a:rPr>
-                        <a:t>доля альфы</a:t>
+                        <a:t>alpha share</a:t>
                       </a:r>
+                      <a:endParaRPr lang="ru-RU" sz="1300" b="1">
+                        <a:solidFill>
+                          <a:srgbClr val="1B1B1B"/>
+                        </a:solidFill>
+                        <a:latin typeface="Calibri" panose="020F0502020204030204" pitchFamily="34" charset="0"/>
+                      </a:endParaRPr>
                     </a:p>
                   </a:txBody>
                   <a:tcPr marL="101600" marR="76200" marT="50800" marB="50800">
@@ -5729,17 +5852,14 @@
                           </a:solidFill>
                           <a:latin typeface="Calibri" panose="020F0502020204030204" pitchFamily="34" charset="0"/>
                         </a:rPr>
-                        <a:t>O1 · 8–13 </a:t>
+                        <a:t>O1 · 8–13 Hz</a:t>
                       </a:r>
-                      <a:r>
-                        <a:rPr lang="ru-RU" sz="1300" b="0">
-                          <a:solidFill>
-                            <a:srgbClr val="1B1B1B"/>
-                          </a:solidFill>
-                          <a:latin typeface="Calibri" panose="020F0502020204030204" pitchFamily="34" charset="0"/>
-                        </a:rPr>
-                        <a:t>Гц</a:t>
-                      </a:r>
+                      <a:endParaRPr lang="ru-RU" sz="1300" b="0">
+                        <a:solidFill>
+                          <a:srgbClr val="1B1B1B"/>
+                        </a:solidFill>
+                        <a:latin typeface="Calibri" panose="020F0502020204030204" pitchFamily="34" charset="0"/>
+                      </a:endParaRPr>
                     </a:p>
                   </a:txBody>
                   <a:tcPr marL="101600" marR="76200" marT="50800" marB="50800">
@@ -5776,14 +5896,20 @@
                     <a:lstStyle/>
                     <a:p>
                       <a:r>
-                        <a:rPr lang="ru-RU" sz="1300" b="0">
+                        <a:rPr lang="en-US" sz="1300" b="0">
                           <a:solidFill>
                             <a:srgbClr val="1B1B1B"/>
                           </a:solidFill>
                           <a:latin typeface="Calibri" panose="020F0502020204030204" pitchFamily="34" charset="0"/>
                         </a:rPr>
-                        <a:t>отделяет пожилых с возрастным ослаблением альфы</a:t>
+                        <a:t>separates older adults with age-related alpha decline</a:t>
                       </a:r>
+                      <a:endParaRPr lang="ru-RU" sz="1300" b="0">
+                        <a:solidFill>
+                          <a:srgbClr val="1B1B1B"/>
+                        </a:solidFill>
+                        <a:latin typeface="Calibri" panose="020F0502020204030204" pitchFamily="34" charset="0"/>
+                      </a:endParaRPr>
                     </a:p>
                   </a:txBody>
                   <a:tcPr marL="101600" marR="76200" marT="50800" marB="50800">
@@ -5794,7 +5920,7 @@
                 </a:tc>
                 <a:extLst>
                   <a:ext uri="{0D108BD9-81ED-4DB2-BD59-A6C34878D82A}">
-                    <a16:rowId xmlns:a16="http://schemas.microsoft.com/office/drawing/2014/main" val="3491466977"/>
+                    <a16:rowId xmlns:a16="http://schemas.microsoft.com/office/drawing/2014/main" val="2275253342"/>
                   </a:ext>
                 </a:extLst>
               </a:tr>
@@ -5805,14 +5931,20 @@
                     <a:lstStyle/>
                     <a:p>
                       <a:r>
-                        <a:rPr lang="ru-RU" sz="1300" b="1">
+                        <a:rPr lang="en-US" sz="1300" b="1">
                           <a:solidFill>
                             <a:srgbClr val="1B1B1B"/>
                           </a:solidFill>
                           <a:latin typeface="Calibri" panose="020F0502020204030204" pitchFamily="34" charset="0"/>
                         </a:rPr>
-                        <a:t>доля теты</a:t>
+                        <a:t>theta share</a:t>
                       </a:r>
+                      <a:endParaRPr lang="ru-RU" sz="1300" b="1">
+                        <a:solidFill>
+                          <a:srgbClr val="1B1B1B"/>
+                        </a:solidFill>
+                        <a:latin typeface="Calibri" panose="020F0502020204030204" pitchFamily="34" charset="0"/>
+                      </a:endParaRPr>
                     </a:p>
                   </a:txBody>
                   <a:tcPr marL="101600" marR="76200" marT="50800" marB="50800">
@@ -5833,17 +5965,14 @@
                           </a:solidFill>
                           <a:latin typeface="Calibri" panose="020F0502020204030204" pitchFamily="34" charset="0"/>
                         </a:rPr>
-                        <a:t>Fp1, T3, T4, O1 · 4–8 </a:t>
+                        <a:t>Fp1, T3, T4, O1 · 4–8 Hz</a:t>
                       </a:r>
-                      <a:r>
-                        <a:rPr lang="ru-RU" sz="1300" b="0">
-                          <a:solidFill>
-                            <a:srgbClr val="1B1B1B"/>
-                          </a:solidFill>
-                          <a:latin typeface="Calibri" panose="020F0502020204030204" pitchFamily="34" charset="0"/>
-                        </a:rPr>
-                        <a:t>Гц</a:t>
-                      </a:r>
+                      <a:endParaRPr lang="ru-RU" sz="1300" b="0">
+                        <a:solidFill>
+                          <a:srgbClr val="1B1B1B"/>
+                        </a:solidFill>
+                        <a:latin typeface="Calibri" panose="020F0502020204030204" pitchFamily="34" charset="0"/>
+                      </a:endParaRPr>
                     </a:p>
                   </a:txBody>
                   <a:tcPr marL="101600" marR="76200" marT="50800" marB="50800">
@@ -5858,14 +5987,20 @@
                     <a:lstStyle/>
                     <a:p>
                       <a:r>
-                        <a:rPr lang="ru-RU" sz="1300" b="0">
+                        <a:rPr lang="en-US" sz="1300" b="0">
                           <a:solidFill>
                             <a:srgbClr val="1B1B1B"/>
                           </a:solidFill>
                           <a:latin typeface="Calibri" panose="020F0502020204030204" pitchFamily="34" charset="0"/>
                         </a:rPr>
-                        <a:t>↑ слегка (−0.40 / −0.47)</a:t>
+                        <a:t>↑ slightly (−0.40 / −0.47)</a:t>
                       </a:r>
+                      <a:endParaRPr lang="ru-RU" sz="1300" b="0">
+                        <a:solidFill>
+                          <a:srgbClr val="1B1B1B"/>
+                        </a:solidFill>
+                        <a:latin typeface="Calibri" panose="020F0502020204030204" pitchFamily="34" charset="0"/>
+                      </a:endParaRPr>
                     </a:p>
                   </a:txBody>
                   <a:tcPr marL="101600" marR="76200" marT="50800" marB="50800">
@@ -5880,14 +6015,20 @@
                     <a:lstStyle/>
                     <a:p>
                       <a:r>
-                        <a:rPr lang="ru-RU" sz="1300" b="0">
+                        <a:rPr lang="en-US" sz="1300" b="0">
                           <a:solidFill>
                             <a:srgbClr val="1B1B1B"/>
                           </a:solidFill>
                           <a:latin typeface="Calibri" panose="020F0502020204030204" pitchFamily="34" charset="0"/>
                         </a:rPr>
-                        <a:t>сниженное бодрствование, нарушения сна</a:t>
+                        <a:t>reduced vigilance, poor sleep</a:t>
                       </a:r>
+                      <a:endParaRPr lang="ru-RU" sz="1300" b="0">
+                        <a:solidFill>
+                          <a:srgbClr val="1B1B1B"/>
+                        </a:solidFill>
+                        <a:latin typeface="Calibri" panose="020F0502020204030204" pitchFamily="34" charset="0"/>
+                      </a:endParaRPr>
                     </a:p>
                   </a:txBody>
                   <a:tcPr marL="101600" marR="76200" marT="50800" marB="50800">
@@ -5898,7 +6039,7 @@
                 </a:tc>
                 <a:extLst>
                   <a:ext uri="{0D108BD9-81ED-4DB2-BD59-A6C34878D82A}">
-                    <a16:rowId xmlns:a16="http://schemas.microsoft.com/office/drawing/2014/main" val="1892447920"/>
+                    <a16:rowId xmlns:a16="http://schemas.microsoft.com/office/drawing/2014/main" val="1893392240"/>
                   </a:ext>
                 </a:extLst>
               </a:tr>
@@ -5909,14 +6050,20 @@
                     <a:lstStyle/>
                     <a:p>
                       <a:r>
-                        <a:rPr lang="ru-RU" sz="1300" b="1">
+                        <a:rPr lang="en-US" sz="1300" b="1">
                           <a:solidFill>
                             <a:srgbClr val="1B1B1B"/>
                           </a:solidFill>
                           <a:latin typeface="Calibri" panose="020F0502020204030204" pitchFamily="34" charset="0"/>
                         </a:rPr>
-                        <a:t>наклон спектра</a:t>
+                        <a:t>spectral slope</a:t>
                       </a:r>
+                      <a:endParaRPr lang="ru-RU" sz="1300" b="1">
+                        <a:solidFill>
+                          <a:srgbClr val="1B1B1B"/>
+                        </a:solidFill>
+                        <a:latin typeface="Calibri" panose="020F0502020204030204" pitchFamily="34" charset="0"/>
+                      </a:endParaRPr>
                     </a:p>
                   </a:txBody>
                   <a:tcPr marL="101600" marR="76200" marT="50800" marB="50800">
@@ -5937,17 +6084,14 @@
                           </a:solidFill>
                           <a:latin typeface="Calibri" panose="020F0502020204030204" pitchFamily="34" charset="0"/>
                         </a:rPr>
-                        <a:t>O1 · 3–30 </a:t>
+                        <a:t>O1 · 3–30 Hz</a:t>
                       </a:r>
-                      <a:r>
-                        <a:rPr lang="ru-RU" sz="1300" b="0">
-                          <a:solidFill>
-                            <a:srgbClr val="1B1B1B"/>
-                          </a:solidFill>
-                          <a:latin typeface="Calibri" panose="020F0502020204030204" pitchFamily="34" charset="0"/>
-                        </a:rPr>
-                        <a:t>Гц</a:t>
-                      </a:r>
+                      <a:endParaRPr lang="ru-RU" sz="1300" b="0">
+                        <a:solidFill>
+                          <a:srgbClr val="1B1B1B"/>
+                        </a:solidFill>
+                        <a:latin typeface="Calibri" panose="020F0502020204030204" pitchFamily="34" charset="0"/>
+                      </a:endParaRPr>
                     </a:p>
                   </a:txBody>
                   <a:tcPr marL="101600" marR="76200" marT="50800" marB="50800">
@@ -5962,14 +6106,20 @@
                     <a:lstStyle/>
                     <a:p>
                       <a:r>
-                        <a:rPr lang="ru-RU" sz="1300" b="0">
+                        <a:rPr lang="en-US" sz="1300" b="0">
                           <a:solidFill>
                             <a:srgbClr val="1B1B1B"/>
                           </a:solidFill>
                           <a:latin typeface="Calibri" panose="020F0502020204030204" pitchFamily="34" charset="0"/>
                         </a:rPr>
-                        <a:t>↓ площе (0.72 / 0.78)</a:t>
+                        <a:t>↓ flatter (0.72 / 0.78)</a:t>
                       </a:r>
+                      <a:endParaRPr lang="ru-RU" sz="1300" b="0">
+                        <a:solidFill>
+                          <a:srgbClr val="1B1B1B"/>
+                        </a:solidFill>
+                        <a:latin typeface="Calibri" panose="020F0502020204030204" pitchFamily="34" charset="0"/>
+                      </a:endParaRPr>
                     </a:p>
                   </a:txBody>
                   <a:tcPr marL="101600" marR="76200" marT="50800" marB="50800">
@@ -5984,14 +6134,20 @@
                     <a:lstStyle/>
                     <a:p>
                       <a:r>
-                        <a:rPr lang="ru-RU" sz="1300" b="0">
+                        <a:rPr lang="en-US" sz="1300" b="0">
                           <a:solidFill>
                             <a:srgbClr val="1B1B1B"/>
                           </a:solidFill>
                           <a:latin typeface="Calibri" panose="020F0502020204030204" pitchFamily="34" charset="0"/>
                         </a:rPr>
-                        <a:t>баланс возбуждения и торможения; так же при старении</a:t>
+                        <a:t>excitation and inhibition balance; same with ageing</a:t>
                       </a:r>
+                      <a:endParaRPr lang="ru-RU" sz="1300" b="0">
+                        <a:solidFill>
+                          <a:srgbClr val="1B1B1B"/>
+                        </a:solidFill>
+                        <a:latin typeface="Calibri" panose="020F0502020204030204" pitchFamily="34" charset="0"/>
+                      </a:endParaRPr>
                     </a:p>
                   </a:txBody>
                   <a:tcPr marL="101600" marR="76200" marT="50800" marB="50800">
@@ -6002,7 +6158,7 @@
                 </a:tc>
                 <a:extLst>
                   <a:ext uri="{0D108BD9-81ED-4DB2-BD59-A6C34878D82A}">
-                    <a16:rowId xmlns:a16="http://schemas.microsoft.com/office/drawing/2014/main" val="1964802657"/>
+                    <a16:rowId xmlns:a16="http://schemas.microsoft.com/office/drawing/2014/main" val="2855328299"/>
                   </a:ext>
                 </a:extLst>
               </a:tr>
@@ -6013,14 +6169,20 @@
                     <a:lstStyle/>
                     <a:p>
                       <a:r>
-                        <a:rPr lang="ru-RU" sz="1300" b="1">
+                        <a:rPr lang="en-US" sz="1300" b="1">
                           <a:solidFill>
                             <a:srgbClr val="1B1B1B"/>
                           </a:solidFill>
                           <a:latin typeface="Calibri" panose="020F0502020204030204" pitchFamily="34" charset="0"/>
                         </a:rPr>
-                        <a:t>частота альфа-пика</a:t>
+                        <a:t>alpha peak frequency</a:t>
                       </a:r>
+                      <a:endParaRPr lang="ru-RU" sz="1300" b="1">
+                        <a:solidFill>
+                          <a:srgbClr val="1B1B1B"/>
+                        </a:solidFill>
+                        <a:latin typeface="Calibri" panose="020F0502020204030204" pitchFamily="34" charset="0"/>
+                      </a:endParaRPr>
                     </a:p>
                   </a:txBody>
                   <a:tcPr marL="101600" marR="76200" marT="50800" marB="50800">
@@ -6041,17 +6203,14 @@
                           </a:solidFill>
                           <a:latin typeface="Calibri" panose="020F0502020204030204" pitchFamily="34" charset="0"/>
                         </a:rPr>
-                        <a:t>O1 · 8–13 </a:t>
+                        <a:t>O1 · 8–13 Hz</a:t>
                       </a:r>
-                      <a:r>
-                        <a:rPr lang="ru-RU" sz="1300" b="0">
-                          <a:solidFill>
-                            <a:srgbClr val="1B1B1B"/>
-                          </a:solidFill>
-                          <a:latin typeface="Calibri" panose="020F0502020204030204" pitchFamily="34" charset="0"/>
-                        </a:rPr>
-                        <a:t>Гц</a:t>
-                      </a:r>
+                      <a:endParaRPr lang="ru-RU" sz="1300" b="0">
+                        <a:solidFill>
+                          <a:srgbClr val="1B1B1B"/>
+                        </a:solidFill>
+                        <a:latin typeface="Calibri" panose="020F0502020204030204" pitchFamily="34" charset="0"/>
+                      </a:endParaRPr>
                     </a:p>
                   </a:txBody>
                   <a:tcPr marL="101600" marR="76200" marT="50800" marB="50800">
@@ -6066,14 +6225,20 @@
                     <a:lstStyle/>
                     <a:p>
                       <a:r>
-                        <a:rPr lang="ru-RU" sz="1300" b="0">
+                        <a:rPr lang="en-US" sz="1300" b="0">
                           <a:solidFill>
                             <a:srgbClr val="1B1B1B"/>
                           </a:solidFill>
                           <a:latin typeface="Calibri" panose="020F0502020204030204" pitchFamily="34" charset="0"/>
                         </a:rPr>
-                        <a:t>≈ (9.95 / 9.69 Гц)</a:t>
+                        <a:t>≈ (9.95 / 9.69 Hz)</a:t>
                       </a:r>
+                      <a:endParaRPr lang="ru-RU" sz="1300" b="0">
+                        <a:solidFill>
+                          <a:srgbClr val="1B1B1B"/>
+                        </a:solidFill>
+                        <a:latin typeface="Calibri" panose="020F0502020204030204" pitchFamily="34" charset="0"/>
+                      </a:endParaRPr>
                     </a:p>
                   </a:txBody>
                   <a:tcPr marL="101600" marR="76200" marT="50800" marB="50800">
@@ -6088,14 +6253,20 @@
                     <a:lstStyle/>
                     <a:p>
                       <a:r>
-                        <a:rPr lang="ru-RU" sz="1300" b="0">
+                        <a:rPr lang="en-US" sz="1300" b="0">
                           <a:solidFill>
                             <a:srgbClr val="1B1B1B"/>
                           </a:solidFill>
                           <a:latin typeface="Calibri" panose="020F0502020204030204" pitchFamily="34" charset="0"/>
                         </a:rPr>
-                        <a:t>замедляется со старением</a:t>
+                        <a:t>slows with age</a:t>
                       </a:r>
+                      <a:endParaRPr lang="ru-RU" sz="1300" b="0">
+                        <a:solidFill>
+                          <a:srgbClr val="1B1B1B"/>
+                        </a:solidFill>
+                        <a:latin typeface="Calibri" panose="020F0502020204030204" pitchFamily="34" charset="0"/>
+                      </a:endParaRPr>
                     </a:p>
                   </a:txBody>
                   <a:tcPr marL="101600" marR="76200" marT="50800" marB="50800">
@@ -6106,7 +6277,7 @@
                 </a:tc>
                 <a:extLst>
                   <a:ext uri="{0D108BD9-81ED-4DB2-BD59-A6C34878D82A}">
-                    <a16:rowId xmlns:a16="http://schemas.microsoft.com/office/drawing/2014/main" val="3440770850"/>
+                    <a16:rowId xmlns:a16="http://schemas.microsoft.com/office/drawing/2014/main" val="411822307"/>
                   </a:ext>
                 </a:extLst>
               </a:tr>
@@ -6117,14 +6288,20 @@
                     <a:lstStyle/>
                     <a:p>
                       <a:r>
-                        <a:rPr lang="ru-RU" sz="1300" b="1">
+                        <a:rPr lang="en-US" sz="1300" b="1">
                           <a:solidFill>
                             <a:srgbClr val="1B1B1B"/>
                           </a:solidFill>
                           <a:latin typeface="Calibri" panose="020F0502020204030204" pitchFamily="34" charset="0"/>
                         </a:rPr>
-                        <a:t>лобная асимметрия</a:t>
+                        <a:t>frontal asymmetry</a:t>
                       </a:r>
+                      <a:endParaRPr lang="ru-RU" sz="1300" b="1">
+                        <a:solidFill>
+                          <a:srgbClr val="1B1B1B"/>
+                        </a:solidFill>
+                        <a:latin typeface="Calibri" panose="020F0502020204030204" pitchFamily="34" charset="0"/>
+                      </a:endParaRPr>
                     </a:p>
                   </a:txBody>
                   <a:tcPr marL="101600" marR="76200" marT="50800" marB="50800">
@@ -6145,17 +6322,14 @@
                           </a:solidFill>
                           <a:latin typeface="Calibri" panose="020F0502020204030204" pitchFamily="34" charset="0"/>
                         </a:rPr>
-                        <a:t>Fp2 − Fp1 · 8–13 </a:t>
+                        <a:t>Fp2 − Fp1 · 8–13 Hz</a:t>
                       </a:r>
-                      <a:r>
-                        <a:rPr lang="ru-RU" sz="1300" b="0">
-                          <a:solidFill>
-                            <a:srgbClr val="1B1B1B"/>
-                          </a:solidFill>
-                          <a:latin typeface="Calibri" panose="020F0502020204030204" pitchFamily="34" charset="0"/>
-                        </a:rPr>
-                        <a:t>Гц</a:t>
-                      </a:r>
+                      <a:endParaRPr lang="ru-RU" sz="1300" b="0">
+                        <a:solidFill>
+                          <a:srgbClr val="1B1B1B"/>
+                        </a:solidFill>
+                        <a:latin typeface="Calibri" panose="020F0502020204030204" pitchFamily="34" charset="0"/>
+                      </a:endParaRPr>
                     </a:p>
                   </a:txBody>
                   <a:tcPr marL="101600" marR="76200" marT="50800" marB="50800">
@@ -6192,14 +6366,20 @@
                     <a:lstStyle/>
                     <a:p>
                       <a:r>
-                        <a:rPr lang="ru-RU" sz="1300" b="0">
+                        <a:rPr lang="en-US" sz="1300" b="0">
                           <a:solidFill>
                             <a:srgbClr val="1B1B1B"/>
                           </a:solidFill>
                           <a:latin typeface="Calibri" panose="020F0502020204030204" pitchFamily="34" charset="0"/>
                         </a:rPr>
-                        <a:t>модель Davidson; классически F3/F4, прироста не дала</a:t>
+                        <a:t>Davidson model; classically F3/F4, no added value</a:t>
                       </a:r>
+                      <a:endParaRPr lang="ru-RU" sz="1300" b="0">
+                        <a:solidFill>
+                          <a:srgbClr val="1B1B1B"/>
+                        </a:solidFill>
+                        <a:latin typeface="Calibri" panose="020F0502020204030204" pitchFamily="34" charset="0"/>
+                      </a:endParaRPr>
                     </a:p>
                   </a:txBody>
                   <a:tcPr marL="101600" marR="76200" marT="50800" marB="50800">
@@ -6210,7 +6390,7 @@
                 </a:tc>
                 <a:extLst>
                   <a:ext uri="{0D108BD9-81ED-4DB2-BD59-A6C34878D82A}">
-                    <a16:rowId xmlns:a16="http://schemas.microsoft.com/office/drawing/2014/main" val="280919922"/>
+                    <a16:rowId xmlns:a16="http://schemas.microsoft.com/office/drawing/2014/main" val="3663882212"/>
                   </a:ext>
                 </a:extLst>
               </a:tr>
@@ -6223,7 +6403,7 @@
           <p:cNvPr id="4" name="TextBox 3">
             <a:extLst>
               <a:ext uri="{FF2B5EF4-FFF2-40B4-BE49-F238E27FC236}">
-                <a16:creationId xmlns:a16="http://schemas.microsoft.com/office/drawing/2014/main" id="{ABB587E9-DC8C-AEAB-F8AC-17AF8BE49776}"/>
+                <a16:creationId xmlns:a16="http://schemas.microsoft.com/office/drawing/2014/main" id="{B2362CA1-B0FA-D537-4974-F2E58F0E10CA}"/>
               </a:ext>
             </a:extLst>
           </p:cNvPr>
@@ -6247,21 +6427,27 @@
           <a:lstStyle/>
           <a:p>
             <a:r>
-              <a:rPr lang="ru-RU" sz="1200">
+              <a:rPr lang="en-US" sz="1200">
                 <a:solidFill>
                   <a:srgbClr val="52514E"/>
                 </a:solidFill>
                 <a:latin typeface="Calibri" panose="020F0502020204030204" pitchFamily="34" charset="0"/>
               </a:rPr>
-              <a:t>* медиана ПТСР / нормы A; ↑/↓ — относительно молодых норм; строки упорядочены по весу в модели. Надёжно (95% ДИ) сдвинуты только наклон и бета на T4 — и оба так же у соматоформных.</a:t>
-            </a:r>
+              <a:t>* median in PTSD / control A; arrows relative to young controls; rows ordered by model weight. Only the slope and beta at T4 shift reliably, and both shift the same way in somatoform patients.</a:t>
+            </a:r>
+            <a:endParaRPr lang="ru-RU" sz="1200">
+              <a:solidFill>
+                <a:srgbClr val="52514E"/>
+              </a:solidFill>
+              <a:latin typeface="Calibri" panose="020F0502020204030204" pitchFamily="34" charset="0"/>
+            </a:endParaRPr>
           </a:p>
         </p:txBody>
       </p:sp>
     </p:spTree>
     <p:extLst>
       <p:ext uri="{BB962C8B-B14F-4D97-AF65-F5344CB8AC3E}">
-        <p14:creationId xmlns:p14="http://schemas.microsoft.com/office/powerpoint/2010/main" val="1795419479"/>
+        <p14:creationId xmlns:p14="http://schemas.microsoft.com/office/powerpoint/2010/main" val="3533609345"/>
       </p:ext>
     </p:extLst>
   </p:cSld>
@@ -6301,7 +6487,7 @@
           <p:cNvPr id="2" name="TextBox 1">
             <a:extLst>
               <a:ext uri="{FF2B5EF4-FFF2-40B4-BE49-F238E27FC236}">
-                <a16:creationId xmlns:a16="http://schemas.microsoft.com/office/drawing/2014/main" id="{9DBBB15B-3AF1-3F0C-5EA2-039CD9FE28C1}"/>
+                <a16:creationId xmlns:a16="http://schemas.microsoft.com/office/drawing/2014/main" id="{60470980-1284-69BB-1C97-9AE60A741942}"/>
               </a:ext>
             </a:extLst>
           </p:cNvPr>
@@ -6325,14 +6511,20 @@
           <a:lstStyle/>
           <a:p>
             <a:r>
-              <a:rPr lang="ru-RU" sz="3000" b="1">
+              <a:rPr lang="en-US" sz="3000" b="1">
                 <a:solidFill>
                   <a:srgbClr val="14213D"/>
                 </a:solidFill>
                 <a:latin typeface="Cambria" panose="02040503050406030204" pitchFamily="18" charset="0"/>
               </a:rPr>
-              <a:t>Что результат не объясняет</a:t>
-            </a:r>
+              <a:t>What does not explain the result</a:t>
+            </a:r>
+            <a:endParaRPr lang="ru-RU" sz="3000" b="1">
+              <a:solidFill>
+                <a:srgbClr val="14213D"/>
+              </a:solidFill>
+              <a:latin typeface="Cambria" panose="02040503050406030204" pitchFamily="18" charset="0"/>
+            </a:endParaRPr>
           </a:p>
         </p:txBody>
       </p:sp>
@@ -6341,7 +6533,7 @@
           <p:cNvPr id="4" name="Рисунок 3">
             <a:extLst>
               <a:ext uri="{FF2B5EF4-FFF2-40B4-BE49-F238E27FC236}">
-                <a16:creationId xmlns:a16="http://schemas.microsoft.com/office/drawing/2014/main" id="{5165BCA0-DD7F-E663-0CBE-8FAC1B299835}"/>
+                <a16:creationId xmlns:a16="http://schemas.microsoft.com/office/drawing/2014/main" id="{EA16777B-C7F2-F95E-C86E-BC5844B8A89B}"/>
               </a:ext>
             </a:extLst>
           </p:cNvPr>
@@ -6364,8 +6556,8 @@
         </p:blipFill>
         <p:spPr>
           <a:xfrm>
-            <a:off x="1041699" y="1066799"/>
-            <a:ext cx="10108602" cy="3175000"/>
+            <a:off x="1392395" y="1066800"/>
+            <a:ext cx="9407210" cy="3175000"/>
           </a:xfrm>
           <a:prstGeom prst="rect">
             <a:avLst/>
@@ -6377,7 +6569,7 @@
           <p:cNvPr id="5" name="Прямоугольник: скругленные углы 4">
             <a:extLst>
               <a:ext uri="{FF2B5EF4-FFF2-40B4-BE49-F238E27FC236}">
-                <a16:creationId xmlns:a16="http://schemas.microsoft.com/office/drawing/2014/main" id="{EBEFDE31-5773-ABC2-68A3-69F57F078747}"/>
+                <a16:creationId xmlns:a16="http://schemas.microsoft.com/office/drawing/2014/main" id="{C974FB18-4E44-6DFD-990A-9D74E9AA267C}"/>
               </a:ext>
             </a:extLst>
           </p:cNvPr>
@@ -6447,7 +6639,7 @@
           <p:cNvPr id="6" name="Овал 5">
             <a:extLst>
               <a:ext uri="{FF2B5EF4-FFF2-40B4-BE49-F238E27FC236}">
-                <a16:creationId xmlns:a16="http://schemas.microsoft.com/office/drawing/2014/main" id="{7FC95D7C-5F40-6B93-0FFD-875323338AAC}"/>
+                <a16:creationId xmlns:a16="http://schemas.microsoft.com/office/drawing/2014/main" id="{54A10F02-9710-FA03-4A53-A4AE6036ADF9}"/>
               </a:ext>
             </a:extLst>
           </p:cNvPr>
@@ -6523,7 +6715,7 @@
           <p:cNvPr id="7" name="TextBox 6">
             <a:extLst>
               <a:ext uri="{FF2B5EF4-FFF2-40B4-BE49-F238E27FC236}">
-                <a16:creationId xmlns:a16="http://schemas.microsoft.com/office/drawing/2014/main" id="{96030FA2-730C-414F-2FB5-532A6DA71F8C}"/>
+                <a16:creationId xmlns:a16="http://schemas.microsoft.com/office/drawing/2014/main" id="{6226B393-70ED-6DC9-0F95-54BEF6B892D4}"/>
               </a:ext>
             </a:extLst>
           </p:cNvPr>
@@ -6547,14 +6739,20 @@
           <a:lstStyle/>
           <a:p>
             <a:r>
-              <a:rPr lang="ru-RU" sz="1500" b="1">
+              <a:rPr lang="en-US" sz="1500" b="1">
                 <a:solidFill>
                   <a:srgbClr val="14213D"/>
                 </a:solidFill>
                 <a:latin typeface="Calibri" panose="020F0502020204030204" pitchFamily="34" charset="0"/>
               </a:rPr>
-              <a:t>Формат</a:t>
-            </a:r>
+              <a:t>Format</a:t>
+            </a:r>
+            <a:endParaRPr lang="ru-RU" sz="1500" b="1">
+              <a:solidFill>
+                <a:srgbClr val="14213D"/>
+              </a:solidFill>
+              <a:latin typeface="Calibri" panose="020F0502020204030204" pitchFamily="34" charset="0"/>
+            </a:endParaRPr>
           </a:p>
         </p:txBody>
       </p:sp>
@@ -6563,7 +6761,7 @@
           <p:cNvPr id="8" name="TextBox 7">
             <a:extLst>
               <a:ext uri="{FF2B5EF4-FFF2-40B4-BE49-F238E27FC236}">
-                <a16:creationId xmlns:a16="http://schemas.microsoft.com/office/drawing/2014/main" id="{ED8F458E-172C-3703-EE36-8C3B7205341A}"/>
+                <a16:creationId xmlns:a16="http://schemas.microsoft.com/office/drawing/2014/main" id="{4776454F-6709-A6F5-D06A-3B10CFC84A25}"/>
               </a:ext>
             </a:extLst>
           </p:cNvPr>
@@ -6587,14 +6785,20 @@
           <a:lstStyle/>
           <a:p>
             <a:r>
-              <a:rPr lang="ru-RU" sz="1200">
+              <a:rPr lang="en-US" sz="1200">
                 <a:solidFill>
                   <a:srgbClr val="52514E"/>
                 </a:solidFill>
                 <a:latin typeface="Calibri" panose="020F0502020204030204" pitchFamily="34" charset="0"/>
               </a:rPr>
-              <a:t>внутри формата B AUC 0.84; перестановки p = 0.016</a:t>
-            </a:r>
+              <a:t>within format B AUC 0.84; permutation p = 0.016</a:t>
+            </a:r>
+            <a:endParaRPr lang="ru-RU" sz="1200">
+              <a:solidFill>
+                <a:srgbClr val="52514E"/>
+              </a:solidFill>
+              <a:latin typeface="Calibri" panose="020F0502020204030204" pitchFamily="34" charset="0"/>
+            </a:endParaRPr>
           </a:p>
         </p:txBody>
       </p:sp>
@@ -6603,7 +6807,7 @@
           <p:cNvPr id="9" name="Прямоугольник: скругленные углы 8">
             <a:extLst>
               <a:ext uri="{FF2B5EF4-FFF2-40B4-BE49-F238E27FC236}">
-                <a16:creationId xmlns:a16="http://schemas.microsoft.com/office/drawing/2014/main" id="{B24E187C-F3AB-9A8C-66D7-1FE2E1F3834C}"/>
+                <a16:creationId xmlns:a16="http://schemas.microsoft.com/office/drawing/2014/main" id="{15DA5E9F-2151-08BF-0B4C-7806EB072B16}"/>
               </a:ext>
             </a:extLst>
           </p:cNvPr>
@@ -6673,7 +6877,7 @@
           <p:cNvPr id="10" name="Овал 9">
             <a:extLst>
               <a:ext uri="{FF2B5EF4-FFF2-40B4-BE49-F238E27FC236}">
-                <a16:creationId xmlns:a16="http://schemas.microsoft.com/office/drawing/2014/main" id="{AC2AB9F8-88D4-77B7-39B0-2FF5D5CA6A1A}"/>
+                <a16:creationId xmlns:a16="http://schemas.microsoft.com/office/drawing/2014/main" id="{415A95D0-52B1-E01E-22C3-C91A494C9738}"/>
               </a:ext>
             </a:extLst>
           </p:cNvPr>
@@ -6749,7 +6953,7 @@
           <p:cNvPr id="11" name="TextBox 10">
             <a:extLst>
               <a:ext uri="{FF2B5EF4-FFF2-40B4-BE49-F238E27FC236}">
-                <a16:creationId xmlns:a16="http://schemas.microsoft.com/office/drawing/2014/main" id="{7C1A4C46-8E90-2305-A8CB-DD66451C1684}"/>
+                <a16:creationId xmlns:a16="http://schemas.microsoft.com/office/drawing/2014/main" id="{71C327DB-1FE1-370A-113B-67C704F0B51A}"/>
               </a:ext>
             </a:extLst>
           </p:cNvPr>
@@ -6773,14 +6977,20 @@
           <a:lstStyle/>
           <a:p>
             <a:r>
-              <a:rPr lang="ru-RU" sz="1500" b="1">
+              <a:rPr lang="en-US" sz="1500" b="1">
                 <a:solidFill>
                   <a:srgbClr val="14213D"/>
                 </a:solidFill>
                 <a:latin typeface="Calibri" panose="020F0502020204030204" pitchFamily="34" charset="0"/>
               </a:rPr>
-              <a:t>Возраст</a:t>
-            </a:r>
+              <a:t>Age</a:t>
+            </a:r>
+            <a:endParaRPr lang="ru-RU" sz="1500" b="1">
+              <a:solidFill>
+                <a:srgbClr val="14213D"/>
+              </a:solidFill>
+              <a:latin typeface="Calibri" panose="020F0502020204030204" pitchFamily="34" charset="0"/>
+            </a:endParaRPr>
           </a:p>
         </p:txBody>
       </p:sp>
@@ -6789,7 +6999,7 @@
           <p:cNvPr id="12" name="TextBox 11">
             <a:extLst>
               <a:ext uri="{FF2B5EF4-FFF2-40B4-BE49-F238E27FC236}">
-                <a16:creationId xmlns:a16="http://schemas.microsoft.com/office/drawing/2014/main" id="{8A1A0997-BA85-2E07-8FC5-7F92A01EDD4F}"/>
+                <a16:creationId xmlns:a16="http://schemas.microsoft.com/office/drawing/2014/main" id="{2B3661B7-205C-4780-A0E6-B86DE27613C7}"/>
               </a:ext>
             </a:extLst>
           </p:cNvPr>
@@ -6813,14 +7023,20 @@
           <a:lstStyle/>
           <a:p>
             <a:r>
-              <a:rPr lang="ru-RU" sz="1200">
+              <a:rPr lang="en-US" sz="1200">
                 <a:solidFill>
                   <a:srgbClr val="52514E"/>
                 </a:solidFill>
                 <a:latin typeface="Calibri" panose="020F0502020204030204" pitchFamily="34" charset="0"/>
               </a:rPr>
-              <a:t>внутри партии R² ≈ 0, P не связана с возрастом</a:t>
-            </a:r>
+              <a:t>within a batch R² ≈ 0; P does not follow age</a:t>
+            </a:r>
+            <a:endParaRPr lang="ru-RU" sz="1200">
+              <a:solidFill>
+                <a:srgbClr val="52514E"/>
+              </a:solidFill>
+              <a:latin typeface="Calibri" panose="020F0502020204030204" pitchFamily="34" charset="0"/>
+            </a:endParaRPr>
           </a:p>
         </p:txBody>
       </p:sp>
@@ -6829,7 +7045,7 @@
           <p:cNvPr id="13" name="Прямоугольник: скругленные углы 12">
             <a:extLst>
               <a:ext uri="{FF2B5EF4-FFF2-40B4-BE49-F238E27FC236}">
-                <a16:creationId xmlns:a16="http://schemas.microsoft.com/office/drawing/2014/main" id="{67A7A23C-451A-AE4D-B70A-17BF7A3474AB}"/>
+                <a16:creationId xmlns:a16="http://schemas.microsoft.com/office/drawing/2014/main" id="{9D3CFCB8-C857-766C-2D24-D5557BB053BB}"/>
               </a:ext>
             </a:extLst>
           </p:cNvPr>
@@ -6899,7 +7115,7 @@
           <p:cNvPr id="14" name="Овал 13">
             <a:extLst>
               <a:ext uri="{FF2B5EF4-FFF2-40B4-BE49-F238E27FC236}">
-                <a16:creationId xmlns:a16="http://schemas.microsoft.com/office/drawing/2014/main" id="{5A331A63-28C8-BF34-D456-4555317F42D4}"/>
+                <a16:creationId xmlns:a16="http://schemas.microsoft.com/office/drawing/2014/main" id="{0627CFB4-9BB2-E47C-F4A1-B38092EF2217}"/>
               </a:ext>
             </a:extLst>
           </p:cNvPr>
@@ -6975,7 +7191,7 @@
           <p:cNvPr id="15" name="TextBox 14">
             <a:extLst>
               <a:ext uri="{FF2B5EF4-FFF2-40B4-BE49-F238E27FC236}">
-                <a16:creationId xmlns:a16="http://schemas.microsoft.com/office/drawing/2014/main" id="{8221CD6B-738F-5C90-F19A-23AE884ED89B}"/>
+                <a16:creationId xmlns:a16="http://schemas.microsoft.com/office/drawing/2014/main" id="{167E59BD-1E42-5099-9EB4-C1EEC9A5C734}"/>
               </a:ext>
             </a:extLst>
           </p:cNvPr>
@@ -6999,14 +7215,20 @@
           <a:lstStyle/>
           <a:p>
             <a:r>
-              <a:rPr lang="ru-RU" sz="1500" b="1">
+              <a:rPr lang="en-US" sz="1500" b="1">
                 <a:solidFill>
                   <a:srgbClr val="14213D"/>
                 </a:solidFill>
                 <a:latin typeface="Calibri" panose="020F0502020204030204" pitchFamily="34" charset="0"/>
               </a:rPr>
-              <a:t>Поведение</a:t>
-            </a:r>
+              <a:t>Behaviour</a:t>
+            </a:r>
+            <a:endParaRPr lang="ru-RU" sz="1500" b="1">
+              <a:solidFill>
+                <a:srgbClr val="14213D"/>
+              </a:solidFill>
+              <a:latin typeface="Calibri" panose="020F0502020204030204" pitchFamily="34" charset="0"/>
+            </a:endParaRPr>
           </a:p>
         </p:txBody>
       </p:sp>
@@ -7015,7 +7237,7 @@
           <p:cNvPr id="16" name="TextBox 15">
             <a:extLst>
               <a:ext uri="{FF2B5EF4-FFF2-40B4-BE49-F238E27FC236}">
-                <a16:creationId xmlns:a16="http://schemas.microsoft.com/office/drawing/2014/main" id="{94016D46-69FB-FF84-EE56-F529C1672F2F}"/>
+                <a16:creationId xmlns:a16="http://schemas.microsoft.com/office/drawing/2014/main" id="{F071D838-9F1F-0DE9-C8B3-BFBDF1275C00}"/>
               </a:ext>
             </a:extLst>
           </p:cNvPr>
@@ -7039,14 +7261,20 @@
           <a:lstStyle/>
           <a:p>
             <a:r>
-              <a:rPr lang="ru-RU" sz="1200">
+              <a:rPr lang="en-US" sz="1200">
                 <a:solidFill>
                   <a:srgbClr val="52514E"/>
                 </a:solidFill>
                 <a:latin typeface="Calibri" panose="020F0502020204030204" pitchFamily="34" charset="0"/>
               </a:rPr>
-              <a:t>P не растёт со временем решения; с таблицами Шульте AUC 0.75</a:t>
-            </a:r>
+              <a:t>P does not follow solve time; with Schulte tables AUC 0.75</a:t>
+            </a:r>
+            <a:endParaRPr lang="ru-RU" sz="1200">
+              <a:solidFill>
+                <a:srgbClr val="52514E"/>
+              </a:solidFill>
+              <a:latin typeface="Calibri" panose="020F0502020204030204" pitchFamily="34" charset="0"/>
+            </a:endParaRPr>
           </a:p>
         </p:txBody>
       </p:sp>
@@ -7055,7 +7283,7 @@
           <p:cNvPr id="17" name="Прямоугольник: скругленные углы 16">
             <a:extLst>
               <a:ext uri="{FF2B5EF4-FFF2-40B4-BE49-F238E27FC236}">
-                <a16:creationId xmlns:a16="http://schemas.microsoft.com/office/drawing/2014/main" id="{D00884FE-D997-F087-5B65-AD1A97CC8F6A}"/>
+                <a16:creationId xmlns:a16="http://schemas.microsoft.com/office/drawing/2014/main" id="{B30DC747-14F5-8275-6166-8E1025E66624}"/>
               </a:ext>
             </a:extLst>
           </p:cNvPr>
@@ -7125,7 +7353,7 @@
           <p:cNvPr id="18" name="Овал 17">
             <a:extLst>
               <a:ext uri="{FF2B5EF4-FFF2-40B4-BE49-F238E27FC236}">
-                <a16:creationId xmlns:a16="http://schemas.microsoft.com/office/drawing/2014/main" id="{84060F40-C973-E1C3-61B4-EB078A719538}"/>
+                <a16:creationId xmlns:a16="http://schemas.microsoft.com/office/drawing/2014/main" id="{4D2A9E52-B022-7DAC-75C7-FF96F71E6658}"/>
               </a:ext>
             </a:extLst>
           </p:cNvPr>
@@ -7207,7 +7435,7 @@
           <p:cNvPr id="19" name="TextBox 18">
             <a:extLst>
               <a:ext uri="{FF2B5EF4-FFF2-40B4-BE49-F238E27FC236}">
-                <a16:creationId xmlns:a16="http://schemas.microsoft.com/office/drawing/2014/main" id="{0F27C201-BC3F-8C8D-D1AF-10978A8623BD}"/>
+                <a16:creationId xmlns:a16="http://schemas.microsoft.com/office/drawing/2014/main" id="{A252BAD9-5F73-1A2A-368E-1A30BB80D218}"/>
               </a:ext>
             </a:extLst>
           </p:cNvPr>
@@ -7231,14 +7459,20 @@
           <a:lstStyle/>
           <a:p>
             <a:r>
-              <a:rPr lang="ru-RU" sz="1500" b="1">
+              <a:rPr lang="en-US" sz="1500" b="1">
                 <a:solidFill>
                   <a:srgbClr val="14213D"/>
                 </a:solidFill>
                 <a:latin typeface="Calibri" panose="020F0502020204030204" pitchFamily="34" charset="0"/>
               </a:rPr>
-              <a:t>Новая партия</a:t>
-            </a:r>
+              <a:t>Unseen batch</a:t>
+            </a:r>
+            <a:endParaRPr lang="ru-RU" sz="1500" b="1">
+              <a:solidFill>
+                <a:srgbClr val="14213D"/>
+              </a:solidFill>
+              <a:latin typeface="Calibri" panose="020F0502020204030204" pitchFamily="34" charset="0"/>
+            </a:endParaRPr>
           </a:p>
         </p:txBody>
       </p:sp>
@@ -7247,7 +7481,7 @@
           <p:cNvPr id="20" name="TextBox 19">
             <a:extLst>
               <a:ext uri="{FF2B5EF4-FFF2-40B4-BE49-F238E27FC236}">
-                <a16:creationId xmlns:a16="http://schemas.microsoft.com/office/drawing/2014/main" id="{6042CBE2-816E-04F5-6344-9E6887FC0D23}"/>
+                <a16:creationId xmlns:a16="http://schemas.microsoft.com/office/drawing/2014/main" id="{188F3F77-335E-16D6-AA0E-E7B7E367D5EA}"/>
               </a:ext>
             </a:extLst>
           </p:cNvPr>
@@ -7271,14 +7505,20 @@
           <a:lstStyle/>
           <a:p>
             <a:r>
-              <a:rPr lang="ru-RU" sz="1200">
+              <a:rPr lang="en-US" sz="1200">
                 <a:solidFill>
                   <a:srgbClr val="52514E"/>
                 </a:solidFill>
                 <a:latin typeface="Calibri" panose="020F0502020204030204" pitchFamily="34" charset="0"/>
               </a:rPr>
-              <a:t>группа вне обучения: AUC ниже примерно на 0.1</a:t>
-            </a:r>
+              <a:t>group left out of training: AUC about 0.1 lower</a:t>
+            </a:r>
+            <a:endParaRPr lang="ru-RU" sz="1200">
+              <a:solidFill>
+                <a:srgbClr val="52514E"/>
+              </a:solidFill>
+              <a:latin typeface="Calibri" panose="020F0502020204030204" pitchFamily="34" charset="0"/>
+            </a:endParaRPr>
           </a:p>
         </p:txBody>
       </p:sp>
@@ -7287,7 +7527,7 @@
           <p:cNvPr id="21" name="Прямоугольник: скругленные углы 20">
             <a:extLst>
               <a:ext uri="{FF2B5EF4-FFF2-40B4-BE49-F238E27FC236}">
-                <a16:creationId xmlns:a16="http://schemas.microsoft.com/office/drawing/2014/main" id="{26A133D3-9F5E-62AF-2011-DE9CB1C54A45}"/>
+                <a16:creationId xmlns:a16="http://schemas.microsoft.com/office/drawing/2014/main" id="{206B561B-5971-927C-7341-7EBD7D78EC8B}"/>
               </a:ext>
             </a:extLst>
           </p:cNvPr>
@@ -7357,7 +7597,7 @@
           <p:cNvPr id="22" name="Овал 21">
             <a:extLst>
               <a:ext uri="{FF2B5EF4-FFF2-40B4-BE49-F238E27FC236}">
-                <a16:creationId xmlns:a16="http://schemas.microsoft.com/office/drawing/2014/main" id="{308B4F03-D29A-861B-14D8-1C3ACD369D83}"/>
+                <a16:creationId xmlns:a16="http://schemas.microsoft.com/office/drawing/2014/main" id="{4718E7C1-E939-A789-3C69-ACAEFA9A7976}"/>
               </a:ext>
             </a:extLst>
           </p:cNvPr>
@@ -7433,7 +7673,7 @@
           <p:cNvPr id="23" name="TextBox 22">
             <a:extLst>
               <a:ext uri="{FF2B5EF4-FFF2-40B4-BE49-F238E27FC236}">
-                <a16:creationId xmlns:a16="http://schemas.microsoft.com/office/drawing/2014/main" id="{01395DAE-464B-28D7-C224-A158B2612F34}"/>
+                <a16:creationId xmlns:a16="http://schemas.microsoft.com/office/drawing/2014/main" id="{3597097B-9339-6E84-BF18-EAC889033E40}"/>
               </a:ext>
             </a:extLst>
           </p:cNvPr>
@@ -7457,14 +7697,20 @@
           <a:lstStyle/>
           <a:p>
             <a:r>
-              <a:rPr lang="ru-RU" sz="1500" b="1">
+              <a:rPr lang="en-US" sz="1500" b="1">
                 <a:solidFill>
                   <a:srgbClr val="14213D"/>
                 </a:solidFill>
                 <a:latin typeface="Calibri" panose="020F0502020204030204" pitchFamily="34" charset="0"/>
               </a:rPr>
-              <a:t>Ограничение</a:t>
-            </a:r>
+              <a:t>Limitation</a:t>
+            </a:r>
+            <a:endParaRPr lang="ru-RU" sz="1500" b="1">
+              <a:solidFill>
+                <a:srgbClr val="14213D"/>
+              </a:solidFill>
+              <a:latin typeface="Calibri" panose="020F0502020204030204" pitchFamily="34" charset="0"/>
+            </a:endParaRPr>
           </a:p>
         </p:txBody>
       </p:sp>
@@ -7473,7 +7719,7 @@
           <p:cNvPr id="24" name="TextBox 23">
             <a:extLst>
               <a:ext uri="{FF2B5EF4-FFF2-40B4-BE49-F238E27FC236}">
-                <a16:creationId xmlns:a16="http://schemas.microsoft.com/office/drawing/2014/main" id="{2ABD4F30-F25C-952D-3440-23729672E307}"/>
+                <a16:creationId xmlns:a16="http://schemas.microsoft.com/office/drawing/2014/main" id="{D5805ED3-ABDE-92D8-9013-A1416146D049}"/>
               </a:ext>
             </a:extLst>
           </p:cNvPr>
@@ -7497,21 +7743,27 @@
           <a:lstStyle/>
           <a:p>
             <a:r>
-              <a:rPr lang="ru-RU" sz="1200">
+              <a:rPr lang="en-US" sz="1200">
                 <a:solidFill>
                   <a:srgbClr val="52514E"/>
                 </a:solidFill>
                 <a:latin typeface="Calibri" panose="020F0502020204030204" pitchFamily="34" charset="0"/>
               </a:rPr>
-              <a:t>без T3/T4 AUC против молодых норм A/B — 0.57</a:t>
-            </a:r>
+              <a:t>without T3/T4, AUC against young controls A/B is 0.57</a:t>
+            </a:r>
+            <a:endParaRPr lang="ru-RU" sz="1200">
+              <a:solidFill>
+                <a:srgbClr val="52514E"/>
+              </a:solidFill>
+              <a:latin typeface="Calibri" panose="020F0502020204030204" pitchFamily="34" charset="0"/>
+            </a:endParaRPr>
           </a:p>
         </p:txBody>
       </p:sp>
     </p:spTree>
     <p:extLst>
       <p:ext uri="{BB962C8B-B14F-4D97-AF65-F5344CB8AC3E}">
-        <p14:creationId xmlns:p14="http://schemas.microsoft.com/office/powerpoint/2010/main" val="1061939826"/>
+        <p14:creationId xmlns:p14="http://schemas.microsoft.com/office/powerpoint/2010/main" val="3806963268"/>
       </p:ext>
     </p:extLst>
   </p:cSld>
@@ -7551,7 +7803,7 @@
           <p:cNvPr id="2" name="TextBox 1">
             <a:extLst>
               <a:ext uri="{FF2B5EF4-FFF2-40B4-BE49-F238E27FC236}">
-                <a16:creationId xmlns:a16="http://schemas.microsoft.com/office/drawing/2014/main" id="{75161F19-E4A9-44A3-BB2F-73097E729480}"/>
+                <a16:creationId xmlns:a16="http://schemas.microsoft.com/office/drawing/2014/main" id="{66C8A8FC-F498-D860-ECD2-8661DFDC9DAA}"/>
               </a:ext>
             </a:extLst>
           </p:cNvPr>
@@ -7575,14 +7827,20 @@
           <a:lstStyle/>
           <a:p>
             <a:r>
-              <a:rPr lang="ru-RU" sz="3000" b="1">
+              <a:rPr lang="en-US" sz="3000" b="1">
                 <a:solidFill>
                   <a:srgbClr val="14213D"/>
                 </a:solidFill>
                 <a:latin typeface="Cambria" panose="02040503050406030204" pitchFamily="18" charset="0"/>
               </a:rPr>
-              <a:t>Бонус: слуховой ответ без меток стимулов</a:t>
-            </a:r>
+              <a:t>Bonus: auditory response without stimulus markers</a:t>
+            </a:r>
+            <a:endParaRPr lang="ru-RU" sz="3000" b="1">
+              <a:solidFill>
+                <a:srgbClr val="14213D"/>
+              </a:solidFill>
+              <a:latin typeface="Cambria" panose="02040503050406030204" pitchFamily="18" charset="0"/>
+            </a:endParaRPr>
           </a:p>
         </p:txBody>
       </p:sp>
@@ -7591,7 +7849,7 @@
           <p:cNvPr id="4" name="Рисунок 3">
             <a:extLst>
               <a:ext uri="{FF2B5EF4-FFF2-40B4-BE49-F238E27FC236}">
-                <a16:creationId xmlns:a16="http://schemas.microsoft.com/office/drawing/2014/main" id="{C60C8AD6-C0B4-358D-FE11-666300419639}"/>
+                <a16:creationId xmlns:a16="http://schemas.microsoft.com/office/drawing/2014/main" id="{5E7D1263-D3E5-AA2D-A05D-A7B0D782C5D3}"/>
               </a:ext>
             </a:extLst>
           </p:cNvPr>
@@ -7627,7 +7885,7 @@
           <p:cNvPr id="5" name="Прямоугольник: скругленные углы 4">
             <a:extLst>
               <a:ext uri="{FF2B5EF4-FFF2-40B4-BE49-F238E27FC236}">
-                <a16:creationId xmlns:a16="http://schemas.microsoft.com/office/drawing/2014/main" id="{C2A51E39-55BC-B001-5BBF-5CCA6DD8753B}"/>
+                <a16:creationId xmlns:a16="http://schemas.microsoft.com/office/drawing/2014/main" id="{DB871B3F-D0A4-77DC-A6C0-0AD03B6D4728}"/>
               </a:ext>
             </a:extLst>
           </p:cNvPr>
@@ -7697,7 +7955,7 @@
           <p:cNvPr id="6" name="Прямоугольник: скругленные углы 5">
             <a:extLst>
               <a:ext uri="{FF2B5EF4-FFF2-40B4-BE49-F238E27FC236}">
-                <a16:creationId xmlns:a16="http://schemas.microsoft.com/office/drawing/2014/main" id="{CF1DB1E0-B13E-D647-BEB4-449F27BF4D8D}"/>
+                <a16:creationId xmlns:a16="http://schemas.microsoft.com/office/drawing/2014/main" id="{7EC4143E-D835-02B6-3FF3-53B4E23406CE}"/>
               </a:ext>
             </a:extLst>
           </p:cNvPr>
@@ -7759,14 +8017,20 @@
           <a:p>
             <a:pPr algn="ctr"/>
             <a:r>
-              <a:rPr lang="ru-RU" sz="1300" b="1">
+              <a:rPr lang="en-US" sz="1300" b="1">
                 <a:solidFill>
                   <a:srgbClr val="FFFFFF"/>
                 </a:solidFill>
                 <a:latin typeface="Calibri" panose="020F0502020204030204" pitchFamily="34" charset="0"/>
               </a:rPr>
-              <a:t>показано</a:t>
-            </a:r>
+              <a:t>shown</a:t>
+            </a:r>
+            <a:endParaRPr lang="ru-RU" sz="1300" b="1">
+              <a:solidFill>
+                <a:srgbClr val="FFFFFF"/>
+              </a:solidFill>
+              <a:latin typeface="Calibri" panose="020F0502020204030204" pitchFamily="34" charset="0"/>
+            </a:endParaRPr>
           </a:p>
         </p:txBody>
       </p:sp>
@@ -7775,7 +8039,7 @@
           <p:cNvPr id="7" name="TextBox 6">
             <a:extLst>
               <a:ext uri="{FF2B5EF4-FFF2-40B4-BE49-F238E27FC236}">
-                <a16:creationId xmlns:a16="http://schemas.microsoft.com/office/drawing/2014/main" id="{24AC0B00-D431-4F6C-72FA-C4BA2C10AAB8}"/>
+                <a16:creationId xmlns:a16="http://schemas.microsoft.com/office/drawing/2014/main" id="{4CEB66AE-0DA0-BA92-6237-517A6B3DA8D5}"/>
               </a:ext>
             </a:extLst>
           </p:cNvPr>
@@ -7799,14 +8063,20 @@
           <a:lstStyle/>
           <a:p>
             <a:r>
-              <a:rPr lang="ru-RU" sz="1400">
+              <a:rPr lang="en-US" sz="1400">
                 <a:solidFill>
                   <a:srgbClr val="1B1B1B"/>
                 </a:solidFill>
                 <a:latin typeface="Calibri" panose="020F0502020204030204" pitchFamily="34" charset="0"/>
               </a:rPr>
-              <a:t>ответ на удары метронома в покое: p = 0.0005, фронтальный</a:t>
-            </a:r>
+              <a:t>response to metronome beats at rest: p = 0.0005, frontal</a:t>
+            </a:r>
+            <a:endParaRPr lang="ru-RU" sz="1400">
+              <a:solidFill>
+                <a:srgbClr val="1B1B1B"/>
+              </a:solidFill>
+              <a:latin typeface="Calibri" panose="020F0502020204030204" pitchFamily="34" charset="0"/>
+            </a:endParaRPr>
           </a:p>
         </p:txBody>
       </p:sp>
@@ -7815,7 +8085,7 @@
           <p:cNvPr id="8" name="Прямоугольник: скругленные углы 7">
             <a:extLst>
               <a:ext uri="{FF2B5EF4-FFF2-40B4-BE49-F238E27FC236}">
-                <a16:creationId xmlns:a16="http://schemas.microsoft.com/office/drawing/2014/main" id="{8738BD40-F020-0C72-AED8-9142CA4E3E25}"/>
+                <a16:creationId xmlns:a16="http://schemas.microsoft.com/office/drawing/2014/main" id="{D3D53D38-9F23-7A26-68A6-2377FA4A00A5}"/>
               </a:ext>
             </a:extLst>
           </p:cNvPr>
@@ -7885,7 +8155,7 @@
           <p:cNvPr id="9" name="Прямоугольник: скругленные углы 8">
             <a:extLst>
               <a:ext uri="{FF2B5EF4-FFF2-40B4-BE49-F238E27FC236}">
-                <a16:creationId xmlns:a16="http://schemas.microsoft.com/office/drawing/2014/main" id="{E1ECF172-7330-CC4E-75CA-49942AD25C4C}"/>
+                <a16:creationId xmlns:a16="http://schemas.microsoft.com/office/drawing/2014/main" id="{5F622CBA-BC47-5674-5A19-C686FD6BCEA5}"/>
               </a:ext>
             </a:extLst>
           </p:cNvPr>
@@ -7947,14 +8217,20 @@
           <a:p>
             <a:pPr algn="ctr"/>
             <a:r>
-              <a:rPr lang="ru-RU" sz="1300" b="1">
+              <a:rPr lang="en-US" sz="1300" b="1">
                 <a:solidFill>
                   <a:srgbClr val="FFFFFF"/>
                 </a:solidFill>
                 <a:latin typeface="Calibri" panose="020F0502020204030204" pitchFamily="34" charset="0"/>
               </a:rPr>
-              <a:t>проверено</a:t>
-            </a:r>
+              <a:t>validated</a:t>
+            </a:r>
+            <a:endParaRPr lang="ru-RU" sz="1300" b="1">
+              <a:solidFill>
+                <a:srgbClr val="FFFFFF"/>
+              </a:solidFill>
+              <a:latin typeface="Calibri" panose="020F0502020204030204" pitchFamily="34" charset="0"/>
+            </a:endParaRPr>
           </a:p>
         </p:txBody>
       </p:sp>
@@ -7963,7 +8239,7 @@
           <p:cNvPr id="10" name="TextBox 9">
             <a:extLst>
               <a:ext uri="{FF2B5EF4-FFF2-40B4-BE49-F238E27FC236}">
-                <a16:creationId xmlns:a16="http://schemas.microsoft.com/office/drawing/2014/main" id="{539A60A4-762A-5172-6111-059F6A71A19D}"/>
+                <a16:creationId xmlns:a16="http://schemas.microsoft.com/office/drawing/2014/main" id="{7C0AB487-1A70-84A7-9716-9038D511512D}"/>
               </a:ext>
             </a:extLst>
           </p:cNvPr>
@@ -7987,14 +8263,20 @@
           <a:lstStyle/>
           <a:p>
             <a:r>
-              <a:rPr lang="ru-RU" sz="1400">
+              <a:rPr lang="en-US" sz="1400">
                 <a:solidFill>
                   <a:srgbClr val="1B1B1B"/>
                 </a:solidFill>
                 <a:latin typeface="Calibri" panose="020F0502020204030204" pitchFamily="34" charset="0"/>
               </a:rPr>
-              <a:t>метод на открытых данных ERP CORE и в гибридной симуляции</a:t>
-            </a:r>
+              <a:t>method checked on open ERP CORE data and in a hybrid simulation</a:t>
+            </a:r>
+            <a:endParaRPr lang="ru-RU" sz="1400">
+              <a:solidFill>
+                <a:srgbClr val="1B1B1B"/>
+              </a:solidFill>
+              <a:latin typeface="Calibri" panose="020F0502020204030204" pitchFamily="34" charset="0"/>
+            </a:endParaRPr>
           </a:p>
         </p:txBody>
       </p:sp>
@@ -8003,7 +8285,7 @@
           <p:cNvPr id="11" name="Прямоугольник: скругленные углы 10">
             <a:extLst>
               <a:ext uri="{FF2B5EF4-FFF2-40B4-BE49-F238E27FC236}">
-                <a16:creationId xmlns:a16="http://schemas.microsoft.com/office/drawing/2014/main" id="{2717BB33-2A9E-5F1E-6475-0C60BF6897A9}"/>
+                <a16:creationId xmlns:a16="http://schemas.microsoft.com/office/drawing/2014/main" id="{B67B71F5-931D-C6E0-E1F6-361DCBF16CA0}"/>
               </a:ext>
             </a:extLst>
           </p:cNvPr>
@@ -8073,7 +8355,7 @@
           <p:cNvPr id="12" name="Прямоугольник: скругленные углы 11">
             <a:extLst>
               <a:ext uri="{FF2B5EF4-FFF2-40B4-BE49-F238E27FC236}">
-                <a16:creationId xmlns:a16="http://schemas.microsoft.com/office/drawing/2014/main" id="{5ED9ED02-E5C5-FDA4-B127-40D2467FECA7}"/>
+                <a16:creationId xmlns:a16="http://schemas.microsoft.com/office/drawing/2014/main" id="{2747BB31-5F60-B6FC-B1B0-F7C8A5CEDB8E}"/>
               </a:ext>
             </a:extLst>
           </p:cNvPr>
@@ -8135,14 +8417,20 @@
           <a:p>
             <a:pPr algn="ctr"/>
             <a:r>
-              <a:rPr lang="ru-RU" sz="1300" b="1">
+              <a:rPr lang="en-US" sz="1300" b="1">
                 <a:solidFill>
                   <a:srgbClr val="FFFFFF"/>
                 </a:solidFill>
                 <a:latin typeface="Calibri" panose="020F0502020204030204" pitchFamily="34" charset="0"/>
               </a:rPr>
-              <a:t>не показано</a:t>
-            </a:r>
+              <a:t>not shown</a:t>
+            </a:r>
+            <a:endParaRPr lang="ru-RU" sz="1300" b="1">
+              <a:solidFill>
+                <a:srgbClr val="FFFFFF"/>
+              </a:solidFill>
+              <a:latin typeface="Calibri" panose="020F0502020204030204" pitchFamily="34" charset="0"/>
+            </a:endParaRPr>
           </a:p>
         </p:txBody>
       </p:sp>
@@ -8151,7 +8439,7 @@
           <p:cNvPr id="13" name="TextBox 12">
             <a:extLst>
               <a:ext uri="{FF2B5EF4-FFF2-40B4-BE49-F238E27FC236}">
-                <a16:creationId xmlns:a16="http://schemas.microsoft.com/office/drawing/2014/main" id="{081891F7-9613-3C90-B55F-E50304BD94F9}"/>
+                <a16:creationId xmlns:a16="http://schemas.microsoft.com/office/drawing/2014/main" id="{9F54983F-C4B9-2A11-C166-6D4F308C2D08}"/>
               </a:ext>
             </a:extLst>
           </p:cNvPr>
@@ -8175,21 +8463,27 @@
           <a:lstStyle/>
           <a:p>
             <a:r>
-              <a:rPr lang="ru-RU" sz="1400">
+              <a:rPr lang="en-US" sz="1400">
                 <a:solidFill>
                   <a:srgbClr val="1B1B1B"/>
                 </a:solidFill>
                 <a:latin typeface="Calibri" panose="020F0502020204030204" pitchFamily="34" charset="0"/>
               </a:rPr>
-              <a:t>ответ на девиант (MMN/P3a): p = 0.048 при пороге 0.025</a:t>
-            </a:r>
+              <a:t>deviant response (MMN/P3a): p = 0.048 against 0.025</a:t>
+            </a:r>
+            <a:endParaRPr lang="ru-RU" sz="1400">
+              <a:solidFill>
+                <a:srgbClr val="1B1B1B"/>
+              </a:solidFill>
+              <a:latin typeface="Calibri" panose="020F0502020204030204" pitchFamily="34" charset="0"/>
+            </a:endParaRPr>
           </a:p>
         </p:txBody>
       </p:sp>
     </p:spTree>
     <p:extLst>
       <p:ext uri="{BB962C8B-B14F-4D97-AF65-F5344CB8AC3E}">
-        <p14:creationId xmlns:p14="http://schemas.microsoft.com/office/powerpoint/2010/main" val="991127657"/>
+        <p14:creationId xmlns:p14="http://schemas.microsoft.com/office/powerpoint/2010/main" val="1988315633"/>
       </p:ext>
     </p:extLst>
   </p:cSld>
@@ -8229,7 +8523,7 @@
           <p:cNvPr id="2" name="TextBox 1">
             <a:extLst>
               <a:ext uri="{FF2B5EF4-FFF2-40B4-BE49-F238E27FC236}">
-                <a16:creationId xmlns:a16="http://schemas.microsoft.com/office/drawing/2014/main" id="{F9183EF3-4C97-A46E-70E0-B84F55F71939}"/>
+                <a16:creationId xmlns:a16="http://schemas.microsoft.com/office/drawing/2014/main" id="{8518E360-37AE-0C0F-68B8-9583F234A3CE}"/>
               </a:ext>
             </a:extLst>
           </p:cNvPr>
@@ -8253,14 +8547,20 @@
           <a:lstStyle/>
           <a:p>
             <a:r>
-              <a:rPr lang="ru-RU" sz="3400" b="1">
+              <a:rPr lang="en-US" sz="3400" b="1">
                 <a:solidFill>
                   <a:srgbClr val="FFFFFF"/>
                 </a:solidFill>
                 <a:latin typeface="Cambria" panose="02040503050406030204" pitchFamily="18" charset="0"/>
               </a:rPr>
-              <a:t>Выводы</a:t>
-            </a:r>
+              <a:t>Conclusions</a:t>
+            </a:r>
+            <a:endParaRPr lang="ru-RU" sz="3400" b="1">
+              <a:solidFill>
+                <a:srgbClr val="FFFFFF"/>
+              </a:solidFill>
+              <a:latin typeface="Cambria" panose="02040503050406030204" pitchFamily="18" charset="0"/>
+            </a:endParaRPr>
           </a:p>
         </p:txBody>
       </p:sp>
@@ -8269,7 +8569,7 @@
           <p:cNvPr id="3" name="Овал 2">
             <a:extLst>
               <a:ext uri="{FF2B5EF4-FFF2-40B4-BE49-F238E27FC236}">
-                <a16:creationId xmlns:a16="http://schemas.microsoft.com/office/drawing/2014/main" id="{842FDD6B-13EC-93AC-D551-8C715751421C}"/>
+                <a16:creationId xmlns:a16="http://schemas.microsoft.com/office/drawing/2014/main" id="{EA600004-2462-B8CE-161A-8C144BD89C0B}"/>
               </a:ext>
             </a:extLst>
           </p:cNvPr>
@@ -8345,7 +8645,7 @@
           <p:cNvPr id="4" name="TextBox 3">
             <a:extLst>
               <a:ext uri="{FF2B5EF4-FFF2-40B4-BE49-F238E27FC236}">
-                <a16:creationId xmlns:a16="http://schemas.microsoft.com/office/drawing/2014/main" id="{F4291ED3-1EE2-80FD-DE8A-459C634D8433}"/>
+                <a16:creationId xmlns:a16="http://schemas.microsoft.com/office/drawing/2014/main" id="{6D90C26B-F57A-4C03-1B94-80498C51BA4B}"/>
               </a:ext>
             </a:extLst>
           </p:cNvPr>
@@ -8369,14 +8669,20 @@
           <a:lstStyle/>
           <a:p>
             <a:r>
-              <a:rPr lang="ru-RU" sz="2000" b="1">
+              <a:rPr lang="en-US" sz="2000" b="1">
                 <a:solidFill>
                   <a:srgbClr val="FFFFFF"/>
                 </a:solidFill>
                 <a:latin typeface="Cambria" panose="02040503050406030204" pitchFamily="18" charset="0"/>
               </a:rPr>
-              <a:t>Что работает</a:t>
-            </a:r>
+              <a:t>What works</a:t>
+            </a:r>
+            <a:endParaRPr lang="ru-RU" sz="2000" b="1">
+              <a:solidFill>
+                <a:srgbClr val="FFFFFF"/>
+              </a:solidFill>
+              <a:latin typeface="Cambria" panose="02040503050406030204" pitchFamily="18" charset="0"/>
+            </a:endParaRPr>
           </a:p>
         </p:txBody>
       </p:sp>
@@ -8385,7 +8691,7 @@
           <p:cNvPr id="5" name="TextBox 4">
             <a:extLst>
               <a:ext uri="{FF2B5EF4-FFF2-40B4-BE49-F238E27FC236}">
-                <a16:creationId xmlns:a16="http://schemas.microsoft.com/office/drawing/2014/main" id="{98C7AA10-5F46-B480-D458-3DB39D10D391}"/>
+                <a16:creationId xmlns:a16="http://schemas.microsoft.com/office/drawing/2014/main" id="{9FEC8DFA-B02E-B18C-203C-9531D98B6E4A}"/>
               </a:ext>
             </a:extLst>
           </p:cNvPr>
@@ -8416,13 +8722,13 @@
               <a:buChar char="•"/>
             </a:pPr>
             <a:r>
-              <a:rPr lang="ru-RU" sz="1500">
+              <a:rPr lang="en-US" sz="1500">
                 <a:solidFill>
                   <a:srgbClr val="C9D3E3"/>
                 </a:solidFill>
                 <a:latin typeface="Calibri" panose="020F0502020204030204" pitchFamily="34" charset="0"/>
               </a:rPr>
-              <a:t>AUC 0.86 вне выборки, чувствительность 0.84</a:t>
+              <a:t>AUC 0.86 out of sample, sensitivity 0.84</a:t>
             </a:r>
           </a:p>
           <a:p>
@@ -8434,13 +8740,13 @@
               <a:buChar char="•"/>
             </a:pPr>
             <a:r>
-              <a:rPr lang="ru-RU" sz="1500">
+              <a:rPr lang="en-US" sz="1500">
                 <a:solidFill>
                   <a:srgbClr val="C9D3E3"/>
                 </a:solidFill>
                 <a:latin typeface="Calibri" panose="020F0502020204030204" pitchFamily="34" charset="0"/>
               </a:rPr>
-              <a:t>надёжное отделение нормального старения</a:t>
+              <a:t>reliable separation from normal ageing</a:t>
             </a:r>
           </a:p>
           <a:p>
@@ -8452,14 +8758,20 @@
               <a:buChar char="•"/>
             </a:pPr>
             <a:r>
-              <a:rPr lang="ru-RU" sz="1500">
+              <a:rPr lang="en-US" sz="1500">
                 <a:solidFill>
                   <a:srgbClr val="C9D3E3"/>
                 </a:solidFill>
                 <a:latin typeface="Calibri" panose="020F0502020204030204" pitchFamily="34" charset="0"/>
               </a:rPr>
-              <a:t>без утечки; устойчиво к перестановкам внутри формата</a:t>
-            </a:r>
+              <a:t>no leakage; survives permutation within a format</a:t>
+            </a:r>
+            <a:endParaRPr lang="ru-RU" sz="1500">
+              <a:solidFill>
+                <a:srgbClr val="C9D3E3"/>
+              </a:solidFill>
+              <a:latin typeface="Calibri" panose="020F0502020204030204" pitchFamily="34" charset="0"/>
+            </a:endParaRPr>
           </a:p>
         </p:txBody>
       </p:sp>
@@ -8468,7 +8780,7 @@
           <p:cNvPr id="6" name="Овал 5">
             <a:extLst>
               <a:ext uri="{FF2B5EF4-FFF2-40B4-BE49-F238E27FC236}">
-                <a16:creationId xmlns:a16="http://schemas.microsoft.com/office/drawing/2014/main" id="{44D64E74-87C4-A836-E19B-9D2E8F899D0A}"/>
+                <a16:creationId xmlns:a16="http://schemas.microsoft.com/office/drawing/2014/main" id="{071F242F-59BE-990D-C8D5-867FE413E3BC}"/>
               </a:ext>
             </a:extLst>
           </p:cNvPr>
@@ -8544,7 +8856,7 @@
           <p:cNvPr id="7" name="TextBox 6">
             <a:extLst>
               <a:ext uri="{FF2B5EF4-FFF2-40B4-BE49-F238E27FC236}">
-                <a16:creationId xmlns:a16="http://schemas.microsoft.com/office/drawing/2014/main" id="{1DFF57E4-8DAF-9905-4A61-F0113EC1E97A}"/>
+                <a16:creationId xmlns:a16="http://schemas.microsoft.com/office/drawing/2014/main" id="{7C323821-5DFD-F592-7F5D-78E62EE6CB1D}"/>
               </a:ext>
             </a:extLst>
           </p:cNvPr>
@@ -8568,14 +8880,20 @@
           <a:lstStyle/>
           <a:p>
             <a:r>
-              <a:rPr lang="ru-RU" sz="2000" b="1">
+              <a:rPr lang="en-US" sz="2000" b="1">
                 <a:solidFill>
                   <a:srgbClr val="FFFFFF"/>
                 </a:solidFill>
                 <a:latin typeface="Cambria" panose="02040503050406030204" pitchFamily="18" charset="0"/>
               </a:rPr>
-              <a:t>Ограничения</a:t>
-            </a:r>
+              <a:t>Limitations</a:t>
+            </a:r>
+            <a:endParaRPr lang="ru-RU" sz="2000" b="1">
+              <a:solidFill>
+                <a:srgbClr val="FFFFFF"/>
+              </a:solidFill>
+              <a:latin typeface="Cambria" panose="02040503050406030204" pitchFamily="18" charset="0"/>
+            </a:endParaRPr>
           </a:p>
         </p:txBody>
       </p:sp>
@@ -8584,7 +8902,7 @@
           <p:cNvPr id="8" name="TextBox 7">
             <a:extLst>
               <a:ext uri="{FF2B5EF4-FFF2-40B4-BE49-F238E27FC236}">
-                <a16:creationId xmlns:a16="http://schemas.microsoft.com/office/drawing/2014/main" id="{6780934D-AF91-7B4C-5E2B-3EFE34DA2CC7}"/>
+                <a16:creationId xmlns:a16="http://schemas.microsoft.com/office/drawing/2014/main" id="{FA8B53D2-ADA7-B5B9-6FF1-6305EF2B64ED}"/>
               </a:ext>
             </a:extLst>
           </p:cNvPr>
@@ -8615,13 +8933,13 @@
               <a:buChar char="•"/>
             </a:pPr>
             <a:r>
-              <a:rPr lang="ru-RU" sz="1500">
+              <a:rPr lang="en-US" sz="1500">
                 <a:solidFill>
                   <a:srgbClr val="C9D3E3"/>
                 </a:solidFill>
                 <a:latin typeface="Calibri" panose="020F0502020204030204" pitchFamily="34" charset="0"/>
               </a:rPr>
-              <a:t>молодые нормы A/B: опора на T3/T4</a:t>
+              <a:t>young controls A/B: relies on T3/T4</a:t>
             </a:r>
           </a:p>
           <a:p>
@@ -8633,13 +8951,13 @@
               <a:buChar char="•"/>
             </a:pPr>
             <a:r>
-              <a:rPr lang="ru-RU" sz="1500">
+              <a:rPr lang="en-US" sz="1500">
                 <a:solidFill>
                   <a:srgbClr val="C9D3E3"/>
                 </a:solidFill>
                 <a:latin typeface="Calibri" panose="020F0502020204030204" pitchFamily="34" charset="0"/>
               </a:rPr>
-              <a:t>соматоформные: 0.61, пол не учтён</a:t>
+              <a:t>somatoform: 0.61, sex not controlled</a:t>
             </a:r>
           </a:p>
           <a:p>
@@ -8651,14 +8969,20 @@
               <a:buChar char="•"/>
             </a:pPr>
             <a:r>
-              <a:rPr lang="ru-RU" sz="1500">
+              <a:rPr lang="en-US" sz="1500">
                 <a:solidFill>
                   <a:srgbClr val="C9D3E3"/>
                 </a:solidFill>
                 <a:latin typeface="Calibri" panose="020F0502020204030204" pitchFamily="34" charset="0"/>
               </a:rPr>
-              <a:t>когорты различаются не только диагнозом</a:t>
-            </a:r>
+              <a:t>cohorts differ beyond the diagnosis</a:t>
+            </a:r>
+            <a:endParaRPr lang="ru-RU" sz="1500">
+              <a:solidFill>
+                <a:srgbClr val="C9D3E3"/>
+              </a:solidFill>
+              <a:latin typeface="Calibri" panose="020F0502020204030204" pitchFamily="34" charset="0"/>
+            </a:endParaRPr>
           </a:p>
         </p:txBody>
       </p:sp>
@@ -8667,7 +8991,7 @@
           <p:cNvPr id="9" name="Овал 8">
             <a:extLst>
               <a:ext uri="{FF2B5EF4-FFF2-40B4-BE49-F238E27FC236}">
-                <a16:creationId xmlns:a16="http://schemas.microsoft.com/office/drawing/2014/main" id="{1D31922A-1928-78C0-63E6-7F3B62CF6EE3}"/>
+                <a16:creationId xmlns:a16="http://schemas.microsoft.com/office/drawing/2014/main" id="{302BDD56-7C44-DFB8-627D-7562786FF1FF}"/>
               </a:ext>
             </a:extLst>
           </p:cNvPr>
@@ -8743,7 +9067,7 @@
           <p:cNvPr id="10" name="TextBox 9">
             <a:extLst>
               <a:ext uri="{FF2B5EF4-FFF2-40B4-BE49-F238E27FC236}">
-                <a16:creationId xmlns:a16="http://schemas.microsoft.com/office/drawing/2014/main" id="{59EA8908-2093-D908-98EF-F8806D45F85C}"/>
+                <a16:creationId xmlns:a16="http://schemas.microsoft.com/office/drawing/2014/main" id="{25001E39-51E6-101A-F9A1-3FAB0765D638}"/>
               </a:ext>
             </a:extLst>
           </p:cNvPr>
@@ -8767,14 +9091,20 @@
           <a:lstStyle/>
           <a:p>
             <a:r>
-              <a:rPr lang="ru-RU" sz="2000" b="1">
+              <a:rPr lang="en-US" sz="2000" b="1">
                 <a:solidFill>
                   <a:srgbClr val="FFFFFF"/>
                 </a:solidFill>
                 <a:latin typeface="Cambria" panose="02040503050406030204" pitchFamily="18" charset="0"/>
               </a:rPr>
-              <a:t>Что дальше</a:t>
-            </a:r>
+              <a:t>Next steps</a:t>
+            </a:r>
+            <a:endParaRPr lang="ru-RU" sz="2000" b="1">
+              <a:solidFill>
+                <a:srgbClr val="FFFFFF"/>
+              </a:solidFill>
+              <a:latin typeface="Cambria" panose="02040503050406030204" pitchFamily="18" charset="0"/>
+            </a:endParaRPr>
           </a:p>
         </p:txBody>
       </p:sp>
@@ -8783,7 +9113,7 @@
           <p:cNvPr id="11" name="TextBox 10">
             <a:extLst>
               <a:ext uri="{FF2B5EF4-FFF2-40B4-BE49-F238E27FC236}">
-                <a16:creationId xmlns:a16="http://schemas.microsoft.com/office/drawing/2014/main" id="{6C57EE45-055E-AF3C-FEB2-0762CEDC1FB6}"/>
+                <a16:creationId xmlns:a16="http://schemas.microsoft.com/office/drawing/2014/main" id="{57344547-2F53-CF38-F8A0-F158EBF869CE}"/>
               </a:ext>
             </a:extLst>
           </p:cNvPr>
@@ -8814,13 +9144,13 @@
               <a:buChar char="•"/>
             </a:pPr>
             <a:r>
-              <a:rPr lang="ru-RU" sz="1500">
+              <a:rPr lang="en-US" sz="1500">
                 <a:solidFill>
                   <a:srgbClr val="C9D3E3"/>
                 </a:solidFill>
                 <a:latin typeface="Calibri" panose="020F0502020204030204" pitchFamily="34" charset="0"/>
               </a:rPr>
-              <a:t>контроль с боевой травмой без ПТСР</a:t>
+              <a:t>combat-exposed controls without PTSD</a:t>
             </a:r>
           </a:p>
           <a:p>
@@ -8832,13 +9162,13 @@
               <a:buChar char="•"/>
             </a:pPr>
             <a:r>
-              <a:rPr lang="ru-RU" sz="1500">
+              <a:rPr lang="en-US" sz="1500">
                 <a:solidFill>
                   <a:srgbClr val="C9D3E3"/>
                 </a:solidFill>
                 <a:latin typeface="Calibri" panose="020F0502020204030204" pitchFamily="34" charset="0"/>
               </a:rPr>
-              <a:t>одна гарнитура и экспорт для всех</a:t>
+              <a:t>one headset and export for everyone</a:t>
             </a:r>
           </a:p>
           <a:p>
@@ -8850,14 +9180,20 @@
               <a:buChar char="•"/>
             </a:pPr>
             <a:r>
-              <a:rPr lang="ru-RU" sz="1500">
+              <a:rPr lang="en-US" sz="1500">
                 <a:solidFill>
                   <a:srgbClr val="C9D3E3"/>
                 </a:solidFill>
                 <a:latin typeface="Calibri" panose="020F0502020204030204" pitchFamily="34" charset="0"/>
               </a:rPr>
-              <a:t>шкалы тяжести, лекарства, ЧМТ, сон</a:t>
-            </a:r>
+              <a:t>severity scales, medication, head injury, sleep</a:t>
+            </a:r>
+            <a:endParaRPr lang="ru-RU" sz="1500">
+              <a:solidFill>
+                <a:srgbClr val="C9D3E3"/>
+              </a:solidFill>
+              <a:latin typeface="Calibri" panose="020F0502020204030204" pitchFamily="34" charset="0"/>
+            </a:endParaRPr>
           </a:p>
         </p:txBody>
       </p:sp>
@@ -8866,7 +9202,7 @@
           <p:cNvPr id="12" name="TextBox 11">
             <a:extLst>
               <a:ext uri="{FF2B5EF4-FFF2-40B4-BE49-F238E27FC236}">
-                <a16:creationId xmlns:a16="http://schemas.microsoft.com/office/drawing/2014/main" id="{1646DEBF-DC26-38CD-5826-6EE69B46A86B}"/>
+                <a16:creationId xmlns:a16="http://schemas.microsoft.com/office/drawing/2014/main" id="{75332A02-462C-D4BD-FC4D-FC908FD3CE29}"/>
               </a:ext>
             </a:extLst>
           </p:cNvPr>
@@ -8890,21 +9226,27 @@
           <a:lstStyle/>
           <a:p>
             <a:r>
-              <a:rPr lang="ru-RU" sz="1400">
+              <a:rPr lang="en-US" sz="1400">
                 <a:solidFill>
                   <a:srgbClr val="C9D3E3"/>
                 </a:solidFill>
                 <a:latin typeface="Calibri" panose="020F0502020204030204" pitchFamily="34" charset="0"/>
               </a:rPr>
-              <a:t>Код, ноутбуки, аудит данных и клиническая интерпретация — в репозитории.</a:t>
-            </a:r>
+              <a:t>Code, notebooks, data audit and clinical interpretation: github.com/igor688-hub/neurodiagnosis-eeg</a:t>
+            </a:r>
+            <a:endParaRPr lang="ru-RU" sz="1400">
+              <a:solidFill>
+                <a:srgbClr val="C9D3E3"/>
+              </a:solidFill>
+              <a:latin typeface="Calibri" panose="020F0502020204030204" pitchFamily="34" charset="0"/>
+            </a:endParaRPr>
           </a:p>
         </p:txBody>
       </p:sp>
     </p:spTree>
     <p:extLst>
       <p:ext uri="{BB962C8B-B14F-4D97-AF65-F5344CB8AC3E}">
-        <p14:creationId xmlns:p14="http://schemas.microsoft.com/office/powerpoint/2010/main" val="577909652"/>
+        <p14:creationId xmlns:p14="http://schemas.microsoft.com/office/powerpoint/2010/main" val="2964481002"/>
       </p:ext>
     </p:extLst>
   </p:cSld>

</xml_diff>